<commit_message>
add something to the slides
</commit_message>
<xml_diff>
--- a/slides/Optimizing Memory Layouts and Traversal Orders in High-Performance Computing.pptx
+++ b/slides/Optimizing Memory Layouts and Traversal Orders in High-Performance Computing.pptx
@@ -6,14 +6,15 @@
   </p:sldMasterIdLst>
   <p:sldIdLst>
     <p:sldId id="256" r:id="rId2"/>
-    <p:sldId id="257" r:id="rId3"/>
-    <p:sldId id="263" r:id="rId4"/>
-    <p:sldId id="264" r:id="rId5"/>
-    <p:sldId id="258" r:id="rId6"/>
-    <p:sldId id="259" r:id="rId7"/>
-    <p:sldId id="260" r:id="rId8"/>
-    <p:sldId id="261" r:id="rId9"/>
-    <p:sldId id="262" r:id="rId10"/>
+    <p:sldId id="265" r:id="rId3"/>
+    <p:sldId id="266" r:id="rId4"/>
+    <p:sldId id="263" r:id="rId5"/>
+    <p:sldId id="264" r:id="rId6"/>
+    <p:sldId id="258" r:id="rId7"/>
+    <p:sldId id="259" r:id="rId8"/>
+    <p:sldId id="260" r:id="rId9"/>
+    <p:sldId id="261" r:id="rId10"/>
+    <p:sldId id="262" r:id="rId11"/>
   </p:sldIdLst>
   <p:sldSz cx="12192000" cy="6858000"/>
   <p:notesSz cx="6858000" cy="9144000"/>
@@ -118,7 +119,8 @@
         <p14:section name="Default Section" id="{293DA01B-4D9B-48A0-906B-75ADFA7BB1A7}">
           <p14:sldIdLst>
             <p14:sldId id="256"/>
-            <p14:sldId id="257"/>
+            <p14:sldId id="265"/>
+            <p14:sldId id="266"/>
             <p14:sldId id="263"/>
             <p14:sldId id="264"/>
           </p14:sldIdLst>
@@ -150,6 +152,9 @@
         </p14:section>
       </p14:sectionLst>
     </p:ext>
+    <p:ext uri="{EFAFB233-063F-42B5-8137-9DF3F51BA10A}">
+      <p15:sldGuideLst xmlns:p15="http://schemas.microsoft.com/office/powerpoint/2012/main"/>
+    </p:ext>
   </p:extLst>
 </p:presentation>
 </file>
@@ -301,7 +306,7 @@
           <a:p>
             <a:fld id="{93F57E82-5604-4F8C-BCFA-F7C026884391}" type="datetimeFigureOut">
               <a:rPr lang="en-US" smtClean="0"/>
-              <a:t>8/8/2026</a:t>
+              <a:t>8/18/2026</a:t>
             </a:fld>
             <a:endParaRPr lang="en-US"/>
           </a:p>
@@ -499,7 +504,7 @@
           <a:p>
             <a:fld id="{93F57E82-5604-4F8C-BCFA-F7C026884391}" type="datetimeFigureOut">
               <a:rPr lang="en-US" smtClean="0"/>
-              <a:t>8/8/2026</a:t>
+              <a:t>8/18/2026</a:t>
             </a:fld>
             <a:endParaRPr lang="en-US"/>
           </a:p>
@@ -707,7 +712,7 @@
           <a:p>
             <a:fld id="{93F57E82-5604-4F8C-BCFA-F7C026884391}" type="datetimeFigureOut">
               <a:rPr lang="en-US" smtClean="0"/>
-              <a:t>8/8/2026</a:t>
+              <a:t>8/18/2026</a:t>
             </a:fld>
             <a:endParaRPr lang="en-US"/>
           </a:p>
@@ -905,7 +910,7 @@
           <a:p>
             <a:fld id="{93F57E82-5604-4F8C-BCFA-F7C026884391}" type="datetimeFigureOut">
               <a:rPr lang="en-US" smtClean="0"/>
-              <a:t>8/8/2026</a:t>
+              <a:t>8/18/2026</a:t>
             </a:fld>
             <a:endParaRPr lang="en-US"/>
           </a:p>
@@ -1180,7 +1185,7 @@
           <a:p>
             <a:fld id="{93F57E82-5604-4F8C-BCFA-F7C026884391}" type="datetimeFigureOut">
               <a:rPr lang="en-US" smtClean="0"/>
-              <a:t>8/8/2026</a:t>
+              <a:t>8/18/2026</a:t>
             </a:fld>
             <a:endParaRPr lang="en-US"/>
           </a:p>
@@ -1445,7 +1450,7 @@
           <a:p>
             <a:fld id="{93F57E82-5604-4F8C-BCFA-F7C026884391}" type="datetimeFigureOut">
               <a:rPr lang="en-US" smtClean="0"/>
-              <a:t>8/8/2026</a:t>
+              <a:t>8/18/2026</a:t>
             </a:fld>
             <a:endParaRPr lang="en-US"/>
           </a:p>
@@ -1857,7 +1862,7 @@
           <a:p>
             <a:fld id="{93F57E82-5604-4F8C-BCFA-F7C026884391}" type="datetimeFigureOut">
               <a:rPr lang="en-US" smtClean="0"/>
-              <a:t>8/8/2026</a:t>
+              <a:t>8/18/2026</a:t>
             </a:fld>
             <a:endParaRPr lang="en-US"/>
           </a:p>
@@ -1998,7 +2003,7 @@
           <a:p>
             <a:fld id="{93F57E82-5604-4F8C-BCFA-F7C026884391}" type="datetimeFigureOut">
               <a:rPr lang="en-US" smtClean="0"/>
-              <a:t>8/8/2026</a:t>
+              <a:t>8/18/2026</a:t>
             </a:fld>
             <a:endParaRPr lang="en-US"/>
           </a:p>
@@ -2111,7 +2116,7 @@
           <a:p>
             <a:fld id="{93F57E82-5604-4F8C-BCFA-F7C026884391}" type="datetimeFigureOut">
               <a:rPr lang="en-US" smtClean="0"/>
-              <a:t>8/8/2026</a:t>
+              <a:t>8/18/2026</a:t>
             </a:fld>
             <a:endParaRPr lang="en-US"/>
           </a:p>
@@ -2422,7 +2427,7 @@
           <a:p>
             <a:fld id="{93F57E82-5604-4F8C-BCFA-F7C026884391}" type="datetimeFigureOut">
               <a:rPr lang="en-US" smtClean="0"/>
-              <a:t>8/8/2026</a:t>
+              <a:t>8/18/2026</a:t>
             </a:fld>
             <a:endParaRPr lang="en-US"/>
           </a:p>
@@ -2710,7 +2715,7 @@
           <a:p>
             <a:fld id="{93F57E82-5604-4F8C-BCFA-F7C026884391}" type="datetimeFigureOut">
               <a:rPr lang="en-US" smtClean="0"/>
-              <a:t>8/8/2026</a:t>
+              <a:t>8/18/2026</a:t>
             </a:fld>
             <a:endParaRPr lang="en-US"/>
           </a:p>
@@ -2951,7 +2956,7 @@
           <a:p>
             <a:fld id="{93F57E82-5604-4F8C-BCFA-F7C026884391}" type="datetimeFigureOut">
               <a:rPr lang="en-US" smtClean="0"/>
-              <a:t>8/8/2026</a:t>
+              <a:t>8/18/2026</a:t>
             </a:fld>
             <a:endParaRPr lang="en-US"/>
           </a:p>
@@ -3450,7 +3455,7 @@
 </p:sld>
 </file>
 
-<file path=ppt/slides/slide2.xml><?xml version="1.0" encoding="utf-8"?>
+<file path=ppt/slides/slide10.xml><?xml version="1.0" encoding="utf-8"?>
 <p:sld xmlns:a="http://schemas.openxmlformats.org/drawingml/2006/main" xmlns:r="http://schemas.openxmlformats.org/officeDocument/2006/relationships" xmlns:p="http://schemas.openxmlformats.org/presentationml/2006/main">
   <p:cSld>
     <p:spTree>
@@ -3472,7 +3477,7 @@
           <p:cNvPr id="2" name="Title 1">
             <a:extLst>
               <a:ext uri="{FF2B5EF4-FFF2-40B4-BE49-F238E27FC236}">
-                <a16:creationId xmlns:a16="http://schemas.microsoft.com/office/drawing/2014/main" id="{36CBB0EF-8FF3-0FBB-5857-EDFAEA9F2716}"/>
+                <a16:creationId xmlns:a16="http://schemas.microsoft.com/office/drawing/2014/main" id="{5EFCD7CC-C2D6-52E6-02D5-F41FC5389A5C}"/>
               </a:ext>
             </a:extLst>
           </p:cNvPr>
@@ -3488,10 +3493,7 @@
           <a:bodyPr/>
           <a:lstStyle/>
           <a:p>
-            <a:r>
-              <a:rPr lang="en-US" dirty="0"/>
-              <a:t>Contribution map</a:t>
-            </a:r>
+            <a:endParaRPr lang="en-US"/>
           </a:p>
         </p:txBody>
       </p:sp>
@@ -3500,7 +3502,7 @@
           <p:cNvPr id="3" name="Content Placeholder 2">
             <a:extLst>
               <a:ext uri="{FF2B5EF4-FFF2-40B4-BE49-F238E27FC236}">
-                <a16:creationId xmlns:a16="http://schemas.microsoft.com/office/drawing/2014/main" id="{5A889E22-7155-1CD3-33A4-DB5C75682770}"/>
+                <a16:creationId xmlns:a16="http://schemas.microsoft.com/office/drawing/2014/main" id="{950373B6-1B3D-2E32-D54A-18C124620153}"/>
               </a:ext>
             </a:extLst>
           </p:cNvPr>
@@ -3523,7 +3525,183 @@
     </p:spTree>
     <p:extLst>
       <p:ext uri="{BB962C8B-B14F-4D97-AF65-F5344CB8AC3E}">
-        <p14:creationId xmlns:p14="http://schemas.microsoft.com/office/powerpoint/2010/main" val="687549363"/>
+        <p14:creationId xmlns:p14="http://schemas.microsoft.com/office/powerpoint/2010/main" val="2595384929"/>
+      </p:ext>
+    </p:extLst>
+  </p:cSld>
+  <p:clrMapOvr>
+    <a:masterClrMapping/>
+  </p:clrMapOvr>
+</p:sld>
+</file>
+
+<file path=ppt/slides/slide2.xml><?xml version="1.0" encoding="utf-8"?>
+<p:sld xmlns:a="http://schemas.openxmlformats.org/drawingml/2006/main" xmlns:r="http://schemas.openxmlformats.org/officeDocument/2006/relationships" xmlns:p="http://schemas.openxmlformats.org/presentationml/2006/main">
+  <p:cSld>
+    <p:spTree>
+      <p:nvGrpSpPr>
+        <p:cNvPr id="1" name="">
+          <a:extLst>
+            <a:ext uri="{FF2B5EF4-FFF2-40B4-BE49-F238E27FC236}">
+              <a16:creationId xmlns:a16="http://schemas.microsoft.com/office/drawing/2014/main" id="{EFDF7620-7AA1-EF30-FDC7-27AAC7FFE5EE}"/>
+            </a:ext>
+          </a:extLst>
+        </p:cNvPr>
+        <p:cNvGrpSpPr/>
+        <p:nvPr/>
+      </p:nvGrpSpPr>
+      <p:grpSpPr>
+        <a:xfrm>
+          <a:off x="0" y="0"/>
+          <a:ext cx="0" cy="0"/>
+          <a:chOff x="0" y="0"/>
+          <a:chExt cx="0" cy="0"/>
+        </a:xfrm>
+      </p:grpSpPr>
+      <p:sp>
+        <p:nvSpPr>
+          <p:cNvPr id="2" name="Title 1">
+            <a:extLst>
+              <a:ext uri="{FF2B5EF4-FFF2-40B4-BE49-F238E27FC236}">
+                <a16:creationId xmlns:a16="http://schemas.microsoft.com/office/drawing/2014/main" id="{F7C42AB4-1D66-61B5-41F3-D1C814D6D79F}"/>
+              </a:ext>
+            </a:extLst>
+          </p:cNvPr>
+          <p:cNvSpPr>
+            <a:spLocks noGrp="1"/>
+          </p:cNvSpPr>
+          <p:nvPr>
+            <p:ph type="title"/>
+          </p:nvPr>
+        </p:nvSpPr>
+        <p:spPr/>
+        <p:txBody>
+          <a:bodyPr/>
+          <a:lstStyle/>
+          <a:p>
+            <a:r>
+              <a:rPr lang="en-US" dirty="0"/>
+              <a:t>Contribution map</a:t>
+            </a:r>
+          </a:p>
+        </p:txBody>
+      </p:sp>
+      <p:sp>
+        <p:nvSpPr>
+          <p:cNvPr id="3" name="Content Placeholder 2">
+            <a:extLst>
+              <a:ext uri="{FF2B5EF4-FFF2-40B4-BE49-F238E27FC236}">
+                <a16:creationId xmlns:a16="http://schemas.microsoft.com/office/drawing/2014/main" id="{7FC71ADE-62E2-F5C5-38A6-5FA51E07F94E}"/>
+              </a:ext>
+            </a:extLst>
+          </p:cNvPr>
+          <p:cNvSpPr>
+            <a:spLocks noGrp="1"/>
+          </p:cNvSpPr>
+          <p:nvPr>
+            <p:ph idx="1"/>
+          </p:nvPr>
+        </p:nvSpPr>
+        <p:spPr/>
+        <p:txBody>
+          <a:bodyPr/>
+          <a:lstStyle/>
+          <a:p>
+            <a:r>
+              <a:rPr lang="en-US" dirty="0"/>
+              <a:t>Background: GPU &amp; Cluster computing</a:t>
+            </a:r>
+          </a:p>
+          <a:p>
+            <a:pPr lvl="1"/>
+            <a:r>
+              <a:rPr lang="en-US" dirty="0"/>
+              <a:t>Too many decisions, complex code </a:t>
+            </a:r>
+            <a:r>
+              <a:rPr lang="en-US" dirty="0">
+                <a:sym typeface="Wingdings" panose="05000000000000000000" pitchFamily="2" charset="2"/>
+              </a:rPr>
+              <a:t> the problem, it is hard</a:t>
+            </a:r>
+            <a:endParaRPr lang="en-US" dirty="0"/>
+          </a:p>
+          <a:p>
+            <a:pPr lvl="2"/>
+            <a:r>
+              <a:rPr lang="en-US" dirty="0"/>
+              <a:t>layout options</a:t>
+            </a:r>
+          </a:p>
+          <a:p>
+            <a:pPr lvl="2"/>
+            <a:r>
+              <a:rPr lang="en-US" dirty="0"/>
+              <a:t>traversal options</a:t>
+            </a:r>
+          </a:p>
+          <a:p>
+            <a:pPr lvl="2"/>
+            <a:r>
+              <a:rPr lang="en-US" dirty="0"/>
+              <a:t>parallelization</a:t>
+            </a:r>
+          </a:p>
+          <a:p>
+            <a:pPr lvl="2"/>
+            <a:r>
+              <a:rPr lang="en-US" dirty="0"/>
+              <a:t>parameters for the above (block sizes, …)</a:t>
+            </a:r>
+          </a:p>
+          <a:p>
+            <a:pPr lvl="1"/>
+            <a:r>
+              <a:rPr lang="en-US" dirty="0"/>
+              <a:t>Our solution: Abstraction &amp; automatization </a:t>
+            </a:r>
+            <a:r>
+              <a:rPr lang="en-US" dirty="0">
+                <a:sym typeface="Wingdings" panose="05000000000000000000" pitchFamily="2" charset="2"/>
+              </a:rPr>
+              <a:t> we offer a solution</a:t>
+            </a:r>
+            <a:endParaRPr lang="en-US" dirty="0"/>
+          </a:p>
+          <a:p>
+            <a:pPr lvl="2"/>
+            <a:r>
+              <a:rPr lang="en-US" dirty="0"/>
+              <a:t>Eco context? (Compilers, other abstractions, autotuning)</a:t>
+            </a:r>
+          </a:p>
+          <a:p>
+            <a:pPr lvl="2"/>
+            <a:r>
+              <a:rPr lang="en-US" dirty="0"/>
+              <a:t>Separation of concerns, independent aspects</a:t>
+            </a:r>
+          </a:p>
+          <a:p>
+            <a:pPr lvl="2"/>
+            <a:r>
+              <a:rPr lang="en-US" dirty="0"/>
+              <a:t>Introducing layout-agnostic and traversal-agnostic algorithm design</a:t>
+            </a:r>
+          </a:p>
+          <a:p>
+            <a:pPr lvl="1"/>
+            <a:r>
+              <a:rPr lang="en-US" dirty="0"/>
+              <a:t>How the world is saved</a:t>
+            </a:r>
+          </a:p>
+        </p:txBody>
+      </p:sp>
+    </p:spTree>
+    <p:extLst>
+      <p:ext uri="{BB962C8B-B14F-4D97-AF65-F5344CB8AC3E}">
+        <p14:creationId xmlns:p14="http://schemas.microsoft.com/office/powerpoint/2010/main" val="1408920348"/>
       </p:ext>
     </p:extLst>
   </p:cSld>
@@ -3555,7 +3733,7 @@
           <p:cNvPr id="2" name="Title 1">
             <a:extLst>
               <a:ext uri="{FF2B5EF4-FFF2-40B4-BE49-F238E27FC236}">
-                <a16:creationId xmlns:a16="http://schemas.microsoft.com/office/drawing/2014/main" id="{BC500110-1A1D-46C5-865E-8C33FFF09E26}"/>
+                <a16:creationId xmlns:a16="http://schemas.microsoft.com/office/drawing/2014/main" id="{6447B745-9B50-DD90-5161-BD2A06CEA44B}"/>
               </a:ext>
             </a:extLst>
           </p:cNvPr>
@@ -3573,7 +3751,7 @@
           <a:p>
             <a:r>
               <a:rPr lang="en-US" dirty="0"/>
-              <a:t>Layout-agnostic design</a:t>
+              <a:t>Contribution map</a:t>
             </a:r>
           </a:p>
         </p:txBody>
@@ -3583,7 +3761,7 @@
           <p:cNvPr id="3" name="Content Placeholder 2">
             <a:extLst>
               <a:ext uri="{FF2B5EF4-FFF2-40B4-BE49-F238E27FC236}">
-                <a16:creationId xmlns:a16="http://schemas.microsoft.com/office/drawing/2014/main" id="{BC98E21C-63B1-8313-A72D-D4A24D26FBA1}"/>
+                <a16:creationId xmlns:a16="http://schemas.microsoft.com/office/drawing/2014/main" id="{FC82B3D9-0F0B-5093-8759-0AA05117C2D6}"/>
               </a:ext>
             </a:extLst>
           </p:cNvPr>
@@ -3599,14 +3777,14 @@
           <a:bodyPr/>
           <a:lstStyle/>
           <a:p>
-            <a:endParaRPr lang="en-US"/>
+            <a:endParaRPr lang="en-US" dirty="0"/>
           </a:p>
         </p:txBody>
       </p:sp>
     </p:spTree>
     <p:extLst>
       <p:ext uri="{BB962C8B-B14F-4D97-AF65-F5344CB8AC3E}">
-        <p14:creationId xmlns:p14="http://schemas.microsoft.com/office/powerpoint/2010/main" val="3503651732"/>
+        <p14:creationId xmlns:p14="http://schemas.microsoft.com/office/powerpoint/2010/main" val="1745489699"/>
       </p:ext>
     </p:extLst>
   </p:cSld>
@@ -3638,7 +3816,7 @@
           <p:cNvPr id="2" name="Title 1">
             <a:extLst>
               <a:ext uri="{FF2B5EF4-FFF2-40B4-BE49-F238E27FC236}">
-                <a16:creationId xmlns:a16="http://schemas.microsoft.com/office/drawing/2014/main" id="{F794F90E-47C1-8163-3DF3-3F88A625B905}"/>
+                <a16:creationId xmlns:a16="http://schemas.microsoft.com/office/drawing/2014/main" id="{BC500110-1A1D-46C5-865E-8C33FFF09E26}"/>
               </a:ext>
             </a:extLst>
           </p:cNvPr>
@@ -3656,7 +3834,7 @@
           <a:p>
             <a:r>
               <a:rPr lang="en-US" dirty="0"/>
-              <a:t>Traversal-agnostic design</a:t>
+              <a:t>Layout-agnostic design</a:t>
             </a:r>
           </a:p>
         </p:txBody>
@@ -3666,7 +3844,7 @@
           <p:cNvPr id="3" name="Content Placeholder 2">
             <a:extLst>
               <a:ext uri="{FF2B5EF4-FFF2-40B4-BE49-F238E27FC236}">
-                <a16:creationId xmlns:a16="http://schemas.microsoft.com/office/drawing/2014/main" id="{3821D725-871B-DFB5-1476-7BE78B119576}"/>
+                <a16:creationId xmlns:a16="http://schemas.microsoft.com/office/drawing/2014/main" id="{BC98E21C-63B1-8313-A72D-D4A24D26FBA1}"/>
               </a:ext>
             </a:extLst>
           </p:cNvPr>
@@ -3682,14 +3860,17 @@
           <a:bodyPr/>
           <a:lstStyle/>
           <a:p>
-            <a:endParaRPr lang="en-US"/>
+            <a:r>
+              <a:rPr lang="en-US" dirty="0"/>
+              <a:t>Algorithm with explicit offset calculations × Algorithm with logical indices</a:t>
+            </a:r>
           </a:p>
         </p:txBody>
       </p:sp>
     </p:spTree>
     <p:extLst>
       <p:ext uri="{BB962C8B-B14F-4D97-AF65-F5344CB8AC3E}">
-        <p14:creationId xmlns:p14="http://schemas.microsoft.com/office/powerpoint/2010/main" val="3026343622"/>
+        <p14:creationId xmlns:p14="http://schemas.microsoft.com/office/powerpoint/2010/main" val="3503651732"/>
       </p:ext>
     </p:extLst>
   </p:cSld>
@@ -3721,7 +3902,7 @@
           <p:cNvPr id="2" name="Title 1">
             <a:extLst>
               <a:ext uri="{FF2B5EF4-FFF2-40B4-BE49-F238E27FC236}">
-                <a16:creationId xmlns:a16="http://schemas.microsoft.com/office/drawing/2014/main" id="{3844D8EA-565C-C8A0-F333-6EBD085AC735}"/>
+                <a16:creationId xmlns:a16="http://schemas.microsoft.com/office/drawing/2014/main" id="{F794F90E-47C1-8163-3DF3-3F88A625B905}"/>
               </a:ext>
             </a:extLst>
           </p:cNvPr>
@@ -3739,7 +3920,7 @@
           <a:p>
             <a:r>
               <a:rPr lang="en-US" dirty="0"/>
-              <a:t>Proposed abstractions</a:t>
+              <a:t>Traversal-agnostic design</a:t>
             </a:r>
           </a:p>
         </p:txBody>
@@ -3749,7 +3930,7 @@
           <p:cNvPr id="3" name="Content Placeholder 2">
             <a:extLst>
               <a:ext uri="{FF2B5EF4-FFF2-40B4-BE49-F238E27FC236}">
-                <a16:creationId xmlns:a16="http://schemas.microsoft.com/office/drawing/2014/main" id="{0B0BC514-DFF4-C541-7399-85275B2EB075}"/>
+                <a16:creationId xmlns:a16="http://schemas.microsoft.com/office/drawing/2014/main" id="{3821D725-871B-DFB5-1476-7BE78B119576}"/>
               </a:ext>
             </a:extLst>
           </p:cNvPr>
@@ -3767,31 +3948,7 @@
           <a:p>
             <a:r>
               <a:rPr lang="en-US" dirty="0"/>
-              <a:t>Layout abstractions</a:t>
-            </a:r>
-          </a:p>
-          <a:p>
-            <a:r>
-              <a:rPr lang="en-US" dirty="0"/>
-              <a:t>Traversal abstractions</a:t>
-            </a:r>
-          </a:p>
-          <a:p>
-            <a:r>
-              <a:rPr lang="en-US" dirty="0"/>
-              <a:t>Practical aspects</a:t>
-            </a:r>
-          </a:p>
-          <a:p>
-            <a:r>
-              <a:rPr lang="en-US" dirty="0"/>
-              <a:t>Distributed computing</a:t>
-            </a:r>
-          </a:p>
-          <a:p>
-            <a:r>
-              <a:rPr lang="en-US" dirty="0"/>
-              <a:t>Stencil computations</a:t>
+              <a:t>We can go even further</a:t>
             </a:r>
           </a:p>
         </p:txBody>
@@ -3799,7 +3956,7 @@
     </p:spTree>
     <p:extLst>
       <p:ext uri="{BB962C8B-B14F-4D97-AF65-F5344CB8AC3E}">
-        <p14:creationId xmlns:p14="http://schemas.microsoft.com/office/powerpoint/2010/main" val="2195190930"/>
+        <p14:creationId xmlns:p14="http://schemas.microsoft.com/office/powerpoint/2010/main" val="3026343622"/>
       </p:ext>
     </p:extLst>
   </p:cSld>
@@ -3831,7 +3988,7 @@
           <p:cNvPr id="2" name="Title 1">
             <a:extLst>
               <a:ext uri="{FF2B5EF4-FFF2-40B4-BE49-F238E27FC236}">
-                <a16:creationId xmlns:a16="http://schemas.microsoft.com/office/drawing/2014/main" id="{1CFD8E19-FCBD-3C1F-9804-55F9EF315364}"/>
+                <a16:creationId xmlns:a16="http://schemas.microsoft.com/office/drawing/2014/main" id="{3844D8EA-565C-C8A0-F333-6EBD085AC735}"/>
               </a:ext>
             </a:extLst>
           </p:cNvPr>
@@ -3849,7 +4006,7 @@
           <a:p>
             <a:r>
               <a:rPr lang="en-US" dirty="0"/>
-              <a:t>LLMs in algorithm design</a:t>
+              <a:t>Proposed abstractions</a:t>
             </a:r>
           </a:p>
         </p:txBody>
@@ -3859,7 +4016,7 @@
           <p:cNvPr id="3" name="Content Placeholder 2">
             <a:extLst>
               <a:ext uri="{FF2B5EF4-FFF2-40B4-BE49-F238E27FC236}">
-                <a16:creationId xmlns:a16="http://schemas.microsoft.com/office/drawing/2014/main" id="{64F2D09B-2F00-3457-9D41-D2EAB2BD84E5}"/>
+                <a16:creationId xmlns:a16="http://schemas.microsoft.com/office/drawing/2014/main" id="{0B0BC514-DFF4-C541-7399-85275B2EB075}"/>
               </a:ext>
             </a:extLst>
           </p:cNvPr>
@@ -3877,13 +4034,31 @@
           <a:p>
             <a:r>
               <a:rPr lang="en-US" dirty="0"/>
-              <a:t>Tutoring LLMs for CUDA optimization</a:t>
+              <a:t>Layout abstractions</a:t>
             </a:r>
           </a:p>
           <a:p>
             <a:r>
               <a:rPr lang="en-US" dirty="0"/>
-              <a:t>LLMs and abstractions</a:t>
+              <a:t>Traversal abstractions</a:t>
+            </a:r>
+          </a:p>
+          <a:p>
+            <a:r>
+              <a:rPr lang="en-US" dirty="0"/>
+              <a:t>Practical aspects</a:t>
+            </a:r>
+          </a:p>
+          <a:p>
+            <a:r>
+              <a:rPr lang="en-US" dirty="0"/>
+              <a:t>Distributed computing</a:t>
+            </a:r>
+          </a:p>
+          <a:p>
+            <a:r>
+              <a:rPr lang="en-US" dirty="0"/>
+              <a:t>Stencil computations</a:t>
             </a:r>
           </a:p>
         </p:txBody>
@@ -3891,7 +4066,7 @@
     </p:spTree>
     <p:extLst>
       <p:ext uri="{BB962C8B-B14F-4D97-AF65-F5344CB8AC3E}">
-        <p14:creationId xmlns:p14="http://schemas.microsoft.com/office/powerpoint/2010/main" val="645810162"/>
+        <p14:creationId xmlns:p14="http://schemas.microsoft.com/office/powerpoint/2010/main" val="2195190930"/>
       </p:ext>
     </p:extLst>
   </p:cSld>
@@ -3923,7 +4098,7 @@
           <p:cNvPr id="2" name="Title 1">
             <a:extLst>
               <a:ext uri="{FF2B5EF4-FFF2-40B4-BE49-F238E27FC236}">
-                <a16:creationId xmlns:a16="http://schemas.microsoft.com/office/drawing/2014/main" id="{928BD501-0287-7E9D-6C52-A86B98F9EB52}"/>
+                <a16:creationId xmlns:a16="http://schemas.microsoft.com/office/drawing/2014/main" id="{1CFD8E19-FCBD-3C1F-9804-55F9EF315364}"/>
               </a:ext>
             </a:extLst>
           </p:cNvPr>
@@ -3941,7 +4116,7 @@
           <a:p>
             <a:r>
               <a:rPr lang="en-US" dirty="0"/>
-              <a:t>Software artifacts</a:t>
+              <a:t>LLMs in algorithm design</a:t>
             </a:r>
           </a:p>
         </p:txBody>
@@ -3951,7 +4126,7 @@
           <p:cNvPr id="3" name="Content Placeholder 2">
             <a:extLst>
               <a:ext uri="{FF2B5EF4-FFF2-40B4-BE49-F238E27FC236}">
-                <a16:creationId xmlns:a16="http://schemas.microsoft.com/office/drawing/2014/main" id="{369E5D67-EA03-A5CA-2D82-199F178CE89C}"/>
+                <a16:creationId xmlns:a16="http://schemas.microsoft.com/office/drawing/2014/main" id="{64F2D09B-2F00-3457-9D41-D2EAB2BD84E5}"/>
               </a:ext>
             </a:extLst>
           </p:cNvPr>
@@ -3968,24 +4143,22 @@
           <a:lstStyle/>
           <a:p>
             <a:r>
-              <a:rPr lang="en-US" dirty="0" err="1"/>
-              <a:t>Noarr</a:t>
-            </a:r>
-            <a:endParaRPr lang="en-US" dirty="0"/>
-          </a:p>
-          <a:p>
-            <a:r>
-              <a:rPr lang="en-US" dirty="0" err="1"/>
-              <a:t>Cellato</a:t>
-            </a:r>
-            <a:endParaRPr lang="en-US" dirty="0"/>
+              <a:rPr lang="en-US" dirty="0"/>
+              <a:t>Tutoring LLMs for CUDA optimization</a:t>
+            </a:r>
+          </a:p>
+          <a:p>
+            <a:r>
+              <a:rPr lang="en-US" dirty="0"/>
+              <a:t>LLMs and abstractions</a:t>
+            </a:r>
           </a:p>
         </p:txBody>
       </p:sp>
     </p:spTree>
     <p:extLst>
       <p:ext uri="{BB962C8B-B14F-4D97-AF65-F5344CB8AC3E}">
-        <p14:creationId xmlns:p14="http://schemas.microsoft.com/office/powerpoint/2010/main" val="4085122203"/>
+        <p14:creationId xmlns:p14="http://schemas.microsoft.com/office/powerpoint/2010/main" val="645810162"/>
       </p:ext>
     </p:extLst>
   </p:cSld>
@@ -4017,7 +4190,7 @@
           <p:cNvPr id="2" name="Title 1">
             <a:extLst>
               <a:ext uri="{FF2B5EF4-FFF2-40B4-BE49-F238E27FC236}">
-                <a16:creationId xmlns:a16="http://schemas.microsoft.com/office/drawing/2014/main" id="{63B07F39-5957-124B-D20D-4A155E0E07D1}"/>
+                <a16:creationId xmlns:a16="http://schemas.microsoft.com/office/drawing/2014/main" id="{928BD501-0287-7E9D-6C52-A86B98F9EB52}"/>
               </a:ext>
             </a:extLst>
           </p:cNvPr>
@@ -4035,7 +4208,7 @@
           <a:p>
             <a:r>
               <a:rPr lang="en-US" dirty="0"/>
-              <a:t>Summary</a:t>
+              <a:t>Software artifacts</a:t>
             </a:r>
           </a:p>
         </p:txBody>
@@ -4045,7 +4218,7 @@
           <p:cNvPr id="3" name="Content Placeholder 2">
             <a:extLst>
               <a:ext uri="{FF2B5EF4-FFF2-40B4-BE49-F238E27FC236}">
-                <a16:creationId xmlns:a16="http://schemas.microsoft.com/office/drawing/2014/main" id="{4437CB38-BBCE-B652-0445-A75C99068419}"/>
+                <a16:creationId xmlns:a16="http://schemas.microsoft.com/office/drawing/2014/main" id="{369E5D67-EA03-A5CA-2D82-199F178CE89C}"/>
               </a:ext>
             </a:extLst>
           </p:cNvPr>
@@ -4062,43 +4235,24 @@
           <a:lstStyle/>
           <a:p>
             <a:r>
-              <a:rPr lang="en-US" dirty="0"/>
-              <a:t>6 peer-reviewed publications </a:t>
-            </a:r>
-          </a:p>
-          <a:p>
-            <a:pPr lvl="1"/>
-            <a:r>
-              <a:rPr lang="en-US" dirty="0"/>
-              <a:t>2 journal articles</a:t>
-            </a:r>
-          </a:p>
-          <a:p>
-            <a:pPr lvl="1"/>
-            <a:r>
-              <a:rPr lang="en-US" dirty="0"/>
-              <a:t>3 conference papers,</a:t>
-            </a:r>
-          </a:p>
-          <a:p>
-            <a:pPr lvl="1"/>
-            <a:r>
-              <a:rPr lang="en-US" dirty="0"/>
-              <a:t>1 workshop paper</a:t>
-            </a:r>
-          </a:p>
-          <a:p>
-            <a:r>
-              <a:rPr lang="en-US" dirty="0"/>
-              <a:t>1 publication awaiting peer review</a:t>
-            </a:r>
+              <a:rPr lang="en-US" dirty="0" err="1"/>
+              <a:t>Noarr</a:t>
+            </a:r>
+            <a:endParaRPr lang="en-US" dirty="0"/>
+          </a:p>
+          <a:p>
+            <a:r>
+              <a:rPr lang="en-US" dirty="0" err="1"/>
+              <a:t>Cellato</a:t>
+            </a:r>
+            <a:endParaRPr lang="en-US" dirty="0"/>
           </a:p>
         </p:txBody>
       </p:sp>
     </p:spTree>
     <p:extLst>
       <p:ext uri="{BB962C8B-B14F-4D97-AF65-F5344CB8AC3E}">
-        <p14:creationId xmlns:p14="http://schemas.microsoft.com/office/powerpoint/2010/main" val="309417143"/>
+        <p14:creationId xmlns:p14="http://schemas.microsoft.com/office/powerpoint/2010/main" val="4085122203"/>
       </p:ext>
     </p:extLst>
   </p:cSld>
@@ -4130,7 +4284,7 @@
           <p:cNvPr id="2" name="Title 1">
             <a:extLst>
               <a:ext uri="{FF2B5EF4-FFF2-40B4-BE49-F238E27FC236}">
-                <a16:creationId xmlns:a16="http://schemas.microsoft.com/office/drawing/2014/main" id="{5EFCD7CC-C2D6-52E6-02D5-F41FC5389A5C}"/>
+                <a16:creationId xmlns:a16="http://schemas.microsoft.com/office/drawing/2014/main" id="{63B07F39-5957-124B-D20D-4A155E0E07D1}"/>
               </a:ext>
             </a:extLst>
           </p:cNvPr>
@@ -4146,7 +4300,10 @@
           <a:bodyPr/>
           <a:lstStyle/>
           <a:p>
-            <a:endParaRPr lang="en-US"/>
+            <a:r>
+              <a:rPr lang="en-US" dirty="0"/>
+              <a:t>Summary</a:t>
+            </a:r>
           </a:p>
         </p:txBody>
       </p:sp>
@@ -4155,7 +4312,7 @@
           <p:cNvPr id="3" name="Content Placeholder 2">
             <a:extLst>
               <a:ext uri="{FF2B5EF4-FFF2-40B4-BE49-F238E27FC236}">
-                <a16:creationId xmlns:a16="http://schemas.microsoft.com/office/drawing/2014/main" id="{950373B6-1B3D-2E32-D54A-18C124620153}"/>
+                <a16:creationId xmlns:a16="http://schemas.microsoft.com/office/drawing/2014/main" id="{4437CB38-BBCE-B652-0445-A75C99068419}"/>
               </a:ext>
             </a:extLst>
           </p:cNvPr>
@@ -4171,14 +4328,44 @@
           <a:bodyPr/>
           <a:lstStyle/>
           <a:p>
-            <a:endParaRPr lang="en-US"/>
+            <a:r>
+              <a:rPr lang="en-US" dirty="0"/>
+              <a:t>6 peer-reviewed publications </a:t>
+            </a:r>
+          </a:p>
+          <a:p>
+            <a:pPr lvl="1"/>
+            <a:r>
+              <a:rPr lang="en-US" dirty="0"/>
+              <a:t>2 journal articles</a:t>
+            </a:r>
+          </a:p>
+          <a:p>
+            <a:pPr lvl="1"/>
+            <a:r>
+              <a:rPr lang="en-US" dirty="0"/>
+              <a:t>3 conference papers,</a:t>
+            </a:r>
+          </a:p>
+          <a:p>
+            <a:pPr lvl="1"/>
+            <a:r>
+              <a:rPr lang="en-US" dirty="0"/>
+              <a:t>1 workshop paper</a:t>
+            </a:r>
+          </a:p>
+          <a:p>
+            <a:r>
+              <a:rPr lang="en-US" dirty="0"/>
+              <a:t>1 publication awaiting peer review</a:t>
+            </a:r>
           </a:p>
         </p:txBody>
       </p:sp>
     </p:spTree>
     <p:extLst>
       <p:ext uri="{BB962C8B-B14F-4D97-AF65-F5344CB8AC3E}">
-        <p14:creationId xmlns:p14="http://schemas.microsoft.com/office/powerpoint/2010/main" val="2595384929"/>
+        <p14:creationId xmlns:p14="http://schemas.microsoft.com/office/powerpoint/2010/main" val="309417143"/>
       </p:ext>
     </p:extLst>
   </p:cSld>

</xml_diff>

<commit_message>
let's continue in the morning
</commit_message>
<xml_diff>
--- a/slides/Optimizing Memory Layouts and Traversal Orders in High-Performance Computing.pptx
+++ b/slides/Optimizing Memory Layouts and Traversal Orders in High-Performance Computing.pptx
@@ -1491,13 +1491,113 @@
             </a:br>
             <a:r>
               <a:rPr lang="en-US" dirty="0"/>
-              <a:t>improves with abstractions that allow user-directed optimizations of the code in a similar manner to our abstractions.</a:t>
-            </a:r>
-          </a:p>
-          <a:p>
-            <a:endParaRPr lang="en-US"/>
-          </a:p>
-          <a:p>
+              <a:t>further improves with abstractions that allow user-directed optimizations of the code in a similar manner to our abstractions.</a:t>
+            </a:r>
+          </a:p>
+          <a:p>
+            <a:endParaRPr lang="en-US" dirty="0"/>
+          </a:p>
+          <a:p>
+            <a:r>
+              <a:rPr lang="en-US" dirty="0"/>
+              <a:t>We have made a study with 3 different abstractions (Halide, Exo, </a:t>
+            </a:r>
+            <a:r>
+              <a:rPr lang="en-US" dirty="0" err="1"/>
+              <a:t>Noarr</a:t>
+            </a:r>
+            <a:r>
+              <a:rPr lang="en-US" dirty="0"/>
+              <a:t>), evaluating a state of the art LLM on the </a:t>
+            </a:r>
+            <a:r>
+              <a:rPr lang="en-US" dirty="0" err="1"/>
+              <a:t>PolyBench</a:t>
+            </a:r>
+            <a:r>
+              <a:rPr lang="en-US" dirty="0"/>
+              <a:t>/C suite;</a:t>
+            </a:r>
+            <a:br>
+              <a:rPr lang="en-US" dirty="0"/>
+            </a:br>
+            <a:r>
+              <a:rPr lang="en-US" dirty="0"/>
+              <a:t>the workflow consisted of 2 generation steps (translation and optimization) combined with an algorithmic selection of the best translation.</a:t>
+            </a:r>
+          </a:p>
+          <a:p>
+            <a:endParaRPr lang="en-US" dirty="0"/>
+          </a:p>
+          <a:p>
+            <a:r>
+              <a:rPr lang="en-US" dirty="0"/>
+              <a:t>This was made to ensure that the LLM would have a working translation to use as a basis for its optimization attempt, as, at the time of the study,</a:t>
+            </a:r>
+          </a:p>
+          <a:p>
+            <a:r>
+              <a:rPr lang="en-US" dirty="0"/>
+              <a:t>it wasn’t feasible to put the entire programming reference for the given abstraction within the LLM’s limited context window.</a:t>
+            </a:r>
+          </a:p>
+          <a:p>
+            <a:endParaRPr lang="en-US" dirty="0"/>
+          </a:p>
+          <a:p>
+            <a:r>
+              <a:rPr lang="en-US" dirty="0"/>
+              <a:t>The prompts were supplied with one example of the translation (/optimization?) to further compensate for the limitation of its context window.</a:t>
+            </a:r>
+          </a:p>
+          <a:p>
+            <a:endParaRPr lang="en-US" dirty="0"/>
+          </a:p>
+          <a:p>
+            <a:r>
+              <a:rPr lang="en-US" dirty="0"/>
+              <a:t>We have compared a naïve prompt (just to optimize the given computation) with more specific prompts giving general optimization hints,</a:t>
+            </a:r>
+            <a:br>
+              <a:rPr lang="en-US" dirty="0"/>
+            </a:br>
+            <a:r>
+              <a:rPr lang="en-US" dirty="0"/>
+              <a:t>and an alternative approach based on first writing an abstract optimization strategy and then implementing it in the second request.</a:t>
+            </a:r>
+          </a:p>
+          <a:p>
+            <a:endParaRPr lang="en-US" dirty="0"/>
+          </a:p>
+          <a:p>
+            <a:r>
+              <a:rPr lang="en-US" dirty="0"/>
+              <a:t>All these combinations of abstractions and prompts were also compared to applying the same methodology to the C baseline.</a:t>
+            </a:r>
+          </a:p>
+          <a:p>
+            <a:endParaRPr lang="en-US" dirty="0"/>
+          </a:p>
+          <a:p>
+            <a:r>
+              <a:rPr lang="en-US" dirty="0"/>
+              <a:t>Very unsurprisingly, more specific prompts performed better across all abstractions and C, but at the same time,</a:t>
+            </a:r>
+            <a:br>
+              <a:rPr lang="en-US"/>
+            </a:br>
+            <a:r>
+              <a:rPr lang="en-US"/>
+              <a:t>pure C </a:t>
+            </a:r>
+            <a:r>
+              <a:rPr lang="en-US" dirty="0"/>
+              <a:t>optimization attempts performed better than </a:t>
+            </a:r>
+            <a:r>
+              <a:rPr lang="en-US"/>
+              <a:t>any abstraction.</a:t>
+            </a:r>
             <a:endParaRPr lang="en-US" dirty="0"/>
           </a:p>
         </p:txBody>

</xml_diff>

<commit_message>
ver 2 main body done
</commit_message>
<xml_diff>
--- a/slides/Optimizing Memory Layouts and Traversal Orders in High-Performance Computing.pptx
+++ b/slides/Optimizing Memory Layouts and Traversal Orders in High-Performance Computing.pptx
@@ -1354,7 +1354,7 @@
           <a:p>
             <a:r>
               <a:rPr lang="en-US" dirty="0"/>
-              <a:t>We have compared the state of the art C++ bindings for MPI in how they manage to seamlessly enable layout-agnostic communication of data over MPI</a:t>
+              <a:t>(key idea: it is very great)</a:t>
             </a:r>
           </a:p>
           <a:p>
@@ -1363,7 +1363,31 @@
           <a:p>
             <a:r>
               <a:rPr lang="en-US" dirty="0"/>
-              <a:t>This requires that the framework encodes the layout correctly so it is automatically transformed between the two end-points</a:t>
+              <a:t>We have compared our approach to various state-of-the-art C++ bindings for MPI in terms of how they manage to seamlessly enable layout-agnostic communication of data over MPI.</a:t>
+            </a:r>
+          </a:p>
+          <a:p>
+            <a:endParaRPr lang="en-US" dirty="0"/>
+          </a:p>
+          <a:p>
+            <a:r>
+              <a:rPr lang="en-US" dirty="0"/>
+              <a:t>Our approach is the only one that automatically handles differing physical layouts on opposite endpoints of communication (as shown on the previous slide),</a:t>
+            </a:r>
+          </a:p>
+          <a:p>
+            <a:r>
+              <a:rPr lang="en-US" dirty="0"/>
+              <a:t>And it also handles general multidimensional data layouts.</a:t>
+            </a:r>
+          </a:p>
+          <a:p>
+            <a:endParaRPr lang="en-US" dirty="0"/>
+          </a:p>
+          <a:p>
+            <a:r>
+              <a:rPr lang="en-US" dirty="0"/>
+              <a:t>And, in terms of performance, it does not add overhead compared to a hand-written native MPI distributed computation.</a:t>
             </a:r>
           </a:p>
         </p:txBody>
@@ -1903,7 +1927,13 @@
           <a:p>
             <a:r>
               <a:rPr lang="en-US" dirty="0"/>
-              <a:t>(key idea: we’ve left abstractions to help LLMs generate better para code)</a:t>
+              <a:t>Thus, we have shown that the abstractions offer a practical solution to parallel CPU and GPU, as well as distributed computations in High-Performance Computing,</a:t>
+            </a:r>
+          </a:p>
+          <a:p>
+            <a:r>
+              <a:rPr lang="en-US" dirty="0"/>
+              <a:t>And enable even stronger optimizations for specific domains, such as Cellular Automata simulation</a:t>
             </a:r>
           </a:p>
           <a:p>
@@ -1912,136 +1942,7 @@
           <a:p>
             <a:r>
               <a:rPr lang="en-US" dirty="0"/>
-              <a:t>After extending our earlier work to cover distributed computing as well and adapting it for a specific domain,</a:t>
-            </a:r>
-          </a:p>
-          <a:p>
-            <a:r>
-              <a:rPr lang="en-US" dirty="0"/>
-              <a:t>We have started to do research in a different approach for simplifying HPC algorithm design.</a:t>
-            </a:r>
-          </a:p>
-          <a:p>
-            <a:endParaRPr lang="en-US" dirty="0"/>
-          </a:p>
-          <a:p>
-            <a:pPr marL="0" marR="0" lvl="0" indent="0" algn="l" defTabSz="914400" rtl="0" eaLnBrk="1" fontAlgn="auto" latinLnBrk="0" hangingPunct="1">
-              <a:lnSpc>
-                <a:spcPct val="100000"/>
-              </a:lnSpc>
-              <a:spcBef>
-                <a:spcPts val="0"/>
-              </a:spcBef>
-              <a:spcAft>
-                <a:spcPts val="0"/>
-              </a:spcAft>
-              <a:buClrTx/>
-              <a:buSzTx/>
-              <a:buFontTx/>
-              <a:buNone/>
-              <a:tabLst/>
-              <a:defRPr/>
-            </a:pPr>
-            <a:r>
-              <a:rPr lang="en-US" dirty="0"/>
-              <a:t>This work reacts to the recent introduction of LLM models to the area of software design.</a:t>
-            </a:r>
-          </a:p>
-          <a:p>
-            <a:pPr marL="0" marR="0" lvl="0" indent="0" algn="l" defTabSz="914400" rtl="0" eaLnBrk="1" fontAlgn="auto" latinLnBrk="0" hangingPunct="1">
-              <a:lnSpc>
-                <a:spcPct val="100000"/>
-              </a:lnSpc>
-              <a:spcBef>
-                <a:spcPts val="0"/>
-              </a:spcBef>
-              <a:spcAft>
-                <a:spcPts val="0"/>
-              </a:spcAft>
-              <a:buClrTx/>
-              <a:buSzTx/>
-              <a:buFontTx/>
-              <a:buNone/>
-              <a:tabLst/>
-              <a:defRPr/>
-            </a:pPr>
-            <a:r>
-              <a:rPr lang="en-US" dirty="0"/>
-              <a:t>At the time of the beginning of our research in this area, LLM models were capable of implementing simple algorithms (like data visualization, simple scripting, </a:t>
-            </a:r>
-            <a:r>
-              <a:rPr lang="en-US" dirty="0" err="1"/>
-              <a:t>etc</a:t>
-            </a:r>
-            <a:r>
-              <a:rPr lang="en-US" dirty="0"/>
-              <a:t>),</a:t>
-            </a:r>
-          </a:p>
-          <a:p>
-            <a:pPr marL="0" marR="0" lvl="0" indent="0" algn="l" defTabSz="914400" rtl="0" eaLnBrk="1" fontAlgn="auto" latinLnBrk="0" hangingPunct="1">
-              <a:lnSpc>
-                <a:spcPct val="100000"/>
-              </a:lnSpc>
-              <a:spcBef>
-                <a:spcPts val="0"/>
-              </a:spcBef>
-              <a:spcAft>
-                <a:spcPts val="0"/>
-              </a:spcAft>
-              <a:buClrTx/>
-              <a:buSzTx/>
-              <a:buFontTx/>
-              <a:buNone/>
-              <a:tabLst/>
-              <a:defRPr/>
-            </a:pPr>
-            <a:r>
-              <a:rPr lang="en-US" dirty="0"/>
-              <a:t>But not yet that competent at making more high-level design decisions for efficient computation, especially in parallel algorithms.</a:t>
-            </a:r>
-          </a:p>
-          <a:p>
-            <a:pPr marL="0" marR="0" lvl="0" indent="0" algn="l" defTabSz="914400" rtl="0" eaLnBrk="1" fontAlgn="auto" latinLnBrk="0" hangingPunct="1">
-              <a:lnSpc>
-                <a:spcPct val="100000"/>
-              </a:lnSpc>
-              <a:spcBef>
-                <a:spcPts val="0"/>
-              </a:spcBef>
-              <a:spcAft>
-                <a:spcPts val="0"/>
-              </a:spcAft>
-              <a:buClrTx/>
-              <a:buSzTx/>
-              <a:buFontTx/>
-              <a:buNone/>
-              <a:tabLst/>
-              <a:defRPr/>
-            </a:pPr>
-            <a:endParaRPr lang="en-US" dirty="0"/>
-          </a:p>
-          <a:p>
-            <a:pPr marL="0" marR="0" lvl="0" indent="0" algn="l" defTabSz="914400" rtl="0" eaLnBrk="1" fontAlgn="auto" latinLnBrk="0" hangingPunct="1">
-              <a:lnSpc>
-                <a:spcPct val="100000"/>
-              </a:lnSpc>
-              <a:spcBef>
-                <a:spcPts val="0"/>
-              </a:spcBef>
-              <a:spcAft>
-                <a:spcPts val="0"/>
-              </a:spcAft>
-              <a:buClrTx/>
-              <a:buSzTx/>
-              <a:buFontTx/>
-              <a:buNone/>
-              <a:tabLst/>
-              <a:defRPr/>
-            </a:pPr>
-            <a:r>
-              <a:rPr lang="en-US" dirty="0"/>
-              <a:t>Therefore, our research has focused on identifying what helps LLMs generate better code and what does not.</a:t>
+              <a:t>These abstractions make the developed algorithms easier to manage, more flexible to transform, and allow automatic application of advanced optimizations.</a:t>
             </a:r>
           </a:p>
         </p:txBody>
@@ -2063,7 +1964,7 @@
           <a:p>
             <a:fld id="{FA8FD632-245B-410D-BCC4-8BF8D37AB67F}" type="slidenum">
               <a:rPr lang="en-US" smtClean="0"/>
-              <a:t>19</a:t>
+              <a:t>18</a:t>
             </a:fld>
             <a:endParaRPr lang="en-US"/>
           </a:p>
@@ -2072,7 +1973,7 @@
     </p:spTree>
     <p:extLst>
       <p:ext uri="{BB962C8B-B14F-4D97-AF65-F5344CB8AC3E}">
-        <p14:creationId xmlns:p14="http://schemas.microsoft.com/office/powerpoint/2010/main" val="3351236279"/>
+        <p14:creationId xmlns:p14="http://schemas.microsoft.com/office/powerpoint/2010/main" val="1243571906"/>
       </p:ext>
     </p:extLst>
   </p:cSld>
@@ -2128,7 +2029,7 @@
           <a:p>
             <a:r>
               <a:rPr lang="en-US" dirty="0"/>
-              <a:t>(key idea: tutoring; what is it?)</a:t>
+              <a:t>(key idea: we’ve left abstractions to help LLMs generate better para code)</a:t>
             </a:r>
           </a:p>
           <a:p>
@@ -2137,23 +2038,136 @@
           <a:p>
             <a:r>
               <a:rPr lang="en-US" dirty="0"/>
-              <a:t>In our first work in this area, we focused on CUDA code generation, which was one of the challenging areas for the contemporary LLMs; more specifically,</a:t>
-            </a:r>
-            <a:br>
-              <a:rPr lang="en-US" dirty="0"/>
-            </a:br>
-            <a:r>
-              <a:rPr lang="en-US" dirty="0"/>
-              <a:t>we studied whether adding increasingly more detailed high-level design hints or outright dictating some design decisions significantly helps LLMs generate better code</a:t>
+              <a:t>After extending our earlier work to cover distributed computing as well and adapting it for a specific domain,</a:t>
+            </a:r>
+          </a:p>
+          <a:p>
+            <a:r>
+              <a:rPr lang="en-US" dirty="0"/>
+              <a:t>We have started to do research in a different approach for simplifying HPC algorithm design.</a:t>
             </a:r>
           </a:p>
           <a:p>
             <a:endParaRPr lang="en-US" dirty="0"/>
           </a:p>
           <a:p>
-            <a:r>
-              <a:rPr lang="en-US" dirty="0"/>
-              <a:t>(…)</a:t>
+            <a:pPr marL="0" marR="0" lvl="0" indent="0" algn="l" defTabSz="914400" rtl="0" eaLnBrk="1" fontAlgn="auto" latinLnBrk="0" hangingPunct="1">
+              <a:lnSpc>
+                <a:spcPct val="100000"/>
+              </a:lnSpc>
+              <a:spcBef>
+                <a:spcPts val="0"/>
+              </a:spcBef>
+              <a:spcAft>
+                <a:spcPts val="0"/>
+              </a:spcAft>
+              <a:buClrTx/>
+              <a:buSzTx/>
+              <a:buFontTx/>
+              <a:buNone/>
+              <a:tabLst/>
+              <a:defRPr/>
+            </a:pPr>
+            <a:r>
+              <a:rPr lang="en-US" dirty="0"/>
+              <a:t>This work reacts to the recent introduction of LLM models to the area of software design.</a:t>
+            </a:r>
+          </a:p>
+          <a:p>
+            <a:pPr marL="0" marR="0" lvl="0" indent="0" algn="l" defTabSz="914400" rtl="0" eaLnBrk="1" fontAlgn="auto" latinLnBrk="0" hangingPunct="1">
+              <a:lnSpc>
+                <a:spcPct val="100000"/>
+              </a:lnSpc>
+              <a:spcBef>
+                <a:spcPts val="0"/>
+              </a:spcBef>
+              <a:spcAft>
+                <a:spcPts val="0"/>
+              </a:spcAft>
+              <a:buClrTx/>
+              <a:buSzTx/>
+              <a:buFontTx/>
+              <a:buNone/>
+              <a:tabLst/>
+              <a:defRPr/>
+            </a:pPr>
+            <a:r>
+              <a:rPr lang="en-US" dirty="0"/>
+              <a:t>At the time of the beginning of our research in this area, LLM models were capable of implementing simple algorithms (like data visualization, simple scripting, </a:t>
+            </a:r>
+            <a:r>
+              <a:rPr lang="en-US" dirty="0" err="1"/>
+              <a:t>etc</a:t>
+            </a:r>
+            <a:r>
+              <a:rPr lang="en-US" dirty="0"/>
+              <a:t>),</a:t>
+            </a:r>
+          </a:p>
+          <a:p>
+            <a:pPr marL="0" marR="0" lvl="0" indent="0" algn="l" defTabSz="914400" rtl="0" eaLnBrk="1" fontAlgn="auto" latinLnBrk="0" hangingPunct="1">
+              <a:lnSpc>
+                <a:spcPct val="100000"/>
+              </a:lnSpc>
+              <a:spcBef>
+                <a:spcPts val="0"/>
+              </a:spcBef>
+              <a:spcAft>
+                <a:spcPts val="0"/>
+              </a:spcAft>
+              <a:buClrTx/>
+              <a:buSzTx/>
+              <a:buFontTx/>
+              <a:buNone/>
+              <a:tabLst/>
+              <a:defRPr/>
+            </a:pPr>
+            <a:r>
+              <a:rPr lang="en-US" dirty="0"/>
+              <a:t>But not yet that competent at making more high-level design decisions for efficient computation, especially in parallel algorithms.</a:t>
+            </a:r>
+          </a:p>
+          <a:p>
+            <a:pPr marL="0" marR="0" lvl="0" indent="0" algn="l" defTabSz="914400" rtl="0" eaLnBrk="1" fontAlgn="auto" latinLnBrk="0" hangingPunct="1">
+              <a:lnSpc>
+                <a:spcPct val="100000"/>
+              </a:lnSpc>
+              <a:spcBef>
+                <a:spcPts val="0"/>
+              </a:spcBef>
+              <a:spcAft>
+                <a:spcPts val="0"/>
+              </a:spcAft>
+              <a:buClrTx/>
+              <a:buSzTx/>
+              <a:buFontTx/>
+              <a:buNone/>
+              <a:tabLst/>
+              <a:defRPr/>
+            </a:pPr>
+            <a:endParaRPr lang="en-US" dirty="0"/>
+          </a:p>
+          <a:p>
+            <a:pPr marL="0" marR="0" lvl="0" indent="0" algn="l" defTabSz="914400" rtl="0" eaLnBrk="1" fontAlgn="auto" latinLnBrk="0" hangingPunct="1">
+              <a:lnSpc>
+                <a:spcPct val="100000"/>
+              </a:lnSpc>
+              <a:spcBef>
+                <a:spcPts val="0"/>
+              </a:spcBef>
+              <a:spcAft>
+                <a:spcPts val="0"/>
+              </a:spcAft>
+              <a:buClrTx/>
+              <a:buSzTx/>
+              <a:buFontTx/>
+              <a:buNone/>
+              <a:tabLst/>
+              <a:defRPr/>
+            </a:pPr>
+            <a:r>
+              <a:rPr lang="en-US" dirty="0"/>
+              <a:t>Therefore, our research has focused on identifying what helps LLMs generate better code and what does not.</a:t>
             </a:r>
           </a:p>
         </p:txBody>
@@ -2175,7 +2189,7 @@
           <a:p>
             <a:fld id="{FA8FD632-245B-410D-BCC4-8BF8D37AB67F}" type="slidenum">
               <a:rPr lang="en-US" smtClean="0"/>
-              <a:t>20</a:t>
+              <a:t>19</a:t>
             </a:fld>
             <a:endParaRPr lang="en-US"/>
           </a:p>
@@ -2184,7 +2198,7 @@
     </p:spTree>
     <p:extLst>
       <p:ext uri="{BB962C8B-B14F-4D97-AF65-F5344CB8AC3E}">
-        <p14:creationId xmlns:p14="http://schemas.microsoft.com/office/powerpoint/2010/main" val="4235059812"/>
+        <p14:creationId xmlns:p14="http://schemas.microsoft.com/office/powerpoint/2010/main" val="3351236279"/>
       </p:ext>
     </p:extLst>
   </p:cSld>
@@ -2383,6 +2397,118 @@
   <p:cSld>
     <p:spTree>
       <p:nvGrpSpPr>
+        <p:cNvPr id="1" name=""/>
+        <p:cNvGrpSpPr/>
+        <p:nvPr/>
+      </p:nvGrpSpPr>
+      <p:grpSpPr>
+        <a:xfrm>
+          <a:off x="0" y="0"/>
+          <a:ext cx="0" cy="0"/>
+          <a:chOff x="0" y="0"/>
+          <a:chExt cx="0" cy="0"/>
+        </a:xfrm>
+      </p:grpSpPr>
+      <p:sp>
+        <p:nvSpPr>
+          <p:cNvPr id="2" name="Slide Image Placeholder 1"/>
+          <p:cNvSpPr>
+            <a:spLocks noGrp="1" noRot="1" noChangeAspect="1"/>
+          </p:cNvSpPr>
+          <p:nvPr>
+            <p:ph type="sldImg"/>
+          </p:nvPr>
+        </p:nvSpPr>
+        <p:spPr/>
+      </p:sp>
+      <p:sp>
+        <p:nvSpPr>
+          <p:cNvPr id="3" name="Notes Placeholder 2"/>
+          <p:cNvSpPr>
+            <a:spLocks noGrp="1"/>
+          </p:cNvSpPr>
+          <p:nvPr>
+            <p:ph type="body" idx="1"/>
+          </p:nvPr>
+        </p:nvSpPr>
+        <p:spPr/>
+        <p:txBody>
+          <a:bodyPr/>
+          <a:lstStyle/>
+          <a:p>
+            <a:r>
+              <a:rPr lang="en-US" dirty="0"/>
+              <a:t>(key idea: tutoring; what is it?)</a:t>
+            </a:r>
+          </a:p>
+          <a:p>
+            <a:endParaRPr lang="en-US" dirty="0"/>
+          </a:p>
+          <a:p>
+            <a:r>
+              <a:rPr lang="en-US" dirty="0"/>
+              <a:t>In our first work in this area, we focused on CUDA code generation, which was one of the challenging areas for the contemporary LLMs; more specifically,</a:t>
+            </a:r>
+            <a:br>
+              <a:rPr lang="en-US" dirty="0"/>
+            </a:br>
+            <a:r>
+              <a:rPr lang="en-US" dirty="0"/>
+              <a:t>we studied whether adding increasingly more detailed high-level design hints or outright dictating some design decisions significantly helps LLMs generate better code</a:t>
+            </a:r>
+          </a:p>
+          <a:p>
+            <a:endParaRPr lang="en-US" dirty="0"/>
+          </a:p>
+          <a:p>
+            <a:r>
+              <a:rPr lang="en-US" dirty="0"/>
+              <a:t>(…)</a:t>
+            </a:r>
+          </a:p>
+        </p:txBody>
+      </p:sp>
+      <p:sp>
+        <p:nvSpPr>
+          <p:cNvPr id="4" name="Slide Number Placeholder 3"/>
+          <p:cNvSpPr>
+            <a:spLocks noGrp="1"/>
+          </p:cNvSpPr>
+          <p:nvPr>
+            <p:ph type="sldNum" sz="quarter" idx="5"/>
+          </p:nvPr>
+        </p:nvSpPr>
+        <p:spPr/>
+        <p:txBody>
+          <a:bodyPr/>
+          <a:lstStyle/>
+          <a:p>
+            <a:fld id="{FA8FD632-245B-410D-BCC4-8BF8D37AB67F}" type="slidenum">
+              <a:rPr lang="en-US" smtClean="0"/>
+              <a:t>20</a:t>
+            </a:fld>
+            <a:endParaRPr lang="en-US"/>
+          </a:p>
+        </p:txBody>
+      </p:sp>
+    </p:spTree>
+    <p:extLst>
+      <p:ext uri="{BB962C8B-B14F-4D97-AF65-F5344CB8AC3E}">
+        <p14:creationId xmlns:p14="http://schemas.microsoft.com/office/powerpoint/2010/main" val="4235059812"/>
+      </p:ext>
+    </p:extLst>
+  </p:cSld>
+  <p:clrMapOvr>
+    <a:masterClrMapping/>
+  </p:clrMapOvr>
+</p:notes>
+</file>
+
+<file path=ppt/notesSlides/notesSlide21.xml><?xml version="1.0" encoding="utf-8"?>
+<p:notes xmlns:a="http://schemas.openxmlformats.org/drawingml/2006/main" xmlns:r="http://schemas.openxmlformats.org/officeDocument/2006/relationships" xmlns:p="http://schemas.openxmlformats.org/presentationml/2006/main">
+  <p:cSld>
+    <p:spTree>
+      <p:nvGrpSpPr>
         <p:cNvPr id="1" name="">
           <a:extLst>
             <a:ext uri="{FF2B5EF4-FFF2-40B4-BE49-F238E27FC236}">
@@ -2507,7 +2633,7 @@
           <a:p>
             <a:r>
               <a:rPr lang="en-US" dirty="0"/>
-              <a:t>Efficient implementations of these three algorithms require considering more obscure or CUDA-specific features such as</a:t>
+              <a:t>Efficient implementations of these three algorithms require considering more obscure or CUDA-specific features, such as</a:t>
             </a:r>
           </a:p>
           <a:p>
@@ -2554,22 +2680,22 @@
             </a:pPr>
             <a:r>
               <a:rPr lang="en-US" dirty="0"/>
-              <a:t>For the easier, Histogram and Game of Life algorithms, the LLM generated progressively better code,</a:t>
+              <a:t>For the easier, Histogram and Game of Life algorithms, GPT-o3-mini, a </a:t>
+            </a:r>
+            <a:r>
+              <a:rPr lang="en-US" dirty="0" err="1"/>
+              <a:t>SotA</a:t>
+            </a:r>
+            <a:r>
+              <a:rPr lang="en-US" dirty="0"/>
+              <a:t> LLM model at that time, generated progressively better code,</a:t>
             </a:r>
             <a:br>
               <a:rPr lang="en-US" dirty="0"/>
             </a:br>
             <a:r>
               <a:rPr lang="en-US" dirty="0"/>
-              <a:t>but for the k-</a:t>
-            </a:r>
-            <a:r>
-              <a:rPr lang="en-US" dirty="0" err="1"/>
-              <a:t>Nearnearest</a:t>
-            </a:r>
-            <a:r>
-              <a:rPr lang="en-US" dirty="0"/>
-              <a:t> Neighbors search, it managed to implement only the naïve implementation,</a:t>
+              <a:t>but for the k-Nearest Neighbors search, it managed to implement only the naïve implementation,</a:t>
             </a:r>
             <a:br>
               <a:rPr lang="en-US" dirty="0"/>
@@ -2623,7 +2749,7 @@
 </p:notes>
 </file>
 
-<file path=ppt/notesSlides/notesSlide21.xml><?xml version="1.0" encoding="utf-8"?>
+<file path=ppt/notesSlides/notesSlide22.xml><?xml version="1.0" encoding="utf-8"?>
 <p:notes xmlns:a="http://schemas.openxmlformats.org/drawingml/2006/main" xmlns:r="http://schemas.openxmlformats.org/officeDocument/2006/relationships" xmlns:p="http://schemas.openxmlformats.org/presentationml/2006/main">
   <p:cSld>
     <p:spTree>
@@ -2687,7 +2813,49 @@
           <a:p>
             <a:r>
               <a:rPr lang="en-US" dirty="0"/>
-              <a:t>(TODO)</a:t>
+              <a:t>(key idea: the performance progression matches the assumption)</a:t>
+            </a:r>
+          </a:p>
+          <a:p>
+            <a:endParaRPr lang="en-US" dirty="0"/>
+          </a:p>
+          <a:p>
+            <a:r>
+              <a:rPr lang="en-US" dirty="0"/>
+              <a:t>Here, we can see the plots for the performance measurements of the generated code for the Histogram and Game of Life algorithms.</a:t>
+            </a:r>
+          </a:p>
+          <a:p>
+            <a:endParaRPr lang="en-US" dirty="0"/>
+          </a:p>
+          <a:p>
+            <a:r>
+              <a:rPr lang="en-US" dirty="0"/>
+              <a:t>Both show wall clock times of the runtime on a representative dataset (on the y-axis), lower is better;</a:t>
+            </a:r>
+          </a:p>
+          <a:p>
+            <a:r>
+              <a:rPr lang="en-US" dirty="0"/>
+              <a:t>And the x-axis of both shows the incrementally more specific prompts.</a:t>
+            </a:r>
+          </a:p>
+          <a:p>
+            <a:endParaRPr lang="en-US" dirty="0"/>
+          </a:p>
+          <a:p>
+            <a:r>
+              <a:rPr lang="en-US" dirty="0"/>
+              <a:t>The horizontal lines show various reference implementations.</a:t>
+            </a:r>
+          </a:p>
+          <a:p>
+            <a:endParaRPr lang="en-US" dirty="0"/>
+          </a:p>
+          <a:p>
+            <a:r>
+              <a:rPr lang="en-US" dirty="0"/>
+              <a:t>The performance improves with more specific prompts, which is slightly noticeable for the Histogram algorithm, and more so for the Game of Life algorithm.</a:t>
             </a:r>
           </a:p>
         </p:txBody>
@@ -2734,7 +2902,7 @@
 </p:notes>
 </file>
 
-<file path=ppt/notesSlides/notesSlide22.xml><?xml version="1.0" encoding="utf-8"?>
+<file path=ppt/notesSlides/notesSlide23.xml><?xml version="1.0" encoding="utf-8"?>
 <p:notes xmlns:a="http://schemas.openxmlformats.org/drawingml/2006/main" xmlns:r="http://schemas.openxmlformats.org/officeDocument/2006/relationships" xmlns:p="http://schemas.openxmlformats.org/presentationml/2006/main">
   <p:cSld>
     <p:spTree>
@@ -2798,7 +2966,28 @@
           <a:p>
             <a:r>
               <a:rPr lang="en-US" dirty="0"/>
-              <a:t>(TODO)</a:t>
+              <a:t>(key idea: LLMs improve over time, the complexity threshold shifts)</a:t>
+            </a:r>
+          </a:p>
+          <a:p>
+            <a:endParaRPr lang="en-US" dirty="0"/>
+          </a:p>
+          <a:p>
+            <a:r>
+              <a:rPr lang="en-US" dirty="0"/>
+              <a:t>When we presented our results, the LLM state of the art had already shifted;</a:t>
+            </a:r>
+          </a:p>
+          <a:p>
+            <a:r>
+              <a:rPr lang="en-US" dirty="0"/>
+              <a:t>The then-current GPT-5 provided expert-level performance on the Game of Life algorithm for all prompts except the naïve one,</a:t>
+            </a:r>
+          </a:p>
+          <a:p>
+            <a:r>
+              <a:rPr lang="en-US" dirty="0"/>
+              <a:t>And it successfully benefitted from tutoring for the k-Nearest Neighbor algorithm.</a:t>
             </a:r>
           </a:p>
         </p:txBody>
@@ -2836,127 +3025,6 @@
     <p:extLst>
       <p:ext uri="{BB962C8B-B14F-4D97-AF65-F5344CB8AC3E}">
         <p14:creationId xmlns:p14="http://schemas.microsoft.com/office/powerpoint/2010/main" val="2367210526"/>
-      </p:ext>
-    </p:extLst>
-  </p:cSld>
-  <p:clrMapOvr>
-    <a:masterClrMapping/>
-  </p:clrMapOvr>
-</p:notes>
-</file>
-
-<file path=ppt/notesSlides/notesSlide23.xml><?xml version="1.0" encoding="utf-8"?>
-<p:notes xmlns:a="http://schemas.openxmlformats.org/drawingml/2006/main" xmlns:r="http://schemas.openxmlformats.org/officeDocument/2006/relationships" xmlns:p="http://schemas.openxmlformats.org/presentationml/2006/main">
-  <p:cSld>
-    <p:spTree>
-      <p:nvGrpSpPr>
-        <p:cNvPr id="1" name=""/>
-        <p:cNvGrpSpPr/>
-        <p:nvPr/>
-      </p:nvGrpSpPr>
-      <p:grpSpPr>
-        <a:xfrm>
-          <a:off x="0" y="0"/>
-          <a:ext cx="0" cy="0"/>
-          <a:chOff x="0" y="0"/>
-          <a:chExt cx="0" cy="0"/>
-        </a:xfrm>
-      </p:grpSpPr>
-      <p:sp>
-        <p:nvSpPr>
-          <p:cNvPr id="2" name="Slide Image Placeholder 1"/>
-          <p:cNvSpPr>
-            <a:spLocks noGrp="1" noRot="1" noChangeAspect="1"/>
-          </p:cNvSpPr>
-          <p:nvPr>
-            <p:ph type="sldImg"/>
-          </p:nvPr>
-        </p:nvSpPr>
-        <p:spPr/>
-      </p:sp>
-      <p:sp>
-        <p:nvSpPr>
-          <p:cNvPr id="3" name="Notes Placeholder 2"/>
-          <p:cNvSpPr>
-            <a:spLocks noGrp="1"/>
-          </p:cNvSpPr>
-          <p:nvPr>
-            <p:ph type="body" idx="1"/>
-          </p:nvPr>
-        </p:nvSpPr>
-        <p:spPr/>
-        <p:txBody>
-          <a:bodyPr/>
-          <a:lstStyle/>
-          <a:p>
-            <a:r>
-              <a:rPr lang="en-US" dirty="0"/>
-              <a:t>(key idea: combining the two branches)</a:t>
-            </a:r>
-          </a:p>
-          <a:p>
-            <a:endParaRPr lang="en-US" dirty="0"/>
-          </a:p>
-          <a:p>
-            <a:r>
-              <a:rPr lang="en-US" dirty="0"/>
-              <a:t>Then, we have studied whether the earlier studied abstractions enabling layout- and traversal-agnostic design significantly improve the correctness and efficiency of the generated parallel code during optimization tasks.</a:t>
-            </a:r>
-          </a:p>
-          <a:p>
-            <a:endParaRPr lang="en-US" dirty="0"/>
-          </a:p>
-          <a:p>
-            <a:r>
-              <a:rPr lang="en-US" dirty="0"/>
-              <a:t>For that, we have compared 3 abstractions (Halide, Exo and </a:t>
-            </a:r>
-            <a:r>
-              <a:rPr lang="en-US" dirty="0" err="1"/>
-              <a:t>Noarr</a:t>
-            </a:r>
-            <a:r>
-              <a:rPr lang="en-US" dirty="0"/>
-              <a:t>) with different designs and principles as well as outputting pure C on the 30 algorithms from the </a:t>
-            </a:r>
-            <a:r>
-              <a:rPr lang="en-US" dirty="0" err="1"/>
-              <a:t>PolyBench</a:t>
-            </a:r>
-            <a:r>
-              <a:rPr lang="en-US" dirty="0"/>
-              <a:t>/C benchmark suite.</a:t>
-            </a:r>
-          </a:p>
-        </p:txBody>
-      </p:sp>
-      <p:sp>
-        <p:nvSpPr>
-          <p:cNvPr id="4" name="Slide Number Placeholder 3"/>
-          <p:cNvSpPr>
-            <a:spLocks noGrp="1"/>
-          </p:cNvSpPr>
-          <p:nvPr>
-            <p:ph type="sldNum" sz="quarter" idx="5"/>
-          </p:nvPr>
-        </p:nvSpPr>
-        <p:spPr/>
-        <p:txBody>
-          <a:bodyPr/>
-          <a:lstStyle/>
-          <a:p>
-            <a:fld id="{FA8FD632-245B-410D-BCC4-8BF8D37AB67F}" type="slidenum">
-              <a:rPr lang="en-US" smtClean="0"/>
-              <a:t>24</a:t>
-            </a:fld>
-            <a:endParaRPr lang="en-US"/>
-          </a:p>
-        </p:txBody>
-      </p:sp>
-    </p:spTree>
-    <p:extLst>
-      <p:ext uri="{BB962C8B-B14F-4D97-AF65-F5344CB8AC3E}">
-        <p14:creationId xmlns:p14="http://schemas.microsoft.com/office/powerpoint/2010/main" val="2436190103"/>
       </p:ext>
     </p:extLst>
   </p:cSld>
@@ -3012,7 +3080,7 @@
           <a:p>
             <a:r>
               <a:rPr lang="en-US" dirty="0"/>
-              <a:t>(key idea: we did a lot)</a:t>
+              <a:t>(key idea: combining the two branches)</a:t>
             </a:r>
           </a:p>
           <a:p>
@@ -3021,120 +3089,32 @@
           <a:p>
             <a:r>
               <a:rPr lang="en-US" dirty="0"/>
-              <a:t>In the experimental setup, we have used a multithreaded datacenter-grade computer, and to avoid many mistakes, the optimization pipeline consisted of two generation steps:</a:t>
-            </a:r>
-          </a:p>
-          <a:p>
-            <a:pPr marL="171450" indent="-171450">
-              <a:buFontTx/>
-              <a:buChar char="-"/>
-            </a:pPr>
-            <a:r>
-              <a:rPr lang="en-US" dirty="0"/>
-              <a:t>The first translated the baseline algorithm into the given abstraction</a:t>
-            </a:r>
-          </a:p>
-          <a:p>
-            <a:pPr marL="171450" indent="-171450">
-              <a:buFontTx/>
-              <a:buChar char="-"/>
-            </a:pPr>
-            <a:r>
-              <a:rPr lang="en-US" dirty="0"/>
-              <a:t>And the second one optimized the translation that best matched the baseline</a:t>
-            </a:r>
-          </a:p>
-          <a:p>
-            <a:pPr marL="0" indent="0">
-              <a:buFontTx/>
-              <a:buNone/>
-            </a:pPr>
+              <a:t>Then, we have studied whether the earlier studied abstractions enabling layout- and traversal-agnostic design significantly improve the correctness and efficiency of the generated parallel code during optimization tasks.</a:t>
+            </a:r>
+          </a:p>
+          <a:p>
             <a:endParaRPr lang="en-US" dirty="0"/>
           </a:p>
           <a:p>
-            <a:pPr marL="0" indent="0">
-              <a:buFontTx/>
-              <a:buNone/>
-            </a:pPr>
-            <a:r>
-              <a:rPr lang="en-US" dirty="0"/>
-              <a:t>The first step was followed up by an automated selection of the best generated translation.</a:t>
-            </a:r>
-          </a:p>
-          <a:p>
-            <a:pPr marL="0" indent="0">
-              <a:buFontTx/>
-              <a:buNone/>
-            </a:pPr>
-            <a:r>
-              <a:rPr lang="en-US" dirty="0"/>
-              <a:t>This helped to avoid implementations that didn’t correctly capture the semantics or the code, improving the overall correctness rate.</a:t>
-            </a:r>
-          </a:p>
-          <a:p>
-            <a:pPr marL="0" indent="0">
-              <a:buFontTx/>
-              <a:buNone/>
-            </a:pPr>
-            <a:endParaRPr lang="en-US" dirty="0"/>
-          </a:p>
-          <a:p>
-            <a:pPr marL="0" indent="0">
-              <a:buFontTx/>
-              <a:buNone/>
-            </a:pPr>
-            <a:r>
-              <a:rPr lang="en-US" dirty="0"/>
-              <a:t>In both generation steps, the prompts were accompanied by official developer guides and custom abstraction-specific hints for the given abstractions</a:t>
-            </a:r>
-            <a:br>
-              <a:rPr lang="en-US" dirty="0"/>
-            </a:br>
-            <a:r>
-              <a:rPr lang="en-US" dirty="0"/>
-              <a:t>to give the LLM a good understanding how to use them, and the translation tasks were accompanied by one example of translating the algorithm to ensure that the translations follow the expected design.</a:t>
-            </a:r>
-          </a:p>
-          <a:p>
-            <a:pPr marL="0" indent="0">
-              <a:buFontTx/>
-              <a:buNone/>
-            </a:pPr>
-            <a:endParaRPr lang="en-US" dirty="0"/>
-          </a:p>
-          <a:p>
-            <a:pPr marL="0" indent="0">
-              <a:buFontTx/>
-              <a:buNone/>
-            </a:pPr>
-            <a:r>
-              <a:rPr lang="en-US" dirty="0"/>
-              <a:t>Finally, we have also prepared multiple optimization prompts to compare the effect of abstraction choice with the effect of prompt specificity.</a:t>
-            </a:r>
-          </a:p>
-          <a:p>
-            <a:pPr marL="0" indent="0">
-              <a:buFontTx/>
-              <a:buNone/>
-            </a:pPr>
-            <a:endParaRPr lang="en-US" dirty="0"/>
-          </a:p>
-          <a:p>
-            <a:pPr marL="0" indent="0">
-              <a:buFontTx/>
-              <a:buNone/>
-            </a:pPr>
-            <a:r>
-              <a:rPr lang="en-US" dirty="0"/>
-              <a:t>With the 30 </a:t>
+            <a:r>
+              <a:rPr lang="en-US" dirty="0"/>
+              <a:t>For that, we have compared 3 abstractions (Halide, Exo and </a:t>
             </a:r>
             <a:r>
               <a:rPr lang="en-US" dirty="0" err="1"/>
-              <a:t>polybench</a:t>
-            </a:r>
-            <a:r>
-              <a:rPr lang="en-US" dirty="0"/>
-              <a:t> algorithms, 4 different abstraction choices, and 4 prompting strategies, this gives almost 500 optimization experiments.</a:t>
+              <a:t>Noarr</a:t>
+            </a:r>
+            <a:r>
+              <a:rPr lang="en-US" dirty="0"/>
+              <a:t>) with different designs and principles as well as outputting pure C on the 30 algorithms from the </a:t>
+            </a:r>
+            <a:r>
+              <a:rPr lang="en-US" dirty="0" err="1"/>
+              <a:t>PolyBench</a:t>
+            </a:r>
+            <a:r>
+              <a:rPr lang="en-US" dirty="0"/>
+              <a:t>/C benchmark suite.</a:t>
             </a:r>
           </a:p>
         </p:txBody>
@@ -3156,7 +3136,7 @@
           <a:p>
             <a:fld id="{FA8FD632-245B-410D-BCC4-8BF8D37AB67F}" type="slidenum">
               <a:rPr lang="en-US" smtClean="0"/>
-              <a:t>25</a:t>
+              <a:t>24</a:t>
             </a:fld>
             <a:endParaRPr lang="en-US"/>
           </a:p>
@@ -3165,7 +3145,7 @@
     </p:spTree>
     <p:extLst>
       <p:ext uri="{BB962C8B-B14F-4D97-AF65-F5344CB8AC3E}">
-        <p14:creationId xmlns:p14="http://schemas.microsoft.com/office/powerpoint/2010/main" val="4284797405"/>
+        <p14:creationId xmlns:p14="http://schemas.microsoft.com/office/powerpoint/2010/main" val="2436190103"/>
       </p:ext>
     </p:extLst>
   </p:cSld>
@@ -3221,56 +3201,129 @@
           <a:p>
             <a:r>
               <a:rPr lang="en-US" dirty="0"/>
-              <a:t>Together with increasing number of optimization attempts from 1to5 to account for LLM generation stochasticity,</a:t>
+              <a:t>(key idea: we did a lot)</a:t>
+            </a:r>
+          </a:p>
+          <a:p>
+            <a:endParaRPr lang="en-US" dirty="0"/>
+          </a:p>
+          <a:p>
+            <a:r>
+              <a:rPr lang="en-US" dirty="0"/>
+              <a:t>In the experimental setup, we have used a multithreaded datacenter-grade computer, and to avoid many mistakes, the optimization pipeline consisted of two generation steps:</a:t>
+            </a:r>
+          </a:p>
+          <a:p>
+            <a:pPr marL="171450" indent="-171450">
+              <a:buFontTx/>
+              <a:buChar char="-"/>
+            </a:pPr>
+            <a:r>
+              <a:rPr lang="en-US" dirty="0"/>
+              <a:t>The first translated the baseline algorithm into the given abstraction</a:t>
+            </a:r>
+          </a:p>
+          <a:p>
+            <a:pPr marL="171450" indent="-171450">
+              <a:buFontTx/>
+              <a:buChar char="-"/>
+            </a:pPr>
+            <a:r>
+              <a:rPr lang="en-US" dirty="0"/>
+              <a:t>And the second one optimized the translation that best matched the baseline</a:t>
+            </a:r>
+          </a:p>
+          <a:p>
+            <a:pPr marL="0" indent="0">
+              <a:buFontTx/>
+              <a:buNone/>
+            </a:pPr>
+            <a:endParaRPr lang="en-US" dirty="0"/>
+          </a:p>
+          <a:p>
+            <a:pPr marL="0" indent="0">
+              <a:buFontTx/>
+              <a:buNone/>
+            </a:pPr>
+            <a:r>
+              <a:rPr lang="en-US" dirty="0"/>
+              <a:t>The first step was followed up by an automated selection of the best generated translation.</a:t>
+            </a:r>
+          </a:p>
+          <a:p>
+            <a:pPr marL="0" indent="0">
+              <a:buFontTx/>
+              <a:buNone/>
+            </a:pPr>
+            <a:r>
+              <a:rPr lang="en-US" dirty="0"/>
+              <a:t>This helped to avoid implementations that didn’t correctly capture the semantics or the code, improving the overall correctness rate.</a:t>
+            </a:r>
+          </a:p>
+          <a:p>
+            <a:pPr marL="0" indent="0">
+              <a:buFontTx/>
+              <a:buNone/>
+            </a:pPr>
+            <a:endParaRPr lang="en-US" dirty="0"/>
+          </a:p>
+          <a:p>
+            <a:pPr marL="0" indent="0">
+              <a:buFontTx/>
+              <a:buNone/>
+            </a:pPr>
+            <a:r>
+              <a:rPr lang="en-US" dirty="0"/>
+              <a:t>In both generation steps, the prompts were accompanied by official developer guides and custom abstraction-specific hints for the given abstractions</a:t>
             </a:r>
             <a:br>
               <a:rPr lang="en-US" dirty="0"/>
             </a:br>
-            <a:br>
-              <a:rPr lang="en-US" dirty="0"/>
-            </a:br>
-            <a:r>
-              <a:rPr lang="en-US" dirty="0"/>
-              <a:t>we observed that contemporary abstractions do not improve the performance nor the correctness of the generated code,</a:t>
-            </a:r>
-            <a:br>
-              <a:rPr lang="en-US" dirty="0"/>
-            </a:br>
-            <a:r>
-              <a:rPr lang="en-US" dirty="0"/>
-              <a:t>as generating C code yielded both the best performance and correctness overall.</a:t>
-            </a:r>
-          </a:p>
-          <a:p>
+            <a:r>
+              <a:rPr lang="en-US" dirty="0"/>
+              <a:t>to give the LLM a good understanding how to use them, and the translation tasks were accompanied by one example of translating the algorithm to ensure that the translations follow the expected design.</a:t>
+            </a:r>
+          </a:p>
+          <a:p>
+            <a:pPr marL="0" indent="0">
+              <a:buFontTx/>
+              <a:buNone/>
+            </a:pPr>
             <a:endParaRPr lang="en-US" dirty="0"/>
           </a:p>
           <a:p>
-            <a:r>
-              <a:rPr lang="en-US" dirty="0"/>
-              <a:t>We didn’t study just the specificity of the hints, but also their </a:t>
+            <a:pPr marL="0" indent="0">
+              <a:buFontTx/>
+              <a:buNone/>
+            </a:pPr>
+            <a:r>
+              <a:rPr lang="en-US" dirty="0"/>
+              <a:t>Finally, we have also prepared multiple optimization prompts to compare the effect of abstraction choice with the effect of prompt specificity.</a:t>
+            </a:r>
+          </a:p>
+          <a:p>
+            <a:pPr marL="0" indent="0">
+              <a:buFontTx/>
+              <a:buNone/>
+            </a:pPr>
+            <a:endParaRPr lang="en-US" dirty="0"/>
+          </a:p>
+          <a:p>
+            <a:pPr marL="0" indent="0">
+              <a:buFontTx/>
+              <a:buNone/>
+            </a:pPr>
+            <a:r>
+              <a:rPr lang="en-US" dirty="0"/>
+              <a:t>With the 30 </a:t>
             </a:r>
             <a:r>
               <a:rPr lang="en-US" dirty="0" err="1"/>
-              <a:t>aggresiveness</a:t>
-            </a:r>
-            <a:r>
-              <a:rPr lang="en-US" dirty="0"/>
-              <a:t> (more assertive hints yielding slightly better performance),</a:t>
-            </a:r>
-          </a:p>
-          <a:p>
-            <a:r>
-              <a:rPr lang="en-US" dirty="0"/>
-              <a:t>and an alternative approach that separated the optimization task into two steps, which didn’t improve correctness and significantly limited the performance.</a:t>
-            </a:r>
-          </a:p>
-          <a:p>
-            <a:endParaRPr lang="en-US" dirty="0"/>
-          </a:p>
-          <a:p>
-            <a:r>
-              <a:rPr lang="en-US" dirty="0"/>
-              <a:t>The conclusion of this work is that correct prompting strategy yields better results than using the abstractions for user-directed optimization.</a:t>
+              <a:t>polybench</a:t>
+            </a:r>
+            <a:r>
+              <a:rPr lang="en-US" dirty="0"/>
+              <a:t> algorithms, 4 different abstraction choices, and 4 prompting strategies, this gives almost 500 optimization experiments.</a:t>
             </a:r>
           </a:p>
         </p:txBody>
@@ -3292,7 +3345,7 @@
           <a:p>
             <a:fld id="{FA8FD632-245B-410D-BCC4-8BF8D37AB67F}" type="slidenum">
               <a:rPr lang="en-US" smtClean="0"/>
-              <a:t>26</a:t>
+              <a:t>25</a:t>
             </a:fld>
             <a:endParaRPr lang="en-US"/>
           </a:p>
@@ -3301,7 +3354,7 @@
     </p:spTree>
     <p:extLst>
       <p:ext uri="{BB962C8B-B14F-4D97-AF65-F5344CB8AC3E}">
-        <p14:creationId xmlns:p14="http://schemas.microsoft.com/office/powerpoint/2010/main" val="2015766894"/>
+        <p14:creationId xmlns:p14="http://schemas.microsoft.com/office/powerpoint/2010/main" val="4284797405"/>
       </p:ext>
     </p:extLst>
   </p:cSld>
@@ -3357,15 +3410,57 @@
           <a:p>
             <a:r>
               <a:rPr lang="en-US" dirty="0"/>
-              <a:t>Still haven’t done this one </a:t>
-            </a:r>
-            <a:r>
-              <a:rPr lang="en-US" dirty="0">
-                <a:sym typeface="Wingdings" panose="05000000000000000000" pitchFamily="2" charset="2"/>
-              </a:rPr>
-              <a:t></a:t>
-            </a:r>
+              <a:t>Together with increasing number of optimization attempts from 1to5 to account for LLM generation stochasticity,</a:t>
+            </a:r>
+            <a:br>
+              <a:rPr lang="en-US" dirty="0"/>
+            </a:br>
+            <a:br>
+              <a:rPr lang="en-US" dirty="0"/>
+            </a:br>
+            <a:r>
+              <a:rPr lang="en-US" dirty="0"/>
+              <a:t>we observed that contemporary abstractions do not improve the performance nor the correctness of the generated code,</a:t>
+            </a:r>
+            <a:br>
+              <a:rPr lang="en-US" dirty="0"/>
+            </a:br>
+            <a:r>
+              <a:rPr lang="en-US" dirty="0"/>
+              <a:t>as generating C code yielded both the best performance and correctness overall.</a:t>
+            </a:r>
+          </a:p>
+          <a:p>
             <a:endParaRPr lang="en-US" dirty="0"/>
+          </a:p>
+          <a:p>
+            <a:r>
+              <a:rPr lang="en-US" dirty="0"/>
+              <a:t>We didn’t study just the specificity of the hints, but also their </a:t>
+            </a:r>
+            <a:r>
+              <a:rPr lang="en-US" dirty="0" err="1"/>
+              <a:t>aggresiveness</a:t>
+            </a:r>
+            <a:r>
+              <a:rPr lang="en-US" dirty="0"/>
+              <a:t> (more assertive hints yielding slightly better performance),</a:t>
+            </a:r>
+          </a:p>
+          <a:p>
+            <a:r>
+              <a:rPr lang="en-US" dirty="0"/>
+              <a:t>and an alternative approach that separated the optimization task into two steps, which didn’t improve correctness and significantly limited the performance.</a:t>
+            </a:r>
+          </a:p>
+          <a:p>
+            <a:endParaRPr lang="en-US" dirty="0"/>
+          </a:p>
+          <a:p>
+            <a:r>
+              <a:rPr lang="en-US" dirty="0"/>
+              <a:t>The conclusion of this work is that correct prompting strategy yields better results than using the abstractions for user-directed optimization.</a:t>
+            </a:r>
           </a:p>
         </p:txBody>
       </p:sp>
@@ -3386,7 +3481,7 @@
           <a:p>
             <a:fld id="{FA8FD632-245B-410D-BCC4-8BF8D37AB67F}" type="slidenum">
               <a:rPr lang="en-US" smtClean="0"/>
-              <a:t>28</a:t>
+              <a:t>26</a:t>
             </a:fld>
             <a:endParaRPr lang="en-US"/>
           </a:p>
@@ -3395,7 +3490,7 @@
     </p:spTree>
     <p:extLst>
       <p:ext uri="{BB962C8B-B14F-4D97-AF65-F5344CB8AC3E}">
-        <p14:creationId xmlns:p14="http://schemas.microsoft.com/office/powerpoint/2010/main" val="2911046873"/>
+        <p14:creationId xmlns:p14="http://schemas.microsoft.com/office/powerpoint/2010/main" val="2015766894"/>
       </p:ext>
     </p:extLst>
   </p:cSld>
@@ -3451,80 +3546,14 @@
           <a:p>
             <a:r>
               <a:rPr lang="en-US" dirty="0"/>
-              <a:t>---(slide 2/2; do not forget to copy from upward)---</a:t>
-            </a:r>
-            <a:br>
-              <a:rPr lang="en-US" dirty="0"/>
-            </a:br>
-            <a:br>
-              <a:rPr lang="en-US" dirty="0"/>
-            </a:br>
-            <a:r>
-              <a:rPr lang="en-US" dirty="0"/>
-              <a:t>(key idea: optimizing the traversal)</a:t>
-            </a:r>
-          </a:p>
-          <a:p>
-            <a:endParaRPr lang="en-US" dirty="0"/>
-          </a:p>
-          <a:p>
-            <a:r>
-              <a:rPr lang="en-US" dirty="0"/>
-              <a:t>By itself, this would be nice, but we can do much more.</a:t>
-            </a:r>
-            <a:br>
-              <a:rPr lang="en-US" dirty="0"/>
-            </a:br>
-            <a:endParaRPr lang="en-US" dirty="0"/>
-          </a:p>
-          <a:p>
-            <a:r>
-              <a:rPr lang="en-US" dirty="0"/>
-              <a:t>We can use the same principles for building memory layouts to specify transformations of the traversal orders as well.</a:t>
-            </a:r>
-          </a:p>
-          <a:p>
-            <a:r>
-              <a:rPr lang="en-US" dirty="0"/>
-              <a:t>Let’s say we want to perform the matrix multiplication by tiles of the output; we can do so by defining the transformation and then applying it to the traverser.</a:t>
-            </a:r>
-            <a:br>
-              <a:rPr lang="en-US" dirty="0"/>
-            </a:br>
-            <a:r>
-              <a:rPr lang="en-US" dirty="0"/>
-              <a:t>We do not need to rewrite the computation logic or change the structures to do that.</a:t>
-            </a:r>
-          </a:p>
-          <a:p>
-            <a:endParaRPr lang="en-US" dirty="0"/>
-          </a:p>
-          <a:p>
-            <a:endParaRPr lang="en-US" dirty="0"/>
-          </a:p>
-          <a:p>
-            <a:r>
-              <a:rPr lang="en-US" dirty="0"/>
-              <a:t>We can also use the traversers as ranges to be parallelized using various parallel backends such as OpenMP or Threading Building Blocks.</a:t>
-            </a:r>
-          </a:p>
-          <a:p>
-            <a:endParaRPr lang="en-US" dirty="0"/>
-          </a:p>
-          <a:p>
-            <a:r>
-              <a:rPr lang="en-US" dirty="0"/>
-              <a:t>For the CUDA framework (used for general-purpose GPU programming), we have shown that the principles pair well with  binding different threads and blocks to the dimensions of the computation</a:t>
-            </a:r>
-            <a:br>
-              <a:rPr lang="en-US" dirty="0"/>
-            </a:br>
-            <a:r>
-              <a:rPr lang="en-US" dirty="0"/>
-              <a:t>and privatizing the data in the GPU shared memory.</a:t>
-            </a:r>
-          </a:p>
-          <a:p>
+              <a:t>Still haven’t done this one </a:t>
+            </a:r>
+            <a:r>
+              <a:rPr lang="en-US" dirty="0">
+                <a:sym typeface="Wingdings" panose="05000000000000000000" pitchFamily="2" charset="2"/>
+              </a:rPr>
+              <a:t></a:t>
+            </a:r>
             <a:endParaRPr lang="en-US" dirty="0"/>
           </a:p>
         </p:txBody>
@@ -3546,7 +3575,7 @@
           <a:p>
             <a:fld id="{FA8FD632-245B-410D-BCC4-8BF8D37AB67F}" type="slidenum">
               <a:rPr lang="en-US" smtClean="0"/>
-              <a:t>30</a:t>
+              <a:t>28</a:t>
             </a:fld>
             <a:endParaRPr lang="en-US"/>
           </a:p>
@@ -3555,7 +3584,7 @@
     </p:spTree>
     <p:extLst>
       <p:ext uri="{BB962C8B-B14F-4D97-AF65-F5344CB8AC3E}">
-        <p14:creationId xmlns:p14="http://schemas.microsoft.com/office/powerpoint/2010/main" val="2539622489"/>
+        <p14:creationId xmlns:p14="http://schemas.microsoft.com/office/powerpoint/2010/main" val="2911046873"/>
       </p:ext>
     </p:extLst>
   </p:cSld>
@@ -3611,14 +3640,17 @@
           <a:p>
             <a:r>
               <a:rPr lang="en-US" dirty="0"/>
-              <a:t>Following up on the recent improvements of LLMs since our previous work, we have become interested in whether their capability</a:t>
+              <a:t>---(slide 2/2; do not forget to copy from upward)---</a:t>
             </a:r>
             <a:br>
               <a:rPr lang="en-US" dirty="0"/>
             </a:br>
-            <a:r>
-              <a:rPr lang="en-US" dirty="0"/>
-              <a:t>further improves with abstractions that allow user-directed optimizations of the code in a similar manner to our abstractions.</a:t>
+            <a:br>
+              <a:rPr lang="en-US" dirty="0"/>
+            </a:br>
+            <a:r>
+              <a:rPr lang="en-US" dirty="0"/>
+              <a:t>(key idea: optimizing the traversal)</a:t>
             </a:r>
           </a:p>
           <a:p>
@@ -3627,96 +3659,62 @@
           <a:p>
             <a:r>
               <a:rPr lang="en-US" dirty="0"/>
-              <a:t>We have made a study with 3 different abstractions (Halide, Exo, </a:t>
-            </a:r>
-            <a:r>
-              <a:rPr lang="en-US" dirty="0" err="1"/>
-              <a:t>Noarr</a:t>
-            </a:r>
-            <a:r>
-              <a:rPr lang="en-US" dirty="0"/>
-              <a:t>), evaluating a state of the art LLM on the </a:t>
-            </a:r>
-            <a:r>
-              <a:rPr lang="en-US" dirty="0" err="1"/>
-              <a:t>PolyBench</a:t>
-            </a:r>
-            <a:r>
-              <a:rPr lang="en-US" dirty="0"/>
-              <a:t>/C suite;</a:t>
+              <a:t>By itself, this would be nice, but we can do much more.</a:t>
             </a:r>
             <a:br>
               <a:rPr lang="en-US" dirty="0"/>
             </a:br>
-            <a:r>
-              <a:rPr lang="en-US" dirty="0"/>
-              <a:t>the workflow consisted of 2 generation steps (translation and optimization) combined with an algorithmic selection of the best translation.</a:t>
-            </a:r>
-          </a:p>
-          <a:p>
             <a:endParaRPr lang="en-US" dirty="0"/>
           </a:p>
           <a:p>
             <a:r>
               <a:rPr lang="en-US" dirty="0"/>
-              <a:t>This was made to ensure that the LLM would have a working translation to use as a basis for its optimization attempt, as, at the time of the study,</a:t>
-            </a:r>
-          </a:p>
-          <a:p>
-            <a:r>
-              <a:rPr lang="en-US" dirty="0"/>
-              <a:t>it wasn’t feasible to put the entire programming reference for the given abstraction within the LLM’s limited context window.</a:t>
+              <a:t>We can use the same principles for building memory layouts to specify transformations of the traversal orders as well.</a:t>
+            </a:r>
+          </a:p>
+          <a:p>
+            <a:r>
+              <a:rPr lang="en-US" dirty="0"/>
+              <a:t>Let’s say we want to perform the matrix multiplication by tiles of the output; we can do so by defining the transformation and then applying it to the traverser.</a:t>
+            </a:r>
+            <a:br>
+              <a:rPr lang="en-US" dirty="0"/>
+            </a:br>
+            <a:r>
+              <a:rPr lang="en-US" dirty="0"/>
+              <a:t>We do not need to rewrite the computation logic or change the structures to do that.</a:t>
             </a:r>
           </a:p>
           <a:p>
             <a:endParaRPr lang="en-US" dirty="0"/>
           </a:p>
           <a:p>
-            <a:r>
-              <a:rPr lang="en-US" dirty="0"/>
-              <a:t>The prompts were supplied with one example of the translation (/optimization?) to further compensate for the limitation of its context window.</a:t>
-            </a:r>
-          </a:p>
-          <a:p>
             <a:endParaRPr lang="en-US" dirty="0"/>
           </a:p>
           <a:p>
             <a:r>
               <a:rPr lang="en-US" dirty="0"/>
-              <a:t>We have compared a naïve prompt (just to optimize the given computation) with more specific prompts giving general optimization hints,</a:t>
+              <a:t>We can also use the traversers as ranges to be parallelized using various parallel backends such as OpenMP or Threading Building Blocks.</a:t>
+            </a:r>
+          </a:p>
+          <a:p>
+            <a:endParaRPr lang="en-US" dirty="0"/>
+          </a:p>
+          <a:p>
+            <a:r>
+              <a:rPr lang="en-US" dirty="0"/>
+              <a:t>For the CUDA framework (used for general-purpose GPU programming), we have shown that the principles pair well with  binding different threads and blocks to the dimensions of the computation</a:t>
             </a:r>
             <a:br>
               <a:rPr lang="en-US" dirty="0"/>
             </a:br>
             <a:r>
               <a:rPr lang="en-US" dirty="0"/>
-              <a:t>and an alternative approach based on first writing an abstract optimization strategy and then implementing it in the second request.</a:t>
+              <a:t>and privatizing the data in the GPU shared memory.</a:t>
             </a:r>
           </a:p>
           <a:p>
             <a:endParaRPr lang="en-US" dirty="0"/>
-          </a:p>
-          <a:p>
-            <a:r>
-              <a:rPr lang="en-US" dirty="0"/>
-              <a:t>All these combinations of abstractions and prompts were also compared to applying the same methodology to the C baseline.</a:t>
-            </a:r>
-          </a:p>
-          <a:p>
-            <a:endParaRPr lang="en-US" dirty="0"/>
-          </a:p>
-          <a:p>
-            <a:r>
-              <a:rPr lang="en-US" dirty="0"/>
-              <a:t>Very unsurprisingly, more specific prompts performed better across all abstractions and C, but at the same time,</a:t>
-            </a:r>
-            <a:br>
-              <a:rPr lang="en-US" dirty="0"/>
-            </a:br>
-            <a:r>
-              <a:rPr lang="en-US" dirty="0"/>
-              <a:t>pure C optimization attempts performed better than any abstraction.</a:t>
-            </a:r>
           </a:p>
         </p:txBody>
       </p:sp>
@@ -3737,7 +3735,7 @@
           <a:p>
             <a:fld id="{FA8FD632-245B-410D-BCC4-8BF8D37AB67F}" type="slidenum">
               <a:rPr lang="en-US" smtClean="0"/>
-              <a:t>31</a:t>
+              <a:t>30</a:t>
             </a:fld>
             <a:endParaRPr lang="en-US"/>
           </a:p>
@@ -3746,7 +3744,7 @@
     </p:spTree>
     <p:extLst>
       <p:ext uri="{BB962C8B-B14F-4D97-AF65-F5344CB8AC3E}">
-        <p14:creationId xmlns:p14="http://schemas.microsoft.com/office/powerpoint/2010/main" val="215031226"/>
+        <p14:creationId xmlns:p14="http://schemas.microsoft.com/office/powerpoint/2010/main" val="2539622489"/>
       </p:ext>
     </p:extLst>
   </p:cSld>
@@ -3761,13 +3759,7 @@
   <p:cSld>
     <p:spTree>
       <p:nvGrpSpPr>
-        <p:cNvPr id="1" name="">
-          <a:extLst>
-            <a:ext uri="{FF2B5EF4-FFF2-40B4-BE49-F238E27FC236}">
-              <a16:creationId xmlns:a16="http://schemas.microsoft.com/office/drawing/2014/main" id="{F9A08B9B-DA7C-CEF0-D2F2-45B10F3312AF}"/>
-            </a:ext>
-          </a:extLst>
-        </p:cNvPr>
+        <p:cNvPr id="1" name=""/>
         <p:cNvGrpSpPr/>
         <p:nvPr/>
       </p:nvGrpSpPr>
@@ -3781,13 +3773,7 @@
       </p:grpSpPr>
       <p:sp>
         <p:nvSpPr>
-          <p:cNvPr id="2" name="Slide Image Placeholder 1">
-            <a:extLst>
-              <a:ext uri="{FF2B5EF4-FFF2-40B4-BE49-F238E27FC236}">
-                <a16:creationId xmlns:a16="http://schemas.microsoft.com/office/drawing/2014/main" id="{ABBA7740-2DAD-1370-B2CB-228DA0882621}"/>
-              </a:ext>
-            </a:extLst>
-          </p:cNvPr>
+          <p:cNvPr id="2" name="Slide Image Placeholder 1"/>
           <p:cNvSpPr>
             <a:spLocks noGrp="1" noRot="1" noChangeAspect="1"/>
           </p:cNvSpPr>
@@ -3799,13 +3785,7 @@
       </p:sp>
       <p:sp>
         <p:nvSpPr>
-          <p:cNvPr id="3" name="Notes Placeholder 2">
-            <a:extLst>
-              <a:ext uri="{FF2B5EF4-FFF2-40B4-BE49-F238E27FC236}">
-                <a16:creationId xmlns:a16="http://schemas.microsoft.com/office/drawing/2014/main" id="{25E4B22E-1818-E5A6-0350-5F174A750D46}"/>
-              </a:ext>
-            </a:extLst>
-          </p:cNvPr>
+          <p:cNvPr id="3" name="Notes Placeholder 2"/>
           <p:cNvSpPr>
             <a:spLocks noGrp="1"/>
           </p:cNvSpPr>
@@ -3883,7 +3863,7 @@
           <a:p>
             <a:r>
               <a:rPr lang="en-US" dirty="0"/>
-              <a:t>The prompts were supplied with one example of the translation (/optimization?) and language-specific documentation and hints to further compensate for the limitation of its context window.</a:t>
+              <a:t>The prompts were supplied with one example of the translation (/optimization?) to further compensate for the limitation of its context window.</a:t>
             </a:r>
           </a:p>
           <a:p>
@@ -3931,13 +3911,7 @@
       </p:sp>
       <p:sp>
         <p:nvSpPr>
-          <p:cNvPr id="4" name="Slide Number Placeholder 3">
-            <a:extLst>
-              <a:ext uri="{FF2B5EF4-FFF2-40B4-BE49-F238E27FC236}">
-                <a16:creationId xmlns:a16="http://schemas.microsoft.com/office/drawing/2014/main" id="{EC9A10B2-2AAB-DC98-721D-F9B66A801B35}"/>
-              </a:ext>
-            </a:extLst>
-          </p:cNvPr>
+          <p:cNvPr id="4" name="Slide Number Placeholder 3"/>
           <p:cNvSpPr>
             <a:spLocks noGrp="1"/>
           </p:cNvSpPr>
@@ -3952,7 +3926,7 @@
           <a:p>
             <a:fld id="{FA8FD632-245B-410D-BCC4-8BF8D37AB67F}" type="slidenum">
               <a:rPr lang="en-US" smtClean="0"/>
-              <a:t>32</a:t>
+              <a:t>31</a:t>
             </a:fld>
             <a:endParaRPr lang="en-US"/>
           </a:p>
@@ -3961,7 +3935,7 @@
     </p:spTree>
     <p:extLst>
       <p:ext uri="{BB962C8B-B14F-4D97-AF65-F5344CB8AC3E}">
-        <p14:creationId xmlns:p14="http://schemas.microsoft.com/office/powerpoint/2010/main" val="3608555400"/>
+        <p14:creationId xmlns:p14="http://schemas.microsoft.com/office/powerpoint/2010/main" val="215031226"/>
       </p:ext>
     </p:extLst>
   </p:cSld>
@@ -4136,6 +4110,221 @@
         <p:cNvPr id="1" name="">
           <a:extLst>
             <a:ext uri="{FF2B5EF4-FFF2-40B4-BE49-F238E27FC236}">
+              <a16:creationId xmlns:a16="http://schemas.microsoft.com/office/drawing/2014/main" id="{F9A08B9B-DA7C-CEF0-D2F2-45B10F3312AF}"/>
+            </a:ext>
+          </a:extLst>
+        </p:cNvPr>
+        <p:cNvGrpSpPr/>
+        <p:nvPr/>
+      </p:nvGrpSpPr>
+      <p:grpSpPr>
+        <a:xfrm>
+          <a:off x="0" y="0"/>
+          <a:ext cx="0" cy="0"/>
+          <a:chOff x="0" y="0"/>
+          <a:chExt cx="0" cy="0"/>
+        </a:xfrm>
+      </p:grpSpPr>
+      <p:sp>
+        <p:nvSpPr>
+          <p:cNvPr id="2" name="Slide Image Placeholder 1">
+            <a:extLst>
+              <a:ext uri="{FF2B5EF4-FFF2-40B4-BE49-F238E27FC236}">
+                <a16:creationId xmlns:a16="http://schemas.microsoft.com/office/drawing/2014/main" id="{ABBA7740-2DAD-1370-B2CB-228DA0882621}"/>
+              </a:ext>
+            </a:extLst>
+          </p:cNvPr>
+          <p:cNvSpPr>
+            <a:spLocks noGrp="1" noRot="1" noChangeAspect="1"/>
+          </p:cNvSpPr>
+          <p:nvPr>
+            <p:ph type="sldImg"/>
+          </p:nvPr>
+        </p:nvSpPr>
+        <p:spPr/>
+      </p:sp>
+      <p:sp>
+        <p:nvSpPr>
+          <p:cNvPr id="3" name="Notes Placeholder 2">
+            <a:extLst>
+              <a:ext uri="{FF2B5EF4-FFF2-40B4-BE49-F238E27FC236}">
+                <a16:creationId xmlns:a16="http://schemas.microsoft.com/office/drawing/2014/main" id="{25E4B22E-1818-E5A6-0350-5F174A750D46}"/>
+              </a:ext>
+            </a:extLst>
+          </p:cNvPr>
+          <p:cNvSpPr>
+            <a:spLocks noGrp="1"/>
+          </p:cNvSpPr>
+          <p:nvPr>
+            <p:ph type="body" idx="1"/>
+          </p:nvPr>
+        </p:nvSpPr>
+        <p:spPr/>
+        <p:txBody>
+          <a:bodyPr/>
+          <a:lstStyle/>
+          <a:p>
+            <a:r>
+              <a:rPr lang="en-US" dirty="0"/>
+              <a:t>Following up on the recent improvements of LLMs since our previous work, we have become interested in whether their capability</a:t>
+            </a:r>
+            <a:br>
+              <a:rPr lang="en-US" dirty="0"/>
+            </a:br>
+            <a:r>
+              <a:rPr lang="en-US" dirty="0"/>
+              <a:t>further improves with abstractions that allow user-directed optimizations of the code in a similar manner to our abstractions.</a:t>
+            </a:r>
+          </a:p>
+          <a:p>
+            <a:endParaRPr lang="en-US" dirty="0"/>
+          </a:p>
+          <a:p>
+            <a:r>
+              <a:rPr lang="en-US" dirty="0"/>
+              <a:t>We have made a study with 3 different abstractions (Halide, Exo, </a:t>
+            </a:r>
+            <a:r>
+              <a:rPr lang="en-US" dirty="0" err="1"/>
+              <a:t>Noarr</a:t>
+            </a:r>
+            <a:r>
+              <a:rPr lang="en-US" dirty="0"/>
+              <a:t>), evaluating a state of the art LLM on the </a:t>
+            </a:r>
+            <a:r>
+              <a:rPr lang="en-US" dirty="0" err="1"/>
+              <a:t>PolyBench</a:t>
+            </a:r>
+            <a:r>
+              <a:rPr lang="en-US" dirty="0"/>
+              <a:t>/C suite;</a:t>
+            </a:r>
+            <a:br>
+              <a:rPr lang="en-US" dirty="0"/>
+            </a:br>
+            <a:r>
+              <a:rPr lang="en-US" dirty="0"/>
+              <a:t>the workflow consisted of 2 generation steps (translation and optimization) combined with an algorithmic selection of the best translation.</a:t>
+            </a:r>
+          </a:p>
+          <a:p>
+            <a:endParaRPr lang="en-US" dirty="0"/>
+          </a:p>
+          <a:p>
+            <a:r>
+              <a:rPr lang="en-US" dirty="0"/>
+              <a:t>This was made to ensure that the LLM would have a working translation to use as a basis for its optimization attempt, as, at the time of the study,</a:t>
+            </a:r>
+          </a:p>
+          <a:p>
+            <a:r>
+              <a:rPr lang="en-US" dirty="0"/>
+              <a:t>it wasn’t feasible to put the entire programming reference for the given abstraction within the LLM’s limited context window.</a:t>
+            </a:r>
+          </a:p>
+          <a:p>
+            <a:endParaRPr lang="en-US" dirty="0"/>
+          </a:p>
+          <a:p>
+            <a:r>
+              <a:rPr lang="en-US" dirty="0"/>
+              <a:t>The prompts were supplied with one example of the translation (/optimization?) and language-specific documentation and hints to further compensate for the limitation of its context window.</a:t>
+            </a:r>
+          </a:p>
+          <a:p>
+            <a:endParaRPr lang="en-US" dirty="0"/>
+          </a:p>
+          <a:p>
+            <a:r>
+              <a:rPr lang="en-US" dirty="0"/>
+              <a:t>We have compared a naïve prompt (just to optimize the given computation) with more specific prompts giving general optimization hints,</a:t>
+            </a:r>
+            <a:br>
+              <a:rPr lang="en-US" dirty="0"/>
+            </a:br>
+            <a:r>
+              <a:rPr lang="en-US" dirty="0"/>
+              <a:t>and an alternative approach based on first writing an abstract optimization strategy and then implementing it in the second request.</a:t>
+            </a:r>
+          </a:p>
+          <a:p>
+            <a:endParaRPr lang="en-US" dirty="0"/>
+          </a:p>
+          <a:p>
+            <a:r>
+              <a:rPr lang="en-US" dirty="0"/>
+              <a:t>All these combinations of abstractions and prompts were also compared to applying the same methodology to the C baseline.</a:t>
+            </a:r>
+          </a:p>
+          <a:p>
+            <a:endParaRPr lang="en-US" dirty="0"/>
+          </a:p>
+          <a:p>
+            <a:r>
+              <a:rPr lang="en-US" dirty="0"/>
+              <a:t>Very unsurprisingly, more specific prompts performed better across all abstractions and C, but at the same time,</a:t>
+            </a:r>
+            <a:br>
+              <a:rPr lang="en-US" dirty="0"/>
+            </a:br>
+            <a:r>
+              <a:rPr lang="en-US" dirty="0"/>
+              <a:t>pure C optimization attempts performed better than any abstraction.</a:t>
+            </a:r>
+          </a:p>
+        </p:txBody>
+      </p:sp>
+      <p:sp>
+        <p:nvSpPr>
+          <p:cNvPr id="4" name="Slide Number Placeholder 3">
+            <a:extLst>
+              <a:ext uri="{FF2B5EF4-FFF2-40B4-BE49-F238E27FC236}">
+                <a16:creationId xmlns:a16="http://schemas.microsoft.com/office/drawing/2014/main" id="{EC9A10B2-2AAB-DC98-721D-F9B66A801B35}"/>
+              </a:ext>
+            </a:extLst>
+          </p:cNvPr>
+          <p:cNvSpPr>
+            <a:spLocks noGrp="1"/>
+          </p:cNvSpPr>
+          <p:nvPr>
+            <p:ph type="sldNum" sz="quarter" idx="5"/>
+          </p:nvPr>
+        </p:nvSpPr>
+        <p:spPr/>
+        <p:txBody>
+          <a:bodyPr/>
+          <a:lstStyle/>
+          <a:p>
+            <a:fld id="{FA8FD632-245B-410D-BCC4-8BF8D37AB67F}" type="slidenum">
+              <a:rPr lang="en-US" smtClean="0"/>
+              <a:t>32</a:t>
+            </a:fld>
+            <a:endParaRPr lang="en-US"/>
+          </a:p>
+        </p:txBody>
+      </p:sp>
+    </p:spTree>
+    <p:extLst>
+      <p:ext uri="{BB962C8B-B14F-4D97-AF65-F5344CB8AC3E}">
+        <p14:creationId xmlns:p14="http://schemas.microsoft.com/office/powerpoint/2010/main" val="3608555400"/>
+      </p:ext>
+    </p:extLst>
+  </p:cSld>
+  <p:clrMapOvr>
+    <a:masterClrMapping/>
+  </p:clrMapOvr>
+</p:notes>
+</file>
+
+<file path=ppt/notesSlides/notesSlide31.xml><?xml version="1.0" encoding="utf-8"?>
+<p:notes xmlns:a="http://schemas.openxmlformats.org/drawingml/2006/main" xmlns:r="http://schemas.openxmlformats.org/officeDocument/2006/relationships" xmlns:p="http://schemas.openxmlformats.org/presentationml/2006/main">
+  <p:cSld>
+    <p:spTree>
+      <p:nvGrpSpPr>
+        <p:cNvPr id="1" name="">
+          <a:extLst>
+            <a:ext uri="{FF2B5EF4-FFF2-40B4-BE49-F238E27FC236}">
               <a16:creationId xmlns:a16="http://schemas.microsoft.com/office/drawing/2014/main" id="{3937F3B2-C0BA-B51C-5F65-FC97C70D1079}"/>
             </a:ext>
           </a:extLst>
@@ -4342,7 +4531,7 @@
 </p:notes>
 </file>
 
-<file path=ppt/notesSlides/notesSlide31.xml><?xml version="1.0" encoding="utf-8"?>
+<file path=ppt/notesSlides/notesSlide32.xml><?xml version="1.0" encoding="utf-8"?>
 <p:notes xmlns:a="http://schemas.openxmlformats.org/drawingml/2006/main" xmlns:r="http://schemas.openxmlformats.org/officeDocument/2006/relationships" xmlns:p="http://schemas.openxmlformats.org/presentationml/2006/main">
   <p:cSld>
     <p:spTree>
@@ -4460,7 +4649,7 @@
 </p:notes>
 </file>
 
-<file path=ppt/notesSlides/notesSlide32.xml><?xml version="1.0" encoding="utf-8"?>
+<file path=ppt/notesSlides/notesSlide33.xml><?xml version="1.0" encoding="utf-8"?>
 <p:notes xmlns:a="http://schemas.openxmlformats.org/drawingml/2006/main" xmlns:r="http://schemas.openxmlformats.org/officeDocument/2006/relationships" xmlns:p="http://schemas.openxmlformats.org/presentationml/2006/main">
   <p:cSld>
     <p:spTree>
@@ -4763,150 +4952,6 @@
     <p:extLst>
       <p:ext uri="{BB962C8B-B14F-4D97-AF65-F5344CB8AC3E}">
         <p14:creationId xmlns:p14="http://schemas.microsoft.com/office/powerpoint/2010/main" val="1453155774"/>
-      </p:ext>
-    </p:extLst>
-  </p:cSld>
-  <p:clrMapOvr>
-    <a:masterClrMapping/>
-  </p:clrMapOvr>
-</p:notes>
-</file>
-
-<file path=ppt/notesSlides/notesSlide33.xml><?xml version="1.0" encoding="utf-8"?>
-<p:notes xmlns:a="http://schemas.openxmlformats.org/drawingml/2006/main" xmlns:r="http://schemas.openxmlformats.org/officeDocument/2006/relationships" xmlns:p="http://schemas.openxmlformats.org/presentationml/2006/main">
-  <p:cSld>
-    <p:spTree>
-      <p:nvGrpSpPr>
-        <p:cNvPr id="1" name=""/>
-        <p:cNvGrpSpPr/>
-        <p:nvPr/>
-      </p:nvGrpSpPr>
-      <p:grpSpPr>
-        <a:xfrm>
-          <a:off x="0" y="0"/>
-          <a:ext cx="0" cy="0"/>
-          <a:chOff x="0" y="0"/>
-          <a:chExt cx="0" cy="0"/>
-        </a:xfrm>
-      </p:grpSpPr>
-      <p:sp>
-        <p:nvSpPr>
-          <p:cNvPr id="2" name="Slide Image Placeholder 1"/>
-          <p:cNvSpPr>
-            <a:spLocks noGrp="1" noRot="1" noChangeAspect="1"/>
-          </p:cNvSpPr>
-          <p:nvPr>
-            <p:ph type="sldImg"/>
-          </p:nvPr>
-        </p:nvSpPr>
-        <p:spPr/>
-      </p:sp>
-      <p:sp>
-        <p:nvSpPr>
-          <p:cNvPr id="3" name="Notes Placeholder 2"/>
-          <p:cNvSpPr>
-            <a:spLocks noGrp="1"/>
-          </p:cNvSpPr>
-          <p:nvPr>
-            <p:ph type="body" idx="1"/>
-          </p:nvPr>
-        </p:nvSpPr>
-        <p:spPr/>
-        <p:txBody>
-          <a:bodyPr/>
-          <a:lstStyle/>
-          <a:p>
-            <a:r>
-              <a:rPr lang="en-US" dirty="0"/>
-              <a:t>For this, our research focused on two (something like compatible) directions</a:t>
-            </a:r>
-          </a:p>
-          <a:p>
-            <a:endParaRPr lang="en-US" dirty="0"/>
-          </a:p>
-          <a:p>
-            <a:r>
-              <a:rPr lang="en-US" dirty="0"/>
-              <a:t>The first one was investigating and implementing abstractions that offer composable building blocks that can be used to design efficient memory layouts and traversal orders; the choices can be algorithmically automatized by techniques such as autotuning</a:t>
-            </a:r>
-          </a:p>
-          <a:p>
-            <a:endParaRPr lang="en-US" dirty="0"/>
-          </a:p>
-          <a:p>
-            <a:r>
-              <a:rPr lang="en-US" dirty="0"/>
-              <a:t>The other direction has opened with the introduction of Large Language Models (LLMs), where the LLM can provide efficient implementation details fulfilling a given API requirement</a:t>
-            </a:r>
-          </a:p>
-          <a:p>
-            <a:endParaRPr lang="en-US" dirty="0"/>
-          </a:p>
-          <a:p>
-            <a:r>
-              <a:rPr lang="en-US" dirty="0"/>
-              <a:t>(?? More yapping?</a:t>
-            </a:r>
-          </a:p>
-          <a:p>
-            <a:r>
-              <a:rPr lang="en-US" dirty="0"/>
-              <a:t>- We have investigated how to … (tutoring)</a:t>
-            </a:r>
-          </a:p>
-          <a:p>
-            <a:r>
-              <a:rPr lang="en-US" dirty="0"/>
-              <a:t>)</a:t>
-            </a:r>
-          </a:p>
-          <a:p>
-            <a:endParaRPr lang="en-US" dirty="0"/>
-          </a:p>
-          <a:p>
-            <a:r>
-              <a:rPr lang="en-US" dirty="0"/>
-              <a:t>?? Since this research area is quite broad, we have mostly focused solely on dense data structures and algorithms utilizing regular loops, as even with this limitation, the area offers interesting challenges and many opportunities for improving the state of the art</a:t>
-            </a:r>
-          </a:p>
-          <a:p>
-            <a:endParaRPr lang="en-US" dirty="0"/>
-          </a:p>
-          <a:p>
-            <a:r>
-              <a:rPr lang="en-US" dirty="0"/>
-              <a:t>(ass bridge: now focusing on the abstractions…)</a:t>
-            </a:r>
-          </a:p>
-        </p:txBody>
-      </p:sp>
-      <p:sp>
-        <p:nvSpPr>
-          <p:cNvPr id="4" name="Slide Number Placeholder 3"/>
-          <p:cNvSpPr>
-            <a:spLocks noGrp="1"/>
-          </p:cNvSpPr>
-          <p:nvPr>
-            <p:ph type="sldNum" sz="quarter" idx="5"/>
-          </p:nvPr>
-        </p:nvSpPr>
-        <p:spPr/>
-        <p:txBody>
-          <a:bodyPr/>
-          <a:lstStyle/>
-          <a:p>
-            <a:fld id="{FA8FD632-245B-410D-BCC4-8BF8D37AB67F}" type="slidenum">
-              <a:rPr lang="en-US" smtClean="0"/>
-              <a:t>37</a:t>
-            </a:fld>
-            <a:endParaRPr lang="en-US"/>
-          </a:p>
-        </p:txBody>
-      </p:sp>
-    </p:spTree>
-    <p:extLst>
-      <p:ext uri="{BB962C8B-B14F-4D97-AF65-F5344CB8AC3E}">
-        <p14:creationId xmlns:p14="http://schemas.microsoft.com/office/powerpoint/2010/main" val="3810469099"/>
       </p:ext>
     </p:extLst>
   </p:cSld>
@@ -4960,7 +5005,67 @@
           <a:bodyPr/>
           <a:lstStyle/>
           <a:p>
+            <a:r>
+              <a:rPr lang="en-US" dirty="0"/>
+              <a:t>For this, our research focused on two (something like compatible) directions</a:t>
+            </a:r>
+          </a:p>
+          <a:p>
             <a:endParaRPr lang="en-US" dirty="0"/>
+          </a:p>
+          <a:p>
+            <a:r>
+              <a:rPr lang="en-US" dirty="0"/>
+              <a:t>The first one was investigating and implementing abstractions that offer composable building blocks that can be used to design efficient memory layouts and traversal orders; the choices can be algorithmically automatized by techniques such as autotuning</a:t>
+            </a:r>
+          </a:p>
+          <a:p>
+            <a:endParaRPr lang="en-US" dirty="0"/>
+          </a:p>
+          <a:p>
+            <a:r>
+              <a:rPr lang="en-US" dirty="0"/>
+              <a:t>The other direction has opened with the introduction of Large Language Models (LLMs), where the LLM can provide efficient implementation details fulfilling a given API requirement</a:t>
+            </a:r>
+          </a:p>
+          <a:p>
+            <a:endParaRPr lang="en-US" dirty="0"/>
+          </a:p>
+          <a:p>
+            <a:r>
+              <a:rPr lang="en-US" dirty="0"/>
+              <a:t>(?? More yapping?</a:t>
+            </a:r>
+          </a:p>
+          <a:p>
+            <a:r>
+              <a:rPr lang="en-US" dirty="0"/>
+              <a:t>- We have investigated how to … (tutoring)</a:t>
+            </a:r>
+          </a:p>
+          <a:p>
+            <a:r>
+              <a:rPr lang="en-US" dirty="0"/>
+              <a:t>)</a:t>
+            </a:r>
+          </a:p>
+          <a:p>
+            <a:endParaRPr lang="en-US" dirty="0"/>
+          </a:p>
+          <a:p>
+            <a:r>
+              <a:rPr lang="en-US" dirty="0"/>
+              <a:t>?? Since this research area is quite broad, we have mostly focused solely on dense data structures and algorithms utilizing regular loops, as even with this limitation, the area offers interesting challenges and many opportunities for improving the state of the art</a:t>
+            </a:r>
+          </a:p>
+          <a:p>
+            <a:endParaRPr lang="en-US" dirty="0"/>
+          </a:p>
+          <a:p>
+            <a:r>
+              <a:rPr lang="en-US" dirty="0"/>
+              <a:t>(ass bridge: now focusing on the abstractions…)</a:t>
+            </a:r>
           </a:p>
         </p:txBody>
       </p:sp>
@@ -4981,7 +5086,7 @@
           <a:p>
             <a:fld id="{FA8FD632-245B-410D-BCC4-8BF8D37AB67F}" type="slidenum">
               <a:rPr lang="en-US" smtClean="0"/>
-              <a:t>38</a:t>
+              <a:t>37</a:t>
             </a:fld>
             <a:endParaRPr lang="en-US"/>
           </a:p>
@@ -4990,7 +5095,7 @@
     </p:spTree>
     <p:extLst>
       <p:ext uri="{BB962C8B-B14F-4D97-AF65-F5344CB8AC3E}">
-        <p14:creationId xmlns:p14="http://schemas.microsoft.com/office/powerpoint/2010/main" val="1067365625"/>
+        <p14:creationId xmlns:p14="http://schemas.microsoft.com/office/powerpoint/2010/main" val="3810469099"/>
       </p:ext>
     </p:extLst>
   </p:cSld>
@@ -5044,133 +5149,7 @@
           <a:bodyPr/>
           <a:lstStyle/>
           <a:p>
-            <a:r>
-              <a:rPr lang="en-US" dirty="0"/>
-              <a:t>(key idea: introducing </a:t>
-            </a:r>
-            <a:r>
-              <a:rPr lang="en-US" dirty="0" err="1"/>
-              <a:t>Noarr</a:t>
-            </a:r>
-            <a:r>
-              <a:rPr lang="en-US" dirty="0"/>
-              <a:t> Structures; or abstractions for layout-agnostic design)</a:t>
-            </a:r>
-            <a:br>
-              <a:rPr lang="en-US" dirty="0"/>
-            </a:br>
-            <a:br>
-              <a:rPr lang="en-US" dirty="0"/>
-            </a:br>
-            <a:r>
-              <a:rPr lang="en-US" dirty="0"/>
-              <a:t>/*</a:t>
-            </a:r>
-          </a:p>
-          <a:p>
-            <a:r>
-              <a:rPr lang="en-US" dirty="0"/>
-              <a:t>As the first contribution of our research, we have devised an abstraction for building and transforming memory layouts that enable the design of layout-agnostic algorithms as well as the reuse of the defined layouts.</a:t>
-            </a:r>
-          </a:p>
-          <a:p>
             <a:endParaRPr lang="en-US" dirty="0"/>
-          </a:p>
-          <a:p>
-            <a:r>
-              <a:rPr lang="en-US" dirty="0"/>
-              <a:t>In real-use algorithms</a:t>
-            </a:r>
-            <a:br>
-              <a:rPr lang="en-US" dirty="0"/>
-            </a:br>
-            <a:r>
-              <a:rPr lang="en-US" dirty="0"/>
-              <a:t>- dimensions have semantic value</a:t>
-            </a:r>
-            <a:br>
-              <a:rPr lang="en-US" dirty="0"/>
-            </a:br>
-            <a:r>
-              <a:rPr lang="en-US" dirty="0"/>
-              <a:t>- a data access more often depends on the semantic (logic) structure than on a specific memory offset</a:t>
-            </a:r>
-            <a:br>
-              <a:rPr lang="en-US" dirty="0"/>
-            </a:br>
-            <a:r>
-              <a:rPr lang="en-US" dirty="0"/>
-              <a:t>- traversals cover the semantic space rather than a set of abstract coordinates</a:t>
-            </a:r>
-          </a:p>
-          <a:p>
-            <a:r>
-              <a:rPr lang="en-US" dirty="0"/>
-              <a:t>*/</a:t>
-            </a:r>
-          </a:p>
-          <a:p>
-            <a:endParaRPr lang="en-US" dirty="0"/>
-          </a:p>
-          <a:p>
-            <a:r>
-              <a:rPr lang="en-US" dirty="0"/>
-              <a:t>At the beginning of our research, we focused on devising abstractions that would enable a more seamless design of algorithms amenable to source-level optimizations allowing for user-direction and automation.</a:t>
-            </a:r>
-          </a:p>
-          <a:p>
-            <a:endParaRPr lang="en-US" dirty="0"/>
-          </a:p>
-          <a:p>
-            <a:r>
-              <a:rPr lang="en-US" dirty="0"/>
-              <a:t>If we slightly optimize a standard matrix multiplication algorithm, we might end up with something similar to the shown code.</a:t>
-            </a:r>
-          </a:p>
-          <a:p>
-            <a:r>
-              <a:rPr lang="en-US" dirty="0"/>
-              <a:t>At first view, it is difficult to see that it is actually a three-dimensional traversal performed in a tiled manner, accessing elements in row-major or column-major layouts.</a:t>
-            </a:r>
-          </a:p>
-          <a:p>
-            <a:br>
-              <a:rPr lang="en-US" dirty="0"/>
-            </a:br>
-            <a:br>
-              <a:rPr lang="en-US" dirty="0"/>
-            </a:br>
-            <a:r>
-              <a:rPr lang="en-US" dirty="0"/>
-              <a:t>[without runtime overhead]</a:t>
-            </a:r>
-            <a:br>
-              <a:rPr lang="en-US" dirty="0"/>
-            </a:br>
-            <a:r>
-              <a:rPr lang="en-US" dirty="0"/>
-              <a:t>Our research iteratively progressed to a point where we can encode the semantic logical structure of layouts independently of the physical layout, naming the dimensions for specifying the logical API that is common to the layouts sharing the same dimensions.</a:t>
-            </a:r>
-          </a:p>
-          <a:p>
-            <a:r>
-              <a:rPr lang="en-US" dirty="0"/>
-              <a:t>This makes the structures more resistant to simple errors and encodes further information that then allows using these names to either identify common dimensions of different structures and thus automatically infer traversals over them, or specify transformations of these traversals.</a:t>
-            </a:r>
-            <a:br>
-              <a:rPr lang="en-US" dirty="0"/>
-            </a:br>
-            <a:r>
-              <a:rPr lang="en-US" dirty="0"/>
-              <a:t>This then allows us to compact the difficult-to-maintain version of the matrix multiplication algorithm into a more compact and semantic code.</a:t>
-            </a:r>
-            <a:br>
-              <a:rPr lang="en-US" dirty="0"/>
-            </a:br>
-            <a:r>
-              <a:rPr lang="en-US" dirty="0"/>
-              <a:t>(The first three rows directly match, then we simply specify we want to traverse the combined space of the three structures, and specify the action that should happen for each point of the space; the order directive then specifies the tiling optimization)</a:t>
-            </a:r>
           </a:p>
         </p:txBody>
       </p:sp>
@@ -5191,7 +5170,7 @@
           <a:p>
             <a:fld id="{FA8FD632-245B-410D-BCC4-8BF8D37AB67F}" type="slidenum">
               <a:rPr lang="en-US" smtClean="0"/>
-              <a:t>39</a:t>
+              <a:t>38</a:t>
             </a:fld>
             <a:endParaRPr lang="en-US"/>
           </a:p>
@@ -5200,7 +5179,7 @@
     </p:spTree>
     <p:extLst>
       <p:ext uri="{BB962C8B-B14F-4D97-AF65-F5344CB8AC3E}">
-        <p14:creationId xmlns:p14="http://schemas.microsoft.com/office/powerpoint/2010/main" val="3577613745"/>
+        <p14:creationId xmlns:p14="http://schemas.microsoft.com/office/powerpoint/2010/main" val="1067365625"/>
       </p:ext>
     </p:extLst>
   </p:cSld>
@@ -5256,6 +5235,216 @@
           <a:p>
             <a:r>
               <a:rPr lang="en-US" dirty="0"/>
+              <a:t>(key idea: introducing </a:t>
+            </a:r>
+            <a:r>
+              <a:rPr lang="en-US" dirty="0" err="1"/>
+              <a:t>Noarr</a:t>
+            </a:r>
+            <a:r>
+              <a:rPr lang="en-US" dirty="0"/>
+              <a:t> Structures; or abstractions for layout-agnostic design)</a:t>
+            </a:r>
+            <a:br>
+              <a:rPr lang="en-US" dirty="0"/>
+            </a:br>
+            <a:br>
+              <a:rPr lang="en-US" dirty="0"/>
+            </a:br>
+            <a:r>
+              <a:rPr lang="en-US" dirty="0"/>
+              <a:t>/*</a:t>
+            </a:r>
+          </a:p>
+          <a:p>
+            <a:r>
+              <a:rPr lang="en-US" dirty="0"/>
+              <a:t>As the first contribution of our research, we have devised an abstraction for building and transforming memory layouts that enable the design of layout-agnostic algorithms as well as the reuse of the defined layouts.</a:t>
+            </a:r>
+          </a:p>
+          <a:p>
+            <a:endParaRPr lang="en-US" dirty="0"/>
+          </a:p>
+          <a:p>
+            <a:r>
+              <a:rPr lang="en-US" dirty="0"/>
+              <a:t>In real-use algorithms</a:t>
+            </a:r>
+            <a:br>
+              <a:rPr lang="en-US" dirty="0"/>
+            </a:br>
+            <a:r>
+              <a:rPr lang="en-US" dirty="0"/>
+              <a:t>- dimensions have semantic value</a:t>
+            </a:r>
+            <a:br>
+              <a:rPr lang="en-US" dirty="0"/>
+            </a:br>
+            <a:r>
+              <a:rPr lang="en-US" dirty="0"/>
+              <a:t>- a data access more often depends on the semantic (logic) structure than on a specific memory offset</a:t>
+            </a:r>
+            <a:br>
+              <a:rPr lang="en-US" dirty="0"/>
+            </a:br>
+            <a:r>
+              <a:rPr lang="en-US" dirty="0"/>
+              <a:t>- traversals cover the semantic space rather than a set of abstract coordinates</a:t>
+            </a:r>
+          </a:p>
+          <a:p>
+            <a:r>
+              <a:rPr lang="en-US" dirty="0"/>
+              <a:t>*/</a:t>
+            </a:r>
+          </a:p>
+          <a:p>
+            <a:endParaRPr lang="en-US" dirty="0"/>
+          </a:p>
+          <a:p>
+            <a:r>
+              <a:rPr lang="en-US" dirty="0"/>
+              <a:t>At the beginning of our research, we focused on devising abstractions that would enable a more seamless design of algorithms amenable to source-level optimizations allowing for user-direction and automation.</a:t>
+            </a:r>
+          </a:p>
+          <a:p>
+            <a:endParaRPr lang="en-US" dirty="0"/>
+          </a:p>
+          <a:p>
+            <a:r>
+              <a:rPr lang="en-US" dirty="0"/>
+              <a:t>If we slightly optimize a standard matrix multiplication algorithm, we might end up with something similar to the shown code.</a:t>
+            </a:r>
+          </a:p>
+          <a:p>
+            <a:r>
+              <a:rPr lang="en-US" dirty="0"/>
+              <a:t>At first view, it is difficult to see that it is actually a three-dimensional traversal performed in a tiled manner, accessing elements in row-major or column-major layouts.</a:t>
+            </a:r>
+          </a:p>
+          <a:p>
+            <a:br>
+              <a:rPr lang="en-US" dirty="0"/>
+            </a:br>
+            <a:br>
+              <a:rPr lang="en-US" dirty="0"/>
+            </a:br>
+            <a:r>
+              <a:rPr lang="en-US" dirty="0"/>
+              <a:t>[without runtime overhead]</a:t>
+            </a:r>
+            <a:br>
+              <a:rPr lang="en-US" dirty="0"/>
+            </a:br>
+            <a:r>
+              <a:rPr lang="en-US" dirty="0"/>
+              <a:t>Our research iteratively progressed to a point where we can encode the semantic logical structure of layouts independently of the physical layout, naming the dimensions for specifying the logical API that is common to the layouts sharing the same dimensions.</a:t>
+            </a:r>
+          </a:p>
+          <a:p>
+            <a:r>
+              <a:rPr lang="en-US" dirty="0"/>
+              <a:t>This makes the structures more resistant to simple errors and encodes further information that then allows using these names to either identify common dimensions of different structures and thus automatically infer traversals over them, or specify transformations of these traversals.</a:t>
+            </a:r>
+            <a:br>
+              <a:rPr lang="en-US" dirty="0"/>
+            </a:br>
+            <a:r>
+              <a:rPr lang="en-US" dirty="0"/>
+              <a:t>This then allows us to compact the difficult-to-maintain version of the matrix multiplication algorithm into a more compact and semantic code.</a:t>
+            </a:r>
+            <a:br>
+              <a:rPr lang="en-US" dirty="0"/>
+            </a:br>
+            <a:r>
+              <a:rPr lang="en-US" dirty="0"/>
+              <a:t>(The first three rows directly match, then we simply specify we want to traverse the combined space of the three structures, and specify the action that should happen for each point of the space; the order directive then specifies the tiling optimization)</a:t>
+            </a:r>
+          </a:p>
+        </p:txBody>
+      </p:sp>
+      <p:sp>
+        <p:nvSpPr>
+          <p:cNvPr id="4" name="Slide Number Placeholder 3"/>
+          <p:cNvSpPr>
+            <a:spLocks noGrp="1"/>
+          </p:cNvSpPr>
+          <p:nvPr>
+            <p:ph type="sldNum" sz="quarter" idx="5"/>
+          </p:nvPr>
+        </p:nvSpPr>
+        <p:spPr/>
+        <p:txBody>
+          <a:bodyPr/>
+          <a:lstStyle/>
+          <a:p>
+            <a:fld id="{FA8FD632-245B-410D-BCC4-8BF8D37AB67F}" type="slidenum">
+              <a:rPr lang="en-US" smtClean="0"/>
+              <a:t>39</a:t>
+            </a:fld>
+            <a:endParaRPr lang="en-US"/>
+          </a:p>
+        </p:txBody>
+      </p:sp>
+    </p:spTree>
+    <p:extLst>
+      <p:ext uri="{BB962C8B-B14F-4D97-AF65-F5344CB8AC3E}">
+        <p14:creationId xmlns:p14="http://schemas.microsoft.com/office/powerpoint/2010/main" val="3577613745"/>
+      </p:ext>
+    </p:extLst>
+  </p:cSld>
+  <p:clrMapOvr>
+    <a:masterClrMapping/>
+  </p:clrMapOvr>
+</p:notes>
+</file>
+
+<file path=ppt/notesSlides/notesSlide37.xml><?xml version="1.0" encoding="utf-8"?>
+<p:notes xmlns:a="http://schemas.openxmlformats.org/drawingml/2006/main" xmlns:r="http://schemas.openxmlformats.org/officeDocument/2006/relationships" xmlns:p="http://schemas.openxmlformats.org/presentationml/2006/main">
+  <p:cSld>
+    <p:spTree>
+      <p:nvGrpSpPr>
+        <p:cNvPr id="1" name=""/>
+        <p:cNvGrpSpPr/>
+        <p:nvPr/>
+      </p:nvGrpSpPr>
+      <p:grpSpPr>
+        <a:xfrm>
+          <a:off x="0" y="0"/>
+          <a:ext cx="0" cy="0"/>
+          <a:chOff x="0" y="0"/>
+          <a:chExt cx="0" cy="0"/>
+        </a:xfrm>
+      </p:grpSpPr>
+      <p:sp>
+        <p:nvSpPr>
+          <p:cNvPr id="2" name="Slide Image Placeholder 1"/>
+          <p:cNvSpPr>
+            <a:spLocks noGrp="1" noRot="1" noChangeAspect="1"/>
+          </p:cNvSpPr>
+          <p:nvPr>
+            <p:ph type="sldImg"/>
+          </p:nvPr>
+        </p:nvSpPr>
+        <p:spPr/>
+      </p:sp>
+      <p:sp>
+        <p:nvSpPr>
+          <p:cNvPr id="3" name="Notes Placeholder 2"/>
+          <p:cNvSpPr>
+            <a:spLocks noGrp="1"/>
+          </p:cNvSpPr>
+          <p:nvPr>
+            <p:ph type="body" idx="1"/>
+          </p:nvPr>
+        </p:nvSpPr>
+        <p:spPr/>
+        <p:txBody>
+          <a:bodyPr/>
+          <a:lstStyle/>
+          <a:p>
+            <a:r>
+              <a:rPr lang="en-US" dirty="0"/>
               <a:t>In our first contribution, we focused on abstractions for encoding the memory layouts so that they separate the logical structure used in the algorithms from the physical memory layout (offsets). Our research is not the only effort on this, as nowadays, we can see similar efforts in the C++ standard with the introduction of </a:t>
             </a:r>
             <a:r>
@@ -5393,7 +5582,7 @@
 </p:notes>
 </file>
 
-<file path=ppt/notesSlides/notesSlide37.xml><?xml version="1.0" encoding="utf-8"?>
+<file path=ppt/notesSlides/notesSlide38.xml><?xml version="1.0" encoding="utf-8"?>
 <p:notes xmlns:a="http://schemas.openxmlformats.org/drawingml/2006/main" xmlns:r="http://schemas.openxmlformats.org/officeDocument/2006/relationships" xmlns:p="http://schemas.openxmlformats.org/presentationml/2006/main">
   <p:cSld>
     <p:spTree>
@@ -6346,7 +6535,15 @@
           <a:p>
             <a:r>
               <a:rPr lang="en-US" dirty="0"/>
-              <a:t>So, these two stages have provided the groundwork for enabling seamless and automatable code optimization in C++ that is fully transparent and directable by the user.</a:t>
+              <a:t>(key idea: autotuning made easier &amp; we can switch </a:t>
+            </a:r>
+            <a:r>
+              <a:rPr lang="en-US" dirty="0" err="1"/>
+              <a:t>autotuners</a:t>
+            </a:r>
+            <a:r>
+              <a:rPr lang="en-US" dirty="0"/>
+              <a:t>)</a:t>
             </a:r>
           </a:p>
           <a:p>
@@ -6355,13 +6552,7 @@
           <a:p>
             <a:r>
               <a:rPr lang="en-US" dirty="0"/>
-              <a:t>We have finalized this effort by implementing an autotuning interface that allows for specifying the tuned parameters in the same code as the algorithm.</a:t>
-            </a:r>
-          </a:p>
-          <a:p>
-            <a:r>
-              <a:rPr lang="en-US" dirty="0"/>
-              <a:t>This interface was designed to pair well with the abstractions.</a:t>
+              <a:t>These two stages have provided the groundwork for enabling seamless and automatable code optimization in C++ that is fully transparent and directable by the user.</a:t>
             </a:r>
           </a:p>
           <a:p>
@@ -6370,15 +6561,87 @@
           <a:p>
             <a:r>
               <a:rPr lang="en-US" dirty="0"/>
-              <a:t>(Oh god I don’t know how to continue </a:t>
+              <a:t>Typically, when we want to use an autotuning framework to optimize an algorithm, we need to:</a:t>
+            </a:r>
+          </a:p>
+          <a:p>
+            <a:pPr marL="171450" indent="-171450">
+              <a:buFontTx/>
+              <a:buChar char="-"/>
+            </a:pPr>
+            <a:r>
+              <a:rPr lang="en-US" dirty="0"/>
+              <a:t>Define each parameter in the code</a:t>
+            </a:r>
+          </a:p>
+          <a:p>
+            <a:pPr marL="171450" indent="-171450">
+              <a:buFontTx/>
+              <a:buChar char="-"/>
+            </a:pPr>
+            <a:r>
+              <a:rPr lang="en-US" dirty="0"/>
+              <a:t>Handle communication with the autotuning framework</a:t>
+            </a:r>
+          </a:p>
+          <a:p>
+            <a:pPr marL="171450" indent="-171450">
+              <a:buFontTx/>
+              <a:buChar char="-"/>
+            </a:pPr>
+            <a:r>
+              <a:rPr lang="en-US" dirty="0"/>
+              <a:t>Define the parameter on the </a:t>
             </a:r>
             <a:r>
               <a:rPr lang="en-US" dirty="0" err="1"/>
-              <a:t>rn</a:t>
-            </a:r>
-            <a:r>
-              <a:rPr lang="en-US" dirty="0"/>
-              <a:t>)</a:t>
+              <a:t>autotuner’s</a:t>
+            </a:r>
+            <a:r>
+              <a:rPr lang="en-US" dirty="0"/>
+              <a:t> side</a:t>
+            </a:r>
+          </a:p>
+          <a:p>
+            <a:pPr marL="0" indent="0">
+              <a:buFontTx/>
+              <a:buNone/>
+            </a:pPr>
+            <a:endParaRPr lang="en-US" dirty="0"/>
+          </a:p>
+          <a:p>
+            <a:pPr marL="0" indent="0">
+              <a:buFontTx/>
+              <a:buNone/>
+            </a:pPr>
+            <a:r>
+              <a:rPr lang="en-US" dirty="0"/>
+              <a:t>This creates unnecessary amount of boilerplate definitions and communication specification that is difficult to maintain and easy to make mistakes in.</a:t>
+            </a:r>
+          </a:p>
+          <a:p>
+            <a:endParaRPr lang="en-US" dirty="0"/>
+          </a:p>
+          <a:p>
+            <a:r>
+              <a:rPr lang="en-US" dirty="0"/>
+              <a:t>We have implemented an autotuning interface that allows for specifying the tuned parameters in the same code as the algorithm,</a:t>
+            </a:r>
+            <a:br>
+              <a:rPr lang="en-US" dirty="0"/>
+            </a:br>
+            <a:r>
+              <a:rPr lang="en-US" dirty="0"/>
+              <a:t>this specification is independent of the autotuning backend, and the whole autotuning process is handled automatically.</a:t>
+            </a:r>
+          </a:p>
+          <a:p>
+            <a:endParaRPr lang="en-US" dirty="0"/>
+          </a:p>
+          <a:p>
+            <a:r>
+              <a:rPr lang="en-US" dirty="0"/>
+              <a:t>Since the specification is independent of the autotuning backend, this also makes switching between different autotuning frameworks easy.</a:t>
             </a:r>
           </a:p>
         </p:txBody>
@@ -13200,14 +13463,6 @@
 <file path=ppt/slides/slide14.xml><?xml version="1.0" encoding="utf-8"?>
 <p:sld xmlns:a="http://schemas.openxmlformats.org/drawingml/2006/main" xmlns:r="http://schemas.openxmlformats.org/officeDocument/2006/relationships" xmlns:p="http://schemas.openxmlformats.org/presentationml/2006/main">
   <p:cSld>
-    <p:bg>
-      <p:bgPr>
-        <a:solidFill>
-          <a:srgbClr val="FFFF00"/>
-        </a:solidFill>
-        <a:effectLst/>
-      </p:bgPr>
-    </p:bg>
     <p:spTree>
       <p:nvGrpSpPr>
         <p:cNvPr id="1" name=""/>
@@ -13272,7 +13527,7 @@
         </p:blipFill>
         <p:spPr>
           <a:xfrm>
-            <a:off x="2940615" y="3429000"/>
+            <a:off x="1794862" y="3305637"/>
             <a:ext cx="8602275" cy="2924583"/>
           </a:xfrm>
           <a:prstGeom prst="rect">
@@ -13302,7 +13557,7 @@
         </p:blipFill>
         <p:spPr>
           <a:xfrm>
-            <a:off x="4121330" y="1293295"/>
+            <a:off x="2733204" y="1356359"/>
             <a:ext cx="6725589" cy="1886213"/>
           </a:xfrm>
           <a:prstGeom prst="rect">
@@ -15766,14 +16021,6 @@
 <file path=ppt/slides/slide18.xml><?xml version="1.0" encoding="utf-8"?>
 <p:sld xmlns:a="http://schemas.openxmlformats.org/drawingml/2006/main" xmlns:r="http://schemas.openxmlformats.org/officeDocument/2006/relationships" xmlns:p="http://schemas.openxmlformats.org/presentationml/2006/main">
   <p:cSld>
-    <p:bg>
-      <p:bgPr>
-        <a:solidFill>
-          <a:srgbClr val="FFFF00"/>
-        </a:solidFill>
-        <a:effectLst/>
-      </p:bgPr>
-    </p:bg>
     <p:spTree>
       <p:nvGrpSpPr>
         <p:cNvPr id="1" name=""/>
@@ -15845,7 +16092,7 @@
           <a:p>
             <a:r>
               <a:rPr lang="en-US" dirty="0"/>
-              <a:t>Applicable to parallel and distributed HPC computing</a:t>
+              <a:t>Applicable to parallel (CPU/GPU) and distributed HPC computing</a:t>
             </a:r>
           </a:p>
           <a:p>
@@ -17617,6 +17864,13 @@
               <a:rPr lang="en-US" noProof="0" dirty="0"/>
               <a:t>Tutoring LLMs for CUDA</a:t>
             </a:r>
+            <a:br>
+              <a:rPr lang="en-US" noProof="0" dirty="0"/>
+            </a:br>
+            <a:r>
+              <a:rPr lang="en-US" sz="2400" i="1" noProof="0" dirty="0"/>
+              <a:t>OpenAI GPT-o3-mini</a:t>
+            </a:r>
           </a:p>
         </p:txBody>
       </p:sp>
@@ -18697,14 +18951,6 @@
 <file path=ppt/slides/slide22.xml><?xml version="1.0" encoding="utf-8"?>
 <p:sld xmlns:a="http://schemas.openxmlformats.org/drawingml/2006/main" xmlns:r="http://schemas.openxmlformats.org/officeDocument/2006/relationships" xmlns:p="http://schemas.openxmlformats.org/presentationml/2006/main">
   <p:cSld>
-    <p:bg>
-      <p:bgPr>
-        <a:solidFill>
-          <a:srgbClr val="FFFF00"/>
-        </a:solidFill>
-        <a:effectLst/>
-      </p:bgPr>
-    </p:bg>
     <p:spTree>
       <p:nvGrpSpPr>
         <p:cNvPr id="1" name="">
@@ -18750,6 +18996,14 @@
               <a:rPr lang="en-US" noProof="0" dirty="0"/>
               <a:t>Tutoring LLMs for CUDA – submission</a:t>
             </a:r>
+            <a:br>
+              <a:rPr lang="en-US" noProof="0" dirty="0"/>
+            </a:br>
+            <a:r>
+              <a:rPr lang="en-US" sz="2400" i="1" dirty="0"/>
+              <a:t>OpenAI GPT-o3-mini</a:t>
+            </a:r>
+            <a:endParaRPr lang="en-US" sz="2400" noProof="0" dirty="0"/>
           </a:p>
         </p:txBody>
       </p:sp>
@@ -18943,6 +19197,90 @@
           </a:p>
         </p:txBody>
       </p:sp>
+      <p:sp>
+        <p:nvSpPr>
+          <p:cNvPr id="9" name="TextBox 8">
+            <a:extLst>
+              <a:ext uri="{FF2B5EF4-FFF2-40B4-BE49-F238E27FC236}">
+                <a16:creationId xmlns:a16="http://schemas.microsoft.com/office/drawing/2014/main" id="{5F4D55C3-3077-8567-A06E-0244BA5AA6CA}"/>
+              </a:ext>
+            </a:extLst>
+          </p:cNvPr>
+          <p:cNvSpPr txBox="1"/>
+          <p:nvPr/>
+        </p:nvSpPr>
+        <p:spPr>
+          <a:xfrm>
+            <a:off x="236845" y="6084477"/>
+            <a:ext cx="5697394" cy="369332"/>
+          </a:xfrm>
+          <a:prstGeom prst="rect">
+            <a:avLst/>
+          </a:prstGeom>
+          <a:noFill/>
+        </p:spPr>
+        <p:txBody>
+          <a:bodyPr wrap="none" rtlCol="0">
+            <a:spAutoFit/>
+          </a:bodyPr>
+          <a:lstStyle/>
+          <a:p>
+            <a:r>
+              <a:rPr lang="en-US" dirty="0"/>
+              <a:t>Prompt specificity (naïve </a:t>
+            </a:r>
+            <a:r>
+              <a:rPr lang="en-US" dirty="0">
+                <a:sym typeface="Wingdings" panose="05000000000000000000" pitchFamily="2" charset="2"/>
+              </a:rPr>
+              <a:t> …  design specification)</a:t>
+            </a:r>
+            <a:endParaRPr lang="en-US" dirty="0"/>
+          </a:p>
+        </p:txBody>
+      </p:sp>
+      <p:sp>
+        <p:nvSpPr>
+          <p:cNvPr id="11" name="TextBox 10">
+            <a:extLst>
+              <a:ext uri="{FF2B5EF4-FFF2-40B4-BE49-F238E27FC236}">
+                <a16:creationId xmlns:a16="http://schemas.microsoft.com/office/drawing/2014/main" id="{BEFC1A91-D2F9-8087-5FD2-A346BE6173B0}"/>
+              </a:ext>
+            </a:extLst>
+          </p:cNvPr>
+          <p:cNvSpPr txBox="1"/>
+          <p:nvPr/>
+        </p:nvSpPr>
+        <p:spPr>
+          <a:xfrm>
+            <a:off x="6189752" y="5756063"/>
+            <a:ext cx="5697394" cy="369332"/>
+          </a:xfrm>
+          <a:prstGeom prst="rect">
+            <a:avLst/>
+          </a:prstGeom>
+          <a:noFill/>
+        </p:spPr>
+        <p:txBody>
+          <a:bodyPr wrap="none" rtlCol="0">
+            <a:spAutoFit/>
+          </a:bodyPr>
+          <a:lstStyle/>
+          <a:p>
+            <a:r>
+              <a:rPr lang="en-US" dirty="0"/>
+              <a:t>Prompt specificity (naïve </a:t>
+            </a:r>
+            <a:r>
+              <a:rPr lang="en-US" dirty="0">
+                <a:sym typeface="Wingdings" panose="05000000000000000000" pitchFamily="2" charset="2"/>
+              </a:rPr>
+              <a:t> …  design specification)</a:t>
+            </a:r>
+            <a:endParaRPr lang="en-US" dirty="0"/>
+          </a:p>
+        </p:txBody>
+      </p:sp>
     </p:spTree>
     <p:extLst>
       <p:ext uri="{BB962C8B-B14F-4D97-AF65-F5344CB8AC3E}">
@@ -18959,14 +19297,6 @@
 <file path=ppt/slides/slide23.xml><?xml version="1.0" encoding="utf-8"?>
 <p:sld xmlns:a="http://schemas.openxmlformats.org/drawingml/2006/main" xmlns:r="http://schemas.openxmlformats.org/officeDocument/2006/relationships" xmlns:p="http://schemas.openxmlformats.org/presentationml/2006/main">
   <p:cSld>
-    <p:bg>
-      <p:bgPr>
-        <a:solidFill>
-          <a:srgbClr val="FFFF00"/>
-        </a:solidFill>
-        <a:effectLst/>
-      </p:bgPr>
-    </p:bg>
     <p:spTree>
       <p:nvGrpSpPr>
         <p:cNvPr id="1" name="">
@@ -19012,6 +19342,14 @@
               <a:rPr lang="en-US" noProof="0" dirty="0"/>
               <a:t>Tutoring LLMs for CUDA – at conference</a:t>
             </a:r>
+            <a:br>
+              <a:rPr lang="en-US" noProof="0" dirty="0"/>
+            </a:br>
+            <a:r>
+              <a:rPr lang="en-US" sz="2400" i="1" dirty="0"/>
+              <a:t>OpenAI GPT-5</a:t>
+            </a:r>
+            <a:endParaRPr lang="en-US" sz="2400" noProof="0" dirty="0"/>
           </a:p>
         </p:txBody>
       </p:sp>
@@ -19200,6 +19538,90 @@
               <a:rPr lang="en-US" dirty="0"/>
               <a:t>k-Nearest Neighbors</a:t>
             </a:r>
+          </a:p>
+        </p:txBody>
+      </p:sp>
+      <p:sp>
+        <p:nvSpPr>
+          <p:cNvPr id="16" name="TextBox 15">
+            <a:extLst>
+              <a:ext uri="{FF2B5EF4-FFF2-40B4-BE49-F238E27FC236}">
+                <a16:creationId xmlns:a16="http://schemas.microsoft.com/office/drawing/2014/main" id="{4CA870EA-9FA0-3527-D9FC-4D14AAF90D3C}"/>
+              </a:ext>
+            </a:extLst>
+          </p:cNvPr>
+          <p:cNvSpPr txBox="1"/>
+          <p:nvPr/>
+        </p:nvSpPr>
+        <p:spPr>
+          <a:xfrm>
+            <a:off x="299642" y="6013676"/>
+            <a:ext cx="5697394" cy="369332"/>
+          </a:xfrm>
+          <a:prstGeom prst="rect">
+            <a:avLst/>
+          </a:prstGeom>
+          <a:noFill/>
+        </p:spPr>
+        <p:txBody>
+          <a:bodyPr wrap="none" rtlCol="0">
+            <a:spAutoFit/>
+          </a:bodyPr>
+          <a:lstStyle/>
+          <a:p>
+            <a:r>
+              <a:rPr lang="en-US" dirty="0"/>
+              <a:t>Prompt specificity (naïve </a:t>
+            </a:r>
+            <a:r>
+              <a:rPr lang="en-US" dirty="0">
+                <a:sym typeface="Wingdings" panose="05000000000000000000" pitchFamily="2" charset="2"/>
+              </a:rPr>
+              <a:t> …  design specification)</a:t>
+            </a:r>
+            <a:endParaRPr lang="en-US" dirty="0"/>
+          </a:p>
+        </p:txBody>
+      </p:sp>
+      <p:sp>
+        <p:nvSpPr>
+          <p:cNvPr id="21" name="TextBox 20">
+            <a:extLst>
+              <a:ext uri="{FF2B5EF4-FFF2-40B4-BE49-F238E27FC236}">
+                <a16:creationId xmlns:a16="http://schemas.microsoft.com/office/drawing/2014/main" id="{EBEA3F10-024D-07D5-20F8-E8C233912E18}"/>
+              </a:ext>
+            </a:extLst>
+          </p:cNvPr>
+          <p:cNvSpPr txBox="1"/>
+          <p:nvPr/>
+        </p:nvSpPr>
+        <p:spPr>
+          <a:xfrm>
+            <a:off x="6350972" y="5987018"/>
+            <a:ext cx="5697394" cy="369332"/>
+          </a:xfrm>
+          <a:prstGeom prst="rect">
+            <a:avLst/>
+          </a:prstGeom>
+          <a:noFill/>
+        </p:spPr>
+        <p:txBody>
+          <a:bodyPr wrap="none" rtlCol="0">
+            <a:spAutoFit/>
+          </a:bodyPr>
+          <a:lstStyle/>
+          <a:p>
+            <a:r>
+              <a:rPr lang="en-US" dirty="0"/>
+              <a:t>Prompt specificity (naïve </a:t>
+            </a:r>
+            <a:r>
+              <a:rPr lang="en-US" dirty="0">
+                <a:sym typeface="Wingdings" panose="05000000000000000000" pitchFamily="2" charset="2"/>
+              </a:rPr>
+              <a:t> …  design specification)</a:t>
+            </a:r>
+            <a:endParaRPr lang="en-US" dirty="0"/>
           </a:p>
         </p:txBody>
       </p:sp>
@@ -20940,8 +21362,8 @@
         </p:nvCxnSpPr>
         <p:spPr>
           <a:xfrm>
-            <a:off x="1200373" y="956745"/>
-            <a:ext cx="761050" cy="683591"/>
+            <a:off x="1371093" y="956745"/>
+            <a:ext cx="590330" cy="683591"/>
           </a:xfrm>
           <a:prstGeom prst="straightConnector1">
             <a:avLst/>
@@ -20983,7 +21405,7 @@
         <p:spPr>
           <a:xfrm>
             <a:off x="216385" y="587413"/>
-            <a:ext cx="1967975" cy="369332"/>
+            <a:ext cx="2309415" cy="369332"/>
           </a:xfrm>
           <a:prstGeom prst="rect">
             <a:avLst/>
@@ -20998,7 +21420,7 @@
           <a:p>
             <a:r>
               <a:rPr lang="en-US" dirty="0"/>
-              <a:t>Best performance</a:t>
+              <a:t>Best performance (C)</a:t>
             </a:r>
           </a:p>
         </p:txBody>
@@ -23314,14 +23736,15 @@
         </p:nvPicPr>
         <p:blipFill>
           <a:blip r:embed="rId4"/>
+          <a:srcRect t="3764" r="7222" b="4370"/>
           <a:stretch>
             <a:fillRect/>
           </a:stretch>
         </p:blipFill>
         <p:spPr>
           <a:xfrm>
-            <a:off x="108065" y="4043553"/>
-            <a:ext cx="12192000" cy="2727753"/>
+            <a:off x="108065" y="4146210"/>
+            <a:ext cx="11311465" cy="2505875"/>
           </a:xfrm>
           <a:prstGeom prst="rect">
             <a:avLst/>
@@ -36037,7 +36460,10 @@
           <a:bodyPr/>
           <a:lstStyle/>
           <a:p>
-            <a:endParaRPr lang="en-US"/>
+            <a:r>
+              <a:rPr lang="en-US" dirty="0"/>
+              <a:t>Layout abstractions</a:t>
+            </a:r>
           </a:p>
         </p:txBody>
       </p:sp>
@@ -37733,7 +38159,10 @@
           <a:bodyPr/>
           <a:lstStyle/>
           <a:p>
-            <a:endParaRPr lang="en-US"/>
+            <a:r>
+              <a:rPr lang="en-US" dirty="0"/>
+              <a:t>Layout abstractions</a:t>
+            </a:r>
           </a:p>
         </p:txBody>
       </p:sp>
@@ -38687,6 +39116,10 @@
           <a:bodyPr/>
           <a:lstStyle/>
           <a:p>
+            <a:r>
+              <a:rPr lang="en-US" dirty="0"/>
+              <a:t>Traversal abstractions</a:t>
+            </a:r>
             <a:endParaRPr lang="en-US" noProof="0" dirty="0"/>
           </a:p>
         </p:txBody>
@@ -40940,7 +41373,10 @@
           <a:bodyPr/>
           <a:lstStyle/>
           <a:p>
-            <a:endParaRPr lang="en-US" noProof="0" dirty="0"/>
+            <a:r>
+              <a:rPr lang="en-US" noProof="0" dirty="0"/>
+              <a:t>Traversal transformations &amp; parallelization</a:t>
+            </a:r>
           </a:p>
         </p:txBody>
       </p:sp>
@@ -42629,14 +43065,6 @@
 <file path=ppt/slides/slide9.xml><?xml version="1.0" encoding="utf-8"?>
 <p:sld xmlns:a="http://schemas.openxmlformats.org/drawingml/2006/main" xmlns:r="http://schemas.openxmlformats.org/officeDocument/2006/relationships" xmlns:p="http://schemas.openxmlformats.org/presentationml/2006/main">
   <p:cSld>
-    <p:bg>
-      <p:bgPr>
-        <a:solidFill>
-          <a:srgbClr val="FF0000"/>
-        </a:solidFill>
-        <a:effectLst/>
-      </p:bgPr>
-    </p:bg>
     <p:spTree>
       <p:nvGrpSpPr>
         <p:cNvPr id="1" name=""/>
@@ -42672,7 +43100,10 @@
           <a:bodyPr/>
           <a:lstStyle/>
           <a:p>
-            <a:endParaRPr lang="en-US" noProof="0" dirty="0"/>
+            <a:r>
+              <a:rPr lang="en-US" noProof="0" dirty="0"/>
+              <a:t>Autotuning</a:t>
+            </a:r>
           </a:p>
         </p:txBody>
       </p:sp>
@@ -42705,46 +43136,198 @@
         </p:blipFill>
         <p:spPr>
           <a:xfrm>
-            <a:off x="3648473" y="3573561"/>
-            <a:ext cx="4208444" cy="1949986"/>
+            <a:off x="2962939" y="4275380"/>
+            <a:ext cx="5573788" cy="2582620"/>
           </a:xfrm>
           <a:prstGeom prst="rect">
             <a:avLst/>
           </a:prstGeom>
         </p:spPr>
       </p:pic>
-      <p:sp>
-        <p:nvSpPr>
-          <p:cNvPr id="10" name="Rectangle 9">
-            <a:extLst>
-              <a:ext uri="{FF2B5EF4-FFF2-40B4-BE49-F238E27FC236}">
-                <a16:creationId xmlns:a16="http://schemas.microsoft.com/office/drawing/2014/main" id="{156176CF-A5A8-202F-6D91-07F22B4C343A}"/>
-              </a:ext>
-            </a:extLst>
-          </p:cNvPr>
-          <p:cNvSpPr/>
+      <p:pic>
+        <p:nvPicPr>
+          <p:cNvPr id="17" name="Picture 16" descr="OpenTuner - An extensible framework for program autotuning">
+            <a:extLst>
+              <a:ext uri="{FF2B5EF4-FFF2-40B4-BE49-F238E27FC236}">
+                <a16:creationId xmlns:a16="http://schemas.microsoft.com/office/drawing/2014/main" id="{9B62B548-A2CB-44E7-8C14-94F9EC04F63D}"/>
+              </a:ext>
+            </a:extLst>
+          </p:cNvPr>
+          <p:cNvPicPr>
+            <a:picLocks noChangeAspect="1"/>
+          </p:cNvPicPr>
           <p:nvPr/>
-        </p:nvSpPr>
+        </p:nvPicPr>
+        <p:blipFill>
+          <a:blip r:embed="rId4"/>
+          <a:stretch>
+            <a:fillRect/>
+          </a:stretch>
+        </p:blipFill>
         <p:spPr>
           <a:xfrm>
-            <a:off x="838200" y="2467778"/>
-            <a:ext cx="2621096" cy="1729649"/>
+            <a:off x="9068399" y="5485816"/>
+            <a:ext cx="2455817" cy="842437"/>
           </a:xfrm>
           <a:prstGeom prst="rect">
             <a:avLst/>
           </a:prstGeom>
         </p:spPr>
+      </p:pic>
+      <p:pic>
+        <p:nvPicPr>
+          <p:cNvPr id="18" name="Picture 17" descr="Optuna: A hyperparameter optimization framework — Optuna 4.9.0 documentation">
+            <a:extLst>
+              <a:ext uri="{FF2B5EF4-FFF2-40B4-BE49-F238E27FC236}">
+                <a16:creationId xmlns:a16="http://schemas.microsoft.com/office/drawing/2014/main" id="{AF010DE9-B658-4682-CFDF-661E5A062AA0}"/>
+              </a:ext>
+            </a:extLst>
+          </p:cNvPr>
+          <p:cNvPicPr>
+            <a:picLocks noChangeAspect="1"/>
+          </p:cNvPicPr>
+          <p:nvPr/>
+        </p:nvPicPr>
+        <p:blipFill>
+          <a:blip r:embed="rId5"/>
+          <a:stretch>
+            <a:fillRect/>
+          </a:stretch>
+        </p:blipFill>
+        <p:spPr>
+          <a:xfrm>
+            <a:off x="9315748" y="4521033"/>
+            <a:ext cx="2455817" cy="515722"/>
+          </a:xfrm>
+          <a:prstGeom prst="rect">
+            <a:avLst/>
+          </a:prstGeom>
+        </p:spPr>
+      </p:pic>
+      <p:pic>
+        <p:nvPicPr>
+          <p:cNvPr id="19" name="Picture 18" descr="Auto-Tuning Framework (ATF) · GitHub">
+            <a:extLst>
+              <a:ext uri="{FF2B5EF4-FFF2-40B4-BE49-F238E27FC236}">
+                <a16:creationId xmlns:a16="http://schemas.microsoft.com/office/drawing/2014/main" id="{F7F7CFF8-EDA0-77B0-914C-2AD8CCB7F8CA}"/>
+              </a:ext>
+            </a:extLst>
+          </p:cNvPr>
+          <p:cNvPicPr>
+            <a:picLocks noChangeAspect="1"/>
+          </p:cNvPicPr>
+          <p:nvPr/>
+        </p:nvPicPr>
+        <p:blipFill>
+          <a:blip r:embed="rId6"/>
+          <a:srcRect/>
+          <a:stretch>
+            <a:fillRect/>
+          </a:stretch>
+        </p:blipFill>
+        <p:spPr>
+          <a:xfrm>
+            <a:off x="9523323" y="3265015"/>
+            <a:ext cx="1099238" cy="1099238"/>
+          </a:xfrm>
+          <a:prstGeom prst="rect">
+            <a:avLst/>
+          </a:prstGeom>
+        </p:spPr>
+      </p:pic>
+      <p:sp>
+        <p:nvSpPr>
+          <p:cNvPr id="2" name="Date Placeholder 1">
+            <a:extLst>
+              <a:ext uri="{FF2B5EF4-FFF2-40B4-BE49-F238E27FC236}">
+                <a16:creationId xmlns:a16="http://schemas.microsoft.com/office/drawing/2014/main" id="{44FA33F8-BA09-FE20-AA3F-F979C5E8EF66}"/>
+              </a:ext>
+            </a:extLst>
+          </p:cNvPr>
+          <p:cNvSpPr>
+            <a:spLocks noGrp="1"/>
+          </p:cNvSpPr>
+          <p:nvPr>
+            <p:ph type="dt" sz="half" idx="10"/>
+          </p:nvPr>
+        </p:nvSpPr>
+        <p:spPr/>
+        <p:txBody>
+          <a:bodyPr/>
+          <a:lstStyle/>
+          <a:p>
+            <a:fld id="{B7D82220-9CE2-4BC9-B6C9-7A7531EEF273}" type="datetime1">
+              <a:rPr lang="en-US" smtClean="0"/>
+              <a:t>8/28/2026</a:t>
+            </a:fld>
+            <a:endParaRPr lang="en-US"/>
+          </a:p>
+        </p:txBody>
+      </p:sp>
+      <p:sp>
+        <p:nvSpPr>
+          <p:cNvPr id="3" name="Slide Number Placeholder 2">
+            <a:extLst>
+              <a:ext uri="{FF2B5EF4-FFF2-40B4-BE49-F238E27FC236}">
+                <a16:creationId xmlns:a16="http://schemas.microsoft.com/office/drawing/2014/main" id="{9CFF31DD-3BF8-7967-3565-500F50D5E9D9}"/>
+              </a:ext>
+            </a:extLst>
+          </p:cNvPr>
+          <p:cNvSpPr>
+            <a:spLocks noGrp="1"/>
+          </p:cNvSpPr>
+          <p:nvPr>
+            <p:ph type="sldNum" sz="quarter" idx="12"/>
+          </p:nvPr>
+        </p:nvSpPr>
+        <p:spPr/>
+        <p:txBody>
+          <a:bodyPr/>
+          <a:lstStyle/>
+          <a:p>
+            <a:fld id="{DA0BB241-1B5F-4309-9407-9EEA04D9598D}" type="slidenum">
+              <a:rPr lang="en-US" smtClean="0"/>
+              <a:t>9</a:t>
+            </a:fld>
+            <a:endParaRPr lang="en-US"/>
+          </a:p>
+        </p:txBody>
+      </p:sp>
+      <p:sp>
+        <p:nvSpPr>
+          <p:cNvPr id="4" name="Flowchart: Process 3">
+            <a:extLst>
+              <a:ext uri="{FF2B5EF4-FFF2-40B4-BE49-F238E27FC236}">
+                <a16:creationId xmlns:a16="http://schemas.microsoft.com/office/drawing/2014/main" id="{1A3646A4-0501-E64C-9EBA-2A5D70FCC45E}"/>
+              </a:ext>
+            </a:extLst>
+          </p:cNvPr>
+          <p:cNvSpPr/>
+          <p:nvPr/>
+        </p:nvSpPr>
+        <p:spPr>
+          <a:xfrm>
+            <a:off x="2719349" y="1987248"/>
+            <a:ext cx="1923615" cy="842437"/>
+          </a:xfrm>
+          <a:prstGeom prst="flowChartProcess">
+            <a:avLst/>
+          </a:prstGeom>
+          <a:ln>
+            <a:solidFill>
+              <a:schemeClr val="tx1"/>
+            </a:solidFill>
+          </a:ln>
+        </p:spPr>
         <p:style>
-          <a:lnRef idx="2">
-            <a:schemeClr val="accent1">
-              <a:shade val="15000"/>
-            </a:schemeClr>
+          <a:lnRef idx="1">
+            <a:schemeClr val="accent2"/>
           </a:lnRef>
-          <a:fillRef idx="1">
-            <a:schemeClr val="accent1"/>
+          <a:fillRef idx="3">
+            <a:schemeClr val="accent2"/>
           </a:fillRef>
-          <a:effectRef idx="0">
-            <a:schemeClr val="accent1"/>
+          <a:effectRef idx="2">
+            <a:schemeClr val="accent2"/>
           </a:effectRef>
           <a:fontRef idx="minor">
             <a:schemeClr val="lt1"/>
@@ -42756,18 +43339,18 @@
           <a:p>
             <a:pPr algn="ctr"/>
             <a:r>
-              <a:rPr lang="en-US" noProof="0" dirty="0"/>
-              <a:t>Tuning parameters</a:t>
-            </a:r>
-          </a:p>
-        </p:txBody>
-      </p:sp>
-      <p:sp>
-        <p:nvSpPr>
-          <p:cNvPr id="12" name="Rectangle 11">
-            <a:extLst>
-              <a:ext uri="{FF2B5EF4-FFF2-40B4-BE49-F238E27FC236}">
-                <a16:creationId xmlns:a16="http://schemas.microsoft.com/office/drawing/2014/main" id="{EF842F52-719B-B662-4BF8-29ED15AC61DB}"/>
+              <a:rPr lang="en-US" dirty="0"/>
+              <a:t>Parameters in the application</a:t>
+            </a:r>
+          </a:p>
+        </p:txBody>
+      </p:sp>
+      <p:sp>
+        <p:nvSpPr>
+          <p:cNvPr id="6" name="Flowchart: Process 5">
+            <a:extLst>
+              <a:ext uri="{FF2B5EF4-FFF2-40B4-BE49-F238E27FC236}">
+                <a16:creationId xmlns:a16="http://schemas.microsoft.com/office/drawing/2014/main" id="{09D4644A-2975-4E43-85E5-AC04135744E4}"/>
               </a:ext>
             </a:extLst>
           </p:cNvPr>
@@ -42776,24 +43359,240 @@
         </p:nvSpPr>
         <p:spPr>
           <a:xfrm>
-            <a:off x="838200" y="4763226"/>
-            <a:ext cx="2621096" cy="1729649"/>
+            <a:off x="6756788" y="1987248"/>
+            <a:ext cx="1923615" cy="842437"/>
           </a:xfrm>
-          <a:prstGeom prst="rect">
+          <a:prstGeom prst="flowChartProcess">
+            <a:avLst/>
+          </a:prstGeom>
+          <a:ln>
+            <a:solidFill>
+              <a:schemeClr val="tx1"/>
+            </a:solidFill>
+          </a:ln>
+        </p:spPr>
+        <p:style>
+          <a:lnRef idx="1">
+            <a:schemeClr val="accent2"/>
+          </a:lnRef>
+          <a:fillRef idx="3">
+            <a:schemeClr val="accent2"/>
+          </a:fillRef>
+          <a:effectRef idx="2">
+            <a:schemeClr val="accent2"/>
+          </a:effectRef>
+          <a:fontRef idx="minor">
+            <a:schemeClr val="lt1"/>
+          </a:fontRef>
+        </p:style>
+        <p:txBody>
+          <a:bodyPr rtlCol="0" anchor="ctr"/>
+          <a:lstStyle/>
+          <a:p>
+            <a:pPr algn="ctr"/>
+            <a:r>
+              <a:rPr lang="en-US" dirty="0"/>
+              <a:t>Parameters in an </a:t>
+            </a:r>
+            <a:r>
+              <a:rPr lang="en-US" dirty="0" err="1"/>
+              <a:t>autotuner</a:t>
+            </a:r>
+            <a:r>
+              <a:rPr lang="en-US" dirty="0"/>
+              <a:t> script</a:t>
+            </a:r>
+          </a:p>
+        </p:txBody>
+      </p:sp>
+      <p:sp>
+        <p:nvSpPr>
+          <p:cNvPr id="8" name="Arrow: Left-Right 7">
+            <a:extLst>
+              <a:ext uri="{FF2B5EF4-FFF2-40B4-BE49-F238E27FC236}">
+                <a16:creationId xmlns:a16="http://schemas.microsoft.com/office/drawing/2014/main" id="{87FD7390-E206-0701-B169-9DA704B413EE}"/>
+              </a:ext>
+            </a:extLst>
+          </p:cNvPr>
+          <p:cNvSpPr/>
+          <p:nvPr/>
+        </p:nvSpPr>
+        <p:spPr>
+          <a:xfrm>
+            <a:off x="4642964" y="2061867"/>
+            <a:ext cx="2113824" cy="690836"/>
+          </a:xfrm>
+          <a:prstGeom prst="leftRightArrow">
+            <a:avLst>
+              <a:gd name="adj1" fmla="val 41917"/>
+              <a:gd name="adj2" fmla="val 50000"/>
+            </a:avLst>
+          </a:prstGeom>
+          <a:gradFill flip="none" rotWithShape="1">
+            <a:gsLst>
+              <a:gs pos="0">
+                <a:schemeClr val="accent2">
+                  <a:lumMod val="67000"/>
+                </a:schemeClr>
+              </a:gs>
+              <a:gs pos="48000">
+                <a:schemeClr val="accent2">
+                  <a:lumMod val="97000"/>
+                  <a:lumOff val="3000"/>
+                </a:schemeClr>
+              </a:gs>
+              <a:gs pos="100000">
+                <a:schemeClr val="accent2">
+                  <a:lumMod val="60000"/>
+                  <a:lumOff val="40000"/>
+                </a:schemeClr>
+              </a:gs>
+            </a:gsLst>
+            <a:lin ang="16200000" scaled="1"/>
+            <a:tileRect/>
+          </a:gradFill>
+          <a:ln>
+            <a:solidFill>
+              <a:schemeClr val="tx1"/>
+            </a:solidFill>
+          </a:ln>
+        </p:spPr>
+        <p:style>
+          <a:lnRef idx="0">
+            <a:scrgbClr r="0" g="0" b="0"/>
+          </a:lnRef>
+          <a:fillRef idx="0">
+            <a:scrgbClr r="0" g="0" b="0"/>
+          </a:fillRef>
+          <a:effectRef idx="0">
+            <a:scrgbClr r="0" g="0" b="0"/>
+          </a:effectRef>
+          <a:fontRef idx="minor">
+            <a:schemeClr val="lt1"/>
+          </a:fontRef>
+        </p:style>
+        <p:txBody>
+          <a:bodyPr rtlCol="0" anchor="ctr"/>
+          <a:lstStyle/>
+          <a:p>
+            <a:pPr algn="ctr"/>
+            <a:r>
+              <a:rPr lang="en-US" dirty="0"/>
+              <a:t>Communication</a:t>
+            </a:r>
+          </a:p>
+        </p:txBody>
+      </p:sp>
+      <p:sp>
+        <p:nvSpPr>
+          <p:cNvPr id="11" name="Right Brace 10">
+            <a:extLst>
+              <a:ext uri="{FF2B5EF4-FFF2-40B4-BE49-F238E27FC236}">
+                <a16:creationId xmlns:a16="http://schemas.microsoft.com/office/drawing/2014/main" id="{0E210CDB-EAA6-0C9F-CAB9-B16CAFD1D4A6}"/>
+              </a:ext>
+            </a:extLst>
+          </p:cNvPr>
+          <p:cNvSpPr/>
+          <p:nvPr/>
+        </p:nvSpPr>
+        <p:spPr>
+          <a:xfrm rot="5400000">
+            <a:off x="5605927" y="17730"/>
+            <a:ext cx="187902" cy="5961054"/>
+          </a:xfrm>
+          <a:prstGeom prst="rightBrace">
             <a:avLst/>
           </a:prstGeom>
         </p:spPr>
         <p:style>
           <a:lnRef idx="2">
-            <a:schemeClr val="accent1">
-              <a:shade val="15000"/>
-            </a:schemeClr>
+            <a:schemeClr val="accent1"/>
           </a:lnRef>
-          <a:fillRef idx="1">
+          <a:fillRef idx="0">
             <a:schemeClr val="accent1"/>
           </a:fillRef>
-          <a:effectRef idx="0">
+          <a:effectRef idx="1">
             <a:schemeClr val="accent1"/>
+          </a:effectRef>
+          <a:fontRef idx="minor">
+            <a:schemeClr val="tx1"/>
+          </a:fontRef>
+        </p:style>
+        <p:txBody>
+          <a:bodyPr rtlCol="0" anchor="ctr"/>
+          <a:lstStyle/>
+          <a:p>
+            <a:pPr algn="ctr"/>
+            <a:endParaRPr lang="en-US"/>
+          </a:p>
+        </p:txBody>
+      </p:sp>
+      <p:sp>
+        <p:nvSpPr>
+          <p:cNvPr id="13" name="TextBox 12">
+            <a:extLst>
+              <a:ext uri="{FF2B5EF4-FFF2-40B4-BE49-F238E27FC236}">
+                <a16:creationId xmlns:a16="http://schemas.microsoft.com/office/drawing/2014/main" id="{41D587DC-555E-F024-2296-A3954C42F0E6}"/>
+              </a:ext>
+            </a:extLst>
+          </p:cNvPr>
+          <p:cNvSpPr txBox="1"/>
+          <p:nvPr/>
+        </p:nvSpPr>
+        <p:spPr>
+          <a:xfrm>
+            <a:off x="3949108" y="3152109"/>
+            <a:ext cx="3501536" cy="369332"/>
+          </a:xfrm>
+          <a:prstGeom prst="rect">
+            <a:avLst/>
+          </a:prstGeom>
+          <a:noFill/>
+        </p:spPr>
+        <p:txBody>
+          <a:bodyPr wrap="none" rtlCol="0">
+            <a:spAutoFit/>
+          </a:bodyPr>
+          <a:lstStyle/>
+          <a:p>
+            <a:pPr algn="ctr"/>
+            <a:r>
+              <a:rPr lang="en-US" dirty="0"/>
+              <a:t>Too much boilerplate, error-prone</a:t>
+            </a:r>
+          </a:p>
+        </p:txBody>
+      </p:sp>
+      <p:sp>
+        <p:nvSpPr>
+          <p:cNvPr id="15" name="Arrow: Down 14">
+            <a:extLst>
+              <a:ext uri="{FF2B5EF4-FFF2-40B4-BE49-F238E27FC236}">
+                <a16:creationId xmlns:a16="http://schemas.microsoft.com/office/drawing/2014/main" id="{6270A02A-F64D-1590-FA37-729E2E1BC765}"/>
+              </a:ext>
+            </a:extLst>
+          </p:cNvPr>
+          <p:cNvSpPr/>
+          <p:nvPr/>
+        </p:nvSpPr>
+        <p:spPr>
+          <a:xfrm>
+            <a:off x="5200214" y="3664580"/>
+            <a:ext cx="1099238" cy="670577"/>
+          </a:xfrm>
+          <a:prstGeom prst="downArrow">
+            <a:avLst/>
+          </a:prstGeom>
+        </p:spPr>
+        <p:style>
+          <a:lnRef idx="1">
+            <a:schemeClr val="accent6"/>
+          </a:lnRef>
+          <a:fillRef idx="3">
+            <a:schemeClr val="accent6"/>
+          </a:fillRef>
+          <a:effectRef idx="2">
+            <a:schemeClr val="accent6"/>
           </a:effectRef>
           <a:fontRef idx="minor">
             <a:schemeClr val="lt1"/>
@@ -42804,29 +43603,28 @@
           <a:lstStyle/>
           <a:p>
             <a:pPr algn="ctr"/>
-            <a:r>
-              <a:rPr lang="en-US" noProof="0" dirty="0"/>
-              <a:t>code</a:t>
-            </a:r>
+            <a:endParaRPr lang="en-US"/>
           </a:p>
         </p:txBody>
       </p:sp>
       <p:cxnSp>
         <p:nvCxnSpPr>
-          <p:cNvPr id="14" name="Straight Arrow Connector 13">
-            <a:extLst>
-              <a:ext uri="{FF2B5EF4-FFF2-40B4-BE49-F238E27FC236}">
-                <a16:creationId xmlns:a16="http://schemas.microsoft.com/office/drawing/2014/main" id="{B602A479-F122-7128-33EA-B0468E099110}"/>
-              </a:ext>
-            </a:extLst>
-          </p:cNvPr>
-          <p:cNvCxnSpPr/>
+          <p:cNvPr id="21" name="Straight Arrow Connector 20">
+            <a:extLst>
+              <a:ext uri="{FF2B5EF4-FFF2-40B4-BE49-F238E27FC236}">
+                <a16:creationId xmlns:a16="http://schemas.microsoft.com/office/drawing/2014/main" id="{A517191D-6E0A-AA15-0D0A-F36C9AFA3E26}"/>
+              </a:ext>
+            </a:extLst>
+          </p:cNvPr>
+          <p:cNvCxnSpPr>
+            <a:endCxn id="19" idx="1"/>
+          </p:cNvCxnSpPr>
           <p:nvPr/>
         </p:nvCxnSpPr>
         <p:spPr>
-          <a:xfrm>
-            <a:off x="8020594" y="4484914"/>
-            <a:ext cx="1297577" cy="0"/>
+          <a:xfrm flipV="1">
+            <a:off x="8306382" y="3814634"/>
+            <a:ext cx="1216941" cy="904431"/>
           </a:xfrm>
           <a:prstGeom prst="straightConnector1">
             <a:avLst/>
@@ -42850,204 +43648,89 @@
           </a:fontRef>
         </p:style>
       </p:cxnSp>
-      <p:sp>
-        <p:nvSpPr>
-          <p:cNvPr id="16" name="Rectangle 15">
-            <a:extLst>
-              <a:ext uri="{FF2B5EF4-FFF2-40B4-BE49-F238E27FC236}">
-                <a16:creationId xmlns:a16="http://schemas.microsoft.com/office/drawing/2014/main" id="{C357A183-7240-A9A1-5A5E-E5F000C6DC05}"/>
-              </a:ext>
-            </a:extLst>
-          </p:cNvPr>
-          <p:cNvSpPr/>
+      <p:cxnSp>
+        <p:nvCxnSpPr>
+          <p:cNvPr id="23" name="Straight Arrow Connector 22">
+            <a:extLst>
+              <a:ext uri="{FF2B5EF4-FFF2-40B4-BE49-F238E27FC236}">
+                <a16:creationId xmlns:a16="http://schemas.microsoft.com/office/drawing/2014/main" id="{77DDBBE2-A63E-674B-08AE-0EFF57E0FE30}"/>
+              </a:ext>
+            </a:extLst>
+          </p:cNvPr>
+          <p:cNvCxnSpPr>
+            <a:cxnSpLocks/>
+            <a:endCxn id="18" idx="1"/>
+          </p:cNvCxnSpPr>
           <p:nvPr/>
-        </p:nvSpPr>
+        </p:nvCxnSpPr>
         <p:spPr>
           <a:xfrm>
-            <a:off x="9394372" y="3683729"/>
-            <a:ext cx="2621096" cy="1729649"/>
+            <a:off x="8306382" y="4719065"/>
+            <a:ext cx="1009366" cy="59829"/>
           </a:xfrm>
-          <a:prstGeom prst="rect">
+          <a:prstGeom prst="straightConnector1">
             <a:avLst/>
           </a:prstGeom>
+          <a:ln>
+            <a:tailEnd type="triangle"/>
+          </a:ln>
         </p:spPr>
         <p:style>
           <a:lnRef idx="2">
-            <a:schemeClr val="accent1">
-              <a:shade val="15000"/>
-            </a:schemeClr>
+            <a:schemeClr val="accent1"/>
           </a:lnRef>
-          <a:fillRef idx="1">
+          <a:fillRef idx="0">
             <a:schemeClr val="accent1"/>
           </a:fillRef>
-          <a:effectRef idx="0">
+          <a:effectRef idx="1">
             <a:schemeClr val="accent1"/>
           </a:effectRef>
           <a:fontRef idx="minor">
-            <a:schemeClr val="lt1"/>
+            <a:schemeClr val="tx1"/>
           </a:fontRef>
         </p:style>
-        <p:txBody>
-          <a:bodyPr rtlCol="0" anchor="ctr"/>
-          <a:lstStyle/>
-          <a:p>
-            <a:pPr algn="ctr"/>
-            <a:r>
-              <a:rPr lang="en-US" noProof="0" dirty="0"/>
-              <a:t>Optimized application</a:t>
-            </a:r>
-          </a:p>
-        </p:txBody>
-      </p:sp>
-      <p:pic>
-        <p:nvPicPr>
-          <p:cNvPr id="17" name="Picture 16" descr="OpenTuner - An extensible framework for program autotuning">
-            <a:extLst>
-              <a:ext uri="{FF2B5EF4-FFF2-40B4-BE49-F238E27FC236}">
-                <a16:creationId xmlns:a16="http://schemas.microsoft.com/office/drawing/2014/main" id="{9B62B548-A2CB-44E7-8C14-94F9EC04F63D}"/>
-              </a:ext>
-            </a:extLst>
-          </p:cNvPr>
-          <p:cNvPicPr>
-            <a:picLocks noChangeAspect="1"/>
-          </p:cNvPicPr>
+      </p:cxnSp>
+      <p:cxnSp>
+        <p:nvCxnSpPr>
+          <p:cNvPr id="25" name="Straight Arrow Connector 24">
+            <a:extLst>
+              <a:ext uri="{FF2B5EF4-FFF2-40B4-BE49-F238E27FC236}">
+                <a16:creationId xmlns:a16="http://schemas.microsoft.com/office/drawing/2014/main" id="{DEE38BC2-DE6F-53AE-919A-9277CD5405A3}"/>
+              </a:ext>
+            </a:extLst>
+          </p:cNvPr>
+          <p:cNvCxnSpPr>
+            <a:endCxn id="17" idx="1"/>
+          </p:cNvCxnSpPr>
           <p:nvPr/>
-        </p:nvPicPr>
-        <p:blipFill>
-          <a:blip r:embed="rId4"/>
-          <a:stretch>
-            <a:fillRect/>
-          </a:stretch>
-        </p:blipFill>
+        </p:nvCxnSpPr>
         <p:spPr>
           <a:xfrm>
-            <a:off x="4324489" y="5513019"/>
-            <a:ext cx="2856411" cy="979856"/>
+            <a:off x="8306382" y="4719065"/>
+            <a:ext cx="762017" cy="1187970"/>
           </a:xfrm>
-          <a:prstGeom prst="rect">
+          <a:prstGeom prst="straightConnector1">
             <a:avLst/>
           </a:prstGeom>
+          <a:ln>
+            <a:tailEnd type="triangle"/>
+          </a:ln>
         </p:spPr>
-      </p:pic>
-      <p:pic>
-        <p:nvPicPr>
-          <p:cNvPr id="18" name="Picture 17" descr="Optuna: A hyperparameter optimization framework — Optuna 4.9.0 documentation">
-            <a:extLst>
-              <a:ext uri="{FF2B5EF4-FFF2-40B4-BE49-F238E27FC236}">
-                <a16:creationId xmlns:a16="http://schemas.microsoft.com/office/drawing/2014/main" id="{AF010DE9-B658-4682-CFDF-661E5A062AA0}"/>
-              </a:ext>
-            </a:extLst>
-          </p:cNvPr>
-          <p:cNvPicPr>
-            <a:picLocks noChangeAspect="1"/>
-          </p:cNvPicPr>
-          <p:nvPr/>
-        </p:nvPicPr>
-        <p:blipFill>
-          <a:blip r:embed="rId5"/>
-          <a:stretch>
-            <a:fillRect/>
-          </a:stretch>
-        </p:blipFill>
-        <p:spPr>
-          <a:xfrm>
-            <a:off x="7707086" y="5750350"/>
-            <a:ext cx="2455817" cy="515722"/>
-          </a:xfrm>
-          <a:prstGeom prst="rect">
-            <a:avLst/>
-          </a:prstGeom>
-        </p:spPr>
-      </p:pic>
-      <p:pic>
-        <p:nvPicPr>
-          <p:cNvPr id="19" name="Picture 18" descr="Auto-Tuning Framework (ATF) · GitHub">
-            <a:extLst>
-              <a:ext uri="{FF2B5EF4-FFF2-40B4-BE49-F238E27FC236}">
-                <a16:creationId xmlns:a16="http://schemas.microsoft.com/office/drawing/2014/main" id="{F7F7CFF8-EDA0-77B0-914C-2AD8CCB7F8CA}"/>
-              </a:ext>
-            </a:extLst>
-          </p:cNvPr>
-          <p:cNvPicPr>
-            <a:picLocks noChangeAspect="1"/>
-          </p:cNvPicPr>
-          <p:nvPr/>
-        </p:nvPicPr>
-        <p:blipFill>
-          <a:blip r:embed="rId6"/>
-          <a:srcRect/>
-          <a:stretch>
-            <a:fillRect/>
-          </a:stretch>
-        </p:blipFill>
-        <p:spPr>
-          <a:xfrm>
-            <a:off x="10474420" y="5500211"/>
-            <a:ext cx="1099238" cy="1099238"/>
-          </a:xfrm>
-          <a:prstGeom prst="rect">
-            <a:avLst/>
-          </a:prstGeom>
-        </p:spPr>
-      </p:pic>
-      <p:sp>
-        <p:nvSpPr>
-          <p:cNvPr id="2" name="Date Placeholder 1">
-            <a:extLst>
-              <a:ext uri="{FF2B5EF4-FFF2-40B4-BE49-F238E27FC236}">
-                <a16:creationId xmlns:a16="http://schemas.microsoft.com/office/drawing/2014/main" id="{44FA33F8-BA09-FE20-AA3F-F979C5E8EF66}"/>
-              </a:ext>
-            </a:extLst>
-          </p:cNvPr>
-          <p:cNvSpPr>
-            <a:spLocks noGrp="1"/>
-          </p:cNvSpPr>
-          <p:nvPr>
-            <p:ph type="dt" sz="half" idx="10"/>
-          </p:nvPr>
-        </p:nvSpPr>
-        <p:spPr/>
-        <p:txBody>
-          <a:bodyPr/>
-          <a:lstStyle/>
-          <a:p>
-            <a:fld id="{B7D82220-9CE2-4BC9-B6C9-7A7531EEF273}" type="datetime1">
-              <a:rPr lang="en-US" smtClean="0"/>
-              <a:t>8/28/2026</a:t>
-            </a:fld>
-            <a:endParaRPr lang="en-US"/>
-          </a:p>
-        </p:txBody>
-      </p:sp>
-      <p:sp>
-        <p:nvSpPr>
-          <p:cNvPr id="3" name="Slide Number Placeholder 2">
-            <a:extLst>
-              <a:ext uri="{FF2B5EF4-FFF2-40B4-BE49-F238E27FC236}">
-                <a16:creationId xmlns:a16="http://schemas.microsoft.com/office/drawing/2014/main" id="{9CFF31DD-3BF8-7967-3565-500F50D5E9D9}"/>
-              </a:ext>
-            </a:extLst>
-          </p:cNvPr>
-          <p:cNvSpPr>
-            <a:spLocks noGrp="1"/>
-          </p:cNvSpPr>
-          <p:nvPr>
-            <p:ph type="sldNum" sz="quarter" idx="12"/>
-          </p:nvPr>
-        </p:nvSpPr>
-        <p:spPr/>
-        <p:txBody>
-          <a:bodyPr/>
-          <a:lstStyle/>
-          <a:p>
-            <a:fld id="{DA0BB241-1B5F-4309-9407-9EEA04D9598D}" type="slidenum">
-              <a:rPr lang="en-US" smtClean="0"/>
-              <a:t>9</a:t>
-            </a:fld>
-            <a:endParaRPr lang="en-US"/>
-          </a:p>
-        </p:txBody>
-      </p:sp>
+        <p:style>
+          <a:lnRef idx="2">
+            <a:schemeClr val="accent1"/>
+          </a:lnRef>
+          <a:fillRef idx="0">
+            <a:schemeClr val="accent1"/>
+          </a:fillRef>
+          <a:effectRef idx="1">
+            <a:schemeClr val="accent1"/>
+          </a:effectRef>
+          <a:fontRef idx="minor">
+            <a:schemeClr val="tx1"/>
+          </a:fontRef>
+        </p:style>
+      </p:cxnSp>
     </p:spTree>
     <p:extLst>
       <p:ext uri="{BB962C8B-B14F-4D97-AF65-F5344CB8AC3E}">

</xml_diff>

<commit_message>
ver 3 almost done
</commit_message>
<xml_diff>
--- a/slides/Optimizing Memory Layouts and Traversal Orders in High-Performance Computing.pptx
+++ b/slides/Optimizing Memory Layouts and Traversal Orders in High-Performance Computing.pptx
@@ -5,7 +5,7 @@
     <p:sldMasterId id="2147483648" r:id="rId1"/>
   </p:sldMasterIdLst>
   <p:notesMasterIdLst>
-    <p:notesMasterId r:id="rId33"/>
+    <p:notesMasterId r:id="rId37"/>
   </p:notesMasterIdLst>
   <p:sldIdLst>
     <p:sldId id="256" r:id="rId2"/>
@@ -39,6 +39,10 @@
     <p:sldId id="266" r:id="rId30"/>
     <p:sldId id="312" r:id="rId31"/>
     <p:sldId id="262" r:id="rId32"/>
+    <p:sldId id="320" r:id="rId33"/>
+    <p:sldId id="318" r:id="rId34"/>
+    <p:sldId id="319" r:id="rId35"/>
+    <p:sldId id="317" r:id="rId36"/>
   </p:sldIdLst>
   <p:sldSz cx="12192000" cy="6858000"/>
   <p:notesSz cx="6858000" cy="9144000"/>
@@ -186,9 +190,13 @@
             <p14:sldId id="312"/>
           </p14:sldIdLst>
         </p14:section>
-        <p14:section name="Reviewers' comments" id="{40190F67-0659-405D-810E-4AC194B72FA5}">
+        <p14:section name="Review comments and questions" id="{40190F67-0659-405D-810E-4AC194B72FA5}">
           <p14:sldIdLst>
             <p14:sldId id="262"/>
+            <p14:sldId id="320"/>
+            <p14:sldId id="318"/>
+            <p14:sldId id="319"/>
+            <p14:sldId id="317"/>
           </p14:sldIdLst>
         </p14:section>
         <p14:section name="supplementary" id="{5D95F6E9-DF15-476C-BE69-BBEF48AA8B86}">
@@ -299,7 +307,7 @@
           <a:p>
             <a:fld id="{34A5C982-A1C5-4AC2-B4BF-466515DA1494}" type="datetimeFigureOut">
               <a:rPr lang="en-US" smtClean="0"/>
-              <a:t>8/29/2026</a:t>
+              <a:t>8/30/2026</a:t>
             </a:fld>
             <a:endParaRPr lang="en-US"/>
           </a:p>
@@ -1417,6 +1425,29 @@
               <a:t>And, in terms of performance, it does not add overhead compared to a hand-written native MPI distributed computation.</a:t>
             </a:r>
           </a:p>
+          <a:p>
+            <a:endParaRPr lang="en-US" dirty="0"/>
+          </a:p>
+          <a:p>
+            <a:r>
+              <a:rPr lang="en-US" dirty="0"/>
+              <a:t>The plot on the left computes on small data of various layouts and highlights the possible performance overhead introduced by the MPI bindings,</a:t>
+            </a:r>
+            <a:br>
+              <a:rPr lang="en-US" dirty="0"/>
+            </a:br>
+            <a:r>
+              <a:rPr lang="en-US" dirty="0"/>
+              <a:t>while the one on the  right highlights the performance overhead introduced by the abstractions used for computation</a:t>
+            </a:r>
+            <a:br>
+              <a:rPr lang="en-US" dirty="0"/>
+            </a:br>
+            <a:r>
+              <a:rPr lang="en-US" dirty="0"/>
+              <a:t>as well as the differences between efficient layouts of data structures (shown on the x axis).</a:t>
+            </a:r>
+          </a:p>
         </p:txBody>
       </p:sp>
       <p:sp>
@@ -3362,53 +3393,91 @@
             <a:endParaRPr lang="en-US" dirty="0"/>
           </a:p>
           <a:p>
+            <a:endParaRPr lang="en-US" dirty="0"/>
+          </a:p>
+          <a:p>
             <a:r>
               <a:rPr lang="en-US" dirty="0"/>
-              <a:t>TODO MOTIVATION</a:t>
-            </a:r>
-          </a:p>
-          <a:p>
+              <a:t>We have shown that both abstractions and LLMs can be practical solutions for simplifying algorithm design &amp; optimization.</a:t>
+            </a:r>
+          </a:p>
+          <a:p>
+            <a:r>
+              <a:rPr lang="en-US" dirty="0"/>
+              <a:t>Both have their strengths and weaknesses;</a:t>
+            </a:r>
+          </a:p>
+          <a:p>
+            <a:pPr marL="171450" indent="-171450">
+              <a:buFontTx/>
+              <a:buChar char="-"/>
+            </a:pPr>
+            <a:r>
+              <a:rPr lang="en-US" dirty="0"/>
+              <a:t>reasonable use of abstractions usually leads to interpretable code with some safety checks and guarantees</a:t>
+            </a:r>
+            <a:br>
+              <a:rPr lang="en-US" dirty="0"/>
+            </a:br>
+            <a:r>
+              <a:rPr lang="en-US" dirty="0"/>
+              <a:t>ensured by the transformation being applied by a deterministic system,</a:t>
+            </a:r>
+            <a:br>
+              <a:rPr lang="en-US" dirty="0"/>
+            </a:br>
+            <a:r>
+              <a:rPr lang="en-US" dirty="0"/>
+              <a:t>while their use may require some learning and the abstractions may not apply to many problems well.</a:t>
+            </a:r>
+          </a:p>
+          <a:p>
+            <a:pPr marL="171450" indent="-171450">
+              <a:buFontTx/>
+              <a:buChar char="-"/>
+            </a:pPr>
+            <a:r>
+              <a:rPr lang="en-US" dirty="0"/>
+              <a:t>LLMs are pretty much unparalleled in the flexibility of their use, and they enable fully automatic solutions that may even</a:t>
+            </a:r>
+            <a:br>
+              <a:rPr lang="en-US" dirty="0"/>
+            </a:br>
+            <a:r>
+              <a:rPr lang="en-US" dirty="0"/>
+              <a:t>interface with the user via natural language; on the other hand, they are inherently stochastic and they may output</a:t>
+            </a:r>
+            <a:br>
+              <a:rPr lang="en-US" dirty="0"/>
+            </a:br>
+            <a:r>
+              <a:rPr lang="en-US" dirty="0"/>
+              <a:t>complex and hard to analyze code with many hidden bugs.</a:t>
+            </a:r>
+          </a:p>
+          <a:p>
+            <a:pPr marL="0" indent="0">
+              <a:buFontTx/>
+              <a:buNone/>
+            </a:pPr>
             <a:endParaRPr lang="en-US" dirty="0"/>
           </a:p>
           <a:p>
+            <a:pPr marL="0" indent="0">
+              <a:buFontTx/>
+              <a:buNone/>
+            </a:pPr>
             <a:r>
               <a:rPr lang="en-US" dirty="0"/>
-              <a:t>OLD:</a:t>
-            </a:r>
-          </a:p>
-          <a:p>
-            <a:r>
+              <a:t>In our next work, we have thus studied a possible combination of these two approaches to see if the abstractions improve</a:t>
+            </a:r>
+            <a:br>
               <a:rPr lang="en-US" dirty="0"/>
-              <a:t>Then, we have studied whether the earlier studied abstractions enabling layout- and traversal-agnostic design significantly improve the correctness and efficiency of the generated parallel code during optimization tasks.</a:t>
-            </a:r>
-          </a:p>
-          <a:p>
-            <a:endParaRPr lang="en-US" dirty="0"/>
-          </a:p>
-          <a:p>
+            </a:br>
             <a:r>
               <a:rPr lang="en-US" dirty="0"/>
-              <a:t>For that, we have compared 3 abstractions (Halide, Exo and </a:t>
-            </a:r>
-            <a:r>
-              <a:rPr lang="en-US" dirty="0" err="1"/>
-              <a:t>Noarr</a:t>
-            </a:r>
-            <a:r>
-              <a:rPr lang="en-US" dirty="0"/>
-              <a:t>) with different designs and principles as well as outputting pure C on the 30 algorithms from the </a:t>
-            </a:r>
-            <a:r>
-              <a:rPr lang="en-US" dirty="0" err="1"/>
-              <a:t>PolyBench</a:t>
-            </a:r>
-            <a:r>
-              <a:rPr lang="en-US" dirty="0"/>
-              <a:t>/C benchmark suite.</a:t>
-            </a:r>
-          </a:p>
-          <a:p>
-            <a:endParaRPr lang="en-US" dirty="0"/>
+              <a:t>the performance and correctness of LLM outputs.</a:t>
+            </a:r>
           </a:p>
         </p:txBody>
       </p:sp>
@@ -3895,15 +3964,16 @@
           <a:p>
             <a:r>
               <a:rPr lang="en-US" dirty="0"/>
-              <a:t>So they can, </a:t>
-            </a:r>
-            <a:r>
-              <a:rPr lang="en-US"/>
-              <a:t>for example, </a:t>
-            </a:r>
+              <a:t>So they can, for example, look up how to use specific abstractions or what algorithm designs to use.</a:t>
+            </a:r>
+          </a:p>
+          <a:p>
+            <a:endParaRPr lang="en-US" dirty="0"/>
+          </a:p>
+          <a:p>
             <a:r>
               <a:rPr lang="en-US" dirty="0"/>
-              <a:t>look up how to use specific abstractions or what algorithm designs to use.</a:t>
+              <a:t>It might also be interesting to explore abstraction design with LLMs as their explicit target</a:t>
             </a:r>
           </a:p>
         </p:txBody>
@@ -4214,6 +4284,341 @@
     <p:extLst>
       <p:ext uri="{BB962C8B-B14F-4D97-AF65-F5344CB8AC3E}">
         <p14:creationId xmlns:p14="http://schemas.microsoft.com/office/powerpoint/2010/main" val="2622264098"/>
+      </p:ext>
+    </p:extLst>
+  </p:cSld>
+  <p:clrMapOvr>
+    <a:masterClrMapping/>
+  </p:clrMapOvr>
+</p:notes>
+</file>
+
+<file path=ppt/notesSlides/notesSlide30.xml><?xml version="1.0" encoding="utf-8"?>
+<p:notes xmlns:a="http://schemas.openxmlformats.org/drawingml/2006/main" xmlns:r="http://schemas.openxmlformats.org/officeDocument/2006/relationships" xmlns:p="http://schemas.openxmlformats.org/presentationml/2006/main">
+  <p:cSld>
+    <p:spTree>
+      <p:nvGrpSpPr>
+        <p:cNvPr id="1" name=""/>
+        <p:cNvGrpSpPr/>
+        <p:nvPr/>
+      </p:nvGrpSpPr>
+      <p:grpSpPr>
+        <a:xfrm>
+          <a:off x="0" y="0"/>
+          <a:ext cx="0" cy="0"/>
+          <a:chOff x="0" y="0"/>
+          <a:chExt cx="0" cy="0"/>
+        </a:xfrm>
+      </p:grpSpPr>
+      <p:sp>
+        <p:nvSpPr>
+          <p:cNvPr id="2" name="Slide Image Placeholder 1"/>
+          <p:cNvSpPr>
+            <a:spLocks noGrp="1" noRot="1" noChangeAspect="1"/>
+          </p:cNvSpPr>
+          <p:nvPr>
+            <p:ph type="sldImg"/>
+          </p:nvPr>
+        </p:nvSpPr>
+        <p:spPr/>
+      </p:sp>
+      <p:sp>
+        <p:nvSpPr>
+          <p:cNvPr id="3" name="Notes Placeholder 2"/>
+          <p:cNvSpPr>
+            <a:spLocks noGrp="1"/>
+          </p:cNvSpPr>
+          <p:nvPr>
+            <p:ph type="body" idx="1"/>
+          </p:nvPr>
+        </p:nvSpPr>
+        <p:spPr/>
+        <p:txBody>
+          <a:bodyPr/>
+          <a:lstStyle/>
+          <a:p>
+            <a:pPr marL="171450" indent="-171450">
+              <a:buFont typeface="Wingdings" panose="05000000000000000000" pitchFamily="2" charset="2"/>
+              <a:buChar char="Ø"/>
+            </a:pPr>
+            <a:r>
+              <a:rPr lang="en-US" dirty="0"/>
+              <a:t>On the other hand, the text suffers from overstated novelty. The text is written in a way </a:t>
+            </a:r>
+            <a:r>
+              <a:rPr lang="en-US" dirty="0" err="1"/>
+              <a:t>thatrisks</a:t>
+            </a:r>
+            <a:r>
+              <a:rPr lang="en-US" dirty="0"/>
+              <a:t> giving the impression that the candidate invented the two </a:t>
+            </a:r>
+            <a:r>
+              <a:rPr lang="en-US" dirty="0" err="1"/>
+              <a:t>optimisation</a:t>
+            </a:r>
+            <a:r>
+              <a:rPr lang="en-US" dirty="0"/>
+              <a:t> paradigms (lay-out-agnostic and traversal-agnostic design) outright. This is misleading and, notably, does </a:t>
+            </a:r>
+            <a:r>
+              <a:rPr lang="en-US" dirty="0" err="1"/>
+              <a:t>notserve</a:t>
+            </a:r>
+            <a:r>
+              <a:rPr lang="en-US" dirty="0"/>
+              <a:t> the candidate's own case well: the candidate's contribution here is best </a:t>
+            </a:r>
+            <a:r>
+              <a:rPr lang="en-US" dirty="0" err="1"/>
+              <a:t>characterised</a:t>
+            </a:r>
+            <a:r>
+              <a:rPr lang="en-US" dirty="0"/>
+              <a:t> </a:t>
+            </a:r>
+            <a:r>
+              <a:rPr lang="en-US" dirty="0" err="1"/>
+              <a:t>asa</a:t>
+            </a:r>
+            <a:r>
+              <a:rPr lang="en-US" dirty="0"/>
+              <a:t> minor, incremental one within an existing landscape of </a:t>
+            </a:r>
+            <a:r>
+              <a:rPr lang="en-US" dirty="0" err="1"/>
+              <a:t>optimisations</a:t>
+            </a:r>
+            <a:r>
+              <a:rPr lang="en-US" dirty="0"/>
+              <a:t>. Which of these </a:t>
+            </a:r>
+            <a:r>
+              <a:rPr lang="en-US" dirty="0" err="1"/>
+              <a:t>ideascan</a:t>
+            </a:r>
+            <a:r>
+              <a:rPr lang="en-US" dirty="0"/>
+              <a:t> also be found in software like </a:t>
+            </a:r>
+            <a:r>
+              <a:rPr lang="en-US" dirty="0" err="1"/>
+              <a:t>Kokkos</a:t>
+            </a:r>
+            <a:r>
+              <a:rPr lang="en-US" dirty="0"/>
+              <a:t> or OpenMP's loop transformations?</a:t>
+            </a:r>
+          </a:p>
+          <a:p>
+            <a:pPr marL="171450" indent="-171450">
+              <a:buFont typeface="Wingdings" panose="05000000000000000000" pitchFamily="2" charset="2"/>
+              <a:buChar char="Ø"/>
+            </a:pPr>
+            <a:endParaRPr lang="en-US" dirty="0"/>
+          </a:p>
+          <a:p>
+            <a:pPr marL="0" indent="0">
+              <a:buFont typeface="Wingdings" panose="05000000000000000000" pitchFamily="2" charset="2"/>
+              <a:buNone/>
+            </a:pPr>
+            <a:r>
+              <a:rPr lang="en-US" dirty="0" err="1"/>
+              <a:t>Kokkos</a:t>
+            </a:r>
+            <a:r>
+              <a:rPr lang="en-US" dirty="0"/>
+              <a:t> views and their related </a:t>
+            </a:r>
+            <a:r>
+              <a:rPr lang="en-US" dirty="0" err="1"/>
+              <a:t>mdspans</a:t>
+            </a:r>
+            <a:r>
+              <a:rPr lang="en-US" dirty="0"/>
+              <a:t> from the standard C++ library support some level of layout agnosticism; namely, they enable defining general interfaces for multidimensional arrays as well as their (rectangular) sub-arrays, which might be useful, for example, for divide-and-conquer strategies in layout-agnostic algorithms.</a:t>
+            </a:r>
+          </a:p>
+          <a:p>
+            <a:pPr marL="0" indent="0">
+              <a:buFont typeface="Wingdings" panose="05000000000000000000" pitchFamily="2" charset="2"/>
+              <a:buNone/>
+            </a:pPr>
+            <a:endParaRPr lang="en-US" dirty="0"/>
+          </a:p>
+          <a:p>
+            <a:pPr marL="0" indent="0">
+              <a:buFont typeface="Wingdings" panose="05000000000000000000" pitchFamily="2" charset="2"/>
+              <a:buNone/>
+            </a:pPr>
+            <a:r>
+              <a:rPr lang="en-US" dirty="0"/>
+              <a:t>This, even by itself, is very useful; </a:t>
+            </a:r>
+            <a:r>
+              <a:rPr lang="en-US" dirty="0" err="1"/>
+              <a:t>CUTe</a:t>
+            </a:r>
+            <a:r>
+              <a:rPr lang="en-US" dirty="0"/>
+              <a:t> layouts even support more general layout algebra and thus come</a:t>
+            </a:r>
+            <a:r>
+              <a:rPr lang="en-US" baseline="0" dirty="0"/>
+              <a:t> very close to our approach. This might help, for example, define other derived views or temporary memory buffers in layout-agnostic way. However, their use is limited to Tensors and the design primarily focuses GPU computation.</a:t>
+            </a:r>
+            <a:br>
+              <a:rPr lang="en-US" baseline="0" dirty="0"/>
+            </a:br>
+            <a:br>
+              <a:rPr lang="en-US" baseline="0" dirty="0"/>
+            </a:br>
+            <a:r>
+              <a:rPr lang="en-US" baseline="0" dirty="0"/>
+              <a:t>New standards of OpenMP support powerful loop transformations, which might be used to optimize algorithms. While this doesn’t enable traversal-agnostic design of algorithms, it offers a good alternative with similar benefits in many use cases. Especially for algorithms that have a natural loop nest representation that allows for such transformations.</a:t>
+            </a:r>
+          </a:p>
+          <a:p>
+            <a:pPr marL="0" indent="0">
+              <a:buFont typeface="Wingdings" panose="05000000000000000000" pitchFamily="2" charset="2"/>
+              <a:buNone/>
+            </a:pPr>
+            <a:endParaRPr lang="en-US" baseline="0" dirty="0"/>
+          </a:p>
+          <a:p>
+            <a:pPr marL="0" indent="0">
+              <a:buFont typeface="Wingdings" panose="05000000000000000000" pitchFamily="2" charset="2"/>
+              <a:buNone/>
+            </a:pPr>
+            <a:r>
+              <a:rPr lang="en-US" baseline="0" dirty="0"/>
+              <a:t>In the thesis (section 2.3.3), we lightly discuss some traversal-agnostic features of </a:t>
+            </a:r>
+            <a:r>
+              <a:rPr lang="en-US" baseline="0" dirty="0" err="1"/>
+              <a:t>GridTools</a:t>
+            </a:r>
+            <a:r>
+              <a:rPr lang="en-US" baseline="0" dirty="0"/>
+              <a:t> and RAJA.</a:t>
+            </a:r>
+          </a:p>
+        </p:txBody>
+      </p:sp>
+      <p:sp>
+        <p:nvSpPr>
+          <p:cNvPr id="4" name="Slide Number Placeholder 3"/>
+          <p:cNvSpPr>
+            <a:spLocks noGrp="1"/>
+          </p:cNvSpPr>
+          <p:nvPr>
+            <p:ph type="sldNum" sz="quarter" idx="5"/>
+          </p:nvPr>
+        </p:nvSpPr>
+        <p:spPr/>
+        <p:txBody>
+          <a:bodyPr/>
+          <a:lstStyle/>
+          <a:p>
+            <a:fld id="{FA8FD632-245B-410D-BCC4-8BF8D37AB67F}" type="slidenum">
+              <a:rPr lang="en-US" smtClean="0"/>
+              <a:t>33</a:t>
+            </a:fld>
+            <a:endParaRPr lang="en-US"/>
+          </a:p>
+        </p:txBody>
+      </p:sp>
+    </p:spTree>
+    <p:extLst>
+      <p:ext uri="{BB962C8B-B14F-4D97-AF65-F5344CB8AC3E}">
+        <p14:creationId xmlns:p14="http://schemas.microsoft.com/office/powerpoint/2010/main" val="3640698019"/>
+      </p:ext>
+    </p:extLst>
+  </p:cSld>
+  <p:clrMapOvr>
+    <a:masterClrMapping/>
+  </p:clrMapOvr>
+</p:notes>
+</file>
+
+<file path=ppt/notesSlides/notesSlide31.xml><?xml version="1.0" encoding="utf-8"?>
+<p:notes xmlns:a="http://schemas.openxmlformats.org/drawingml/2006/main" xmlns:r="http://schemas.openxmlformats.org/officeDocument/2006/relationships" xmlns:p="http://schemas.openxmlformats.org/presentationml/2006/main">
+  <p:cSld>
+    <p:spTree>
+      <p:nvGrpSpPr>
+        <p:cNvPr id="1" name=""/>
+        <p:cNvGrpSpPr/>
+        <p:nvPr/>
+      </p:nvGrpSpPr>
+      <p:grpSpPr>
+        <a:xfrm>
+          <a:off x="0" y="0"/>
+          <a:ext cx="0" cy="0"/>
+          <a:chOff x="0" y="0"/>
+          <a:chExt cx="0" cy="0"/>
+        </a:xfrm>
+      </p:grpSpPr>
+      <p:sp>
+        <p:nvSpPr>
+          <p:cNvPr id="2" name="Slide Image Placeholder 1"/>
+          <p:cNvSpPr>
+            <a:spLocks noGrp="1" noRot="1" noChangeAspect="1"/>
+          </p:cNvSpPr>
+          <p:nvPr>
+            <p:ph type="sldImg"/>
+          </p:nvPr>
+        </p:nvSpPr>
+        <p:spPr/>
+      </p:sp>
+      <p:sp>
+        <p:nvSpPr>
+          <p:cNvPr id="3" name="Notes Placeholder 2"/>
+          <p:cNvSpPr>
+            <a:spLocks noGrp="1"/>
+          </p:cNvSpPr>
+          <p:nvPr>
+            <p:ph type="body" idx="1"/>
+          </p:nvPr>
+        </p:nvSpPr>
+        <p:spPr/>
+        <p:txBody>
+          <a:bodyPr/>
+          <a:lstStyle/>
+          <a:p>
+            <a:r>
+              <a:rPr lang="en-US" dirty="0"/>
+              <a:t>I currently struggle with interpreting the reviewer’s concern, will return to that.</a:t>
+            </a:r>
+          </a:p>
+        </p:txBody>
+      </p:sp>
+      <p:sp>
+        <p:nvSpPr>
+          <p:cNvPr id="4" name="Slide Number Placeholder 3"/>
+          <p:cNvSpPr>
+            <a:spLocks noGrp="1"/>
+          </p:cNvSpPr>
+          <p:nvPr>
+            <p:ph type="sldNum" sz="quarter" idx="5"/>
+          </p:nvPr>
+        </p:nvSpPr>
+        <p:spPr/>
+        <p:txBody>
+          <a:bodyPr/>
+          <a:lstStyle/>
+          <a:p>
+            <a:fld id="{FA8FD632-245B-410D-BCC4-8BF8D37AB67F}" type="slidenum">
+              <a:rPr lang="en-US" smtClean="0"/>
+              <a:t>35</a:t>
+            </a:fld>
+            <a:endParaRPr lang="en-US"/>
+          </a:p>
+        </p:txBody>
+      </p:sp>
+    </p:spTree>
+    <p:extLst>
+      <p:ext uri="{BB962C8B-B14F-4D97-AF65-F5344CB8AC3E}">
+        <p14:creationId xmlns:p14="http://schemas.microsoft.com/office/powerpoint/2010/main" val="4179121380"/>
       </p:ext>
     </p:extLst>
   </p:cSld>
@@ -5545,7 +5950,7 @@
           <a:p>
             <a:fld id="{B82E97BC-A89E-4CE1-A4AA-4F62BE5183B8}" type="datetime1">
               <a:rPr lang="en-US" smtClean="0"/>
-              <a:t>8/29/2026</a:t>
+              <a:t>8/30/2026</a:t>
             </a:fld>
             <a:endParaRPr lang="en-US" dirty="0"/>
           </a:p>
@@ -5743,7 +6148,7 @@
           <a:p>
             <a:fld id="{6653D07F-EA1B-48C7-9BD0-6BED24C9ED67}" type="datetime1">
               <a:rPr lang="en-US" smtClean="0"/>
-              <a:t>8/29/2026</a:t>
+              <a:t>8/30/2026</a:t>
             </a:fld>
             <a:endParaRPr lang="en-US"/>
           </a:p>
@@ -5951,7 +6356,7 @@
           <a:p>
             <a:fld id="{FDA4DF48-C056-4522-9BC2-031A9D197A93}" type="datetime1">
               <a:rPr lang="en-US" smtClean="0"/>
-              <a:t>8/29/2026</a:t>
+              <a:t>8/30/2026</a:t>
             </a:fld>
             <a:endParaRPr lang="en-US"/>
           </a:p>
@@ -6149,7 +6554,7 @@
           <a:p>
             <a:fld id="{358C28A6-2969-482E-9A3B-5E13FCD8DD03}" type="datetime1">
               <a:rPr lang="en-US" smtClean="0"/>
-              <a:t>8/29/2026</a:t>
+              <a:t>8/30/2026</a:t>
             </a:fld>
             <a:endParaRPr lang="en-US"/>
           </a:p>
@@ -6424,7 +6829,7 @@
           <a:p>
             <a:fld id="{34463B7D-19AB-44BF-8DCC-FDF87A48CBC2}" type="datetime1">
               <a:rPr lang="en-US" smtClean="0"/>
-              <a:t>8/29/2026</a:t>
+              <a:t>8/30/2026</a:t>
             </a:fld>
             <a:endParaRPr lang="en-US"/>
           </a:p>
@@ -6689,7 +7094,7 @@
           <a:p>
             <a:fld id="{149987F8-7DF8-4BA7-9208-8F32E5310AB4}" type="datetime1">
               <a:rPr lang="en-US" smtClean="0"/>
-              <a:t>8/29/2026</a:t>
+              <a:t>8/30/2026</a:t>
             </a:fld>
             <a:endParaRPr lang="en-US"/>
           </a:p>
@@ -7101,7 +7506,7 @@
           <a:p>
             <a:fld id="{D64A8A3C-441E-40C3-8DCE-8F1C2EB0BADE}" type="datetime1">
               <a:rPr lang="en-US" smtClean="0"/>
-              <a:t>8/29/2026</a:t>
+              <a:t>8/30/2026</a:t>
             </a:fld>
             <a:endParaRPr lang="en-US"/>
           </a:p>
@@ -7242,7 +7647,7 @@
           <a:p>
             <a:fld id="{1AB26190-46ED-4A0C-A5E8-CDBCA5C2D5C3}" type="datetime1">
               <a:rPr lang="en-US" smtClean="0"/>
-              <a:t>8/29/2026</a:t>
+              <a:t>8/30/2026</a:t>
             </a:fld>
             <a:endParaRPr lang="en-US"/>
           </a:p>
@@ -7355,7 +7760,7 @@
           <a:p>
             <a:fld id="{2E4D20BF-4C0E-41E5-B4FC-9D48FCD3AF33}" type="datetime1">
               <a:rPr lang="en-US" smtClean="0"/>
-              <a:t>8/29/2026</a:t>
+              <a:t>8/30/2026</a:t>
             </a:fld>
             <a:endParaRPr lang="en-US"/>
           </a:p>
@@ -7666,7 +8071,7 @@
           <a:p>
             <a:fld id="{BEACC2DC-9E3A-44FF-B316-55456058A0CC}" type="datetime1">
               <a:rPr lang="en-US" smtClean="0"/>
-              <a:t>8/29/2026</a:t>
+              <a:t>8/30/2026</a:t>
             </a:fld>
             <a:endParaRPr lang="en-US"/>
           </a:p>
@@ -7954,7 +8359,7 @@
           <a:p>
             <a:fld id="{A4FE5055-4E7B-4EEB-A9E4-14CB598FDB7C}" type="datetime1">
               <a:rPr lang="en-US" smtClean="0"/>
-              <a:t>8/29/2026</a:t>
+              <a:t>8/30/2026</a:t>
             </a:fld>
             <a:endParaRPr lang="en-US"/>
           </a:p>
@@ -8195,7 +8600,7 @@
           <a:p>
             <a:fld id="{FDEB8912-975C-4DE8-9A59-8B9C133AEEC5}" type="datetime1">
               <a:rPr lang="en-US" smtClean="0"/>
-              <a:t>8/29/2026</a:t>
+              <a:t>8/30/2026</a:t>
             </a:fld>
             <a:endParaRPr lang="en-US"/>
           </a:p>
@@ -8701,7 +9106,7 @@
           <a:p>
             <a:fld id="{A606699D-645B-483D-AF03-42C342BFDBA5}" type="datetime1">
               <a:rPr lang="en-US" noProof="0" smtClean="0"/>
-              <a:t>8/29/2026</a:t>
+              <a:t>8/30/2026</a:t>
             </a:fld>
             <a:endParaRPr lang="en-US" noProof="0" dirty="0"/>
           </a:p>
@@ -8894,7 +9299,7 @@
           <a:p>
             <a:fld id="{1A21DD6E-5048-4D3D-823A-657D259BCC38}" type="datetime1">
               <a:rPr lang="en-US" noProof="0" smtClean="0"/>
-              <a:t>8/29/2026</a:t>
+              <a:t>8/30/2026</a:t>
             </a:fld>
             <a:endParaRPr lang="en-US" noProof="0" dirty="0"/>
           </a:p>
@@ -9454,7 +9859,7 @@
           <a:p>
             <a:fld id="{426C01F6-8E80-4F75-81D6-E35CABA351AD}" type="datetime1">
               <a:rPr lang="en-US" noProof="0" smtClean="0"/>
-              <a:t>8/29/2026</a:t>
+              <a:t>8/30/2026</a:t>
             </a:fld>
             <a:endParaRPr lang="en-US" noProof="0" dirty="0"/>
           </a:p>
@@ -9921,7 +10326,7 @@
           <a:p>
             <a:fld id="{6D8553D1-8D82-4D70-AAA7-91480DF3CCDB}" type="datetime1">
               <a:rPr lang="en-US" noProof="0" smtClean="0"/>
-              <a:t>8/29/2026</a:t>
+              <a:t>8/30/2026</a:t>
             </a:fld>
             <a:endParaRPr lang="en-US" noProof="0" dirty="0"/>
           </a:p>
@@ -10953,8 +11358,8 @@
           </a:p>
         </p:txBody>
       </p:sp>
-      <mc:AlternateContent xmlns:mc="http://schemas.openxmlformats.org/markup-compatibility/2006">
-        <mc:Choice xmlns:a14="http://schemas.microsoft.com/office/drawing/2010/main" Requires="a14">
+      <mc:AlternateContent xmlns:mc="http://schemas.openxmlformats.org/markup-compatibility/2006" xmlns:a14="http://schemas.microsoft.com/office/drawing/2010/main">
+        <mc:Choice Requires="a14">
           <p:sp>
             <p:nvSpPr>
               <p:cNvPr id="31" name="TextBox 30">
@@ -11018,7 +11423,7 @@
             </p:txBody>
           </p:sp>
         </mc:Choice>
-        <mc:Fallback>
+        <mc:Fallback xmlns="">
           <p:sp>
             <p:nvSpPr>
               <p:cNvPr id="31" name="TextBox 30">
@@ -11063,8 +11468,8 @@
           </p:sp>
         </mc:Fallback>
       </mc:AlternateContent>
-      <mc:AlternateContent xmlns:mc="http://schemas.openxmlformats.org/markup-compatibility/2006">
-        <mc:Choice xmlns:a14="http://schemas.microsoft.com/office/drawing/2010/main" Requires="a14">
+      <mc:AlternateContent xmlns:mc="http://schemas.openxmlformats.org/markup-compatibility/2006" xmlns:a14="http://schemas.microsoft.com/office/drawing/2010/main">
+        <mc:Choice Requires="a14">
           <p:sp>
             <p:nvSpPr>
               <p:cNvPr id="33" name="TextBox 32">
@@ -11093,6 +11498,7 @@
               </a:bodyPr>
               <a:lstStyle/>
               <a:p>
+                <a:pPr/>
                 <a14:m>
                   <m:oMathPara xmlns:m="http://schemas.openxmlformats.org/officeDocument/2006/math">
                     <m:oMath>
@@ -11113,7 +11519,7 @@
             </p:txBody>
           </p:sp>
         </mc:Choice>
-        <mc:Fallback>
+        <mc:Fallback xmlns="">
           <p:sp>
             <p:nvSpPr>
               <p:cNvPr id="33" name="TextBox 32">
@@ -11620,7 +12026,7 @@
           <a:p>
             <a:fld id="{2B64091F-5E68-4514-9CCC-EC8E47A52419}" type="datetime1">
               <a:rPr lang="en-US" noProof="0" smtClean="0"/>
-              <a:t>8/29/2026</a:t>
+              <a:t>8/30/2026</a:t>
             </a:fld>
             <a:endParaRPr lang="en-US" noProof="0" dirty="0"/>
           </a:p>
@@ -12613,7 +13019,7 @@
           <a:p>
             <a:fld id="{D2B8A75C-05AF-4892-8E0E-22A5D3C1A1D7}" type="datetime1">
               <a:rPr lang="en-US" noProof="0" smtClean="0"/>
-              <a:t>8/29/2026</a:t>
+              <a:t>8/30/2026</a:t>
             </a:fld>
             <a:endParaRPr lang="en-US" noProof="0" dirty="0"/>
           </a:p>
@@ -12729,7 +13135,7 @@
           <a:p>
             <a:fld id="{3282519B-8553-4EB5-804E-C162E89AEEEB}" type="datetime1">
               <a:rPr lang="en-US" noProof="0" smtClean="0"/>
-              <a:t>8/29/2026</a:t>
+              <a:t>8/30/2026</a:t>
             </a:fld>
             <a:endParaRPr lang="en-US" noProof="0" dirty="0"/>
           </a:p>
@@ -12971,8 +13377,8 @@
           </a:prstGeom>
         </p:spPr>
       </p:pic>
-      <mc:AlternateContent xmlns:mc="http://schemas.openxmlformats.org/markup-compatibility/2006">
-        <mc:Choice xmlns:a14="http://schemas.microsoft.com/office/drawing/2010/main" Requires="a14">
+      <mc:AlternateContent xmlns:mc="http://schemas.openxmlformats.org/markup-compatibility/2006" xmlns:a14="http://schemas.microsoft.com/office/drawing/2010/main">
+        <mc:Choice Requires="a14">
           <p:sp>
             <p:nvSpPr>
               <p:cNvPr id="19" name="TextBox 18">
@@ -13001,6 +13407,7 @@
               </a:bodyPr>
               <a:lstStyle/>
               <a:p>
+                <a:pPr/>
                 <a14:m>
                   <m:oMathPara xmlns:m="http://schemas.openxmlformats.org/officeDocument/2006/math">
                     <m:oMath>
@@ -13348,7 +13755,7 @@
             </p:txBody>
           </p:sp>
         </mc:Choice>
-        <mc:Fallback>
+        <mc:Fallback xmlns="">
           <p:sp>
             <p:nvSpPr>
               <p:cNvPr id="19" name="TextBox 18">
@@ -13702,7 +14109,7 @@
           <a:p>
             <a:fld id="{3282519B-8553-4EB5-804E-C162E89AEEEB}" type="datetime1">
               <a:rPr lang="en-US" noProof="0" smtClean="0"/>
-              <a:t>8/29/2026</a:t>
+              <a:t>8/30/2026</a:t>
             </a:fld>
             <a:endParaRPr lang="en-US" noProof="0" dirty="0"/>
           </a:p>
@@ -15143,7 +15550,7 @@
           <a:p>
             <a:fld id="{1AB26190-46ED-4A0C-A5E8-CDBCA5C2D5C3}" type="datetime1">
               <a:rPr lang="en-US" noProof="0" smtClean="0"/>
-              <a:t>8/29/2026</a:t>
+              <a:t>8/30/2026</a:t>
             </a:fld>
             <a:endParaRPr lang="en-US" noProof="0" dirty="0"/>
           </a:p>
@@ -15851,7 +16258,7 @@
           <a:p>
             <a:fld id="{78C2F5E9-57E3-4F5E-A80F-B6C9DE65874A}" type="datetime1">
               <a:rPr lang="en-US" noProof="0" smtClean="0"/>
-              <a:t>8/29/2026</a:t>
+              <a:t>8/30/2026</a:t>
             </a:fld>
             <a:endParaRPr lang="en-US" noProof="0" dirty="0"/>
           </a:p>
@@ -16119,7 +16526,7 @@
           <a:p>
             <a:fld id="{1AB26190-46ED-4A0C-A5E8-CDBCA5C2D5C3}" type="datetime1">
               <a:rPr lang="en-US" noProof="0" smtClean="0"/>
-              <a:t>8/29/2026</a:t>
+              <a:t>8/30/2026</a:t>
             </a:fld>
             <a:endParaRPr lang="en-US" noProof="0" dirty="0"/>
           </a:p>
@@ -16329,14 +16736,14 @@
             <a:pPr algn="ctr"/>
             <a:r>
               <a:rPr lang="en-US" dirty="0"/>
-              <a:t>I am an LLM</a:t>
+              <a:t>I, an LLM,</a:t>
             </a:r>
             <a:br>
               <a:rPr lang="en-US" dirty="0"/>
             </a:br>
             <a:r>
               <a:rPr lang="en-US" dirty="0"/>
-              <a:t>and I can do that too</a:t>
+              <a:t>can do that too</a:t>
             </a:r>
           </a:p>
         </p:txBody>
@@ -16504,7 +16911,7 @@
           <a:p>
             <a:fld id="{0DAFEF2F-EB87-44F5-8698-5E050EDDA902}" type="datetime1">
               <a:rPr lang="en-US" noProof="0" smtClean="0"/>
-              <a:t>8/29/2026</a:t>
+              <a:t>8/30/2026</a:t>
             </a:fld>
             <a:endParaRPr lang="en-US" noProof="0" dirty="0"/>
           </a:p>
@@ -16691,7 +17098,7 @@
           <a:p>
             <a:fld id="{33B56853-0028-4549-B0D0-953613129C64}" type="datetime1">
               <a:rPr lang="en-US" noProof="0" smtClean="0"/>
-              <a:t>8/29/2026</a:t>
+              <a:t>8/30/2026</a:t>
             </a:fld>
             <a:endParaRPr lang="en-US" noProof="0" dirty="0"/>
           </a:p>
@@ -16808,14 +17215,14 @@
             <a:pPr algn="ctr"/>
             <a:r>
               <a:rPr lang="en-US" dirty="0"/>
-              <a:t>I am an LLM</a:t>
+              <a:t>I, an LLM,</a:t>
             </a:r>
             <a:br>
               <a:rPr lang="en-US" dirty="0"/>
             </a:br>
             <a:r>
               <a:rPr lang="en-US" dirty="0"/>
-              <a:t>and I can do that too</a:t>
+              <a:t>can do that too</a:t>
             </a:r>
           </a:p>
         </p:txBody>
@@ -16901,7 +17308,7 @@
           <a:p>
             <a:fld id="{472E5813-EC9F-4C36-A7F2-49C469A5F96E}" type="datetime1">
               <a:rPr lang="en-US" noProof="0" smtClean="0"/>
-              <a:t>8/29/2026</a:t>
+              <a:t>8/30/2026</a:t>
             </a:fld>
             <a:endParaRPr lang="en-US" noProof="0" dirty="0"/>
           </a:p>
@@ -17758,7 +18165,7 @@
           <a:p>
             <a:fld id="{472E5813-EC9F-4C36-A7F2-49C469A5F96E}" type="datetime1">
               <a:rPr lang="en-US" noProof="0" smtClean="0"/>
-              <a:t>8/29/2026</a:t>
+              <a:t>8/30/2026</a:t>
             </a:fld>
             <a:endParaRPr lang="en-US" noProof="0" dirty="0"/>
           </a:p>
@@ -18953,7 +19360,7 @@
           <a:p>
             <a:fld id="{15A7FB29-F852-41FB-A0DF-F798C9C0E438}" type="datetime1">
               <a:rPr lang="en-US" noProof="0" smtClean="0"/>
-              <a:t>8/29/2026</a:t>
+              <a:t>8/30/2026</a:t>
             </a:fld>
             <a:endParaRPr lang="en-US" noProof="0" dirty="0"/>
           </a:p>
@@ -19297,7 +19704,7 @@
           <a:p>
             <a:fld id="{15A7FB29-F852-41FB-A0DF-F798C9C0E438}" type="datetime1">
               <a:rPr lang="en-US" noProof="0" smtClean="0"/>
-              <a:t>8/29/2026</a:t>
+              <a:t>8/30/2026</a:t>
             </a:fld>
             <a:endParaRPr lang="en-US" noProof="0" dirty="0"/>
           </a:p>
@@ -19502,14 +19909,6 @@
 <file path=ppt/slides/slide25.xml><?xml version="1.0" encoding="utf-8"?>
 <p:sld xmlns:a="http://schemas.openxmlformats.org/drawingml/2006/main" xmlns:r="http://schemas.openxmlformats.org/officeDocument/2006/relationships" xmlns:p="http://schemas.openxmlformats.org/presentationml/2006/main">
   <p:cSld>
-    <p:bg>
-      <p:bgPr>
-        <a:solidFill>
-          <a:srgbClr val="FFFF00"/>
-        </a:solidFill>
-        <a:effectLst/>
-      </p:bgPr>
-    </p:bg>
     <p:spTree>
       <p:nvGrpSpPr>
         <p:cNvPr id="1" name=""/>
@@ -19575,7 +19974,7 @@
           <a:p>
             <a:fld id="{1AB26190-46ED-4A0C-A5E8-CDBCA5C2D5C3}" type="datetime1">
               <a:rPr lang="en-US" smtClean="0"/>
-              <a:t>8/29/2026</a:t>
+              <a:t>8/30/2026</a:t>
             </a:fld>
             <a:endParaRPr lang="en-US"/>
           </a:p>
@@ -19610,6 +20009,1084 @@
           </a:p>
         </p:txBody>
       </p:sp>
+      <p:sp>
+        <p:nvSpPr>
+          <p:cNvPr id="6" name="TextBox 5">
+            <a:extLst>
+              <a:ext uri="{FF2B5EF4-FFF2-40B4-BE49-F238E27FC236}">
+                <a16:creationId xmlns:a16="http://schemas.microsoft.com/office/drawing/2014/main" id="{19E4B8FB-55FB-804F-D918-87CA02061244}"/>
+              </a:ext>
+            </a:extLst>
+          </p:cNvPr>
+          <p:cNvSpPr txBox="1"/>
+          <p:nvPr/>
+        </p:nvSpPr>
+        <p:spPr>
+          <a:xfrm>
+            <a:off x="2598019" y="3224688"/>
+            <a:ext cx="1474203" cy="408623"/>
+          </a:xfrm>
+          <a:prstGeom prst="roundRect">
+            <a:avLst/>
+          </a:prstGeom>
+        </p:spPr>
+        <p:style>
+          <a:lnRef idx="1">
+            <a:schemeClr val="accent4"/>
+          </a:lnRef>
+          <a:fillRef idx="2">
+            <a:schemeClr val="accent4"/>
+          </a:fillRef>
+          <a:effectRef idx="1">
+            <a:schemeClr val="accent4"/>
+          </a:effectRef>
+          <a:fontRef idx="minor">
+            <a:schemeClr val="dk1"/>
+          </a:fontRef>
+        </p:style>
+        <p:txBody>
+          <a:bodyPr wrap="none" rtlCol="0">
+            <a:spAutoFit/>
+          </a:bodyPr>
+          <a:lstStyle/>
+          <a:p>
+            <a:pPr algn="ctr"/>
+            <a:r>
+              <a:rPr lang="en-US" dirty="0"/>
+              <a:t>Abstractions</a:t>
+            </a:r>
+          </a:p>
+        </p:txBody>
+      </p:sp>
+      <p:sp>
+        <p:nvSpPr>
+          <p:cNvPr id="7" name="TextBox 6">
+            <a:extLst>
+              <a:ext uri="{FF2B5EF4-FFF2-40B4-BE49-F238E27FC236}">
+                <a16:creationId xmlns:a16="http://schemas.microsoft.com/office/drawing/2014/main" id="{11B47FF7-FF2B-E35C-C5DC-D36095FC9DA6}"/>
+              </a:ext>
+            </a:extLst>
+          </p:cNvPr>
+          <p:cNvSpPr txBox="1"/>
+          <p:nvPr/>
+        </p:nvSpPr>
+        <p:spPr>
+          <a:xfrm>
+            <a:off x="8119778" y="3224688"/>
+            <a:ext cx="1474203" cy="408623"/>
+          </a:xfrm>
+          <a:prstGeom prst="roundRect">
+            <a:avLst/>
+          </a:prstGeom>
+        </p:spPr>
+        <p:style>
+          <a:lnRef idx="1">
+            <a:schemeClr val="accent4"/>
+          </a:lnRef>
+          <a:fillRef idx="2">
+            <a:schemeClr val="accent4"/>
+          </a:fillRef>
+          <a:effectRef idx="1">
+            <a:schemeClr val="accent4"/>
+          </a:effectRef>
+          <a:fontRef idx="minor">
+            <a:schemeClr val="dk1"/>
+          </a:fontRef>
+        </p:style>
+        <p:txBody>
+          <a:bodyPr wrap="square" rtlCol="0">
+            <a:spAutoFit/>
+          </a:bodyPr>
+          <a:lstStyle/>
+          <a:p>
+            <a:pPr algn="ctr"/>
+            <a:r>
+              <a:rPr lang="en-US" dirty="0"/>
+              <a:t>LLMs</a:t>
+            </a:r>
+          </a:p>
+        </p:txBody>
+      </p:sp>
+      <p:sp>
+        <p:nvSpPr>
+          <p:cNvPr id="9" name="TextBox 8">
+            <a:extLst>
+              <a:ext uri="{FF2B5EF4-FFF2-40B4-BE49-F238E27FC236}">
+                <a16:creationId xmlns:a16="http://schemas.microsoft.com/office/drawing/2014/main" id="{ABDD9E2C-DB94-9465-C838-8C4F60DDBD33}"/>
+              </a:ext>
+            </a:extLst>
+          </p:cNvPr>
+          <p:cNvSpPr txBox="1"/>
+          <p:nvPr/>
+        </p:nvSpPr>
+        <p:spPr>
+          <a:xfrm>
+            <a:off x="3863658" y="2566736"/>
+            <a:ext cx="4464684" cy="408623"/>
+          </a:xfrm>
+          <a:prstGeom prst="roundRect">
+            <a:avLst/>
+          </a:prstGeom>
+        </p:spPr>
+        <p:style>
+          <a:lnRef idx="1">
+            <a:schemeClr val="accent4"/>
+          </a:lnRef>
+          <a:fillRef idx="2">
+            <a:schemeClr val="accent4"/>
+          </a:fillRef>
+          <a:effectRef idx="1">
+            <a:schemeClr val="accent4"/>
+          </a:effectRef>
+          <a:fontRef idx="minor">
+            <a:schemeClr val="dk1"/>
+          </a:fontRef>
+        </p:style>
+        <p:txBody>
+          <a:bodyPr wrap="none" rtlCol="0">
+            <a:spAutoFit/>
+          </a:bodyPr>
+          <a:lstStyle/>
+          <a:p>
+            <a:pPr algn="ctr"/>
+            <a:r>
+              <a:rPr lang="en-US" dirty="0"/>
+              <a:t>Simplifying algorithm design &amp; optimization</a:t>
+            </a:r>
+          </a:p>
+        </p:txBody>
+      </p:sp>
+      <p:cxnSp>
+        <p:nvCxnSpPr>
+          <p:cNvPr id="11" name="Straight Arrow Connector 10">
+            <a:extLst>
+              <a:ext uri="{FF2B5EF4-FFF2-40B4-BE49-F238E27FC236}">
+                <a16:creationId xmlns:a16="http://schemas.microsoft.com/office/drawing/2014/main" id="{BF39B83B-4C76-1D1B-19E8-3F68E2DC03EF}"/>
+              </a:ext>
+            </a:extLst>
+          </p:cNvPr>
+          <p:cNvCxnSpPr>
+            <a:cxnSpLocks/>
+            <a:endCxn id="6" idx="0"/>
+          </p:cNvCxnSpPr>
+          <p:nvPr/>
+        </p:nvCxnSpPr>
+        <p:spPr>
+          <a:xfrm flipH="1">
+            <a:off x="3335121" y="2975359"/>
+            <a:ext cx="851868" cy="249329"/>
+          </a:xfrm>
+          <a:prstGeom prst="straightConnector1">
+            <a:avLst/>
+          </a:prstGeom>
+          <a:ln>
+            <a:tailEnd type="triangle"/>
+          </a:ln>
+        </p:spPr>
+        <p:style>
+          <a:lnRef idx="2">
+            <a:schemeClr val="accent1"/>
+          </a:lnRef>
+          <a:fillRef idx="0">
+            <a:schemeClr val="accent1"/>
+          </a:fillRef>
+          <a:effectRef idx="1">
+            <a:schemeClr val="accent1"/>
+          </a:effectRef>
+          <a:fontRef idx="minor">
+            <a:schemeClr val="tx1"/>
+          </a:fontRef>
+        </p:style>
+      </p:cxnSp>
+      <p:cxnSp>
+        <p:nvCxnSpPr>
+          <p:cNvPr id="13" name="Straight Arrow Connector 12">
+            <a:extLst>
+              <a:ext uri="{FF2B5EF4-FFF2-40B4-BE49-F238E27FC236}">
+                <a16:creationId xmlns:a16="http://schemas.microsoft.com/office/drawing/2014/main" id="{EDC6E5E0-5E49-A14A-1A69-8F74E4643E8D}"/>
+              </a:ext>
+            </a:extLst>
+          </p:cNvPr>
+          <p:cNvCxnSpPr>
+            <a:cxnSpLocks/>
+            <a:endCxn id="7" idx="0"/>
+          </p:cNvCxnSpPr>
+          <p:nvPr/>
+        </p:nvCxnSpPr>
+        <p:spPr>
+          <a:xfrm>
+            <a:off x="8005013" y="2975359"/>
+            <a:ext cx="851867" cy="249329"/>
+          </a:xfrm>
+          <a:prstGeom prst="straightConnector1">
+            <a:avLst/>
+          </a:prstGeom>
+          <a:ln>
+            <a:tailEnd type="triangle"/>
+          </a:ln>
+        </p:spPr>
+        <p:style>
+          <a:lnRef idx="2">
+            <a:schemeClr val="accent1"/>
+          </a:lnRef>
+          <a:fillRef idx="0">
+            <a:schemeClr val="accent1"/>
+          </a:fillRef>
+          <a:effectRef idx="1">
+            <a:schemeClr val="accent1"/>
+          </a:effectRef>
+          <a:fontRef idx="minor">
+            <a:schemeClr val="tx1"/>
+          </a:fontRef>
+        </p:style>
+      </p:cxnSp>
+      <p:sp>
+        <p:nvSpPr>
+          <p:cNvPr id="14" name="TextBox 13">
+            <a:extLst>
+              <a:ext uri="{FF2B5EF4-FFF2-40B4-BE49-F238E27FC236}">
+                <a16:creationId xmlns:a16="http://schemas.microsoft.com/office/drawing/2014/main" id="{FBC68EF8-2BD7-3EAB-EBBD-E77F253B6551}"/>
+              </a:ext>
+            </a:extLst>
+          </p:cNvPr>
+          <p:cNvSpPr txBox="1"/>
+          <p:nvPr/>
+        </p:nvSpPr>
+        <p:spPr>
+          <a:xfrm>
+            <a:off x="1272695" y="3977774"/>
+            <a:ext cx="1506491" cy="408623"/>
+          </a:xfrm>
+          <a:prstGeom prst="roundRect">
+            <a:avLst/>
+          </a:prstGeom>
+        </p:spPr>
+        <p:style>
+          <a:lnRef idx="1">
+            <a:schemeClr val="accent6"/>
+          </a:lnRef>
+          <a:fillRef idx="2">
+            <a:schemeClr val="accent6"/>
+          </a:fillRef>
+          <a:effectRef idx="1">
+            <a:schemeClr val="accent6"/>
+          </a:effectRef>
+          <a:fontRef idx="minor">
+            <a:schemeClr val="dk1"/>
+          </a:fontRef>
+        </p:style>
+        <p:txBody>
+          <a:bodyPr wrap="none" rtlCol="0">
+            <a:spAutoFit/>
+          </a:bodyPr>
+          <a:lstStyle/>
+          <a:p>
+            <a:pPr algn="ctr"/>
+            <a:r>
+              <a:rPr lang="en-US" dirty="0"/>
+              <a:t>Interpretable</a:t>
+            </a:r>
+          </a:p>
+        </p:txBody>
+      </p:sp>
+      <p:sp>
+        <p:nvSpPr>
+          <p:cNvPr id="16" name="TextBox 15">
+            <a:extLst>
+              <a:ext uri="{FF2B5EF4-FFF2-40B4-BE49-F238E27FC236}">
+                <a16:creationId xmlns:a16="http://schemas.microsoft.com/office/drawing/2014/main" id="{145ED155-D147-8024-5E14-14189388C2EE}"/>
+              </a:ext>
+            </a:extLst>
+          </p:cNvPr>
+          <p:cNvSpPr txBox="1"/>
+          <p:nvPr/>
+        </p:nvSpPr>
+        <p:spPr>
+          <a:xfrm>
+            <a:off x="7339256" y="3981345"/>
+            <a:ext cx="989086" cy="408623"/>
+          </a:xfrm>
+          <a:prstGeom prst="roundRect">
+            <a:avLst/>
+          </a:prstGeom>
+        </p:spPr>
+        <p:style>
+          <a:lnRef idx="1">
+            <a:schemeClr val="accent6"/>
+          </a:lnRef>
+          <a:fillRef idx="2">
+            <a:schemeClr val="accent6"/>
+          </a:fillRef>
+          <a:effectRef idx="1">
+            <a:schemeClr val="accent6"/>
+          </a:effectRef>
+          <a:fontRef idx="minor">
+            <a:schemeClr val="dk1"/>
+          </a:fontRef>
+        </p:style>
+        <p:txBody>
+          <a:bodyPr wrap="none" rtlCol="0">
+            <a:spAutoFit/>
+          </a:bodyPr>
+          <a:lstStyle/>
+          <a:p>
+            <a:pPr algn="ctr"/>
+            <a:r>
+              <a:rPr lang="en-US" dirty="0"/>
+              <a:t>Flexible</a:t>
+            </a:r>
+          </a:p>
+        </p:txBody>
+      </p:sp>
+      <p:sp>
+        <p:nvSpPr>
+          <p:cNvPr id="20" name="TextBox 19">
+            <a:extLst>
+              <a:ext uri="{FF2B5EF4-FFF2-40B4-BE49-F238E27FC236}">
+                <a16:creationId xmlns:a16="http://schemas.microsoft.com/office/drawing/2014/main" id="{2BAB4CE5-730D-15C7-FE5D-C7F62D2A14B1}"/>
+              </a:ext>
+            </a:extLst>
+          </p:cNvPr>
+          <p:cNvSpPr txBox="1"/>
+          <p:nvPr/>
+        </p:nvSpPr>
+        <p:spPr>
+          <a:xfrm>
+            <a:off x="6954309" y="4525356"/>
+            <a:ext cx="1758979" cy="408623"/>
+          </a:xfrm>
+          <a:prstGeom prst="roundRect">
+            <a:avLst/>
+          </a:prstGeom>
+        </p:spPr>
+        <p:style>
+          <a:lnRef idx="1">
+            <a:schemeClr val="accent6"/>
+          </a:lnRef>
+          <a:fillRef idx="2">
+            <a:schemeClr val="accent6"/>
+          </a:fillRef>
+          <a:effectRef idx="1">
+            <a:schemeClr val="accent6"/>
+          </a:effectRef>
+          <a:fontRef idx="minor">
+            <a:schemeClr val="dk1"/>
+          </a:fontRef>
+        </p:style>
+        <p:txBody>
+          <a:bodyPr wrap="none" rtlCol="0">
+            <a:spAutoFit/>
+          </a:bodyPr>
+          <a:lstStyle/>
+          <a:p>
+            <a:pPr algn="ctr"/>
+            <a:r>
+              <a:rPr lang="en-US" dirty="0"/>
+              <a:t>Fully automatic</a:t>
+            </a:r>
+          </a:p>
+        </p:txBody>
+      </p:sp>
+      <p:sp>
+        <p:nvSpPr>
+          <p:cNvPr id="22" name="TextBox 21">
+            <a:extLst>
+              <a:ext uri="{FF2B5EF4-FFF2-40B4-BE49-F238E27FC236}">
+                <a16:creationId xmlns:a16="http://schemas.microsoft.com/office/drawing/2014/main" id="{00AE5E7C-9BCF-9753-06F8-EAF716A55760}"/>
+              </a:ext>
+            </a:extLst>
+          </p:cNvPr>
+          <p:cNvSpPr txBox="1"/>
+          <p:nvPr/>
+        </p:nvSpPr>
+        <p:spPr>
+          <a:xfrm>
+            <a:off x="1307498" y="4526548"/>
+            <a:ext cx="1436883" cy="408623"/>
+          </a:xfrm>
+          <a:prstGeom prst="roundRect">
+            <a:avLst/>
+          </a:prstGeom>
+        </p:spPr>
+        <p:style>
+          <a:lnRef idx="1">
+            <a:schemeClr val="accent6"/>
+          </a:lnRef>
+          <a:fillRef idx="2">
+            <a:schemeClr val="accent6"/>
+          </a:fillRef>
+          <a:effectRef idx="1">
+            <a:schemeClr val="accent6"/>
+          </a:effectRef>
+          <a:fontRef idx="minor">
+            <a:schemeClr val="dk1"/>
+          </a:fontRef>
+        </p:style>
+        <p:txBody>
+          <a:bodyPr wrap="none" rtlCol="0">
+            <a:spAutoFit/>
+          </a:bodyPr>
+          <a:lstStyle/>
+          <a:p>
+            <a:pPr algn="ctr"/>
+            <a:r>
+              <a:rPr lang="en-US" dirty="0"/>
+              <a:t>Some safety</a:t>
+            </a:r>
+          </a:p>
+        </p:txBody>
+      </p:sp>
+      <p:sp>
+        <p:nvSpPr>
+          <p:cNvPr id="24" name="TextBox 23">
+            <a:extLst>
+              <a:ext uri="{FF2B5EF4-FFF2-40B4-BE49-F238E27FC236}">
+                <a16:creationId xmlns:a16="http://schemas.microsoft.com/office/drawing/2014/main" id="{56DFA2B2-D1FB-7E40-AA4F-77E26D5DACCE}"/>
+              </a:ext>
+            </a:extLst>
+          </p:cNvPr>
+          <p:cNvSpPr txBox="1"/>
+          <p:nvPr/>
+        </p:nvSpPr>
+        <p:spPr>
+          <a:xfrm>
+            <a:off x="3802966" y="3978297"/>
+            <a:ext cx="1675382" cy="408623"/>
+          </a:xfrm>
+          <a:prstGeom prst="roundRect">
+            <a:avLst/>
+          </a:prstGeom>
+          <a:gradFill>
+            <a:gsLst>
+              <a:gs pos="0">
+                <a:srgbClr val="DC9494"/>
+              </a:gs>
+              <a:gs pos="50000">
+                <a:srgbClr val="D08888"/>
+              </a:gs>
+              <a:gs pos="100000">
+                <a:srgbClr val="D07070"/>
+              </a:gs>
+            </a:gsLst>
+          </a:gradFill>
+          <a:ln>
+            <a:solidFill>
+              <a:srgbClr val="A12B2B"/>
+            </a:solidFill>
+          </a:ln>
+        </p:spPr>
+        <p:style>
+          <a:lnRef idx="1">
+            <a:schemeClr val="accent5"/>
+          </a:lnRef>
+          <a:fillRef idx="2">
+            <a:schemeClr val="accent5"/>
+          </a:fillRef>
+          <a:effectRef idx="1">
+            <a:schemeClr val="accent5"/>
+          </a:effectRef>
+          <a:fontRef idx="minor">
+            <a:schemeClr val="dk1"/>
+          </a:fontRef>
+        </p:style>
+        <p:txBody>
+          <a:bodyPr wrap="none" rtlCol="0">
+            <a:spAutoFit/>
+          </a:bodyPr>
+          <a:lstStyle/>
+          <a:p>
+            <a:pPr algn="ctr"/>
+            <a:r>
+              <a:rPr lang="en-US" dirty="0"/>
+              <a:t>Learning curve</a:t>
+            </a:r>
+          </a:p>
+        </p:txBody>
+      </p:sp>
+      <p:sp>
+        <p:nvSpPr>
+          <p:cNvPr id="26" name="TextBox 25">
+            <a:extLst>
+              <a:ext uri="{FF2B5EF4-FFF2-40B4-BE49-F238E27FC236}">
+                <a16:creationId xmlns:a16="http://schemas.microsoft.com/office/drawing/2014/main" id="{FDBFF3EE-C465-006F-A738-B2C3CB9FD4F2}"/>
+              </a:ext>
+            </a:extLst>
+          </p:cNvPr>
+          <p:cNvSpPr txBox="1"/>
+          <p:nvPr/>
+        </p:nvSpPr>
+        <p:spPr>
+          <a:xfrm>
+            <a:off x="3956208" y="4526547"/>
+            <a:ext cx="1368897" cy="408623"/>
+          </a:xfrm>
+          <a:prstGeom prst="roundRect">
+            <a:avLst/>
+          </a:prstGeom>
+          <a:gradFill>
+            <a:gsLst>
+              <a:gs pos="0">
+                <a:srgbClr val="DC9494"/>
+              </a:gs>
+              <a:gs pos="50000">
+                <a:srgbClr val="D08888"/>
+              </a:gs>
+              <a:gs pos="100000">
+                <a:srgbClr val="D07070"/>
+              </a:gs>
+            </a:gsLst>
+          </a:gradFill>
+          <a:ln>
+            <a:solidFill>
+              <a:srgbClr val="A12B2B"/>
+            </a:solidFill>
+          </a:ln>
+        </p:spPr>
+        <p:style>
+          <a:lnRef idx="1">
+            <a:schemeClr val="accent5"/>
+          </a:lnRef>
+          <a:fillRef idx="2">
+            <a:schemeClr val="accent5"/>
+          </a:fillRef>
+          <a:effectRef idx="1">
+            <a:schemeClr val="accent5"/>
+          </a:effectRef>
+          <a:fontRef idx="minor">
+            <a:schemeClr val="dk1"/>
+          </a:fontRef>
+        </p:style>
+        <p:txBody>
+          <a:bodyPr wrap="none" rtlCol="0">
+            <a:spAutoFit/>
+          </a:bodyPr>
+          <a:lstStyle/>
+          <a:p>
+            <a:pPr algn="ctr"/>
+            <a:r>
+              <a:rPr lang="en-US" dirty="0"/>
+              <a:t>Not general</a:t>
+            </a:r>
+          </a:p>
+        </p:txBody>
+      </p:sp>
+      <p:sp>
+        <p:nvSpPr>
+          <p:cNvPr id="28" name="TextBox 27">
+            <a:extLst>
+              <a:ext uri="{FF2B5EF4-FFF2-40B4-BE49-F238E27FC236}">
+                <a16:creationId xmlns:a16="http://schemas.microsoft.com/office/drawing/2014/main" id="{23290D71-6DEC-174A-0D4C-C5A0334D42F9}"/>
+              </a:ext>
+            </a:extLst>
+          </p:cNvPr>
+          <p:cNvSpPr txBox="1"/>
+          <p:nvPr/>
+        </p:nvSpPr>
+        <p:spPr>
+          <a:xfrm>
+            <a:off x="9395405" y="3977774"/>
+            <a:ext cx="1286026" cy="408623"/>
+          </a:xfrm>
+          <a:prstGeom prst="roundRect">
+            <a:avLst/>
+          </a:prstGeom>
+          <a:gradFill>
+            <a:gsLst>
+              <a:gs pos="0">
+                <a:srgbClr val="DC9494"/>
+              </a:gs>
+              <a:gs pos="50000">
+                <a:srgbClr val="D08888"/>
+              </a:gs>
+              <a:gs pos="100000">
+                <a:srgbClr val="D07070"/>
+              </a:gs>
+            </a:gsLst>
+          </a:gradFill>
+          <a:ln>
+            <a:solidFill>
+              <a:srgbClr val="A12B2B"/>
+            </a:solidFill>
+          </a:ln>
+        </p:spPr>
+        <p:style>
+          <a:lnRef idx="1">
+            <a:schemeClr val="accent5"/>
+          </a:lnRef>
+          <a:fillRef idx="2">
+            <a:schemeClr val="accent5"/>
+          </a:fillRef>
+          <a:effectRef idx="1">
+            <a:schemeClr val="accent5"/>
+          </a:effectRef>
+          <a:fontRef idx="minor">
+            <a:schemeClr val="dk1"/>
+          </a:fontRef>
+        </p:style>
+        <p:txBody>
+          <a:bodyPr wrap="none" rtlCol="0">
+            <a:spAutoFit/>
+          </a:bodyPr>
+          <a:lstStyle>
+            <a:defPPr>
+              <a:defRPr lang="en-US"/>
+            </a:defPPr>
+            <a:lvl1pPr algn="ctr">
+              <a:defRPr/>
+            </a:lvl1pPr>
+            <a:lvl2pPr>
+              <a:defRPr>
+                <a:solidFill>
+                  <a:schemeClr val="dk1"/>
+                </a:solidFill>
+              </a:defRPr>
+            </a:lvl2pPr>
+            <a:lvl3pPr>
+              <a:defRPr>
+                <a:solidFill>
+                  <a:schemeClr val="dk1"/>
+                </a:solidFill>
+              </a:defRPr>
+            </a:lvl3pPr>
+            <a:lvl4pPr>
+              <a:defRPr>
+                <a:solidFill>
+                  <a:schemeClr val="dk1"/>
+                </a:solidFill>
+              </a:defRPr>
+            </a:lvl4pPr>
+            <a:lvl5pPr>
+              <a:defRPr>
+                <a:solidFill>
+                  <a:schemeClr val="dk1"/>
+                </a:solidFill>
+              </a:defRPr>
+            </a:lvl5pPr>
+            <a:lvl6pPr>
+              <a:defRPr>
+                <a:solidFill>
+                  <a:schemeClr val="dk1"/>
+                </a:solidFill>
+              </a:defRPr>
+            </a:lvl6pPr>
+            <a:lvl7pPr>
+              <a:defRPr>
+                <a:solidFill>
+                  <a:schemeClr val="dk1"/>
+                </a:solidFill>
+              </a:defRPr>
+            </a:lvl7pPr>
+            <a:lvl8pPr>
+              <a:defRPr>
+                <a:solidFill>
+                  <a:schemeClr val="dk1"/>
+                </a:solidFill>
+              </a:defRPr>
+            </a:lvl8pPr>
+            <a:lvl9pPr>
+              <a:defRPr>
+                <a:solidFill>
+                  <a:schemeClr val="dk1"/>
+                </a:solidFill>
+              </a:defRPr>
+            </a:lvl9pPr>
+          </a:lstStyle>
+          <a:p>
+            <a:r>
+              <a:rPr lang="en-US" dirty="0"/>
+              <a:t>Stochastic</a:t>
+            </a:r>
+          </a:p>
+        </p:txBody>
+      </p:sp>
+      <p:sp>
+        <p:nvSpPr>
+          <p:cNvPr id="30" name="TextBox 29">
+            <a:extLst>
+              <a:ext uri="{FF2B5EF4-FFF2-40B4-BE49-F238E27FC236}">
+                <a16:creationId xmlns:a16="http://schemas.microsoft.com/office/drawing/2014/main" id="{52B42A5D-EA70-C360-ADE0-BC629217A2FF}"/>
+              </a:ext>
+            </a:extLst>
+          </p:cNvPr>
+          <p:cNvSpPr txBox="1"/>
+          <p:nvPr/>
+        </p:nvSpPr>
+        <p:spPr>
+          <a:xfrm>
+            <a:off x="9126608" y="4525356"/>
+            <a:ext cx="1823620" cy="408623"/>
+          </a:xfrm>
+          <a:prstGeom prst="roundRect">
+            <a:avLst/>
+          </a:prstGeom>
+          <a:gradFill>
+            <a:gsLst>
+              <a:gs pos="0">
+                <a:srgbClr val="DC9494"/>
+              </a:gs>
+              <a:gs pos="50000">
+                <a:srgbClr val="D08888"/>
+              </a:gs>
+              <a:gs pos="100000">
+                <a:srgbClr val="D07070"/>
+              </a:gs>
+            </a:gsLst>
+          </a:gradFill>
+          <a:ln>
+            <a:solidFill>
+              <a:srgbClr val="A12B2B"/>
+            </a:solidFill>
+          </a:ln>
+        </p:spPr>
+        <p:style>
+          <a:lnRef idx="1">
+            <a:schemeClr val="accent5"/>
+          </a:lnRef>
+          <a:fillRef idx="2">
+            <a:schemeClr val="accent5"/>
+          </a:fillRef>
+          <a:effectRef idx="1">
+            <a:schemeClr val="accent5"/>
+          </a:effectRef>
+          <a:fontRef idx="minor">
+            <a:schemeClr val="dk1"/>
+          </a:fontRef>
+        </p:style>
+        <p:txBody>
+          <a:bodyPr wrap="none" rtlCol="0">
+            <a:spAutoFit/>
+          </a:bodyPr>
+          <a:lstStyle>
+            <a:defPPr>
+              <a:defRPr lang="en-US"/>
+            </a:defPPr>
+            <a:lvl1pPr algn="ctr">
+              <a:defRPr>
+                <a:solidFill>
+                  <a:schemeClr val="dk1"/>
+                </a:solidFill>
+              </a:defRPr>
+            </a:lvl1pPr>
+            <a:lvl2pPr>
+              <a:defRPr>
+                <a:solidFill>
+                  <a:schemeClr val="dk1"/>
+                </a:solidFill>
+              </a:defRPr>
+            </a:lvl2pPr>
+            <a:lvl3pPr>
+              <a:defRPr>
+                <a:solidFill>
+                  <a:schemeClr val="dk1"/>
+                </a:solidFill>
+              </a:defRPr>
+            </a:lvl3pPr>
+            <a:lvl4pPr>
+              <a:defRPr>
+                <a:solidFill>
+                  <a:schemeClr val="dk1"/>
+                </a:solidFill>
+              </a:defRPr>
+            </a:lvl4pPr>
+            <a:lvl5pPr>
+              <a:defRPr>
+                <a:solidFill>
+                  <a:schemeClr val="dk1"/>
+                </a:solidFill>
+              </a:defRPr>
+            </a:lvl5pPr>
+            <a:lvl6pPr>
+              <a:defRPr>
+                <a:solidFill>
+                  <a:schemeClr val="dk1"/>
+                </a:solidFill>
+              </a:defRPr>
+            </a:lvl6pPr>
+            <a:lvl7pPr>
+              <a:defRPr>
+                <a:solidFill>
+                  <a:schemeClr val="dk1"/>
+                </a:solidFill>
+              </a:defRPr>
+            </a:lvl7pPr>
+            <a:lvl8pPr>
+              <a:defRPr>
+                <a:solidFill>
+                  <a:schemeClr val="dk1"/>
+                </a:solidFill>
+              </a:defRPr>
+            </a:lvl8pPr>
+            <a:lvl9pPr>
+              <a:defRPr>
+                <a:solidFill>
+                  <a:schemeClr val="dk1"/>
+                </a:solidFill>
+              </a:defRPr>
+            </a:lvl9pPr>
+          </a:lstStyle>
+          <a:p>
+            <a:r>
+              <a:rPr lang="en-US" dirty="0"/>
+              <a:t>Complex output</a:t>
+            </a:r>
+          </a:p>
+        </p:txBody>
+      </p:sp>
+      <p:sp>
+        <p:nvSpPr>
+          <p:cNvPr id="35" name="Right Brace 34">
+            <a:extLst>
+              <a:ext uri="{FF2B5EF4-FFF2-40B4-BE49-F238E27FC236}">
+                <a16:creationId xmlns:a16="http://schemas.microsoft.com/office/drawing/2014/main" id="{9F09A8EB-ABF6-B6C8-D0BA-80FB857DE93D}"/>
+              </a:ext>
+            </a:extLst>
+          </p:cNvPr>
+          <p:cNvSpPr/>
+          <p:nvPr/>
+        </p:nvSpPr>
+        <p:spPr>
+          <a:xfrm rot="5400000">
+            <a:off x="6019868" y="1648644"/>
+            <a:ext cx="152264" cy="6995962"/>
+          </a:xfrm>
+          <a:prstGeom prst="rightBrace">
+            <a:avLst/>
+          </a:prstGeom>
+        </p:spPr>
+        <p:style>
+          <a:lnRef idx="2">
+            <a:schemeClr val="accent1"/>
+          </a:lnRef>
+          <a:fillRef idx="0">
+            <a:schemeClr val="accent1"/>
+          </a:fillRef>
+          <a:effectRef idx="1">
+            <a:schemeClr val="accent1"/>
+          </a:effectRef>
+          <a:fontRef idx="minor">
+            <a:schemeClr val="tx1"/>
+          </a:fontRef>
+        </p:style>
+        <p:txBody>
+          <a:bodyPr rtlCol="0" anchor="ctr"/>
+          <a:lstStyle/>
+          <a:p>
+            <a:pPr algn="ctr"/>
+            <a:endParaRPr lang="en-US"/>
+          </a:p>
+        </p:txBody>
+      </p:sp>
+      <p:sp>
+        <p:nvSpPr>
+          <p:cNvPr id="36" name="TextBox 35">
+            <a:extLst>
+              <a:ext uri="{FF2B5EF4-FFF2-40B4-BE49-F238E27FC236}">
+                <a16:creationId xmlns:a16="http://schemas.microsoft.com/office/drawing/2014/main" id="{2389E2B3-4BCB-989F-B436-E7DF27AF788B}"/>
+              </a:ext>
+            </a:extLst>
+          </p:cNvPr>
+          <p:cNvSpPr txBox="1"/>
+          <p:nvPr/>
+        </p:nvSpPr>
+        <p:spPr>
+          <a:xfrm>
+            <a:off x="4505436" y="5222758"/>
+            <a:ext cx="3181127" cy="646331"/>
+          </a:xfrm>
+          <a:prstGeom prst="rect">
+            <a:avLst/>
+          </a:prstGeom>
+          <a:noFill/>
+        </p:spPr>
+        <p:txBody>
+          <a:bodyPr wrap="none" rtlCol="0">
+            <a:spAutoFit/>
+          </a:bodyPr>
+          <a:lstStyle/>
+          <a:p>
+            <a:pPr algn="ctr"/>
+            <a:r>
+              <a:rPr lang="en-US" dirty="0"/>
+              <a:t>Would abstractions help LLMs</a:t>
+            </a:r>
+            <a:br>
+              <a:rPr lang="en-US" dirty="0"/>
+            </a:br>
+            <a:r>
+              <a:rPr lang="en-US" dirty="0"/>
+              <a:t>generate better code</a:t>
+            </a:r>
+          </a:p>
+        </p:txBody>
+      </p:sp>
+      <p:cxnSp>
+        <p:nvCxnSpPr>
+          <p:cNvPr id="38" name="Straight Connector 37">
+            <a:extLst>
+              <a:ext uri="{FF2B5EF4-FFF2-40B4-BE49-F238E27FC236}">
+                <a16:creationId xmlns:a16="http://schemas.microsoft.com/office/drawing/2014/main" id="{89876299-1652-9960-0CF0-FAE18BAA3D39}"/>
+              </a:ext>
+            </a:extLst>
+          </p:cNvPr>
+          <p:cNvCxnSpPr>
+            <a:cxnSpLocks/>
+            <a:endCxn id="6" idx="2"/>
+          </p:cNvCxnSpPr>
+          <p:nvPr/>
+        </p:nvCxnSpPr>
+        <p:spPr>
+          <a:xfrm flipV="1">
+            <a:off x="2188369" y="3633311"/>
+            <a:ext cx="1146752" cy="303590"/>
+          </a:xfrm>
+          <a:prstGeom prst="line">
+            <a:avLst/>
+          </a:prstGeom>
+          <a:ln w="19050">
+            <a:prstDash val="sysDot"/>
+          </a:ln>
+        </p:spPr>
+        <p:style>
+          <a:lnRef idx="2">
+            <a:schemeClr val="accent1"/>
+          </a:lnRef>
+          <a:fillRef idx="0">
+            <a:schemeClr val="accent1"/>
+          </a:fillRef>
+          <a:effectRef idx="1">
+            <a:schemeClr val="accent1"/>
+          </a:effectRef>
+          <a:fontRef idx="minor">
+            <a:schemeClr val="tx1"/>
+          </a:fontRef>
+        </p:style>
+      </p:cxnSp>
+      <p:cxnSp>
+        <p:nvCxnSpPr>
+          <p:cNvPr id="40" name="Straight Connector 39">
+            <a:extLst>
+              <a:ext uri="{FF2B5EF4-FFF2-40B4-BE49-F238E27FC236}">
+                <a16:creationId xmlns:a16="http://schemas.microsoft.com/office/drawing/2014/main" id="{09A658A6-462A-721C-919E-76FEB163D5B8}"/>
+              </a:ext>
+            </a:extLst>
+          </p:cNvPr>
+          <p:cNvCxnSpPr>
+            <a:cxnSpLocks/>
+            <a:stCxn id="6" idx="2"/>
+          </p:cNvCxnSpPr>
+          <p:nvPr/>
+        </p:nvCxnSpPr>
+        <p:spPr>
+          <a:xfrm>
+            <a:off x="3335121" y="3633311"/>
+            <a:ext cx="1170315" cy="303590"/>
+          </a:xfrm>
+          <a:prstGeom prst="line">
+            <a:avLst/>
+          </a:prstGeom>
+          <a:ln w="19050">
+            <a:prstDash val="sysDot"/>
+          </a:ln>
+        </p:spPr>
+        <p:style>
+          <a:lnRef idx="2">
+            <a:schemeClr val="accent1"/>
+          </a:lnRef>
+          <a:fillRef idx="0">
+            <a:schemeClr val="accent1"/>
+          </a:fillRef>
+          <a:effectRef idx="1">
+            <a:schemeClr val="accent1"/>
+          </a:effectRef>
+          <a:fontRef idx="minor">
+            <a:schemeClr val="tx1"/>
+          </a:fontRef>
+        </p:style>
+      </p:cxnSp>
+      <p:cxnSp>
+        <p:nvCxnSpPr>
+          <p:cNvPr id="42" name="Straight Connector 41">
+            <a:extLst>
+              <a:ext uri="{FF2B5EF4-FFF2-40B4-BE49-F238E27FC236}">
+                <a16:creationId xmlns:a16="http://schemas.microsoft.com/office/drawing/2014/main" id="{6BD53AA8-39CA-47DE-F5FA-41E1EE49B24D}"/>
+              </a:ext>
+            </a:extLst>
+          </p:cNvPr>
+          <p:cNvCxnSpPr>
+            <a:cxnSpLocks/>
+            <a:endCxn id="7" idx="2"/>
+          </p:cNvCxnSpPr>
+          <p:nvPr/>
+        </p:nvCxnSpPr>
+        <p:spPr>
+          <a:xfrm flipV="1">
+            <a:off x="7898606" y="3633311"/>
+            <a:ext cx="958274" cy="303590"/>
+          </a:xfrm>
+          <a:prstGeom prst="line">
+            <a:avLst/>
+          </a:prstGeom>
+          <a:ln w="19050">
+            <a:prstDash val="sysDot"/>
+          </a:ln>
+        </p:spPr>
+        <p:style>
+          <a:lnRef idx="2">
+            <a:schemeClr val="accent1"/>
+          </a:lnRef>
+          <a:fillRef idx="0">
+            <a:schemeClr val="accent1"/>
+          </a:fillRef>
+          <a:effectRef idx="1">
+            <a:schemeClr val="accent1"/>
+          </a:effectRef>
+          <a:fontRef idx="minor">
+            <a:schemeClr val="tx1"/>
+          </a:fontRef>
+        </p:style>
+      </p:cxnSp>
+      <p:cxnSp>
+        <p:nvCxnSpPr>
+          <p:cNvPr id="44" name="Straight Connector 43">
+            <a:extLst>
+              <a:ext uri="{FF2B5EF4-FFF2-40B4-BE49-F238E27FC236}">
+                <a16:creationId xmlns:a16="http://schemas.microsoft.com/office/drawing/2014/main" id="{57CF218E-2303-9C34-7EE9-CD93166E4988}"/>
+              </a:ext>
+            </a:extLst>
+          </p:cNvPr>
+          <p:cNvCxnSpPr>
+            <a:cxnSpLocks/>
+            <a:endCxn id="7" idx="2"/>
+          </p:cNvCxnSpPr>
+          <p:nvPr/>
+        </p:nvCxnSpPr>
+        <p:spPr>
+          <a:xfrm flipH="1" flipV="1">
+            <a:off x="8856880" y="3633311"/>
+            <a:ext cx="1015783" cy="303590"/>
+          </a:xfrm>
+          <a:prstGeom prst="line">
+            <a:avLst/>
+          </a:prstGeom>
+          <a:ln w="19050">
+            <a:prstDash val="sysDot"/>
+          </a:ln>
+        </p:spPr>
+        <p:style>
+          <a:lnRef idx="2">
+            <a:schemeClr val="accent1"/>
+          </a:lnRef>
+          <a:fillRef idx="0">
+            <a:schemeClr val="accent1"/>
+          </a:fillRef>
+          <a:effectRef idx="1">
+            <a:schemeClr val="accent1"/>
+          </a:effectRef>
+          <a:fontRef idx="minor">
+            <a:schemeClr val="tx1"/>
+          </a:fontRef>
+        </p:style>
+      </p:cxnSp>
     </p:spTree>
     <p:extLst>
       <p:ext uri="{BB962C8B-B14F-4D97-AF65-F5344CB8AC3E}">
@@ -19898,7 +21375,7 @@
           <a:p>
             <a:fld id="{1AB26190-46ED-4A0C-A5E8-CDBCA5C2D5C3}" type="datetime1">
               <a:rPr lang="en-US" noProof="0" smtClean="0"/>
-              <a:t>8/29/2026</a:t>
+              <a:t>8/30/2026</a:t>
             </a:fld>
             <a:endParaRPr lang="en-US" noProof="0" dirty="0"/>
           </a:p>
@@ -20445,7 +21922,7 @@
           <a:p>
             <a:fld id="{1AB26190-46ED-4A0C-A5E8-CDBCA5C2D5C3}" type="datetime1">
               <a:rPr lang="en-US" noProof="0" smtClean="0"/>
-              <a:t>8/29/2026</a:t>
+              <a:t>8/30/2026</a:t>
             </a:fld>
             <a:endParaRPr lang="en-US" noProof="0" dirty="0"/>
           </a:p>
@@ -20606,14 +22083,6 @@
 <file path=ppt/slides/slide28.xml><?xml version="1.0" encoding="utf-8"?>
 <p:sld xmlns:a="http://schemas.openxmlformats.org/drawingml/2006/main" xmlns:r="http://schemas.openxmlformats.org/officeDocument/2006/relationships" xmlns:p="http://schemas.openxmlformats.org/presentationml/2006/main">
   <p:cSld>
-    <p:bg>
-      <p:bgPr>
-        <a:solidFill>
-          <a:srgbClr val="FFFF00"/>
-        </a:solidFill>
-        <a:effectLst/>
-      </p:bgPr>
-    </p:bg>
     <p:spTree>
       <p:nvGrpSpPr>
         <p:cNvPr id="1" name=""/>
@@ -20693,12 +22162,16 @@
           </a:p>
           <a:p>
             <a:r>
-              <a:rPr lang="en-US" noProof="0" dirty="0">
-                <a:solidFill>
-                  <a:srgbClr val="FF0000"/>
-                </a:solidFill>
-              </a:rPr>
-              <a:t>Future research</a:t>
+              <a:rPr lang="en-US" dirty="0"/>
+              <a:t>Possible f</a:t>
+            </a:r>
+            <a:r>
+              <a:rPr lang="en-US" noProof="0" dirty="0" err="1"/>
+              <a:t>uture</a:t>
+            </a:r>
+            <a:r>
+              <a:rPr lang="en-US" noProof="0" dirty="0"/>
+              <a:t> research</a:t>
             </a:r>
           </a:p>
           <a:p>
@@ -20712,7 +22185,7 @@
             <a:pPr lvl="2"/>
             <a:r>
               <a:rPr lang="en-US" noProof="0" dirty="0"/>
-              <a:t>Automatically gather feedback</a:t>
+              <a:t>Automatically gather feedback (performance, compile errors, …)</a:t>
             </a:r>
           </a:p>
           <a:p>
@@ -20724,9 +22197,13 @@
           </a:p>
           <a:p>
             <a:pPr lvl="1"/>
+            <a:endParaRPr lang="en-US" noProof="0" dirty="0"/>
+          </a:p>
+          <a:p>
+            <a:pPr lvl="1"/>
             <a:r>
               <a:rPr lang="en-US" noProof="0" dirty="0"/>
-              <a:t>More LLM-focused abstractions or scaffolding</a:t>
+              <a:t>More LLM-focused abstractions</a:t>
             </a:r>
           </a:p>
         </p:txBody>
@@ -20754,7 +22231,7 @@
           <a:p>
             <a:fld id="{2E4D20BF-4C0E-41E5-B4FC-9D48FCD3AF33}" type="datetime1">
               <a:rPr lang="en-US" noProof="0" smtClean="0"/>
-              <a:t>8/29/2026</a:t>
+              <a:t>8/30/2026</a:t>
             </a:fld>
             <a:endParaRPr lang="en-US" noProof="0" dirty="0"/>
           </a:p>
@@ -20870,7 +22347,7 @@
           <a:p>
             <a:fld id="{6DAC1E11-C476-4762-AFFB-C3D6ECD7A44E}" type="datetime1">
               <a:rPr lang="en-US" noProof="0" smtClean="0"/>
-              <a:t>8/29/2026</a:t>
+              <a:t>8/30/2026</a:t>
             </a:fld>
             <a:endParaRPr lang="en-US" noProof="0" dirty="0"/>
           </a:p>
@@ -23117,8 +24594,8 @@
         </p:blipFill>
         <p:spPr>
           <a:xfrm>
-            <a:off x="7703081" y="3886390"/>
-            <a:ext cx="511973" cy="511973"/>
+            <a:off x="7814178" y="3997487"/>
+            <a:ext cx="289780" cy="289780"/>
           </a:xfrm>
           <a:prstGeom prst="rect">
             <a:avLst/>
@@ -23153,8 +24630,8 @@
         </p:blipFill>
         <p:spPr>
           <a:xfrm>
-            <a:off x="2233671" y="4449065"/>
-            <a:ext cx="511973" cy="511973"/>
+            <a:off x="2344768" y="4560162"/>
+            <a:ext cx="289780" cy="289780"/>
           </a:xfrm>
           <a:prstGeom prst="rect">
             <a:avLst/>
@@ -23189,8 +24666,8 @@
         </p:blipFill>
         <p:spPr>
           <a:xfrm>
-            <a:off x="5106973" y="2878271"/>
-            <a:ext cx="511973" cy="511973"/>
+            <a:off x="5218070" y="2989368"/>
+            <a:ext cx="289780" cy="289780"/>
           </a:xfrm>
           <a:prstGeom prst="rect">
             <a:avLst/>
@@ -24865,8 +26342,8 @@
           </p:txBody>
         </p:sp>
       </p:grpSp>
-      <mc:AlternateContent xmlns:mc="http://schemas.openxmlformats.org/markup-compatibility/2006">
-        <mc:Choice xmlns:a14="http://schemas.microsoft.com/office/drawing/2010/main" Requires="a14">
+      <mc:AlternateContent xmlns:mc="http://schemas.openxmlformats.org/markup-compatibility/2006" xmlns:a14="http://schemas.microsoft.com/office/drawing/2010/main">
+        <mc:Choice Requires="a14">
           <p:sp>
             <p:nvSpPr>
               <p:cNvPr id="16" name="TextBox 15">
@@ -24930,7 +26407,7 @@
             </p:txBody>
           </p:sp>
         </mc:Choice>
-        <mc:Fallback>
+        <mc:Fallback xmlns="">
           <p:sp>
             <p:nvSpPr>
               <p:cNvPr id="16" name="TextBox 15">
@@ -25443,7 +26920,7 @@
           <a:p>
             <a:fld id="{4A613F15-5634-45C6-B470-EBFC7B0054B0}" type="datetime1">
               <a:rPr lang="en-US" noProof="0" smtClean="0"/>
-              <a:t>8/29/2026</a:t>
+              <a:t>8/30/2026</a:t>
             </a:fld>
             <a:endParaRPr lang="en-US" noProof="0" dirty="0"/>
           </a:p>
@@ -25705,7 +27182,7 @@
           <a:p>
             <a:fld id="{1AB26190-46ED-4A0C-A5E8-CDBCA5C2D5C3}" type="datetime1">
               <a:rPr lang="en-US" noProof="0" smtClean="0"/>
-              <a:t>8/29/2026</a:t>
+              <a:t>8/30/2026</a:t>
             </a:fld>
             <a:endParaRPr lang="en-US" noProof="0" dirty="0"/>
           </a:p>
@@ -26291,10 +27768,10 @@
       </p:grpSpPr>
       <p:sp>
         <p:nvSpPr>
-          <p:cNvPr id="2" name="Title 1">
-            <a:extLst>
-              <a:ext uri="{FF2B5EF4-FFF2-40B4-BE49-F238E27FC236}">
-                <a16:creationId xmlns:a16="http://schemas.microsoft.com/office/drawing/2014/main" id="{5EFCD7CC-C2D6-52E6-02D5-F41FC5389A5C}"/>
+          <p:cNvPr id="6" name="Title 5">
+            <a:extLst>
+              <a:ext uri="{FF2B5EF4-FFF2-40B4-BE49-F238E27FC236}">
+                <a16:creationId xmlns:a16="http://schemas.microsoft.com/office/drawing/2014/main" id="{C814D937-1CAE-414B-A7D5-018C68698F98}"/>
               </a:ext>
             </a:extLst>
           </p:cNvPr>
@@ -26310,16 +27787,160 @@
           <a:bodyPr/>
           <a:lstStyle/>
           <a:p>
+            <a:r>
+              <a:rPr lang="en-US" dirty="0"/>
+              <a:t>Review comments and questions</a:t>
+            </a:r>
+          </a:p>
+        </p:txBody>
+      </p:sp>
+      <p:sp>
+        <p:nvSpPr>
+          <p:cNvPr id="7" name="Text Placeholder 6">
+            <a:extLst>
+              <a:ext uri="{FF2B5EF4-FFF2-40B4-BE49-F238E27FC236}">
+                <a16:creationId xmlns:a16="http://schemas.microsoft.com/office/drawing/2014/main" id="{5130AF46-445A-EA10-5B0A-764E1CA13B08}"/>
+              </a:ext>
+            </a:extLst>
+          </p:cNvPr>
+          <p:cNvSpPr>
+            <a:spLocks noGrp="1"/>
+          </p:cNvSpPr>
+          <p:nvPr>
+            <p:ph type="body" idx="1"/>
+          </p:nvPr>
+        </p:nvSpPr>
+        <p:spPr/>
+        <p:txBody>
+          <a:bodyPr/>
+          <a:lstStyle/>
+          <a:p>
+            <a:endParaRPr lang="en-US"/>
+          </a:p>
+        </p:txBody>
+      </p:sp>
+      <p:sp>
+        <p:nvSpPr>
+          <p:cNvPr id="4" name="Date Placeholder 3">
+            <a:extLst>
+              <a:ext uri="{FF2B5EF4-FFF2-40B4-BE49-F238E27FC236}">
+                <a16:creationId xmlns:a16="http://schemas.microsoft.com/office/drawing/2014/main" id="{1384B596-5AF7-51AF-3EE6-313BDA5CC3C0}"/>
+              </a:ext>
+            </a:extLst>
+          </p:cNvPr>
+          <p:cNvSpPr>
+            <a:spLocks noGrp="1"/>
+          </p:cNvSpPr>
+          <p:nvPr>
+            <p:ph type="dt" sz="half" idx="10"/>
+          </p:nvPr>
+        </p:nvSpPr>
+        <p:spPr/>
+        <p:txBody>
+          <a:bodyPr/>
+          <a:lstStyle/>
+          <a:p>
+            <a:fld id="{0601A530-81CA-410E-A053-EF7BD11F8EF0}" type="datetime1">
+              <a:rPr lang="en-US" noProof="0" smtClean="0"/>
+              <a:t>8/30/2026</a:t>
+            </a:fld>
             <a:endParaRPr lang="en-US" noProof="0" dirty="0"/>
           </a:p>
         </p:txBody>
       </p:sp>
       <p:sp>
         <p:nvSpPr>
+          <p:cNvPr id="5" name="Slide Number Placeholder 4">
+            <a:extLst>
+              <a:ext uri="{FF2B5EF4-FFF2-40B4-BE49-F238E27FC236}">
+                <a16:creationId xmlns:a16="http://schemas.microsoft.com/office/drawing/2014/main" id="{3BD45EBF-BF5B-CB1B-7863-61BA3DD3C837}"/>
+              </a:ext>
+            </a:extLst>
+          </p:cNvPr>
+          <p:cNvSpPr>
+            <a:spLocks noGrp="1"/>
+          </p:cNvSpPr>
+          <p:nvPr>
+            <p:ph type="sldNum" sz="quarter" idx="12"/>
+          </p:nvPr>
+        </p:nvSpPr>
+        <p:spPr/>
+        <p:txBody>
+          <a:bodyPr/>
+          <a:lstStyle/>
+          <a:p>
+            <a:fld id="{DA0BB241-1B5F-4309-9407-9EEA04D9598D}" type="slidenum">
+              <a:rPr lang="en-US" noProof="0" smtClean="0"/>
+              <a:t>31</a:t>
+            </a:fld>
+            <a:endParaRPr lang="en-US" noProof="0" dirty="0"/>
+          </a:p>
+        </p:txBody>
+      </p:sp>
+    </p:spTree>
+    <p:extLst>
+      <p:ext uri="{BB962C8B-B14F-4D97-AF65-F5344CB8AC3E}">
+        <p14:creationId xmlns:p14="http://schemas.microsoft.com/office/powerpoint/2010/main" val="2595384929"/>
+      </p:ext>
+    </p:extLst>
+  </p:cSld>
+  <p:clrMapOvr>
+    <a:masterClrMapping/>
+  </p:clrMapOvr>
+</p:sld>
+</file>
+
+<file path=ppt/slides/slide32.xml><?xml version="1.0" encoding="utf-8"?>
+<p:sld xmlns:a="http://schemas.openxmlformats.org/drawingml/2006/main" xmlns:r="http://schemas.openxmlformats.org/officeDocument/2006/relationships" xmlns:p="http://schemas.openxmlformats.org/presentationml/2006/main">
+  <p:cSld>
+    <p:spTree>
+      <p:nvGrpSpPr>
+        <p:cNvPr id="1" name=""/>
+        <p:cNvGrpSpPr/>
+        <p:nvPr/>
+      </p:nvGrpSpPr>
+      <p:grpSpPr>
+        <a:xfrm>
+          <a:off x="0" y="0"/>
+          <a:ext cx="0" cy="0"/>
+          <a:chOff x="0" y="0"/>
+          <a:chExt cx="0" cy="0"/>
+        </a:xfrm>
+      </p:grpSpPr>
+      <p:sp>
+        <p:nvSpPr>
+          <p:cNvPr id="2" name="Title 1">
+            <a:extLst>
+              <a:ext uri="{FF2B5EF4-FFF2-40B4-BE49-F238E27FC236}">
+                <a16:creationId xmlns:a16="http://schemas.microsoft.com/office/drawing/2014/main" id="{0C75DEE5-750D-2E34-780B-7B30703452C0}"/>
+              </a:ext>
+            </a:extLst>
+          </p:cNvPr>
+          <p:cNvSpPr>
+            <a:spLocks noGrp="1"/>
+          </p:cNvSpPr>
+          <p:nvPr>
+            <p:ph type="title"/>
+          </p:nvPr>
+        </p:nvSpPr>
+        <p:spPr/>
+        <p:txBody>
+          <a:bodyPr/>
+          <a:lstStyle/>
+          <a:p>
+            <a:r>
+              <a:rPr lang="en-US" dirty="0"/>
+              <a:t>Novelty in layout- and traversal-agnosticism</a:t>
+            </a:r>
+          </a:p>
+        </p:txBody>
+      </p:sp>
+      <p:sp>
+        <p:nvSpPr>
           <p:cNvPr id="3" name="Content Placeholder 2">
             <a:extLst>
               <a:ext uri="{FF2B5EF4-FFF2-40B4-BE49-F238E27FC236}">
-                <a16:creationId xmlns:a16="http://schemas.microsoft.com/office/drawing/2014/main" id="{950373B6-1B3D-2E32-D54A-18C124620153}"/>
+                <a16:creationId xmlns:a16="http://schemas.microsoft.com/office/drawing/2014/main" id="{7A4C7CE7-A5CF-9AB9-4808-73A235F6B8CE}"/>
               </a:ext>
             </a:extLst>
           </p:cNvPr>
@@ -26335,7 +27956,68 @@
           <a:bodyPr/>
           <a:lstStyle/>
           <a:p>
-            <a:endParaRPr lang="en-US" noProof="0" dirty="0"/>
+            <a:r>
+              <a:rPr lang="en-US" dirty="0"/>
+              <a:t>We do not claim to invent these two concepts as new paradigms</a:t>
+            </a:r>
+          </a:p>
+          <a:p>
+            <a:pPr lvl="1"/>
+            <a:r>
+              <a:rPr lang="en-US" dirty="0"/>
+              <a:t>The thesis explicitly studies the two concepts</a:t>
+            </a:r>
+          </a:p>
+          <a:p>
+            <a:pPr lvl="2"/>
+            <a:r>
+              <a:rPr lang="en-US" dirty="0"/>
+              <a:t>introducing them as two identified underexplored principles</a:t>
+            </a:r>
+          </a:p>
+          <a:p>
+            <a:pPr lvl="1"/>
+            <a:r>
+              <a:rPr lang="en-US" dirty="0"/>
+              <a:t>Not targeted by prior research or design in HPC algorithms</a:t>
+            </a:r>
+          </a:p>
+          <a:p>
+            <a:r>
+              <a:rPr lang="en-US" dirty="0"/>
+              <a:t>Main novelty</a:t>
+            </a:r>
+          </a:p>
+          <a:p>
+            <a:pPr lvl="1"/>
+            <a:r>
+              <a:rPr lang="en-US" dirty="0"/>
+              <a:t>Unified approach for layout &amp; traversal-agnostic algorithm design</a:t>
+            </a:r>
+          </a:p>
+          <a:p>
+            <a:pPr lvl="1"/>
+            <a:r>
+              <a:rPr lang="en-US" dirty="0"/>
+              <a:t>Named dimensions and compositional approach</a:t>
+            </a:r>
+          </a:p>
+          <a:p>
+            <a:pPr lvl="1"/>
+            <a:r>
+              <a:rPr lang="en-US" dirty="0"/>
+              <a:t>Support for heterogeneous layouts</a:t>
+            </a:r>
+          </a:p>
+          <a:p>
+            <a:pPr lvl="1"/>
+            <a:r>
+              <a:rPr lang="en-US" dirty="0"/>
+              <a:t>Abstracting evaluation strategy and encoding for Cellular Automata</a:t>
+            </a:r>
+          </a:p>
+          <a:p>
+            <a:endParaRPr lang="en-US" dirty="0"/>
           </a:p>
         </p:txBody>
       </p:sp>
@@ -26344,7 +28026,7 @@
           <p:cNvPr id="4" name="Date Placeholder 3">
             <a:extLst>
               <a:ext uri="{FF2B5EF4-FFF2-40B4-BE49-F238E27FC236}">
-                <a16:creationId xmlns:a16="http://schemas.microsoft.com/office/drawing/2014/main" id="{1384B596-5AF7-51AF-3EE6-313BDA5CC3C0}"/>
+                <a16:creationId xmlns:a16="http://schemas.microsoft.com/office/drawing/2014/main" id="{948C54E1-6E6D-2E32-65E2-74ED092C4452}"/>
               </a:ext>
             </a:extLst>
           </p:cNvPr>
@@ -26360,11 +28042,11 @@
           <a:bodyPr/>
           <a:lstStyle/>
           <a:p>
-            <a:fld id="{0601A530-81CA-410E-A053-EF7BD11F8EF0}" type="datetime1">
-              <a:rPr lang="en-US" noProof="0" smtClean="0"/>
-              <a:t>8/29/2026</a:t>
+            <a:fld id="{358C28A6-2969-482E-9A3B-5E13FCD8DD03}" type="datetime1">
+              <a:rPr lang="en-US" smtClean="0"/>
+              <a:t>8/30/2026</a:t>
             </a:fld>
-            <a:endParaRPr lang="en-US" noProof="0" dirty="0"/>
+            <a:endParaRPr lang="en-US"/>
           </a:p>
         </p:txBody>
       </p:sp>
@@ -26373,7 +28055,7 @@
           <p:cNvPr id="5" name="Slide Number Placeholder 4">
             <a:extLst>
               <a:ext uri="{FF2B5EF4-FFF2-40B4-BE49-F238E27FC236}">
-                <a16:creationId xmlns:a16="http://schemas.microsoft.com/office/drawing/2014/main" id="{3BD45EBF-BF5B-CB1B-7863-61BA3DD3C837}"/>
+                <a16:creationId xmlns:a16="http://schemas.microsoft.com/office/drawing/2014/main" id="{4F0AAC9A-8584-05EF-C97F-9A8A4DE36F9D}"/>
               </a:ext>
             </a:extLst>
           </p:cNvPr>
@@ -26390,17 +28072,620 @@
           <a:lstStyle/>
           <a:p>
             <a:fld id="{DA0BB241-1B5F-4309-9407-9EEA04D9598D}" type="slidenum">
-              <a:rPr lang="en-US" noProof="0" smtClean="0"/>
-              <a:t>31</a:t>
+              <a:rPr lang="en-US" smtClean="0"/>
+              <a:t>32</a:t>
             </a:fld>
-            <a:endParaRPr lang="en-US" noProof="0" dirty="0"/>
+            <a:endParaRPr lang="en-US"/>
           </a:p>
         </p:txBody>
       </p:sp>
     </p:spTree>
     <p:extLst>
       <p:ext uri="{BB962C8B-B14F-4D97-AF65-F5344CB8AC3E}">
-        <p14:creationId xmlns:p14="http://schemas.microsoft.com/office/powerpoint/2010/main" val="2595384929"/>
+        <p14:creationId xmlns:p14="http://schemas.microsoft.com/office/powerpoint/2010/main" val="1756571368"/>
+      </p:ext>
+    </p:extLst>
+  </p:cSld>
+  <p:clrMapOvr>
+    <a:masterClrMapping/>
+  </p:clrMapOvr>
+</p:sld>
+</file>
+
+<file path=ppt/slides/slide33.xml><?xml version="1.0" encoding="utf-8"?>
+<p:sld xmlns:a="http://schemas.openxmlformats.org/drawingml/2006/main" xmlns:r="http://schemas.openxmlformats.org/officeDocument/2006/relationships" xmlns:p="http://schemas.openxmlformats.org/presentationml/2006/main">
+  <p:cSld>
+    <p:bg>
+      <p:bgPr>
+        <a:solidFill>
+          <a:srgbClr val="FF0000"/>
+        </a:solidFill>
+        <a:effectLst/>
+      </p:bgPr>
+    </p:bg>
+    <p:spTree>
+      <p:nvGrpSpPr>
+        <p:cNvPr id="1" name=""/>
+        <p:cNvGrpSpPr/>
+        <p:nvPr/>
+      </p:nvGrpSpPr>
+      <p:grpSpPr>
+        <a:xfrm>
+          <a:off x="0" y="0"/>
+          <a:ext cx="0" cy="0"/>
+          <a:chOff x="0" y="0"/>
+          <a:chExt cx="0" cy="0"/>
+        </a:xfrm>
+      </p:grpSpPr>
+      <p:sp>
+        <p:nvSpPr>
+          <p:cNvPr id="2" name="Title 1">
+            <a:extLst>
+              <a:ext uri="{FF2B5EF4-FFF2-40B4-BE49-F238E27FC236}">
+                <a16:creationId xmlns:a16="http://schemas.microsoft.com/office/drawing/2014/main" id="{EF5B94CF-19F9-112D-5812-9019906C4F6E}"/>
+              </a:ext>
+            </a:extLst>
+          </p:cNvPr>
+          <p:cNvSpPr>
+            <a:spLocks noGrp="1"/>
+          </p:cNvSpPr>
+          <p:nvPr>
+            <p:ph type="title"/>
+          </p:nvPr>
+        </p:nvSpPr>
+        <p:spPr/>
+        <p:txBody>
+          <a:bodyPr>
+            <a:normAutofit fontScale="90000"/>
+          </a:bodyPr>
+          <a:lstStyle/>
+          <a:p>
+            <a:r>
+              <a:rPr lang="en-US" dirty="0"/>
+              <a:t>Which of these ideas can be found in software like </a:t>
+            </a:r>
+            <a:r>
+              <a:rPr lang="en-US" dirty="0" err="1"/>
+              <a:t>Kokkos</a:t>
+            </a:r>
+            <a:r>
+              <a:rPr lang="en-US" dirty="0"/>
+              <a:t> or OpenMP's loop transformations?</a:t>
+            </a:r>
+          </a:p>
+        </p:txBody>
+      </p:sp>
+      <p:sp>
+        <p:nvSpPr>
+          <p:cNvPr id="3" name="Content Placeholder 2">
+            <a:extLst>
+              <a:ext uri="{FF2B5EF4-FFF2-40B4-BE49-F238E27FC236}">
+                <a16:creationId xmlns:a16="http://schemas.microsoft.com/office/drawing/2014/main" id="{5E30BABB-A5A5-A95D-8DB1-6B93F86A91B6}"/>
+              </a:ext>
+            </a:extLst>
+          </p:cNvPr>
+          <p:cNvSpPr>
+            <a:spLocks noGrp="1"/>
+          </p:cNvSpPr>
+          <p:nvPr>
+            <p:ph idx="1"/>
+          </p:nvPr>
+        </p:nvSpPr>
+        <p:spPr/>
+        <p:txBody>
+          <a:bodyPr>
+            <a:noAutofit/>
+          </a:bodyPr>
+          <a:lstStyle/>
+          <a:p>
+            <a:pPr marL="0" indent="0">
+              <a:buNone/>
+            </a:pPr>
+            <a:r>
+              <a:rPr lang="en-US" dirty="0"/>
+              <a:t>(reaction to layout- and traversal-agnostic design)</a:t>
+            </a:r>
+          </a:p>
+          <a:p>
+            <a:endParaRPr lang="en-US" dirty="0"/>
+          </a:p>
+          <a:p>
+            <a:r>
+              <a:rPr lang="en-US" dirty="0" err="1"/>
+              <a:t>Kokkos</a:t>
+            </a:r>
+            <a:r>
+              <a:rPr lang="en-US" dirty="0"/>
+              <a:t> Views (and </a:t>
+            </a:r>
+            <a:r>
+              <a:rPr lang="en-US" dirty="0" err="1"/>
+              <a:t>mdspans</a:t>
+            </a:r>
+            <a:r>
+              <a:rPr lang="en-US" dirty="0"/>
+              <a:t>) abstract physical memory layout</a:t>
+            </a:r>
+          </a:p>
+          <a:p>
+            <a:pPr lvl="1"/>
+            <a:r>
+              <a:rPr lang="en-US" dirty="0"/>
+              <a:t>Limited to multidimensional arrays</a:t>
+            </a:r>
+          </a:p>
+          <a:p>
+            <a:pPr lvl="1"/>
+            <a:r>
+              <a:rPr lang="en-US" dirty="0"/>
+              <a:t>Mostly focus row-major vs column-major (and custom strides)</a:t>
+            </a:r>
+          </a:p>
+          <a:p>
+            <a:pPr lvl="1"/>
+            <a:r>
+              <a:rPr lang="en-US" dirty="0" err="1"/>
+              <a:t>Subview</a:t>
+            </a:r>
+            <a:r>
+              <a:rPr lang="en-US" dirty="0"/>
+              <a:t> </a:t>
+            </a:r>
+            <a:r>
+              <a:rPr lang="en-US" dirty="0">
+                <a:sym typeface="Wingdings" panose="05000000000000000000" pitchFamily="2" charset="2"/>
+              </a:rPr>
+              <a:t> the only supported transformation</a:t>
+            </a:r>
+          </a:p>
+          <a:p>
+            <a:pPr lvl="1"/>
+            <a:r>
+              <a:rPr lang="en-US" dirty="0" err="1">
+                <a:sym typeface="Wingdings" panose="05000000000000000000" pitchFamily="2" charset="2"/>
+              </a:rPr>
+              <a:t>CUTe</a:t>
+            </a:r>
+            <a:r>
+              <a:rPr lang="en-US" dirty="0">
+                <a:sym typeface="Wingdings" panose="05000000000000000000" pitchFamily="2" charset="2"/>
+              </a:rPr>
+              <a:t> supports more general layout algebra</a:t>
+            </a:r>
+          </a:p>
+          <a:p>
+            <a:r>
+              <a:rPr lang="en-US" dirty="0">
+                <a:sym typeface="Wingdings" panose="05000000000000000000" pitchFamily="2" charset="2"/>
+              </a:rPr>
+              <a:t>OpenMP (6.0)  some powerful loop transformation directives</a:t>
+            </a:r>
+          </a:p>
+          <a:p>
+            <a:pPr lvl="1"/>
+            <a:r>
+              <a:rPr lang="en-US" dirty="0"/>
+              <a:t>Not exactly traversal-agnostic design; good alternative in many use cases</a:t>
+            </a:r>
+          </a:p>
+          <a:p>
+            <a:r>
+              <a:rPr lang="en-US" dirty="0"/>
+              <a:t>Some traversal-agnostic capabilities in </a:t>
+            </a:r>
+            <a:r>
+              <a:rPr lang="en-US" dirty="0" err="1"/>
+              <a:t>GridTools</a:t>
+            </a:r>
+            <a:r>
+              <a:rPr lang="en-US" dirty="0"/>
+              <a:t> and RAJA</a:t>
+            </a:r>
+          </a:p>
+        </p:txBody>
+      </p:sp>
+      <p:sp>
+        <p:nvSpPr>
+          <p:cNvPr id="4" name="Date Placeholder 3">
+            <a:extLst>
+              <a:ext uri="{FF2B5EF4-FFF2-40B4-BE49-F238E27FC236}">
+                <a16:creationId xmlns:a16="http://schemas.microsoft.com/office/drawing/2014/main" id="{1D30CB14-538F-D9BD-31BC-4BF79D148A24}"/>
+              </a:ext>
+            </a:extLst>
+          </p:cNvPr>
+          <p:cNvSpPr>
+            <a:spLocks noGrp="1"/>
+          </p:cNvSpPr>
+          <p:nvPr>
+            <p:ph type="dt" sz="half" idx="10"/>
+          </p:nvPr>
+        </p:nvSpPr>
+        <p:spPr/>
+        <p:txBody>
+          <a:bodyPr/>
+          <a:lstStyle/>
+          <a:p>
+            <a:fld id="{358C28A6-2969-482E-9A3B-5E13FCD8DD03}" type="datetime1">
+              <a:rPr lang="en-US" smtClean="0"/>
+              <a:t>8/30/2026</a:t>
+            </a:fld>
+            <a:endParaRPr lang="en-US"/>
+          </a:p>
+        </p:txBody>
+      </p:sp>
+      <p:sp>
+        <p:nvSpPr>
+          <p:cNvPr id="5" name="Slide Number Placeholder 4">
+            <a:extLst>
+              <a:ext uri="{FF2B5EF4-FFF2-40B4-BE49-F238E27FC236}">
+                <a16:creationId xmlns:a16="http://schemas.microsoft.com/office/drawing/2014/main" id="{6CB55591-70A5-4366-E73A-F1A5B371B2E3}"/>
+              </a:ext>
+            </a:extLst>
+          </p:cNvPr>
+          <p:cNvSpPr>
+            <a:spLocks noGrp="1"/>
+          </p:cNvSpPr>
+          <p:nvPr>
+            <p:ph type="sldNum" sz="quarter" idx="12"/>
+          </p:nvPr>
+        </p:nvSpPr>
+        <p:spPr/>
+        <p:txBody>
+          <a:bodyPr/>
+          <a:lstStyle/>
+          <a:p>
+            <a:fld id="{DA0BB241-1B5F-4309-9407-9EEA04D9598D}" type="slidenum">
+              <a:rPr lang="en-US" smtClean="0"/>
+              <a:t>33</a:t>
+            </a:fld>
+            <a:endParaRPr lang="en-US"/>
+          </a:p>
+        </p:txBody>
+      </p:sp>
+    </p:spTree>
+    <p:extLst>
+      <p:ext uri="{BB962C8B-B14F-4D97-AF65-F5344CB8AC3E}">
+        <p14:creationId xmlns:p14="http://schemas.microsoft.com/office/powerpoint/2010/main" val="390188030"/>
+      </p:ext>
+    </p:extLst>
+  </p:cSld>
+  <p:clrMapOvr>
+    <a:masterClrMapping/>
+  </p:clrMapOvr>
+</p:sld>
+</file>
+
+<file path=ppt/slides/slide34.xml><?xml version="1.0" encoding="utf-8"?>
+<p:sld xmlns:a="http://schemas.openxmlformats.org/drawingml/2006/main" xmlns:r="http://schemas.openxmlformats.org/officeDocument/2006/relationships" xmlns:p="http://schemas.openxmlformats.org/presentationml/2006/main">
+  <p:cSld>
+    <p:spTree>
+      <p:nvGrpSpPr>
+        <p:cNvPr id="1" name=""/>
+        <p:cNvGrpSpPr/>
+        <p:nvPr/>
+      </p:nvGrpSpPr>
+      <p:grpSpPr>
+        <a:xfrm>
+          <a:off x="0" y="0"/>
+          <a:ext cx="0" cy="0"/>
+          <a:chOff x="0" y="0"/>
+          <a:chExt cx="0" cy="0"/>
+        </a:xfrm>
+      </p:grpSpPr>
+      <p:sp>
+        <p:nvSpPr>
+          <p:cNvPr id="2" name="Title 1">
+            <a:extLst>
+              <a:ext uri="{FF2B5EF4-FFF2-40B4-BE49-F238E27FC236}">
+                <a16:creationId xmlns:a16="http://schemas.microsoft.com/office/drawing/2014/main" id="{F24C5C75-72D4-F8D1-AAB2-87E7B5F2197D}"/>
+              </a:ext>
+            </a:extLst>
+          </p:cNvPr>
+          <p:cNvSpPr>
+            <a:spLocks noGrp="1"/>
+          </p:cNvSpPr>
+          <p:nvPr>
+            <p:ph type="title"/>
+          </p:nvPr>
+        </p:nvSpPr>
+        <p:spPr/>
+        <p:txBody>
+          <a:bodyPr/>
+          <a:lstStyle/>
+          <a:p>
+            <a:r>
+              <a:rPr lang="en-US" dirty="0"/>
+              <a:t>Comparison table?</a:t>
+            </a:r>
+          </a:p>
+        </p:txBody>
+      </p:sp>
+      <p:sp>
+        <p:nvSpPr>
+          <p:cNvPr id="3" name="Content Placeholder 2">
+            <a:extLst>
+              <a:ext uri="{FF2B5EF4-FFF2-40B4-BE49-F238E27FC236}">
+                <a16:creationId xmlns:a16="http://schemas.microsoft.com/office/drawing/2014/main" id="{EFD4FC06-723D-4133-C57B-96E03F8E703F}"/>
+              </a:ext>
+            </a:extLst>
+          </p:cNvPr>
+          <p:cNvSpPr>
+            <a:spLocks noGrp="1"/>
+          </p:cNvSpPr>
+          <p:nvPr>
+            <p:ph idx="1"/>
+          </p:nvPr>
+        </p:nvSpPr>
+        <p:spPr/>
+        <p:txBody>
+          <a:bodyPr/>
+          <a:lstStyle/>
+          <a:p>
+            <a:r>
+              <a:rPr lang="en-US" dirty="0" err="1"/>
+              <a:t>Mdspan</a:t>
+            </a:r>
+            <a:r>
+              <a:rPr lang="en-US" dirty="0"/>
+              <a:t>, </a:t>
+            </a:r>
+            <a:r>
+              <a:rPr lang="en-US" dirty="0" err="1"/>
+              <a:t>Kokkos</a:t>
+            </a:r>
+            <a:r>
+              <a:rPr lang="en-US" dirty="0"/>
+              <a:t>, Raja, </a:t>
+            </a:r>
+            <a:r>
+              <a:rPr lang="en-US" dirty="0" err="1"/>
+              <a:t>CuTe</a:t>
+            </a:r>
+            <a:r>
+              <a:rPr lang="en-US" dirty="0"/>
+              <a:t>, </a:t>
+            </a:r>
+            <a:r>
+              <a:rPr lang="en-US" dirty="0" err="1"/>
+              <a:t>GridTools</a:t>
+            </a:r>
+            <a:r>
+              <a:rPr lang="en-US" dirty="0"/>
+              <a:t>, OpenMP loops, </a:t>
+            </a:r>
+            <a:r>
+              <a:rPr lang="en-US" dirty="0" err="1"/>
+              <a:t>Noarr</a:t>
+            </a:r>
+            <a:r>
+              <a:rPr lang="en-US" dirty="0"/>
+              <a:t> </a:t>
+            </a:r>
+            <a:r>
+              <a:rPr lang="en-US" dirty="0" err="1"/>
+              <a:t>Cellato</a:t>
+            </a:r>
+            <a:endParaRPr lang="en-US" dirty="0"/>
+          </a:p>
+        </p:txBody>
+      </p:sp>
+      <p:sp>
+        <p:nvSpPr>
+          <p:cNvPr id="4" name="Date Placeholder 3">
+            <a:extLst>
+              <a:ext uri="{FF2B5EF4-FFF2-40B4-BE49-F238E27FC236}">
+                <a16:creationId xmlns:a16="http://schemas.microsoft.com/office/drawing/2014/main" id="{AC63D3EB-3E46-0420-084C-0ABC25889B18}"/>
+              </a:ext>
+            </a:extLst>
+          </p:cNvPr>
+          <p:cNvSpPr>
+            <a:spLocks noGrp="1"/>
+          </p:cNvSpPr>
+          <p:nvPr>
+            <p:ph type="dt" sz="half" idx="10"/>
+          </p:nvPr>
+        </p:nvSpPr>
+        <p:spPr/>
+        <p:txBody>
+          <a:bodyPr/>
+          <a:lstStyle/>
+          <a:p>
+            <a:fld id="{358C28A6-2969-482E-9A3B-5E13FCD8DD03}" type="datetime1">
+              <a:rPr lang="en-US" smtClean="0"/>
+              <a:t>8/30/2026</a:t>
+            </a:fld>
+            <a:endParaRPr lang="en-US"/>
+          </a:p>
+        </p:txBody>
+      </p:sp>
+      <p:sp>
+        <p:nvSpPr>
+          <p:cNvPr id="5" name="Slide Number Placeholder 4">
+            <a:extLst>
+              <a:ext uri="{FF2B5EF4-FFF2-40B4-BE49-F238E27FC236}">
+                <a16:creationId xmlns:a16="http://schemas.microsoft.com/office/drawing/2014/main" id="{69B0E3B4-2FE9-EF9E-DBB8-AFE3DD090B8B}"/>
+              </a:ext>
+            </a:extLst>
+          </p:cNvPr>
+          <p:cNvSpPr>
+            <a:spLocks noGrp="1"/>
+          </p:cNvSpPr>
+          <p:nvPr>
+            <p:ph type="sldNum" sz="quarter" idx="12"/>
+          </p:nvPr>
+        </p:nvSpPr>
+        <p:spPr/>
+        <p:txBody>
+          <a:bodyPr/>
+          <a:lstStyle/>
+          <a:p>
+            <a:fld id="{DA0BB241-1B5F-4309-9407-9EEA04D9598D}" type="slidenum">
+              <a:rPr lang="en-US" smtClean="0"/>
+              <a:t>34</a:t>
+            </a:fld>
+            <a:endParaRPr lang="en-US"/>
+          </a:p>
+        </p:txBody>
+      </p:sp>
+    </p:spTree>
+    <p:extLst>
+      <p:ext uri="{BB962C8B-B14F-4D97-AF65-F5344CB8AC3E}">
+        <p14:creationId xmlns:p14="http://schemas.microsoft.com/office/powerpoint/2010/main" val="1413752545"/>
+      </p:ext>
+    </p:extLst>
+  </p:cSld>
+  <p:clrMapOvr>
+    <a:masterClrMapping/>
+  </p:clrMapOvr>
+</p:sld>
+</file>
+
+<file path=ppt/slides/slide35.xml><?xml version="1.0" encoding="utf-8"?>
+<p:sld xmlns:a="http://schemas.openxmlformats.org/drawingml/2006/main" xmlns:r="http://schemas.openxmlformats.org/officeDocument/2006/relationships" xmlns:p="http://schemas.openxmlformats.org/presentationml/2006/main">
+  <p:cSld>
+    <p:bg>
+      <p:bgPr>
+        <a:solidFill>
+          <a:srgbClr val="FFFF00"/>
+        </a:solidFill>
+        <a:effectLst/>
+      </p:bgPr>
+    </p:bg>
+    <p:spTree>
+      <p:nvGrpSpPr>
+        <p:cNvPr id="1" name="">
+          <a:extLst>
+            <a:ext uri="{FF2B5EF4-FFF2-40B4-BE49-F238E27FC236}">
+              <a16:creationId xmlns:a16="http://schemas.microsoft.com/office/drawing/2014/main" id="{A9270497-CBB6-D2E1-4D1A-ED2AA0BB713B}"/>
+            </a:ext>
+          </a:extLst>
+        </p:cNvPr>
+        <p:cNvGrpSpPr/>
+        <p:nvPr/>
+      </p:nvGrpSpPr>
+      <p:grpSpPr>
+        <a:xfrm>
+          <a:off x="0" y="0"/>
+          <a:ext cx="0" cy="0"/>
+          <a:chOff x="0" y="0"/>
+          <a:chExt cx="0" cy="0"/>
+        </a:xfrm>
+      </p:grpSpPr>
+      <p:sp>
+        <p:nvSpPr>
+          <p:cNvPr id="2" name="Title 1">
+            <a:extLst>
+              <a:ext uri="{FF2B5EF4-FFF2-40B4-BE49-F238E27FC236}">
+                <a16:creationId xmlns:a16="http://schemas.microsoft.com/office/drawing/2014/main" id="{F14ECE5F-2C1C-357D-AE8A-7FA4DA556E91}"/>
+              </a:ext>
+            </a:extLst>
+          </p:cNvPr>
+          <p:cNvSpPr>
+            <a:spLocks noGrp="1"/>
+          </p:cNvSpPr>
+          <p:nvPr>
+            <p:ph type="title"/>
+          </p:nvPr>
+        </p:nvSpPr>
+        <p:spPr/>
+        <p:txBody>
+          <a:bodyPr/>
+          <a:lstStyle/>
+          <a:p>
+            <a:r>
+              <a:rPr lang="en-US" noProof="0" dirty="0"/>
+              <a:t>Template-exclusive statements</a:t>
+            </a:r>
+          </a:p>
+        </p:txBody>
+      </p:sp>
+      <p:sp>
+        <p:nvSpPr>
+          <p:cNvPr id="3" name="Content Placeholder 2">
+            <a:extLst>
+              <a:ext uri="{FF2B5EF4-FFF2-40B4-BE49-F238E27FC236}">
+                <a16:creationId xmlns:a16="http://schemas.microsoft.com/office/drawing/2014/main" id="{8FF9516C-E8E3-08CD-1240-AB67A5640919}"/>
+              </a:ext>
+            </a:extLst>
+          </p:cNvPr>
+          <p:cNvSpPr>
+            <a:spLocks noGrp="1"/>
+          </p:cNvSpPr>
+          <p:nvPr>
+            <p:ph idx="1"/>
+          </p:nvPr>
+        </p:nvSpPr>
+        <p:spPr/>
+        <p:txBody>
+          <a:bodyPr/>
+          <a:lstStyle/>
+          <a:p>
+            <a:endParaRPr lang="en-US" noProof="0" dirty="0"/>
+          </a:p>
+        </p:txBody>
+      </p:sp>
+      <p:sp>
+        <p:nvSpPr>
+          <p:cNvPr id="4" name="Date Placeholder 3">
+            <a:extLst>
+              <a:ext uri="{FF2B5EF4-FFF2-40B4-BE49-F238E27FC236}">
+                <a16:creationId xmlns:a16="http://schemas.microsoft.com/office/drawing/2014/main" id="{201D6062-9A3A-0AD5-574A-E26659D7FBAC}"/>
+              </a:ext>
+            </a:extLst>
+          </p:cNvPr>
+          <p:cNvSpPr>
+            <a:spLocks noGrp="1"/>
+          </p:cNvSpPr>
+          <p:nvPr>
+            <p:ph type="dt" sz="half" idx="10"/>
+          </p:nvPr>
+        </p:nvSpPr>
+        <p:spPr/>
+        <p:txBody>
+          <a:bodyPr/>
+          <a:lstStyle/>
+          <a:p>
+            <a:fld id="{0601A530-81CA-410E-A053-EF7BD11F8EF0}" type="datetime1">
+              <a:rPr lang="en-US" noProof="0" smtClean="0"/>
+              <a:t>8/30/2026</a:t>
+            </a:fld>
+            <a:endParaRPr lang="en-US" noProof="0" dirty="0"/>
+          </a:p>
+        </p:txBody>
+      </p:sp>
+      <p:sp>
+        <p:nvSpPr>
+          <p:cNvPr id="5" name="Slide Number Placeholder 4">
+            <a:extLst>
+              <a:ext uri="{FF2B5EF4-FFF2-40B4-BE49-F238E27FC236}">
+                <a16:creationId xmlns:a16="http://schemas.microsoft.com/office/drawing/2014/main" id="{86B73E9E-8DA4-6D98-F073-7AF2BF2083AC}"/>
+              </a:ext>
+            </a:extLst>
+          </p:cNvPr>
+          <p:cNvSpPr>
+            <a:spLocks noGrp="1"/>
+          </p:cNvSpPr>
+          <p:nvPr>
+            <p:ph type="sldNum" sz="quarter" idx="12"/>
+          </p:nvPr>
+        </p:nvSpPr>
+        <p:spPr/>
+        <p:txBody>
+          <a:bodyPr/>
+          <a:lstStyle/>
+          <a:p>
+            <a:fld id="{DA0BB241-1B5F-4309-9407-9EEA04D9598D}" type="slidenum">
+              <a:rPr lang="en-US" noProof="0" smtClean="0"/>
+              <a:t>35</a:t>
+            </a:fld>
+            <a:endParaRPr lang="en-US" noProof="0" dirty="0"/>
+          </a:p>
+        </p:txBody>
+      </p:sp>
+    </p:spTree>
+    <p:extLst>
+      <p:ext uri="{BB962C8B-B14F-4D97-AF65-F5344CB8AC3E}">
+        <p14:creationId xmlns:p14="http://schemas.microsoft.com/office/powerpoint/2010/main" val="3444521087"/>
       </p:ext>
     </p:extLst>
   </p:cSld>
@@ -26657,7 +28942,7 @@
           <a:p>
             <a:fld id="{938C8B4D-7ED9-4C51-A12C-8A3FEA1E5194}" type="datetime1">
               <a:rPr lang="en-US" noProof="0" smtClean="0"/>
-              <a:t>8/29/2026</a:t>
+              <a:t>8/30/2026</a:t>
             </a:fld>
             <a:endParaRPr lang="en-US" noProof="0" dirty="0"/>
           </a:p>
@@ -27406,8 +29691,8 @@
           </a:p>
         </p:txBody>
       </p:sp>
-      <mc:AlternateContent xmlns:mc="http://schemas.openxmlformats.org/markup-compatibility/2006">
-        <mc:Choice xmlns:a14="http://schemas.microsoft.com/office/drawing/2010/main" Requires="a14">
+      <mc:AlternateContent xmlns:mc="http://schemas.openxmlformats.org/markup-compatibility/2006" xmlns:a14="http://schemas.microsoft.com/office/drawing/2010/main">
+        <mc:Choice Requires="a14">
           <p:sp>
             <p:nvSpPr>
               <p:cNvPr id="3" name="TextBox 2">
@@ -27436,6 +29721,7 @@
               </a:bodyPr>
               <a:lstStyle/>
               <a:p>
+                <a:pPr/>
                 <a14:m>
                   <m:oMathPara xmlns:m="http://schemas.openxmlformats.org/officeDocument/2006/math">
                     <m:oMath>
@@ -27477,7 +29763,7 @@
             </p:txBody>
           </p:sp>
         </mc:Choice>
-        <mc:Fallback>
+        <mc:Fallback xmlns="">
           <p:sp>
             <p:nvSpPr>
               <p:cNvPr id="3" name="TextBox 2">
@@ -27522,8 +29808,8 @@
           </p:sp>
         </mc:Fallback>
       </mc:AlternateContent>
-      <mc:AlternateContent xmlns:mc="http://schemas.openxmlformats.org/markup-compatibility/2006">
-        <mc:Choice xmlns:a14="http://schemas.microsoft.com/office/drawing/2010/main" Requires="a14">
+      <mc:AlternateContent xmlns:mc="http://schemas.openxmlformats.org/markup-compatibility/2006" xmlns:a14="http://schemas.microsoft.com/office/drawing/2010/main">
+        <mc:Choice Requires="a14">
           <p:sp>
             <p:nvSpPr>
               <p:cNvPr id="5" name="TextBox 4">
@@ -27594,7 +29880,7 @@
             </p:txBody>
           </p:sp>
         </mc:Choice>
-        <mc:Fallback>
+        <mc:Fallback xmlns="">
           <p:sp>
             <p:nvSpPr>
               <p:cNvPr id="5" name="TextBox 4">
@@ -29044,7 +31330,7 @@
           <a:p>
             <a:fld id="{2A57731D-07D7-4C44-A482-993035AAE3B2}" type="datetime1">
               <a:rPr lang="en-US" noProof="0" smtClean="0"/>
-              <a:t>8/29/2026</a:t>
+              <a:t>8/30/2026</a:t>
             </a:fld>
             <a:endParaRPr lang="en-US" noProof="0" dirty="0"/>
           </a:p>
@@ -30769,7 +33055,7 @@
           <a:p>
             <a:fld id="{EDBD1638-F548-41E6-A67D-BF07DFBF4593}" type="datetime1">
               <a:rPr lang="en-US" noProof="0" smtClean="0"/>
-              <a:t>8/29/2026</a:t>
+              <a:t>8/30/2026</a:t>
             </a:fld>
             <a:endParaRPr lang="en-US" noProof="0" dirty="0"/>
           </a:p>
@@ -30967,7 +33253,7 @@
           <a:p>
             <a:fld id="{EDBD1638-F548-41E6-A67D-BF07DFBF4593}" type="datetime1">
               <a:rPr lang="en-US" noProof="0" smtClean="0"/>
-              <a:t>8/29/2026</a:t>
+              <a:t>8/30/2026</a:t>
             </a:fld>
             <a:endParaRPr lang="en-US" noProof="0" dirty="0"/>
           </a:p>
@@ -34926,8 +37212,8 @@
               </p:txBody>
             </p:sp>
           </p:grpSp>
-          <mc:AlternateContent xmlns:mc="http://schemas.openxmlformats.org/markup-compatibility/2006">
-            <mc:Choice xmlns:a14="http://schemas.microsoft.com/office/drawing/2010/main" Requires="a14">
+          <mc:AlternateContent xmlns:mc="http://schemas.openxmlformats.org/markup-compatibility/2006" xmlns:a14="http://schemas.microsoft.com/office/drawing/2010/main">
+            <mc:Choice Requires="a14">
               <p:sp>
                 <p:nvSpPr>
                   <p:cNvPr id="161" name="TextBox 160">
@@ -34956,6 +37242,7 @@
                   </a:bodyPr>
                   <a:lstStyle/>
                   <a:p>
+                    <a:pPr/>
                     <a14:m>
                       <m:oMathPara xmlns:m="http://schemas.openxmlformats.org/officeDocument/2006/math">
                         <m:oMath>
@@ -34973,7 +37260,7 @@
                 </p:txBody>
               </p:sp>
             </mc:Choice>
-            <mc:Fallback>
+            <mc:Fallback xmlns="">
               <p:sp>
                 <p:nvSpPr>
                   <p:cNvPr id="161" name="TextBox 160">
@@ -35018,8 +37305,8 @@
               </p:sp>
             </mc:Fallback>
           </mc:AlternateContent>
-          <mc:AlternateContent xmlns:mc="http://schemas.openxmlformats.org/markup-compatibility/2006">
-            <mc:Choice xmlns:a14="http://schemas.microsoft.com/office/drawing/2010/main" Requires="a14">
+          <mc:AlternateContent xmlns:mc="http://schemas.openxmlformats.org/markup-compatibility/2006" xmlns:a14="http://schemas.microsoft.com/office/drawing/2010/main">
+            <mc:Choice Requires="a14">
               <p:sp>
                 <p:nvSpPr>
                   <p:cNvPr id="163" name="TextBox 162">
@@ -35066,7 +37353,7 @@
                 </p:txBody>
               </p:sp>
             </mc:Choice>
-            <mc:Fallback>
+            <mc:Fallback xmlns="">
               <p:sp>
                 <p:nvSpPr>
                   <p:cNvPr id="163" name="TextBox 162">
@@ -35234,8 +37521,8 @@
               </a:p>
             </p:txBody>
           </p:sp>
-          <mc:AlternateContent xmlns:mc="http://schemas.openxmlformats.org/markup-compatibility/2006">
-            <mc:Choice xmlns:a14="http://schemas.microsoft.com/office/drawing/2010/main" Requires="a14">
+          <mc:AlternateContent xmlns:mc="http://schemas.openxmlformats.org/markup-compatibility/2006" xmlns:a14="http://schemas.microsoft.com/office/drawing/2010/main">
+            <mc:Choice Requires="a14">
               <p:sp>
                 <p:nvSpPr>
                   <p:cNvPr id="169" name="TextBox 168">
@@ -35264,6 +37551,7 @@
                   </a:bodyPr>
                   <a:lstStyle/>
                   <a:p>
+                    <a:pPr/>
                     <a14:m>
                       <m:oMathPara xmlns:m="http://schemas.openxmlformats.org/officeDocument/2006/math">
                         <m:oMath>
@@ -35281,7 +37569,7 @@
                 </p:txBody>
               </p:sp>
             </mc:Choice>
-            <mc:Fallback>
+            <mc:Fallback xmlns="">
               <p:sp>
                 <p:nvSpPr>
                   <p:cNvPr id="169" name="TextBox 168">
@@ -35326,8 +37614,8 @@
               </p:sp>
             </mc:Fallback>
           </mc:AlternateContent>
-          <mc:AlternateContent xmlns:mc="http://schemas.openxmlformats.org/markup-compatibility/2006">
-            <mc:Choice xmlns:a14="http://schemas.microsoft.com/office/drawing/2010/main" Requires="a14">
+          <mc:AlternateContent xmlns:mc="http://schemas.openxmlformats.org/markup-compatibility/2006" xmlns:a14="http://schemas.microsoft.com/office/drawing/2010/main">
+            <mc:Choice Requires="a14">
               <p:sp>
                 <p:nvSpPr>
                   <p:cNvPr id="171" name="TextBox 170">
@@ -35374,7 +37662,7 @@
                 </p:txBody>
               </p:sp>
             </mc:Choice>
-            <mc:Fallback>
+            <mc:Fallback xmlns="">
               <p:sp>
                 <p:nvSpPr>
                   <p:cNvPr id="171" name="TextBox 170">
@@ -35419,8 +37707,8 @@
               </p:sp>
             </mc:Fallback>
           </mc:AlternateContent>
-          <mc:AlternateContent xmlns:mc="http://schemas.openxmlformats.org/markup-compatibility/2006">
-            <mc:Choice xmlns:a14="http://schemas.microsoft.com/office/drawing/2010/main" Requires="a14">
+          <mc:AlternateContent xmlns:mc="http://schemas.openxmlformats.org/markup-compatibility/2006" xmlns:a14="http://schemas.microsoft.com/office/drawing/2010/main">
+            <mc:Choice Requires="a14">
               <p:sp>
                 <p:nvSpPr>
                   <p:cNvPr id="173" name="TextBox 172">
@@ -35467,7 +37755,7 @@
                 </p:txBody>
               </p:sp>
             </mc:Choice>
-            <mc:Fallback>
+            <mc:Fallback xmlns="">
               <p:sp>
                 <p:nvSpPr>
                   <p:cNvPr id="173" name="TextBox 172">
@@ -35512,8 +37800,8 @@
               </p:sp>
             </mc:Fallback>
           </mc:AlternateContent>
-          <mc:AlternateContent xmlns:mc="http://schemas.openxmlformats.org/markup-compatibility/2006">
-            <mc:Choice xmlns:a14="http://schemas.microsoft.com/office/drawing/2010/main" Requires="a14">
+          <mc:AlternateContent xmlns:mc="http://schemas.openxmlformats.org/markup-compatibility/2006" xmlns:a14="http://schemas.microsoft.com/office/drawing/2010/main">
+            <mc:Choice Requires="a14">
               <p:sp>
                 <p:nvSpPr>
                   <p:cNvPr id="175" name="TextBox 174">
@@ -35560,7 +37848,7 @@
                 </p:txBody>
               </p:sp>
             </mc:Choice>
-            <mc:Fallback>
+            <mc:Fallback xmlns="">
               <p:sp>
                 <p:nvSpPr>
                   <p:cNvPr id="175" name="TextBox 174">
@@ -35605,8 +37893,8 @@
               </p:sp>
             </mc:Fallback>
           </mc:AlternateContent>
-          <mc:AlternateContent xmlns:mc="http://schemas.openxmlformats.org/markup-compatibility/2006">
-            <mc:Choice xmlns:a14="http://schemas.microsoft.com/office/drawing/2010/main" Requires="a14">
+          <mc:AlternateContent xmlns:mc="http://schemas.openxmlformats.org/markup-compatibility/2006" xmlns:a14="http://schemas.microsoft.com/office/drawing/2010/main">
+            <mc:Choice Requires="a14">
               <p:sp>
                 <p:nvSpPr>
                   <p:cNvPr id="177" name="TextBox 176">
@@ -35653,7 +37941,7 @@
                 </p:txBody>
               </p:sp>
             </mc:Choice>
-            <mc:Fallback>
+            <mc:Fallback xmlns="">
               <p:sp>
                 <p:nvSpPr>
                   <p:cNvPr id="177" name="TextBox 176">
@@ -35698,8 +37986,8 @@
               </p:sp>
             </mc:Fallback>
           </mc:AlternateContent>
-          <mc:AlternateContent xmlns:mc="http://schemas.openxmlformats.org/markup-compatibility/2006">
-            <mc:Choice xmlns:a14="http://schemas.microsoft.com/office/drawing/2010/main" Requires="a14">
+          <mc:AlternateContent xmlns:mc="http://schemas.openxmlformats.org/markup-compatibility/2006" xmlns:a14="http://schemas.microsoft.com/office/drawing/2010/main">
+            <mc:Choice Requires="a14">
               <p:sp>
                 <p:nvSpPr>
                   <p:cNvPr id="179" name="TextBox 178">
@@ -35746,7 +38034,7 @@
                 </p:txBody>
               </p:sp>
             </mc:Choice>
-            <mc:Fallback>
+            <mc:Fallback xmlns="">
               <p:sp>
                 <p:nvSpPr>
                   <p:cNvPr id="179" name="TextBox 178">
@@ -35793,8 +38081,8 @@
           </mc:AlternateContent>
         </p:grpSp>
       </p:grpSp>
-      <mc:AlternateContent xmlns:mc="http://schemas.openxmlformats.org/markup-compatibility/2006">
-        <mc:Choice xmlns:a14="http://schemas.microsoft.com/office/drawing/2010/main" Requires="a14">
+      <mc:AlternateContent xmlns:mc="http://schemas.openxmlformats.org/markup-compatibility/2006" xmlns:a14="http://schemas.microsoft.com/office/drawing/2010/main">
+        <mc:Choice Requires="a14">
           <p:sp>
             <p:nvSpPr>
               <p:cNvPr id="183" name="TextBox 182">
@@ -35828,6 +38116,7 @@
               </a:bodyPr>
               <a:lstStyle/>
               <a:p>
+                <a:pPr/>
                 <a14:m>
                   <m:oMathPara xmlns:m="http://schemas.openxmlformats.org/officeDocument/2006/math">
                     <m:oMath>
@@ -35981,7 +38270,7 @@
             </p:txBody>
           </p:sp>
         </mc:Choice>
-        <mc:Fallback>
+        <mc:Fallback xmlns="">
           <p:sp>
             <p:nvSpPr>
               <p:cNvPr id="183" name="TextBox 182">
@@ -36096,11 +38385,6 @@
           <a:prstGeom prst="leftBrace">
             <a:avLst/>
           </a:prstGeom>
-          <a:ln>
-            <a:solidFill>
-              <a:schemeClr val="tx1"/>
-            </a:solidFill>
-          </a:ln>
         </p:spPr>
         <p:style>
           <a:lnRef idx="2">
@@ -36308,6 +38592,476 @@
       </p:sp>
       <p:sp>
         <p:nvSpPr>
+          <p:cNvPr id="26" name="Date Placeholder 25">
+            <a:extLst>
+              <a:ext uri="{FF2B5EF4-FFF2-40B4-BE49-F238E27FC236}">
+                <a16:creationId xmlns:a16="http://schemas.microsoft.com/office/drawing/2014/main" id="{FE517BC7-E591-4BF3-D827-EFF2CD30D196}"/>
+              </a:ext>
+            </a:extLst>
+          </p:cNvPr>
+          <p:cNvSpPr>
+            <a:spLocks noGrp="1"/>
+          </p:cNvSpPr>
+          <p:nvPr>
+            <p:ph type="dt" sz="half" idx="10"/>
+          </p:nvPr>
+        </p:nvSpPr>
+        <p:spPr/>
+        <p:txBody>
+          <a:bodyPr/>
+          <a:lstStyle/>
+          <a:p>
+            <a:fld id="{8BB690F1-35CC-4B34-B898-A35702C2DAD5}" type="datetime1">
+              <a:rPr lang="en-US" noProof="0" smtClean="0"/>
+              <a:t>8/30/2026</a:t>
+            </a:fld>
+            <a:endParaRPr lang="en-US" noProof="0" dirty="0"/>
+          </a:p>
+        </p:txBody>
+      </p:sp>
+      <p:sp>
+        <p:nvSpPr>
+          <p:cNvPr id="27" name="Slide Number Placeholder 26">
+            <a:extLst>
+              <a:ext uri="{FF2B5EF4-FFF2-40B4-BE49-F238E27FC236}">
+                <a16:creationId xmlns:a16="http://schemas.microsoft.com/office/drawing/2014/main" id="{B740945D-1B4C-1335-1A43-458E59CE57FB}"/>
+              </a:ext>
+            </a:extLst>
+          </p:cNvPr>
+          <p:cNvSpPr>
+            <a:spLocks noGrp="1"/>
+          </p:cNvSpPr>
+          <p:nvPr>
+            <p:ph type="sldNum" sz="quarter" idx="12"/>
+          </p:nvPr>
+        </p:nvSpPr>
+        <p:spPr/>
+        <p:txBody>
+          <a:bodyPr/>
+          <a:lstStyle/>
+          <a:p>
+            <a:fld id="{DA0BB241-1B5F-4309-9407-9EEA04D9598D}" type="slidenum">
+              <a:rPr lang="en-US" noProof="0" smtClean="0"/>
+              <a:t>8</a:t>
+            </a:fld>
+            <a:endParaRPr lang="en-US" noProof="0" dirty="0"/>
+          </a:p>
+        </p:txBody>
+      </p:sp>
+      <p:sp>
+        <p:nvSpPr>
+          <p:cNvPr id="21" name="TextBox 20">
+            <a:extLst>
+              <a:ext uri="{FF2B5EF4-FFF2-40B4-BE49-F238E27FC236}">
+                <a16:creationId xmlns:a16="http://schemas.microsoft.com/office/drawing/2014/main" id="{3F6B7F5F-6A6B-7B50-99CB-AE3DAB2E86D8}"/>
+              </a:ext>
+            </a:extLst>
+          </p:cNvPr>
+          <p:cNvSpPr txBox="1"/>
+          <p:nvPr/>
+        </p:nvSpPr>
+        <p:spPr>
+          <a:xfrm>
+            <a:off x="5068155" y="4495744"/>
+            <a:ext cx="2055691" cy="461665"/>
+          </a:xfrm>
+          <a:prstGeom prst="rect">
+            <a:avLst/>
+          </a:prstGeom>
+        </p:spPr>
+        <p:style>
+          <a:lnRef idx="1">
+            <a:schemeClr val="accent4"/>
+          </a:lnRef>
+          <a:fillRef idx="2">
+            <a:schemeClr val="accent4"/>
+          </a:fillRef>
+          <a:effectRef idx="1">
+            <a:schemeClr val="accent4"/>
+          </a:effectRef>
+          <a:fontRef idx="minor">
+            <a:schemeClr val="dk1"/>
+          </a:fontRef>
+        </p:style>
+        <p:txBody>
+          <a:bodyPr wrap="none" rtlCol="0">
+            <a:spAutoFit/>
+          </a:bodyPr>
+          <a:lstStyle/>
+          <a:p>
+            <a:r>
+              <a:rPr lang="en-US" sz="2400" dirty="0"/>
+              <a:t>Parallelization</a:t>
+            </a:r>
+          </a:p>
+        </p:txBody>
+      </p:sp>
+      <p:sp>
+        <p:nvSpPr>
+          <p:cNvPr id="23" name="TextBox 22">
+            <a:extLst>
+              <a:ext uri="{FF2B5EF4-FFF2-40B4-BE49-F238E27FC236}">
+                <a16:creationId xmlns:a16="http://schemas.microsoft.com/office/drawing/2014/main" id="{BB09330A-A449-CB40-3FCF-2B26BA222655}"/>
+              </a:ext>
+            </a:extLst>
+          </p:cNvPr>
+          <p:cNvSpPr txBox="1"/>
+          <p:nvPr/>
+        </p:nvSpPr>
+        <p:spPr>
+          <a:xfrm>
+            <a:off x="1716323" y="5458711"/>
+            <a:ext cx="2264558" cy="715089"/>
+          </a:xfrm>
+          <a:prstGeom prst="roundRect">
+            <a:avLst/>
+          </a:prstGeom>
+        </p:spPr>
+        <p:style>
+          <a:lnRef idx="1">
+            <a:schemeClr val="accent6"/>
+          </a:lnRef>
+          <a:fillRef idx="2">
+            <a:schemeClr val="accent6"/>
+          </a:fillRef>
+          <a:effectRef idx="1">
+            <a:schemeClr val="accent6"/>
+          </a:effectRef>
+          <a:fontRef idx="minor">
+            <a:schemeClr val="dk1"/>
+          </a:fontRef>
+        </p:style>
+        <p:txBody>
+          <a:bodyPr wrap="square">
+            <a:spAutoFit/>
+          </a:bodyPr>
+          <a:lstStyle/>
+          <a:p>
+            <a:pPr algn="ctr"/>
+            <a:r>
+              <a:rPr lang="en-US" b="0" noProof="0" dirty="0">
+                <a:solidFill>
+                  <a:schemeClr val="tx1"/>
+                </a:solidFill>
+                <a:effectLst/>
+              </a:rPr>
+              <a:t>OpenMP</a:t>
+            </a:r>
+            <a:br>
+              <a:rPr lang="en-US" b="0" noProof="0" dirty="0">
+                <a:solidFill>
+                  <a:schemeClr val="tx1"/>
+                </a:solidFill>
+                <a:effectLst/>
+                <a:latin typeface="Fira Code" panose="020B0809050000020004" pitchFamily="49" charset="0"/>
+              </a:rPr>
+            </a:br>
+            <a:r>
+              <a:rPr lang="en-US" b="0" noProof="0" dirty="0" err="1">
+                <a:solidFill>
+                  <a:schemeClr val="tx1"/>
+                </a:solidFill>
+                <a:effectLst/>
+                <a:latin typeface="Fira Code" panose="020B0809050000020004" pitchFamily="49" charset="0"/>
+              </a:rPr>
+              <a:t>omp_for_each</a:t>
+            </a:r>
+            <a:endParaRPr lang="en-US" sz="2400" dirty="0">
+              <a:solidFill>
+                <a:schemeClr val="tx1"/>
+              </a:solidFill>
+            </a:endParaRPr>
+          </a:p>
+        </p:txBody>
+      </p:sp>
+      <p:sp>
+        <p:nvSpPr>
+          <p:cNvPr id="25" name="TextBox 24">
+            <a:extLst>
+              <a:ext uri="{FF2B5EF4-FFF2-40B4-BE49-F238E27FC236}">
+                <a16:creationId xmlns:a16="http://schemas.microsoft.com/office/drawing/2014/main" id="{65FADC59-989F-AE0F-9D16-0E35E9C69C74}"/>
+              </a:ext>
+            </a:extLst>
+          </p:cNvPr>
+          <p:cNvSpPr txBox="1"/>
+          <p:nvPr/>
+        </p:nvSpPr>
+        <p:spPr>
+          <a:xfrm>
+            <a:off x="4964185" y="5458712"/>
+            <a:ext cx="2263630" cy="715089"/>
+          </a:xfrm>
+          <a:prstGeom prst="roundRect">
+            <a:avLst/>
+          </a:prstGeom>
+        </p:spPr>
+        <p:style>
+          <a:lnRef idx="1">
+            <a:schemeClr val="accent6"/>
+          </a:lnRef>
+          <a:fillRef idx="2">
+            <a:schemeClr val="accent6"/>
+          </a:fillRef>
+          <a:effectRef idx="1">
+            <a:schemeClr val="accent6"/>
+          </a:effectRef>
+          <a:fontRef idx="minor">
+            <a:schemeClr val="dk1"/>
+          </a:fontRef>
+        </p:style>
+        <p:txBody>
+          <a:bodyPr wrap="square">
+            <a:spAutoFit/>
+          </a:bodyPr>
+          <a:lstStyle/>
+          <a:p>
+            <a:pPr algn="ctr"/>
+            <a:r>
+              <a:rPr lang="en-US" b="0" noProof="0" dirty="0" err="1">
+                <a:solidFill>
+                  <a:schemeClr val="tx1"/>
+                </a:solidFill>
+                <a:effectLst/>
+                <a:latin typeface="Fira Code" panose="020B0809050000020004" pitchFamily="49" charset="0"/>
+              </a:rPr>
+              <a:t>oneTBB</a:t>
+            </a:r>
+            <a:br>
+              <a:rPr lang="en-US" b="0" noProof="0" dirty="0">
+                <a:solidFill>
+                  <a:schemeClr val="tx1"/>
+                </a:solidFill>
+                <a:effectLst/>
+                <a:latin typeface="Fira Code" panose="020B0809050000020004" pitchFamily="49" charset="0"/>
+              </a:rPr>
+            </a:br>
+            <a:r>
+              <a:rPr lang="en-US" b="0" noProof="0" dirty="0" err="1">
+                <a:solidFill>
+                  <a:schemeClr val="tx1"/>
+                </a:solidFill>
+                <a:effectLst/>
+                <a:latin typeface="Fira Code" panose="020B0809050000020004" pitchFamily="49" charset="0"/>
+              </a:rPr>
+              <a:t>tbb_for_each</a:t>
+            </a:r>
+            <a:endParaRPr lang="en-US" sz="2400" dirty="0">
+              <a:solidFill>
+                <a:schemeClr val="tx1"/>
+              </a:solidFill>
+            </a:endParaRPr>
+          </a:p>
+        </p:txBody>
+      </p:sp>
+      <p:sp>
+        <p:nvSpPr>
+          <p:cNvPr id="29" name="TextBox 28">
+            <a:extLst>
+              <a:ext uri="{FF2B5EF4-FFF2-40B4-BE49-F238E27FC236}">
+                <a16:creationId xmlns:a16="http://schemas.microsoft.com/office/drawing/2014/main" id="{BC584833-E86B-4C27-58B9-4ED8496F2A50}"/>
+              </a:ext>
+            </a:extLst>
+          </p:cNvPr>
+          <p:cNvSpPr txBox="1"/>
+          <p:nvPr/>
+        </p:nvSpPr>
+        <p:spPr>
+          <a:xfrm>
+            <a:off x="8212047" y="5458712"/>
+            <a:ext cx="2263630" cy="715089"/>
+          </a:xfrm>
+          <a:prstGeom prst="roundRect">
+            <a:avLst/>
+          </a:prstGeom>
+        </p:spPr>
+        <p:style>
+          <a:lnRef idx="1">
+            <a:schemeClr val="accent6"/>
+          </a:lnRef>
+          <a:fillRef idx="2">
+            <a:schemeClr val="accent6"/>
+          </a:fillRef>
+          <a:effectRef idx="1">
+            <a:schemeClr val="accent6"/>
+          </a:effectRef>
+          <a:fontRef idx="minor">
+            <a:schemeClr val="dk1"/>
+          </a:fontRef>
+        </p:style>
+        <p:txBody>
+          <a:bodyPr wrap="square">
+            <a:spAutoFit/>
+          </a:bodyPr>
+          <a:lstStyle/>
+          <a:p>
+            <a:pPr algn="ctr"/>
+            <a:r>
+              <a:rPr lang="en-US" b="0" noProof="0" dirty="0">
+                <a:solidFill>
+                  <a:schemeClr val="tx1"/>
+                </a:solidFill>
+                <a:effectLst/>
+                <a:latin typeface="Fira Code" panose="020B0809050000020004" pitchFamily="49" charset="0"/>
+              </a:rPr>
+              <a:t>CUDA</a:t>
+            </a:r>
+            <a:br>
+              <a:rPr lang="en-US" b="0" noProof="0" dirty="0">
+                <a:solidFill>
+                  <a:schemeClr val="tx1"/>
+                </a:solidFill>
+                <a:effectLst/>
+                <a:latin typeface="Fira Code" panose="020B0809050000020004" pitchFamily="49" charset="0"/>
+              </a:rPr>
+            </a:br>
+            <a:r>
+              <a:rPr lang="en-US" noProof="0" dirty="0">
+                <a:solidFill>
+                  <a:schemeClr val="tx1"/>
+                </a:solidFill>
+                <a:effectLst/>
+                <a:latin typeface="Fira Code" panose="020B0809050000020004" pitchFamily="49" charset="0"/>
+              </a:rPr>
+              <a:t>cuda_traverser</a:t>
+            </a:r>
+            <a:endParaRPr lang="en-US" sz="2400" dirty="0">
+              <a:solidFill>
+                <a:schemeClr val="tx1"/>
+              </a:solidFill>
+            </a:endParaRPr>
+          </a:p>
+        </p:txBody>
+      </p:sp>
+      <p:cxnSp>
+        <p:nvCxnSpPr>
+          <p:cNvPr id="33" name="Straight Arrow Connector 32">
+            <a:extLst>
+              <a:ext uri="{FF2B5EF4-FFF2-40B4-BE49-F238E27FC236}">
+                <a16:creationId xmlns:a16="http://schemas.microsoft.com/office/drawing/2014/main" id="{8BAD00C5-4215-60FE-63AA-DCA7EB732E24}"/>
+              </a:ext>
+            </a:extLst>
+          </p:cNvPr>
+          <p:cNvCxnSpPr>
+            <a:stCxn id="21" idx="2"/>
+            <a:endCxn id="25" idx="0"/>
+          </p:cNvCxnSpPr>
+          <p:nvPr/>
+        </p:nvCxnSpPr>
+        <p:spPr>
+          <a:xfrm flipH="1">
+            <a:off x="6096000" y="4957409"/>
+            <a:ext cx="1" cy="501303"/>
+          </a:xfrm>
+          <a:prstGeom prst="straightConnector1">
+            <a:avLst/>
+          </a:prstGeom>
+          <a:ln>
+            <a:tailEnd type="triangle"/>
+          </a:ln>
+        </p:spPr>
+        <p:style>
+          <a:lnRef idx="2">
+            <a:schemeClr val="accent4"/>
+          </a:lnRef>
+          <a:fillRef idx="0">
+            <a:schemeClr val="accent4"/>
+          </a:fillRef>
+          <a:effectRef idx="1">
+            <a:schemeClr val="accent4"/>
+          </a:effectRef>
+          <a:fontRef idx="minor">
+            <a:schemeClr val="tx1"/>
+          </a:fontRef>
+        </p:style>
+      </p:cxnSp>
+      <p:cxnSp>
+        <p:nvCxnSpPr>
+          <p:cNvPr id="35" name="Straight Arrow Connector 34">
+            <a:extLst>
+              <a:ext uri="{FF2B5EF4-FFF2-40B4-BE49-F238E27FC236}">
+                <a16:creationId xmlns:a16="http://schemas.microsoft.com/office/drawing/2014/main" id="{DFEA1C61-7960-E9FD-D288-69F76C20F474}"/>
+              </a:ext>
+            </a:extLst>
+          </p:cNvPr>
+          <p:cNvCxnSpPr>
+            <a:cxnSpLocks/>
+            <a:stCxn id="21" idx="2"/>
+            <a:endCxn id="23" idx="3"/>
+          </p:cNvCxnSpPr>
+          <p:nvPr/>
+        </p:nvCxnSpPr>
+        <p:spPr>
+          <a:xfrm flipH="1">
+            <a:off x="3980881" y="4957409"/>
+            <a:ext cx="2115120" cy="858847"/>
+          </a:xfrm>
+          <a:prstGeom prst="straightConnector1">
+            <a:avLst/>
+          </a:prstGeom>
+          <a:ln>
+            <a:tailEnd type="triangle"/>
+          </a:ln>
+        </p:spPr>
+        <p:style>
+          <a:lnRef idx="2">
+            <a:schemeClr val="accent4"/>
+          </a:lnRef>
+          <a:fillRef idx="0">
+            <a:schemeClr val="accent4"/>
+          </a:fillRef>
+          <a:effectRef idx="1">
+            <a:schemeClr val="accent4"/>
+          </a:effectRef>
+          <a:fontRef idx="minor">
+            <a:schemeClr val="tx1"/>
+          </a:fontRef>
+        </p:style>
+      </p:cxnSp>
+      <p:cxnSp>
+        <p:nvCxnSpPr>
+          <p:cNvPr id="37" name="Straight Arrow Connector 36">
+            <a:extLst>
+              <a:ext uri="{FF2B5EF4-FFF2-40B4-BE49-F238E27FC236}">
+                <a16:creationId xmlns:a16="http://schemas.microsoft.com/office/drawing/2014/main" id="{CFFA2151-7675-411C-6539-37EA8EE743B3}"/>
+              </a:ext>
+            </a:extLst>
+          </p:cNvPr>
+          <p:cNvCxnSpPr>
+            <a:cxnSpLocks/>
+            <a:stCxn id="21" idx="2"/>
+            <a:endCxn id="29" idx="1"/>
+          </p:cNvCxnSpPr>
+          <p:nvPr/>
+        </p:nvCxnSpPr>
+        <p:spPr>
+          <a:xfrm>
+            <a:off x="6096001" y="4957409"/>
+            <a:ext cx="2116046" cy="858848"/>
+          </a:xfrm>
+          <a:prstGeom prst="straightConnector1">
+            <a:avLst/>
+          </a:prstGeom>
+          <a:ln>
+            <a:tailEnd type="triangle"/>
+          </a:ln>
+        </p:spPr>
+        <p:style>
+          <a:lnRef idx="2">
+            <a:schemeClr val="accent4"/>
+          </a:lnRef>
+          <a:fillRef idx="0">
+            <a:schemeClr val="accent4"/>
+          </a:fillRef>
+          <a:effectRef idx="1">
+            <a:schemeClr val="accent4"/>
+          </a:effectRef>
+          <a:fontRef idx="minor">
+            <a:schemeClr val="tx1"/>
+          </a:fontRef>
+        </p:style>
+      </p:cxnSp>
+      <p:sp>
+        <p:nvSpPr>
           <p:cNvPr id="6" name="Rectangle 5">
             <a:extLst>
               <a:ext uri="{FF2B5EF4-FFF2-40B4-BE49-F238E27FC236}">
@@ -36320,7 +39074,7 @@
         </p:nvSpPr>
         <p:spPr>
           <a:xfrm>
-            <a:off x="6782428" y="2166505"/>
+            <a:off x="6782428" y="1847750"/>
             <a:ext cx="1102519" cy="223837"/>
           </a:xfrm>
           <a:prstGeom prst="rect">
@@ -36374,7 +39128,7 @@
         </p:nvSpPr>
         <p:spPr>
           <a:xfrm>
-            <a:off x="6782427" y="2431083"/>
+            <a:off x="6782427" y="2112328"/>
             <a:ext cx="1102519" cy="223837"/>
           </a:xfrm>
           <a:prstGeom prst="rect">
@@ -36428,7 +39182,7 @@
         </p:nvSpPr>
         <p:spPr>
           <a:xfrm>
-            <a:off x="6049003" y="2702147"/>
+            <a:off x="6049003" y="2383392"/>
             <a:ext cx="1102519" cy="223837"/>
           </a:xfrm>
           <a:prstGeom prst="rect">
@@ -36482,7 +39236,7 @@
         </p:nvSpPr>
         <p:spPr>
           <a:xfrm>
-            <a:off x="3363539" y="2084062"/>
+            <a:off x="3363539" y="1765307"/>
             <a:ext cx="5464923" cy="917880"/>
           </a:xfrm>
           <a:prstGeom prst="rect">
@@ -36950,7 +39704,7 @@
         </p:nvSpPr>
         <p:spPr>
           <a:xfrm>
-            <a:off x="2393643" y="3395316"/>
+            <a:off x="2393643" y="3076561"/>
             <a:ext cx="7404714" cy="917880"/>
           </a:xfrm>
           <a:prstGeom prst="rect">
@@ -37320,7 +40074,7 @@
         </p:nvCxnSpPr>
         <p:spPr>
           <a:xfrm flipH="1">
-            <a:off x="6096000" y="3001942"/>
+            <a:off x="6096000" y="2683187"/>
             <a:ext cx="1" cy="393374"/>
           </a:xfrm>
           <a:prstGeom prst="straightConnector1">
@@ -37350,68 +40104,10 @@
       </p:cxnSp>
       <p:sp>
         <p:nvSpPr>
-          <p:cNvPr id="26" name="Date Placeholder 25">
-            <a:extLst>
-              <a:ext uri="{FF2B5EF4-FFF2-40B4-BE49-F238E27FC236}">
-                <a16:creationId xmlns:a16="http://schemas.microsoft.com/office/drawing/2014/main" id="{FE517BC7-E591-4BF3-D827-EFF2CD30D196}"/>
-              </a:ext>
-            </a:extLst>
-          </p:cNvPr>
-          <p:cNvSpPr>
-            <a:spLocks noGrp="1"/>
-          </p:cNvSpPr>
-          <p:nvPr>
-            <p:ph type="dt" sz="half" idx="10"/>
-          </p:nvPr>
-        </p:nvSpPr>
-        <p:spPr/>
-        <p:txBody>
-          <a:bodyPr/>
-          <a:lstStyle/>
-          <a:p>
-            <a:fld id="{8BB690F1-35CC-4B34-B898-A35702C2DAD5}" type="datetime1">
-              <a:rPr lang="en-US" noProof="0" smtClean="0"/>
-              <a:t>8/29/2026</a:t>
-            </a:fld>
-            <a:endParaRPr lang="en-US" noProof="0" dirty="0"/>
-          </a:p>
-        </p:txBody>
-      </p:sp>
-      <p:sp>
-        <p:nvSpPr>
-          <p:cNvPr id="27" name="Slide Number Placeholder 26">
-            <a:extLst>
-              <a:ext uri="{FF2B5EF4-FFF2-40B4-BE49-F238E27FC236}">
-                <a16:creationId xmlns:a16="http://schemas.microsoft.com/office/drawing/2014/main" id="{B740945D-1B4C-1335-1A43-458E59CE57FB}"/>
-              </a:ext>
-            </a:extLst>
-          </p:cNvPr>
-          <p:cNvSpPr>
-            <a:spLocks noGrp="1"/>
-          </p:cNvSpPr>
-          <p:nvPr>
-            <p:ph type="sldNum" sz="quarter" idx="12"/>
-          </p:nvPr>
-        </p:nvSpPr>
-        <p:spPr/>
-        <p:txBody>
-          <a:bodyPr/>
-          <a:lstStyle/>
-          <a:p>
-            <a:fld id="{DA0BB241-1B5F-4309-9407-9EEA04D9598D}" type="slidenum">
-              <a:rPr lang="en-US" noProof="0" smtClean="0"/>
-              <a:t>8</a:t>
-            </a:fld>
-            <a:endParaRPr lang="en-US" noProof="0" dirty="0"/>
-          </a:p>
-        </p:txBody>
-      </p:sp>
-      <p:sp>
-        <p:nvSpPr>
-          <p:cNvPr id="21" name="TextBox 20">
-            <a:extLst>
-              <a:ext uri="{FF2B5EF4-FFF2-40B4-BE49-F238E27FC236}">
-                <a16:creationId xmlns:a16="http://schemas.microsoft.com/office/drawing/2014/main" id="{3F6B7F5F-6A6B-7B50-99CB-AE3DAB2E86D8}"/>
+          <p:cNvPr id="43" name="TextBox 42">
+            <a:extLst>
+              <a:ext uri="{FF2B5EF4-FFF2-40B4-BE49-F238E27FC236}">
+                <a16:creationId xmlns:a16="http://schemas.microsoft.com/office/drawing/2014/main" id="{0D3DC4ED-8B07-FA72-912D-D5AFDF1779D5}"/>
               </a:ext>
             </a:extLst>
           </p:cNvPr>
@@ -37420,419 +40116,7 @@
         </p:nvSpPr>
         <p:spPr>
           <a:xfrm>
-            <a:off x="5068155" y="4765415"/>
-            <a:ext cx="2055691" cy="461665"/>
-          </a:xfrm>
-          <a:prstGeom prst="rect">
-            <a:avLst/>
-          </a:prstGeom>
-        </p:spPr>
-        <p:style>
-          <a:lnRef idx="1">
-            <a:schemeClr val="accent4"/>
-          </a:lnRef>
-          <a:fillRef idx="2">
-            <a:schemeClr val="accent4"/>
-          </a:fillRef>
-          <a:effectRef idx="1">
-            <a:schemeClr val="accent4"/>
-          </a:effectRef>
-          <a:fontRef idx="minor">
-            <a:schemeClr val="dk1"/>
-          </a:fontRef>
-        </p:style>
-        <p:txBody>
-          <a:bodyPr wrap="none" rtlCol="0">
-            <a:spAutoFit/>
-          </a:bodyPr>
-          <a:lstStyle/>
-          <a:p>
-            <a:r>
-              <a:rPr lang="en-US" sz="2400" dirty="0"/>
-              <a:t>Parallelization</a:t>
-            </a:r>
-          </a:p>
-        </p:txBody>
-      </p:sp>
-      <p:sp>
-        <p:nvSpPr>
-          <p:cNvPr id="23" name="TextBox 22">
-            <a:extLst>
-              <a:ext uri="{FF2B5EF4-FFF2-40B4-BE49-F238E27FC236}">
-                <a16:creationId xmlns:a16="http://schemas.microsoft.com/office/drawing/2014/main" id="{BB09330A-A449-CB40-3FCF-2B26BA222655}"/>
-              </a:ext>
-            </a:extLst>
-          </p:cNvPr>
-          <p:cNvSpPr txBox="1"/>
-          <p:nvPr/>
-        </p:nvSpPr>
-        <p:spPr>
-          <a:xfrm>
-            <a:off x="1716323" y="5728382"/>
-            <a:ext cx="2264558" cy="715089"/>
-          </a:xfrm>
-          <a:prstGeom prst="roundRect">
-            <a:avLst/>
-          </a:prstGeom>
-        </p:spPr>
-        <p:style>
-          <a:lnRef idx="1">
-            <a:schemeClr val="accent6"/>
-          </a:lnRef>
-          <a:fillRef idx="2">
-            <a:schemeClr val="accent6"/>
-          </a:fillRef>
-          <a:effectRef idx="1">
-            <a:schemeClr val="accent6"/>
-          </a:effectRef>
-          <a:fontRef idx="minor">
-            <a:schemeClr val="dk1"/>
-          </a:fontRef>
-        </p:style>
-        <p:txBody>
-          <a:bodyPr wrap="square">
-            <a:spAutoFit/>
-          </a:bodyPr>
-          <a:lstStyle/>
-          <a:p>
-            <a:pPr algn="ctr"/>
-            <a:r>
-              <a:rPr lang="en-US" b="0" noProof="0" dirty="0">
-                <a:solidFill>
-                  <a:schemeClr val="tx1"/>
-                </a:solidFill>
-                <a:effectLst/>
-              </a:rPr>
-              <a:t>OpenMP</a:t>
-            </a:r>
-            <a:br>
-              <a:rPr lang="en-US" b="0" noProof="0" dirty="0">
-                <a:solidFill>
-                  <a:schemeClr val="tx1"/>
-                </a:solidFill>
-                <a:effectLst/>
-                <a:latin typeface="Fira Code" panose="020B0809050000020004" pitchFamily="49" charset="0"/>
-              </a:rPr>
-            </a:br>
-            <a:r>
-              <a:rPr lang="en-US" b="0" noProof="0" dirty="0" err="1">
-                <a:solidFill>
-                  <a:schemeClr val="tx1"/>
-                </a:solidFill>
-                <a:effectLst/>
-                <a:latin typeface="Fira Code" panose="020B0809050000020004" pitchFamily="49" charset="0"/>
-              </a:rPr>
-              <a:t>omp_for_each</a:t>
-            </a:r>
-            <a:endParaRPr lang="en-US" sz="2400" dirty="0">
-              <a:solidFill>
-                <a:schemeClr val="tx1"/>
-              </a:solidFill>
-            </a:endParaRPr>
-          </a:p>
-        </p:txBody>
-      </p:sp>
-      <p:sp>
-        <p:nvSpPr>
-          <p:cNvPr id="25" name="TextBox 24">
-            <a:extLst>
-              <a:ext uri="{FF2B5EF4-FFF2-40B4-BE49-F238E27FC236}">
-                <a16:creationId xmlns:a16="http://schemas.microsoft.com/office/drawing/2014/main" id="{65FADC59-989F-AE0F-9D16-0E35E9C69C74}"/>
-              </a:ext>
-            </a:extLst>
-          </p:cNvPr>
-          <p:cNvSpPr txBox="1"/>
-          <p:nvPr/>
-        </p:nvSpPr>
-        <p:spPr>
-          <a:xfrm>
-            <a:off x="4964185" y="5728383"/>
-            <a:ext cx="2263630" cy="715089"/>
-          </a:xfrm>
-          <a:prstGeom prst="roundRect">
-            <a:avLst/>
-          </a:prstGeom>
-        </p:spPr>
-        <p:style>
-          <a:lnRef idx="1">
-            <a:schemeClr val="accent6"/>
-          </a:lnRef>
-          <a:fillRef idx="2">
-            <a:schemeClr val="accent6"/>
-          </a:fillRef>
-          <a:effectRef idx="1">
-            <a:schemeClr val="accent6"/>
-          </a:effectRef>
-          <a:fontRef idx="minor">
-            <a:schemeClr val="dk1"/>
-          </a:fontRef>
-        </p:style>
-        <p:txBody>
-          <a:bodyPr wrap="square">
-            <a:spAutoFit/>
-          </a:bodyPr>
-          <a:lstStyle/>
-          <a:p>
-            <a:pPr algn="ctr"/>
-            <a:r>
-              <a:rPr lang="en-US" b="0" noProof="0" dirty="0" err="1">
-                <a:solidFill>
-                  <a:schemeClr val="tx1"/>
-                </a:solidFill>
-                <a:effectLst/>
-                <a:latin typeface="Fira Code" panose="020B0809050000020004" pitchFamily="49" charset="0"/>
-              </a:rPr>
-              <a:t>oneTBB</a:t>
-            </a:r>
-            <a:br>
-              <a:rPr lang="en-US" b="0" noProof="0" dirty="0">
-                <a:solidFill>
-                  <a:schemeClr val="tx1"/>
-                </a:solidFill>
-                <a:effectLst/>
-                <a:latin typeface="Fira Code" panose="020B0809050000020004" pitchFamily="49" charset="0"/>
-              </a:rPr>
-            </a:br>
-            <a:r>
-              <a:rPr lang="en-US" b="0" noProof="0" dirty="0" err="1">
-                <a:solidFill>
-                  <a:schemeClr val="tx1"/>
-                </a:solidFill>
-                <a:effectLst/>
-                <a:latin typeface="Fira Code" panose="020B0809050000020004" pitchFamily="49" charset="0"/>
-              </a:rPr>
-              <a:t>tbb_for_each</a:t>
-            </a:r>
-            <a:endParaRPr lang="en-US" sz="2400" dirty="0">
-              <a:solidFill>
-                <a:schemeClr val="tx1"/>
-              </a:solidFill>
-            </a:endParaRPr>
-          </a:p>
-        </p:txBody>
-      </p:sp>
-      <p:sp>
-        <p:nvSpPr>
-          <p:cNvPr id="29" name="TextBox 28">
-            <a:extLst>
-              <a:ext uri="{FF2B5EF4-FFF2-40B4-BE49-F238E27FC236}">
-                <a16:creationId xmlns:a16="http://schemas.microsoft.com/office/drawing/2014/main" id="{BC584833-E86B-4C27-58B9-4ED8496F2A50}"/>
-              </a:ext>
-            </a:extLst>
-          </p:cNvPr>
-          <p:cNvSpPr txBox="1"/>
-          <p:nvPr/>
-        </p:nvSpPr>
-        <p:spPr>
-          <a:xfrm>
-            <a:off x="8212047" y="5728383"/>
-            <a:ext cx="2263630" cy="715089"/>
-          </a:xfrm>
-          <a:prstGeom prst="roundRect">
-            <a:avLst/>
-          </a:prstGeom>
-        </p:spPr>
-        <p:style>
-          <a:lnRef idx="1">
-            <a:schemeClr val="accent6"/>
-          </a:lnRef>
-          <a:fillRef idx="2">
-            <a:schemeClr val="accent6"/>
-          </a:fillRef>
-          <a:effectRef idx="1">
-            <a:schemeClr val="accent6"/>
-          </a:effectRef>
-          <a:fontRef idx="minor">
-            <a:schemeClr val="dk1"/>
-          </a:fontRef>
-        </p:style>
-        <p:txBody>
-          <a:bodyPr wrap="square">
-            <a:spAutoFit/>
-          </a:bodyPr>
-          <a:lstStyle/>
-          <a:p>
-            <a:pPr algn="ctr"/>
-            <a:r>
-              <a:rPr lang="en-US" b="0" noProof="0" dirty="0">
-                <a:solidFill>
-                  <a:schemeClr val="tx1"/>
-                </a:solidFill>
-                <a:effectLst/>
-                <a:latin typeface="Fira Code" panose="020B0809050000020004" pitchFamily="49" charset="0"/>
-              </a:rPr>
-              <a:t>CUDA</a:t>
-            </a:r>
-            <a:br>
-              <a:rPr lang="en-US" b="0" noProof="0" dirty="0">
-                <a:solidFill>
-                  <a:schemeClr val="tx1"/>
-                </a:solidFill>
-                <a:effectLst/>
-                <a:latin typeface="Fira Code" panose="020B0809050000020004" pitchFamily="49" charset="0"/>
-              </a:rPr>
-            </a:br>
-            <a:r>
-              <a:rPr lang="en-US" noProof="0" dirty="0">
-                <a:solidFill>
-                  <a:schemeClr val="tx1"/>
-                </a:solidFill>
-                <a:effectLst/>
-                <a:latin typeface="Fira Code" panose="020B0809050000020004" pitchFamily="49" charset="0"/>
-              </a:rPr>
-              <a:t>cuda_traverser</a:t>
-            </a:r>
-            <a:endParaRPr lang="en-US" sz="2400" dirty="0">
-              <a:solidFill>
-                <a:schemeClr val="tx1"/>
-              </a:solidFill>
-            </a:endParaRPr>
-          </a:p>
-        </p:txBody>
-      </p:sp>
-      <p:cxnSp>
-        <p:nvCxnSpPr>
-          <p:cNvPr id="33" name="Straight Arrow Connector 32">
-            <a:extLst>
-              <a:ext uri="{FF2B5EF4-FFF2-40B4-BE49-F238E27FC236}">
-                <a16:creationId xmlns:a16="http://schemas.microsoft.com/office/drawing/2014/main" id="{8BAD00C5-4215-60FE-63AA-DCA7EB732E24}"/>
-              </a:ext>
-            </a:extLst>
-          </p:cNvPr>
-          <p:cNvCxnSpPr>
-            <a:stCxn id="21" idx="2"/>
-            <a:endCxn id="25" idx="0"/>
-          </p:cNvCxnSpPr>
-          <p:nvPr/>
-        </p:nvCxnSpPr>
-        <p:spPr>
-          <a:xfrm flipH="1">
-            <a:off x="6096000" y="5227080"/>
-            <a:ext cx="1" cy="501303"/>
-          </a:xfrm>
-          <a:prstGeom prst="straightConnector1">
-            <a:avLst/>
-          </a:prstGeom>
-          <a:ln>
-            <a:tailEnd type="triangle"/>
-          </a:ln>
-        </p:spPr>
-        <p:style>
-          <a:lnRef idx="2">
-            <a:schemeClr val="accent4"/>
-          </a:lnRef>
-          <a:fillRef idx="0">
-            <a:schemeClr val="accent4"/>
-          </a:fillRef>
-          <a:effectRef idx="1">
-            <a:schemeClr val="accent4"/>
-          </a:effectRef>
-          <a:fontRef idx="minor">
-            <a:schemeClr val="tx1"/>
-          </a:fontRef>
-        </p:style>
-      </p:cxnSp>
-      <p:cxnSp>
-        <p:nvCxnSpPr>
-          <p:cNvPr id="35" name="Straight Arrow Connector 34">
-            <a:extLst>
-              <a:ext uri="{FF2B5EF4-FFF2-40B4-BE49-F238E27FC236}">
-                <a16:creationId xmlns:a16="http://schemas.microsoft.com/office/drawing/2014/main" id="{DFEA1C61-7960-E9FD-D288-69F76C20F474}"/>
-              </a:ext>
-            </a:extLst>
-          </p:cNvPr>
-          <p:cNvCxnSpPr>
-            <a:cxnSpLocks/>
-            <a:stCxn id="21" idx="2"/>
-            <a:endCxn id="23" idx="3"/>
-          </p:cNvCxnSpPr>
-          <p:nvPr/>
-        </p:nvCxnSpPr>
-        <p:spPr>
-          <a:xfrm flipH="1">
-            <a:off x="3980881" y="5227080"/>
-            <a:ext cx="2115120" cy="858847"/>
-          </a:xfrm>
-          <a:prstGeom prst="straightConnector1">
-            <a:avLst/>
-          </a:prstGeom>
-          <a:ln>
-            <a:tailEnd type="triangle"/>
-          </a:ln>
-        </p:spPr>
-        <p:style>
-          <a:lnRef idx="2">
-            <a:schemeClr val="accent4"/>
-          </a:lnRef>
-          <a:fillRef idx="0">
-            <a:schemeClr val="accent4"/>
-          </a:fillRef>
-          <a:effectRef idx="1">
-            <a:schemeClr val="accent4"/>
-          </a:effectRef>
-          <a:fontRef idx="minor">
-            <a:schemeClr val="tx1"/>
-          </a:fontRef>
-        </p:style>
-      </p:cxnSp>
-      <p:cxnSp>
-        <p:nvCxnSpPr>
-          <p:cNvPr id="37" name="Straight Arrow Connector 36">
-            <a:extLst>
-              <a:ext uri="{FF2B5EF4-FFF2-40B4-BE49-F238E27FC236}">
-                <a16:creationId xmlns:a16="http://schemas.microsoft.com/office/drawing/2014/main" id="{CFFA2151-7675-411C-6539-37EA8EE743B3}"/>
-              </a:ext>
-            </a:extLst>
-          </p:cNvPr>
-          <p:cNvCxnSpPr>
-            <a:cxnSpLocks/>
-            <a:stCxn id="21" idx="2"/>
-            <a:endCxn id="29" idx="1"/>
-          </p:cNvCxnSpPr>
-          <p:nvPr/>
-        </p:nvCxnSpPr>
-        <p:spPr>
-          <a:xfrm>
-            <a:off x="6096001" y="5227080"/>
-            <a:ext cx="2116046" cy="858848"/>
-          </a:xfrm>
-          <a:prstGeom prst="straightConnector1">
-            <a:avLst/>
-          </a:prstGeom>
-          <a:ln>
-            <a:tailEnd type="triangle"/>
-          </a:ln>
-        </p:spPr>
-        <p:style>
-          <a:lnRef idx="2">
-            <a:schemeClr val="accent4"/>
-          </a:lnRef>
-          <a:fillRef idx="0">
-            <a:schemeClr val="accent4"/>
-          </a:fillRef>
-          <a:effectRef idx="1">
-            <a:schemeClr val="accent4"/>
-          </a:effectRef>
-          <a:fontRef idx="minor">
-            <a:schemeClr val="tx1"/>
-          </a:fontRef>
-        </p:style>
-      </p:cxnSp>
-      <p:sp>
-        <p:nvSpPr>
-          <p:cNvPr id="43" name="TextBox 42">
-            <a:extLst>
-              <a:ext uri="{FF2B5EF4-FFF2-40B4-BE49-F238E27FC236}">
-                <a16:creationId xmlns:a16="http://schemas.microsoft.com/office/drawing/2014/main" id="{0D3DC4ED-8B07-FA72-912D-D5AFDF1779D5}"/>
-              </a:ext>
-            </a:extLst>
-          </p:cNvPr>
-          <p:cNvSpPr txBox="1"/>
-          <p:nvPr/>
-        </p:nvSpPr>
-        <p:spPr>
-          <a:xfrm>
-            <a:off x="2393643" y="3395316"/>
+            <a:off x="2393643" y="3076561"/>
             <a:ext cx="7404714" cy="917880"/>
           </a:xfrm>
           <a:prstGeom prst="rect">
@@ -38153,6 +40437,176 @@
                 <a:latin typeface="Fira Code" panose="020B0809050000020004" pitchFamily="49" charset="0"/>
               </a:rPr>
               <a:t>});</a:t>
+            </a:r>
+          </a:p>
+        </p:txBody>
+      </p:sp>
+      <p:sp>
+        <p:nvSpPr>
+          <p:cNvPr id="9" name="Right Brace 8">
+            <a:extLst>
+              <a:ext uri="{FF2B5EF4-FFF2-40B4-BE49-F238E27FC236}">
+                <a16:creationId xmlns:a16="http://schemas.microsoft.com/office/drawing/2014/main" id="{91045F7D-5F95-D4A4-2108-8EF08244EF72}"/>
+              </a:ext>
+            </a:extLst>
+          </p:cNvPr>
+          <p:cNvSpPr/>
+          <p:nvPr/>
+        </p:nvSpPr>
+        <p:spPr>
+          <a:xfrm rot="5400000">
+            <a:off x="4432819" y="3561426"/>
+            <a:ext cx="78497" cy="5511492"/>
+          </a:xfrm>
+          <a:prstGeom prst="rightBrace">
+            <a:avLst/>
+          </a:prstGeom>
+          <a:ln>
+            <a:solidFill>
+              <a:srgbClr val="0F9ED5"/>
+            </a:solidFill>
+          </a:ln>
+        </p:spPr>
+        <p:style>
+          <a:lnRef idx="2">
+            <a:schemeClr val="accent1"/>
+          </a:lnRef>
+          <a:fillRef idx="0">
+            <a:schemeClr val="accent1"/>
+          </a:fillRef>
+          <a:effectRef idx="1">
+            <a:schemeClr val="accent1"/>
+          </a:effectRef>
+          <a:fontRef idx="minor">
+            <a:schemeClr val="tx1"/>
+          </a:fontRef>
+        </p:style>
+        <p:txBody>
+          <a:bodyPr rtlCol="0" anchor="ctr"/>
+          <a:lstStyle/>
+          <a:p>
+            <a:pPr algn="ctr"/>
+            <a:endParaRPr lang="en-US"/>
+          </a:p>
+        </p:txBody>
+      </p:sp>
+      <p:sp>
+        <p:nvSpPr>
+          <p:cNvPr id="11" name="TextBox 10">
+            <a:extLst>
+              <a:ext uri="{FF2B5EF4-FFF2-40B4-BE49-F238E27FC236}">
+                <a16:creationId xmlns:a16="http://schemas.microsoft.com/office/drawing/2014/main" id="{E10EEBB8-CEAC-5121-92BA-FBA1CBC662D5}"/>
+              </a:ext>
+            </a:extLst>
+          </p:cNvPr>
+          <p:cNvSpPr txBox="1"/>
+          <p:nvPr/>
+        </p:nvSpPr>
+        <p:spPr>
+          <a:xfrm>
+            <a:off x="4154512" y="6352143"/>
+            <a:ext cx="635110" cy="369332"/>
+          </a:xfrm>
+          <a:prstGeom prst="rect">
+            <a:avLst/>
+          </a:prstGeom>
+          <a:noFill/>
+        </p:spPr>
+        <p:txBody>
+          <a:bodyPr wrap="none" rtlCol="0">
+            <a:spAutoFit/>
+          </a:bodyPr>
+          <a:lstStyle/>
+          <a:p>
+            <a:pPr algn="ctr"/>
+            <a:r>
+              <a:rPr lang="en-US" dirty="0"/>
+              <a:t>CPU</a:t>
+            </a:r>
+          </a:p>
+        </p:txBody>
+      </p:sp>
+      <p:sp>
+        <p:nvSpPr>
+          <p:cNvPr id="14" name="Right Brace 13">
+            <a:extLst>
+              <a:ext uri="{FF2B5EF4-FFF2-40B4-BE49-F238E27FC236}">
+                <a16:creationId xmlns:a16="http://schemas.microsoft.com/office/drawing/2014/main" id="{31D2927F-1B91-15E0-3A30-9D2B9E9F1A75}"/>
+              </a:ext>
+            </a:extLst>
+          </p:cNvPr>
+          <p:cNvSpPr/>
+          <p:nvPr/>
+        </p:nvSpPr>
+        <p:spPr>
+          <a:xfrm rot="5400000">
+            <a:off x="9315742" y="5192211"/>
+            <a:ext cx="74219" cy="2245650"/>
+          </a:xfrm>
+          <a:prstGeom prst="rightBrace">
+            <a:avLst/>
+          </a:prstGeom>
+          <a:ln>
+            <a:solidFill>
+              <a:srgbClr val="0F9ED5"/>
+            </a:solidFill>
+          </a:ln>
+        </p:spPr>
+        <p:style>
+          <a:lnRef idx="2">
+            <a:schemeClr val="accent1"/>
+          </a:lnRef>
+          <a:fillRef idx="0">
+            <a:schemeClr val="accent1"/>
+          </a:fillRef>
+          <a:effectRef idx="1">
+            <a:schemeClr val="accent1"/>
+          </a:effectRef>
+          <a:fontRef idx="minor">
+            <a:schemeClr val="tx1"/>
+          </a:fontRef>
+        </p:style>
+        <p:txBody>
+          <a:bodyPr rtlCol="0" anchor="ctr"/>
+          <a:lstStyle/>
+          <a:p>
+            <a:pPr algn="ctr"/>
+            <a:endParaRPr lang="en-US"/>
+          </a:p>
+        </p:txBody>
+      </p:sp>
+      <p:sp>
+        <p:nvSpPr>
+          <p:cNvPr id="15" name="TextBox 14">
+            <a:extLst>
+              <a:ext uri="{FF2B5EF4-FFF2-40B4-BE49-F238E27FC236}">
+                <a16:creationId xmlns:a16="http://schemas.microsoft.com/office/drawing/2014/main" id="{48453C35-A3D1-C43A-87EB-29D2FECA4E69}"/>
+              </a:ext>
+            </a:extLst>
+          </p:cNvPr>
+          <p:cNvSpPr txBox="1"/>
+          <p:nvPr/>
+        </p:nvSpPr>
+        <p:spPr>
+          <a:xfrm>
+            <a:off x="9024704" y="6352143"/>
+            <a:ext cx="638316" cy="369332"/>
+          </a:xfrm>
+          <a:prstGeom prst="rect">
+            <a:avLst/>
+          </a:prstGeom>
+          <a:noFill/>
+        </p:spPr>
+        <p:txBody>
+          <a:bodyPr wrap="none" rtlCol="0">
+            <a:spAutoFit/>
+          </a:bodyPr>
+          <a:lstStyle/>
+          <a:p>
+            <a:pPr algn="ctr"/>
+            <a:r>
+              <a:rPr lang="en-US" dirty="0"/>
+              <a:t>GPU</a:t>
             </a:r>
           </a:p>
         </p:txBody>
@@ -38366,7 +40820,7 @@
           <a:p>
             <a:fld id="{B7D82220-9CE2-4BC9-B6C9-7A7531EEF273}" type="datetime1">
               <a:rPr lang="en-US" noProof="0" smtClean="0"/>
-              <a:t>8/29/2026</a:t>
+              <a:t>8/30/2026</a:t>
             </a:fld>
             <a:endParaRPr lang="en-US" noProof="0" dirty="0"/>
           </a:p>

</xml_diff>

<commit_message>
only animations are missing & need to optimize the script
</commit_message>
<xml_diff>
--- a/slides/Optimizing Memory Layouts and Traversal Orders in High-Performance Computing.pptx
+++ b/slides/Optimizing Memory Layouts and Traversal Orders in High-Performance Computing.pptx
@@ -5,11 +5,11 @@
     <p:sldMasterId id="2147483648" r:id="rId1"/>
   </p:sldMasterIdLst>
   <p:notesMasterIdLst>
-    <p:notesMasterId r:id="rId37"/>
+    <p:notesMasterId r:id="rId38"/>
   </p:notesMasterIdLst>
   <p:sldIdLst>
     <p:sldId id="256" r:id="rId2"/>
-    <p:sldId id="293" r:id="rId3"/>
+    <p:sldId id="322" r:id="rId3"/>
     <p:sldId id="277" r:id="rId4"/>
     <p:sldId id="296" r:id="rId5"/>
     <p:sldId id="297" r:id="rId6"/>
@@ -43,6 +43,7 @@
     <p:sldId id="318" r:id="rId34"/>
     <p:sldId id="319" r:id="rId35"/>
     <p:sldId id="317" r:id="rId36"/>
+    <p:sldId id="321" r:id="rId37"/>
   </p:sldIdLst>
   <p:sldSz cx="12192000" cy="6858000"/>
   <p:notesSz cx="6858000" cy="9144000"/>
@@ -147,7 +148,7 @@
         <p14:section name="Default Section" id="{293DA01B-4D9B-48A0-906B-75ADFA7BB1A7}">
           <p14:sldIdLst>
             <p14:sldId id="256"/>
-            <p14:sldId id="293"/>
+            <p14:sldId id="322"/>
             <p14:sldId id="277"/>
           </p14:sldIdLst>
         </p14:section>
@@ -197,6 +198,7 @@
             <p14:sldId id="318"/>
             <p14:sldId id="319"/>
             <p14:sldId id="317"/>
+            <p14:sldId id="321"/>
           </p14:sldIdLst>
         </p14:section>
         <p14:section name="supplementary" id="{5D95F6E9-DF15-476C-BE69-BBEF48AA8B86}">
@@ -2257,7 +2259,13 @@
   <p:cSld>
     <p:spTree>
       <p:nvGrpSpPr>
-        <p:cNvPr id="1" name=""/>
+        <p:cNvPr id="1" name="">
+          <a:extLst>
+            <a:ext uri="{FF2B5EF4-FFF2-40B4-BE49-F238E27FC236}">
+              <a16:creationId xmlns:a16="http://schemas.microsoft.com/office/drawing/2014/main" id="{BDF329ED-D737-34A6-0925-8C1CCC2C51F2}"/>
+            </a:ext>
+          </a:extLst>
+        </p:cNvPr>
         <p:cNvGrpSpPr/>
         <p:nvPr/>
       </p:nvGrpSpPr>
@@ -2271,7 +2279,13 @@
       </p:grpSpPr>
       <p:sp>
         <p:nvSpPr>
-          <p:cNvPr id="2" name="Slide Image Placeholder 1"/>
+          <p:cNvPr id="2" name="Slide Image Placeholder 1">
+            <a:extLst>
+              <a:ext uri="{FF2B5EF4-FFF2-40B4-BE49-F238E27FC236}">
+                <a16:creationId xmlns:a16="http://schemas.microsoft.com/office/drawing/2014/main" id="{8E5F9F78-7659-2C4C-F035-CA080DB17C92}"/>
+              </a:ext>
+            </a:extLst>
+          </p:cNvPr>
           <p:cNvSpPr>
             <a:spLocks noGrp="1" noRot="1" noChangeAspect="1"/>
           </p:cNvSpPr>
@@ -2290,7 +2304,13 @@
       </p:sp>
       <p:sp>
         <p:nvSpPr>
-          <p:cNvPr id="3" name="Notes Placeholder 2"/>
+          <p:cNvPr id="3" name="Notes Placeholder 2">
+            <a:extLst>
+              <a:ext uri="{FF2B5EF4-FFF2-40B4-BE49-F238E27FC236}">
+                <a16:creationId xmlns:a16="http://schemas.microsoft.com/office/drawing/2014/main" id="{4E57B2AE-D16B-B352-80B6-22209338C121}"/>
+              </a:ext>
+            </a:extLst>
+          </p:cNvPr>
           <p:cNvSpPr>
             <a:spLocks noGrp="1"/>
           </p:cNvSpPr>
@@ -2305,17 +2325,61 @@
           <a:p>
             <a:r>
               <a:rPr lang="en-US" dirty="0"/>
-              <a:t>(key idea: very boring, completely off-topic and uninformative start)</a:t>
+              <a:t>(key idea: pitch the research in 30s)</a:t>
             </a:r>
             <a:br>
               <a:rPr lang="en-US" dirty="0"/>
             </a:br>
+            <a:endParaRPr lang="en-US" dirty="0"/>
+          </a:p>
+          <a:p>
+            <a:r>
+              <a:rPr lang="en-US" dirty="0"/>
+              <a:t>Implementing efficient HPC algorithms is challenging.</a:t>
+            </a:r>
+          </a:p>
+          <a:p>
+            <a:r>
+              <a:rPr lang="en-US" dirty="0"/>
+              <a:t>Apart from ensuring the functionality and the right high-level algorithm design so it scales well for the expected use cases, the design must also ensure efficient evaluation.</a:t>
+            </a:r>
+          </a:p>
+          <a:p>
+            <a:endParaRPr lang="en-US" dirty="0"/>
+          </a:p>
+          <a:p>
+            <a:r>
+              <a:rPr lang="en-US" dirty="0"/>
+              <a:t>Most algorithms that we consider perform computations on large, often multidimensional data.</a:t>
+            </a:r>
+          </a:p>
+          <a:p>
+            <a:r>
+              <a:rPr lang="en-US" dirty="0"/>
+              <a:t>These data are operated on using multi-level nested loops that iteratively perform reads and writes.</a:t>
+            </a:r>
+          </a:p>
+          <a:p>
+            <a:endParaRPr lang="en-US" dirty="0"/>
+          </a:p>
+          <a:p>
+            <a:r>
+              <a:rPr lang="en-US" dirty="0"/>
+              <a:t>In such algorithms, the data and the loops may often be rearranged without changing the functionality,</a:t>
+            </a:r>
             <a:br>
               <a:rPr lang="en-US" dirty="0"/>
             </a:br>
             <a:r>
               <a:rPr lang="en-US" dirty="0"/>
-              <a:t>Our research is in the area of High-Performance Computing (HPC), focusing on exploring and implementing methods for easier and faster development of efficient scientific algorithms.</a:t>
+              <a:t>but doing so may influence the performance. The right choice of the data layouts and loop traversals can</a:t>
+            </a:r>
+            <a:br>
+              <a:rPr lang="en-US" dirty="0"/>
+            </a:br>
+            <a:r>
+              <a:rPr lang="en-US" dirty="0"/>
+              <a:t>significantly speed up computation, especially if it is memory-bound (limited by memory access speed).</a:t>
             </a:r>
           </a:p>
           <a:p>
@@ -2324,7 +2388,14 @@
           <a:p>
             <a:r>
               <a:rPr lang="en-US" dirty="0"/>
-              <a:t>These algorithms often contain multidimensional structures and computation in regular loops</a:t>
+              <a:t>This problem is especially pronounced on modern, massively parallel systems that process large datasets –</a:t>
+            </a:r>
+            <a:br>
+              <a:rPr lang="en-US" dirty="0"/>
+            </a:br>
+            <a:r>
+              <a:rPr lang="en-US" dirty="0"/>
+              <a:t>for example, modern AI systems.</a:t>
             </a:r>
           </a:p>
           <a:p>
@@ -2333,54 +2404,62 @@
           <a:p>
             <a:r>
               <a:rPr lang="en-US" dirty="0"/>
-              <a:t>One of the core problems when optimizing such algorithms for a particular computing system is that their complexity increases with every specific design decision made.</a:t>
+              <a:t>In many cases, the right choice of data layouts and traversals requires an empirical approach of trial and error,</a:t>
             </a:r>
           </a:p>
           <a:p>
             <a:r>
               <a:rPr lang="en-US" dirty="0"/>
-              <a:t>These design decisions range from choosing specific algorithm to smaller decisions such as how data structures such as matrices are stored in memory or in what order a computation is performed.</a:t>
-            </a:r>
-          </a:p>
-          <a:p>
-            <a:pPr marL="0" indent="0">
-              <a:buFontTx/>
-              <a:buNone/>
-            </a:pPr>
+              <a:t>And finding the most efficient implementation may require re-evaluating the algorithm with many</a:t>
+            </a:r>
+            <a:br>
+              <a:rPr lang="en-US" dirty="0"/>
+            </a:br>
+            <a:r>
+              <a:rPr lang="en-US" dirty="0"/>
+              <a:t>different choices of layouts and traversals. Furthermore, it may be necessary to repeat the process on each target system.</a:t>
+            </a:r>
+          </a:p>
+          <a:p>
             <a:endParaRPr lang="en-US" dirty="0"/>
           </a:p>
           <a:p>
-            <a:pPr marL="0" indent="0">
-              <a:buFontTx/>
-              <a:buNone/>
-            </a:pPr>
             <a:r>
               <a:rPr lang="en-US" dirty="0"/>
-              <a:t>It is important to choose the right *memory layout* to achieve the best possible performance (due to various hardware-specific effects such as caching or performance of memory operations); but the right choice is usually not obvious, and it often differs between different hardware architectures.</a:t>
-            </a:r>
-          </a:p>
-          <a:p>
-            <a:pPr marL="0" indent="0">
-              <a:buFontTx/>
-              <a:buNone/>
-            </a:pPr>
-            <a:endParaRPr lang="en-US" dirty="0"/>
-          </a:p>
-          <a:p>
-            <a:pPr marL="0" indent="0">
-              <a:buFontTx/>
-              <a:buNone/>
-            </a:pPr>
-            <a:r>
+              <a:t>Our research starts by decoupling layouts from the algorithm design so they can be optimized independently,</a:t>
+            </a:r>
+            <a:br>
               <a:rPr lang="en-US" dirty="0"/>
-              <a:t>Furthermore, if these choices are hard-coded in the algorithm, the algorithm becomes unreadable and more difficult to port to other hardware.</a:t>
-            </a:r>
-          </a:p>
-        </p:txBody>
-      </p:sp>
-      <p:sp>
-        <p:nvSpPr>
-          <p:cNvPr id="4" name="Slide Number Placeholder 3"/>
+            </a:br>
+            <a:r>
+              <a:rPr lang="en-US" dirty="0"/>
+              <a:t>which we then iterate on to also consider traversals, and then enable full automation.</a:t>
+            </a:r>
+          </a:p>
+          <a:p>
+            <a:r>
+              <a:rPr lang="en-US" dirty="0"/>
+              <a:t>This may simplify the implementation of efficient algorithms for domain experts who do not have the resources to study and iterate</a:t>
+            </a:r>
+            <a:br>
+              <a:rPr lang="en-US" dirty="0"/>
+            </a:br>
+            <a:r>
+              <a:rPr lang="en-US" dirty="0"/>
+              <a:t>different optimization decisions.</a:t>
+            </a:r>
+          </a:p>
+        </p:txBody>
+      </p:sp>
+      <p:sp>
+        <p:nvSpPr>
+          <p:cNvPr id="4" name="Slide Number Placeholder 3">
+            <a:extLst>
+              <a:ext uri="{FF2B5EF4-FFF2-40B4-BE49-F238E27FC236}">
+                <a16:creationId xmlns:a16="http://schemas.microsoft.com/office/drawing/2014/main" id="{C3AD30D6-FB5C-C6E6-8452-1EC18E3B9F72}"/>
+              </a:ext>
+            </a:extLst>
+          </p:cNvPr>
           <p:cNvSpPr>
             <a:spLocks noGrp="1"/>
           </p:cNvSpPr>
@@ -2404,7 +2483,7 @@
     </p:spTree>
     <p:extLst>
       <p:ext uri="{BB962C8B-B14F-4D97-AF65-F5344CB8AC3E}">
-        <p14:creationId xmlns:p14="http://schemas.microsoft.com/office/powerpoint/2010/main" val="3723586764"/>
+        <p14:creationId xmlns:p14="http://schemas.microsoft.com/office/powerpoint/2010/main" val="1888872044"/>
       </p:ext>
     </p:extLst>
   </p:cSld>
@@ -16764,17 +16843,15 @@
 <file path=ppt/slides/slide2.xml><?xml version="1.0" encoding="utf-8"?>
 <p:sld xmlns:a="http://schemas.openxmlformats.org/drawingml/2006/main" xmlns:r="http://schemas.openxmlformats.org/officeDocument/2006/relationships" xmlns:p="http://schemas.openxmlformats.org/presentationml/2006/main">
   <p:cSld>
-    <p:bg>
-      <p:bgPr>
-        <a:solidFill>
-          <a:srgbClr val="FFFF00"/>
-        </a:solidFill>
-        <a:effectLst/>
-      </p:bgPr>
-    </p:bg>
     <p:spTree>
       <p:nvGrpSpPr>
-        <p:cNvPr id="1" name=""/>
+        <p:cNvPr id="1" name="">
+          <a:extLst>
+            <a:ext uri="{FF2B5EF4-FFF2-40B4-BE49-F238E27FC236}">
+              <a16:creationId xmlns:a16="http://schemas.microsoft.com/office/drawing/2014/main" id="{9C25D00A-C97B-2737-13F2-3DAF74AE2143}"/>
+            </a:ext>
+          </a:extLst>
+        </p:cNvPr>
         <p:cNvGrpSpPr/>
         <p:nvPr/>
       </p:nvGrpSpPr>
@@ -16791,7 +16868,7 @@
           <p:cNvPr id="2" name="Title 1">
             <a:extLst>
               <a:ext uri="{FF2B5EF4-FFF2-40B4-BE49-F238E27FC236}">
-                <a16:creationId xmlns:a16="http://schemas.microsoft.com/office/drawing/2014/main" id="{BD32B0F3-07AF-DDF2-75A9-BE53A93E33B4}"/>
+                <a16:creationId xmlns:a16="http://schemas.microsoft.com/office/drawing/2014/main" id="{A5D2ED1B-55E3-6487-BD53-B3FDC45B760D}"/>
               </a:ext>
             </a:extLst>
           </p:cNvPr>
@@ -16809,7 +16886,7 @@
           <a:p>
             <a:r>
               <a:rPr lang="en-US" noProof="0" dirty="0"/>
-              <a:t>Motivation for memory layouts</a:t>
+              <a:t>Motivation</a:t>
             </a:r>
           </a:p>
         </p:txBody>
@@ -16819,7 +16896,7 @@
           <p:cNvPr id="3" name="Content Placeholder 2">
             <a:extLst>
               <a:ext uri="{FF2B5EF4-FFF2-40B4-BE49-F238E27FC236}">
-                <a16:creationId xmlns:a16="http://schemas.microsoft.com/office/drawing/2014/main" id="{9CCFAC94-5637-4468-27F3-D65EF4095823}"/>
+                <a16:creationId xmlns:a16="http://schemas.microsoft.com/office/drawing/2014/main" id="{43B1B8F4-47B3-8AEC-FEE0-BBA2C521EE8C}"/>
               </a:ext>
             </a:extLst>
           </p:cNvPr>
@@ -16837,54 +16914,89 @@
           <a:p>
             <a:r>
               <a:rPr lang="en-US" noProof="0" dirty="0"/>
-              <a:t>Development of algorithms for scientific computing</a:t>
+              <a:t>Designing efficient HPC algorithms is challenging</a:t>
+            </a:r>
+          </a:p>
+          <a:p>
+            <a:r>
+              <a:rPr lang="en-US" dirty="0"/>
+              <a:t>Multidimensional data processed in multi-level loops</a:t>
             </a:r>
           </a:p>
           <a:p>
             <a:pPr lvl="1"/>
             <a:r>
-              <a:rPr lang="en-US" noProof="0" dirty="0"/>
-              <a:t>Multidimensional data structures</a:t>
+              <a:rPr lang="en-US" dirty="0"/>
+              <a:t>Changing data layouts and traversals often preserves functionality</a:t>
             </a:r>
           </a:p>
           <a:p>
             <a:pPr lvl="1"/>
             <a:r>
-              <a:rPr lang="en-US" noProof="0" dirty="0"/>
-              <a:t>Regular loops</a:t>
-            </a:r>
-          </a:p>
-          <a:p>
-            <a:r>
-              <a:rPr lang="en-US" noProof="0" dirty="0"/>
-              <a:t>Complexity rises with every design decision</a:t>
-            </a:r>
-          </a:p>
-          <a:p>
-            <a:pPr lvl="1"/>
-            <a:r>
-              <a:rPr lang="en-US" noProof="0" dirty="0"/>
-              <a:t>How to store the data</a:t>
-            </a:r>
-          </a:p>
-          <a:p>
-            <a:pPr lvl="1"/>
-            <a:r>
-              <a:rPr lang="en-US" noProof="0" dirty="0"/>
-              <a:t>In what order do the computations</a:t>
-            </a:r>
-          </a:p>
-          <a:p>
-            <a:endParaRPr lang="en-US" noProof="0" dirty="0"/>
-          </a:p>
-          <a:p>
-            <a:r>
-              <a:rPr lang="en-US" noProof="0" dirty="0"/>
-              <a:t>Performance very difficult to predict</a:t>
-            </a:r>
-          </a:p>
-          <a:p>
-            <a:endParaRPr lang="en-US" noProof="0" dirty="0"/>
+              <a:rPr lang="en-US" b="1" dirty="0"/>
+              <a:t>Right</a:t>
+            </a:r>
+            <a:r>
+              <a:rPr lang="en-US" dirty="0"/>
+              <a:t> </a:t>
+            </a:r>
+            <a:r>
+              <a:rPr lang="en-US" b="1" dirty="0"/>
+              <a:t>data layouts</a:t>
+            </a:r>
+            <a:r>
+              <a:rPr lang="en-US" dirty="0"/>
+              <a:t> and </a:t>
+            </a:r>
+            <a:r>
+              <a:rPr lang="en-US" b="1" dirty="0"/>
+              <a:t>traversals</a:t>
+            </a:r>
+            <a:r>
+              <a:rPr lang="en-US" dirty="0"/>
+              <a:t> </a:t>
+            </a:r>
+            <a:r>
+              <a:rPr lang="en-US" dirty="0">
+                <a:sym typeface="Wingdings" panose="05000000000000000000" pitchFamily="2" charset="2"/>
+              </a:rPr>
+              <a:t> </a:t>
+            </a:r>
+            <a:r>
+              <a:rPr lang="en-US" dirty="0"/>
+              <a:t>significant </a:t>
+            </a:r>
+            <a:r>
+              <a:rPr lang="en-US" b="1" dirty="0"/>
+              <a:t>speedup</a:t>
+            </a:r>
+          </a:p>
+          <a:p>
+            <a:r>
+              <a:rPr lang="en-US" dirty="0"/>
+              <a:t>Massively parallel systems processing large datasets</a:t>
+            </a:r>
+          </a:p>
+          <a:p>
+            <a:r>
+              <a:rPr lang="en-US" dirty="0"/>
+              <a:t>Trial-and-error evaluation of many different choices</a:t>
+            </a:r>
+          </a:p>
+          <a:p>
+            <a:r>
+              <a:rPr lang="en-US" dirty="0"/>
+              <a:t>Different optima on different systems</a:t>
+            </a:r>
+          </a:p>
+          <a:p>
+            <a:endParaRPr lang="en-US" dirty="0"/>
+          </a:p>
+          <a:p>
+            <a:r>
+              <a:rPr lang="en-US" dirty="0"/>
+              <a:t>Decoupling data layouts, then traversals, then full automation</a:t>
+            </a:r>
           </a:p>
         </p:txBody>
       </p:sp>
@@ -16893,7 +17005,7 @@
           <p:cNvPr id="4" name="Date Placeholder 3">
             <a:extLst>
               <a:ext uri="{FF2B5EF4-FFF2-40B4-BE49-F238E27FC236}">
-                <a16:creationId xmlns:a16="http://schemas.microsoft.com/office/drawing/2014/main" id="{C879A157-F47D-07F8-BBBF-9D9647E138A7}"/>
+                <a16:creationId xmlns:a16="http://schemas.microsoft.com/office/drawing/2014/main" id="{7BE174B8-24C5-EFF8-68D7-B0BAFDA2C8B9}"/>
               </a:ext>
             </a:extLst>
           </p:cNvPr>
@@ -16922,7 +17034,7 @@
           <p:cNvPr id="5" name="Slide Number Placeholder 4">
             <a:extLst>
               <a:ext uri="{FF2B5EF4-FFF2-40B4-BE49-F238E27FC236}">
-                <a16:creationId xmlns:a16="http://schemas.microsoft.com/office/drawing/2014/main" id="{1674A618-B628-9F85-14EF-1E83AA91CA35}"/>
+                <a16:creationId xmlns:a16="http://schemas.microsoft.com/office/drawing/2014/main" id="{FBE8A958-9CA9-B376-C939-4B09FEE669DD}"/>
               </a:ext>
             </a:extLst>
           </p:cNvPr>
@@ -16946,10 +17058,70 @@
           </a:p>
         </p:txBody>
       </p:sp>
+      <p:pic>
+        <p:nvPicPr>
+          <p:cNvPr id="6" name="Picture 5" descr="Thinking Man PNG Images Transparent Free Download">
+            <a:extLst>
+              <a:ext uri="{FF2B5EF4-FFF2-40B4-BE49-F238E27FC236}">
+                <a16:creationId xmlns:a16="http://schemas.microsoft.com/office/drawing/2014/main" id="{EECB4EAE-D14C-1C42-94B6-34013519EA66}"/>
+              </a:ext>
+            </a:extLst>
+          </p:cNvPr>
+          <p:cNvPicPr>
+            <a:picLocks noChangeAspect="1"/>
+          </p:cNvPicPr>
+          <p:nvPr/>
+        </p:nvPicPr>
+        <p:blipFill>
+          <a:blip r:embed="rId3"/>
+          <a:stretch>
+            <a:fillRect/>
+          </a:stretch>
+        </p:blipFill>
+        <p:spPr>
+          <a:xfrm>
+            <a:off x="8950656" y="915929"/>
+            <a:ext cx="1640006" cy="1640006"/>
+          </a:xfrm>
+          <a:prstGeom prst="rect">
+            <a:avLst/>
+          </a:prstGeom>
+        </p:spPr>
+      </p:pic>
+      <p:pic>
+        <p:nvPicPr>
+          <p:cNvPr id="7" name="Picture 6" descr="Trial and error - Free education icons">
+            <a:extLst>
+              <a:ext uri="{FF2B5EF4-FFF2-40B4-BE49-F238E27FC236}">
+                <a16:creationId xmlns:a16="http://schemas.microsoft.com/office/drawing/2014/main" id="{28071A90-4986-3170-8847-B34F3D13814E}"/>
+              </a:ext>
+            </a:extLst>
+          </p:cNvPr>
+          <p:cNvPicPr>
+            <a:picLocks noChangeAspect="1"/>
+          </p:cNvPicPr>
+          <p:nvPr/>
+        </p:nvPicPr>
+        <p:blipFill>
+          <a:blip r:embed="rId4"/>
+          <a:stretch>
+            <a:fillRect/>
+          </a:stretch>
+        </p:blipFill>
+        <p:spPr>
+          <a:xfrm>
+            <a:off x="9144000" y="4061022"/>
+            <a:ext cx="1269681" cy="1269681"/>
+          </a:xfrm>
+          <a:prstGeom prst="rect">
+            <a:avLst/>
+          </a:prstGeom>
+        </p:spPr>
+      </p:pic>
     </p:spTree>
     <p:extLst>
       <p:ext uri="{BB962C8B-B14F-4D97-AF65-F5344CB8AC3E}">
-        <p14:creationId xmlns:p14="http://schemas.microsoft.com/office/powerpoint/2010/main" val="387481787"/>
+        <p14:creationId xmlns:p14="http://schemas.microsoft.com/office/powerpoint/2010/main" val="2931822369"/>
       </p:ext>
     </p:extLst>
   </p:cSld>
@@ -28098,7 +28270,7 @@
     <p:bg>
       <p:bgPr>
         <a:solidFill>
-          <a:srgbClr val="FF0000"/>
+          <a:srgbClr val="FFFF00"/>
         </a:solidFill>
         <a:effectLst/>
       </p:bgPr>
@@ -28686,6 +28858,155 @@
     <p:extLst>
       <p:ext uri="{BB962C8B-B14F-4D97-AF65-F5344CB8AC3E}">
         <p14:creationId xmlns:p14="http://schemas.microsoft.com/office/powerpoint/2010/main" val="3444521087"/>
+      </p:ext>
+    </p:extLst>
+  </p:cSld>
+  <p:clrMapOvr>
+    <a:masterClrMapping/>
+  </p:clrMapOvr>
+</p:sld>
+</file>
+
+<file path=ppt/slides/slide36.xml><?xml version="1.0" encoding="utf-8"?>
+<p:sld xmlns:a="http://schemas.openxmlformats.org/drawingml/2006/main" xmlns:r="http://schemas.openxmlformats.org/officeDocument/2006/relationships" xmlns:p="http://schemas.openxmlformats.org/presentationml/2006/main">
+  <p:cSld>
+    <p:bg>
+      <p:bgPr>
+        <a:solidFill>
+          <a:srgbClr val="FFFF00"/>
+        </a:solidFill>
+        <a:effectLst/>
+      </p:bgPr>
+    </p:bg>
+    <p:spTree>
+      <p:nvGrpSpPr>
+        <p:cNvPr id="1" name=""/>
+        <p:cNvGrpSpPr/>
+        <p:nvPr/>
+      </p:nvGrpSpPr>
+      <p:grpSpPr>
+        <a:xfrm>
+          <a:off x="0" y="0"/>
+          <a:ext cx="0" cy="0"/>
+          <a:chOff x="0" y="0"/>
+          <a:chExt cx="0" cy="0"/>
+        </a:xfrm>
+      </p:grpSpPr>
+      <p:sp>
+        <p:nvSpPr>
+          <p:cNvPr id="2" name="Title 1">
+            <a:extLst>
+              <a:ext uri="{FF2B5EF4-FFF2-40B4-BE49-F238E27FC236}">
+                <a16:creationId xmlns:a16="http://schemas.microsoft.com/office/drawing/2014/main" id="{C516181A-2F41-81F5-2007-5244DC687F1D}"/>
+              </a:ext>
+            </a:extLst>
+          </p:cNvPr>
+          <p:cNvSpPr>
+            <a:spLocks noGrp="1"/>
+          </p:cNvSpPr>
+          <p:nvPr>
+            <p:ph type="title"/>
+          </p:nvPr>
+        </p:nvSpPr>
+        <p:spPr/>
+        <p:txBody>
+          <a:bodyPr/>
+          <a:lstStyle/>
+          <a:p>
+            <a:r>
+              <a:rPr lang="en-US" dirty="0"/>
+              <a:t>Why did the abstractions hinder the LLM</a:t>
+            </a:r>
+          </a:p>
+        </p:txBody>
+      </p:sp>
+      <p:sp>
+        <p:nvSpPr>
+          <p:cNvPr id="3" name="Content Placeholder 2">
+            <a:extLst>
+              <a:ext uri="{FF2B5EF4-FFF2-40B4-BE49-F238E27FC236}">
+                <a16:creationId xmlns:a16="http://schemas.microsoft.com/office/drawing/2014/main" id="{BFE9388A-2481-EE41-E355-566C2612FC2B}"/>
+              </a:ext>
+            </a:extLst>
+          </p:cNvPr>
+          <p:cNvSpPr>
+            <a:spLocks noGrp="1"/>
+          </p:cNvSpPr>
+          <p:nvPr>
+            <p:ph idx="1"/>
+          </p:nvPr>
+        </p:nvSpPr>
+        <p:spPr/>
+        <p:txBody>
+          <a:bodyPr/>
+          <a:lstStyle/>
+          <a:p>
+            <a:endParaRPr lang="en-US"/>
+          </a:p>
+        </p:txBody>
+      </p:sp>
+      <p:sp>
+        <p:nvSpPr>
+          <p:cNvPr id="4" name="Date Placeholder 3">
+            <a:extLst>
+              <a:ext uri="{FF2B5EF4-FFF2-40B4-BE49-F238E27FC236}">
+                <a16:creationId xmlns:a16="http://schemas.microsoft.com/office/drawing/2014/main" id="{38A398BB-7A0C-F187-3DAA-0CA6E59EF3D1}"/>
+              </a:ext>
+            </a:extLst>
+          </p:cNvPr>
+          <p:cNvSpPr>
+            <a:spLocks noGrp="1"/>
+          </p:cNvSpPr>
+          <p:nvPr>
+            <p:ph type="dt" sz="half" idx="10"/>
+          </p:nvPr>
+        </p:nvSpPr>
+        <p:spPr/>
+        <p:txBody>
+          <a:bodyPr/>
+          <a:lstStyle/>
+          <a:p>
+            <a:fld id="{358C28A6-2969-482E-9A3B-5E13FCD8DD03}" type="datetime1">
+              <a:rPr lang="en-US" smtClean="0"/>
+              <a:t>8/30/2026</a:t>
+            </a:fld>
+            <a:endParaRPr lang="en-US"/>
+          </a:p>
+        </p:txBody>
+      </p:sp>
+      <p:sp>
+        <p:nvSpPr>
+          <p:cNvPr id="5" name="Slide Number Placeholder 4">
+            <a:extLst>
+              <a:ext uri="{FF2B5EF4-FFF2-40B4-BE49-F238E27FC236}">
+                <a16:creationId xmlns:a16="http://schemas.microsoft.com/office/drawing/2014/main" id="{A236833A-9918-E7AE-C3D5-650A1C45B68A}"/>
+              </a:ext>
+            </a:extLst>
+          </p:cNvPr>
+          <p:cNvSpPr>
+            <a:spLocks noGrp="1"/>
+          </p:cNvSpPr>
+          <p:nvPr>
+            <p:ph type="sldNum" sz="quarter" idx="12"/>
+          </p:nvPr>
+        </p:nvSpPr>
+        <p:spPr/>
+        <p:txBody>
+          <a:bodyPr/>
+          <a:lstStyle/>
+          <a:p>
+            <a:fld id="{DA0BB241-1B5F-4309-9407-9EEA04D9598D}" type="slidenum">
+              <a:rPr lang="en-US" smtClean="0"/>
+              <a:t>36</a:t>
+            </a:fld>
+            <a:endParaRPr lang="en-US"/>
+          </a:p>
+        </p:txBody>
+      </p:sp>
+    </p:spTree>
+    <p:extLst>
+      <p:ext uri="{BB962C8B-B14F-4D97-AF65-F5344CB8AC3E}">
+        <p14:creationId xmlns:p14="http://schemas.microsoft.com/office/powerpoint/2010/main" val="4113959115"/>
       </p:ext>
     </p:extLst>
   </p:cSld>

</xml_diff>